<commit_message>
Revise ESMO P305 poster content for ML rigour
State the task as conditional density estimation with a continuous relaxation;
add leakage controls, AUPRC, calibration and joint-fidelity endpoints; tighten
claims on amplification recovery and the paired-assay comparison.

Co-Authored-By: Claude Opus 5.5 <noreply@anthropic.com>
Claude-Session: https://claude.ai/code/session_01XfxNdpDPmWZQpH5ScSMkJ1
</commit_message>
<xml_diff>
--- a/docs/poster/ESMO_P305_poster.pptx
+++ b/docs/poster/ESMO_P305_poster.pptx
@@ -1893,7 +1893,7 @@
         <p:spPr>
           <a:xfrm>
             <a:off x="571500" y="6588506"/>
-            <a:ext cx="7873344" cy="870014"/>
+            <a:ext cx="7873344" cy="1147826"/>
           </a:xfrm>
           <a:prstGeom prst="rect">
             <a:avLst/>
@@ -1931,7 +1931,7 @@
                 <a:ea typeface="Calibri" pitchFamily="34" charset="-122"/>
                 <a:cs typeface="Calibri" pitchFamily="34" charset="-120"/>
               </a:rPr>
-              <a:t>To determine whether a conditional generative model can infer alterations in genes absent from a targeted panel, and to quantify which biological signals make this possible.</a:t>
+              <a:t>To learn the conditional distribution of alterations in genes absent from a targeted panel given the genes it measures, to benchmark it against simple statistical baselines, and to identify which signals make the missing genes predictable.</a:t>
             </a:r>
             <a:endParaRPr lang="en-US" sz="1750" dirty="0"/>
           </a:p>
@@ -1945,7 +1945,7 @@
         </p:nvSpPr>
         <p:spPr>
           <a:xfrm>
-            <a:off x="571500" y="7778560"/>
+            <a:off x="571500" y="8056372"/>
             <a:ext cx="7873344" cy="0"/>
           </a:xfrm>
           <a:prstGeom prst="line">
@@ -1968,7 +1968,7 @@
         </p:nvSpPr>
         <p:spPr>
           <a:xfrm>
-            <a:off x="571500" y="7870000"/>
+            <a:off x="571500" y="8147812"/>
             <a:ext cx="7873344" cy="566928"/>
           </a:xfrm>
           <a:prstGeom prst="rect">
@@ -2007,7 +2007,7 @@
         </p:nvSpPr>
         <p:spPr>
           <a:xfrm>
-            <a:off x="571500" y="8647240"/>
+            <a:off x="571500" y="8925052"/>
             <a:ext cx="5314507" cy="566928"/>
           </a:xfrm>
           <a:prstGeom prst="rect">
@@ -2027,7 +2027,7 @@
         </p:nvSpPr>
         <p:spPr>
           <a:xfrm>
-            <a:off x="571500" y="8647240"/>
+            <a:off x="571500" y="8925052"/>
             <a:ext cx="5314507" cy="566928"/>
           </a:xfrm>
           <a:prstGeom prst="rect">
@@ -2066,7 +2066,7 @@
         </p:nvSpPr>
         <p:spPr>
           <a:xfrm>
-            <a:off x="5886007" y="8647240"/>
+            <a:off x="5886007" y="8925052"/>
             <a:ext cx="2558837" cy="566928"/>
           </a:xfrm>
           <a:prstGeom prst="rect">
@@ -2091,7 +2091,7 @@
         </p:nvSpPr>
         <p:spPr>
           <a:xfrm>
-            <a:off x="5886007" y="8647240"/>
+            <a:off x="5886007" y="8925052"/>
             <a:ext cx="2558837" cy="566928"/>
           </a:xfrm>
           <a:prstGeom prst="rect">
@@ -2130,7 +2130,7 @@
         </p:nvSpPr>
         <p:spPr>
           <a:xfrm>
-            <a:off x="571500" y="9323896"/>
+            <a:off x="571500" y="9601708"/>
             <a:ext cx="7873344" cy="481076"/>
           </a:xfrm>
           <a:prstGeom prst="rect">
@@ -2183,7 +2183,7 @@
         </p:nvSpPr>
         <p:spPr>
           <a:xfrm>
-            <a:off x="571500" y="10079292"/>
+            <a:off x="571500" y="10357104"/>
             <a:ext cx="7873344" cy="258826"/>
           </a:xfrm>
           <a:prstGeom prst="rect">
@@ -2243,7 +2243,7 @@
           </p:nvPr>
         </p:nvGraphicFramePr>
         <p:xfrm>
-          <a:off x="571500" y="10447846"/>
+          <a:off x="571500" y="10725658"/>
           <a:ext cx="7873344" cy="914400"/>
         </p:xfrm>
         <a:graphic>
@@ -3058,7 +3058,7 @@
         </p:nvSpPr>
         <p:spPr>
           <a:xfrm>
-            <a:off x="571500" y="10447846"/>
+            <a:off x="571500" y="10725658"/>
             <a:ext cx="7873344" cy="0"/>
           </a:xfrm>
           <a:prstGeom prst="line">
@@ -3081,7 +3081,7 @@
         </p:nvSpPr>
         <p:spPr>
           <a:xfrm>
-            <a:off x="571500" y="12752133"/>
+            <a:off x="571500" y="13029946"/>
             <a:ext cx="7873344" cy="0"/>
           </a:xfrm>
           <a:prstGeom prst="line">
@@ -3104,8 +3104,8 @@
         </p:nvSpPr>
         <p:spPr>
           <a:xfrm>
-            <a:off x="571500" y="13026454"/>
-            <a:ext cx="7873344" cy="870014"/>
+            <a:off x="571500" y="13304266"/>
+            <a:ext cx="7873344" cy="1703451"/>
           </a:xfrm>
           <a:prstGeom prst="rect">
             <a:avLst/>
@@ -3143,7 +3143,7 @@
                 <a:ea typeface="Calibri" pitchFamily="34" charset="-122"/>
                 <a:cs typeface="Calibri" pitchFamily="34" charset="-120"/>
               </a:rPr>
-              <a:t>One binary event per gene and patient: non-synonymous mutation, amplification or deep deletion. One sample per patient; [state handling of VUS and structural variants].</a:t>
+              <a:t>Target: one binary event per gene and patient (non-synonymous mutation, amplification or deep deletion; [state VUS and structural-variant handling]). Input: separate mutation, amplification and deletion indicators for the 341 assayed genes. One sample per patient. Genes not covered by a sample's panel are treated as missing, never as wild type.</a:t>
             </a:r>
             <a:endParaRPr lang="en-US" sz="1750" dirty="0"/>
           </a:p>
@@ -3220,7 +3220,7 @@
         <p:spPr>
           <a:xfrm>
             <a:off x="8966052" y="5212080"/>
-            <a:ext cx="7873344" cy="1147826"/>
+            <a:ext cx="7873344" cy="1703451"/>
           </a:xfrm>
           <a:prstGeom prst="rect">
             <a:avLst/>
@@ -3244,7 +3244,7 @@
                 <a:ea typeface="Calibri" pitchFamily="34" charset="-122"/>
                 <a:cs typeface="Calibri" pitchFamily="34" charset="-120"/>
               </a:rPr>
-              <a:t>3.1 Conditional flow matching. </a:t>
+              <a:t>3.1 Problem formulation. </a:t>
             </a:r>
             <a:pPr indent="0" marL="0">
               <a:buNone/>
@@ -3258,7 +3258,63 @@
                 <a:ea typeface="Calibri" pitchFamily="34" charset="-122"/>
                 <a:cs typeface="Calibri" pitchFamily="34" charset="-120"/>
               </a:rPr>
-              <a:t>Let c ∈ {0,1}</a:t>
+              <a:t>Given the observed IMPACT341 profile c, we learn the conditional distribution p(x</a:t>
+            </a:r>
+            <a:pPr indent="0" marL="0">
+              <a:buNone/>
+            </a:pPr>
+            <a:r>
+              <a:rPr lang="en-US" sz="1750" baseline="-40000" dirty="0">
+                <a:solidFill>
+                  <a:srgbClr val="12202E"/>
+                </a:solidFill>
+                <a:latin typeface="Calibri" pitchFamily="34" charset="0"/>
+                <a:ea typeface="Calibri" pitchFamily="34" charset="-122"/>
+                <a:cs typeface="Calibri" pitchFamily="34" charset="-120"/>
+              </a:rPr>
+              <a:t>1</a:t>
+            </a:r>
+            <a:pPr indent="0" marL="0">
+              <a:buNone/>
+            </a:pPr>
+            <a:r>
+              <a:rPr lang="en-US" sz="1750" dirty="0">
+                <a:solidFill>
+                  <a:srgbClr val="12202E"/>
+                </a:solidFill>
+                <a:latin typeface="Calibri" pitchFamily="34" charset="0"/>
+                <a:ea typeface="Calibri" pitchFamily="34" charset="-122"/>
+                <a:cs typeface="Calibri" pitchFamily="34" charset="-120"/>
+              </a:rPr>
+              <a:t> | c) over the 164 target genes. Binary targets are embedded as x</a:t>
+            </a:r>
+            <a:pPr indent="0" marL="0">
+              <a:buNone/>
+            </a:pPr>
+            <a:r>
+              <a:rPr lang="en-US" sz="1750" baseline="-40000" dirty="0">
+                <a:solidFill>
+                  <a:srgbClr val="12202E"/>
+                </a:solidFill>
+                <a:latin typeface="Calibri" pitchFamily="34" charset="0"/>
+                <a:ea typeface="Calibri" pitchFamily="34" charset="-122"/>
+                <a:cs typeface="Calibri" pitchFamily="34" charset="-120"/>
+              </a:rPr>
+              <a:t>1</a:t>
+            </a:r>
+            <a:pPr indent="0" marL="0">
+              <a:buNone/>
+            </a:pPr>
+            <a:r>
+              <a:rPr lang="en-US" sz="1750" dirty="0">
+                <a:solidFill>
+                  <a:srgbClr val="12202E"/>
+                </a:solidFill>
+                <a:latin typeface="Calibri" pitchFamily="34" charset="0"/>
+                <a:ea typeface="Calibri" pitchFamily="34" charset="-122"/>
+                <a:cs typeface="Calibri" pitchFamily="34" charset="-120"/>
+              </a:rPr>
+              <a:t> ∈ {−1,+1}</a:t>
             </a:r>
             <a:pPr indent="0" marL="0">
               <a:buNone/>
@@ -3272,7 +3328,7 @@
                 <a:ea typeface="Calibri" pitchFamily="34" charset="-122"/>
                 <a:cs typeface="Calibri" pitchFamily="34" charset="-120"/>
               </a:rPr>
-              <a:t>p</a:t>
+              <a:t>164</a:t>
             </a:r>
             <a:pPr indent="0" marL="0">
               <a:buNone/>
@@ -3286,7 +3342,60 @@
                 <a:ea typeface="Calibri" pitchFamily="34" charset="-122"/>
                 <a:cs typeface="Calibri" pitchFamily="34" charset="-120"/>
               </a:rPr>
-              <a:t> denote a patient's IMPACT341 profile and x</a:t>
+              <a:t> (continuous relaxation); generated profiles are binarised by sign. Data were split by patient into 70% training, 15% validation (all model and hyper-parameter selection) and 15% test, evaluated once.</a:t>
+            </a:r>
+            <a:endParaRPr lang="en-US" sz="1750" dirty="0"/>
+          </a:p>
+        </p:txBody>
+      </p:sp>
+      <p:sp>
+        <p:nvSpPr>
+          <p:cNvPr id="28" name="Text 25"/>
+          <p:cNvSpPr txBox="1"/>
+          <p:nvPr/>
+        </p:nvSpPr>
+        <p:spPr>
+          <a:xfrm>
+            <a:off x="8966052" y="7144131"/>
+            <a:ext cx="7873344" cy="870014"/>
+          </a:xfrm>
+          <a:prstGeom prst="rect">
+            <a:avLst/>
+          </a:prstGeom>
+          <a:noFill/>
+          <a:ln/>
+        </p:spPr>
+        <p:txBody>
+          <a:bodyPr wrap="square" lIns="0" tIns="0" rIns="0" bIns="0" rtlCol="0" anchor="t"/>
+          <a:lstStyle/>
+          <a:p>
+            <a:pPr indent="0" marL="0">
+              <a:buNone/>
+            </a:pPr>
+            <a:r>
+              <a:rPr lang="en-US" sz="1750" b="1" dirty="0">
+                <a:solidFill>
+                  <a:srgbClr val="12202E"/>
+                </a:solidFill>
+                <a:latin typeface="Calibri" pitchFamily="34" charset="0"/>
+                <a:ea typeface="Calibri" pitchFamily="34" charset="-122"/>
+                <a:cs typeface="Calibri" pitchFamily="34" charset="-120"/>
+              </a:rPr>
+              <a:t>3.2 Conditional flow matching. </a:t>
+            </a:r>
+            <a:pPr indent="0" marL="0">
+              <a:buNone/>
+            </a:pPr>
+            <a:r>
+              <a:rPr lang="en-US" sz="1750" dirty="0">
+                <a:solidFill>
+                  <a:srgbClr val="12202E"/>
+                </a:solidFill>
+                <a:latin typeface="Calibri" pitchFamily="34" charset="0"/>
+                <a:ea typeface="Calibri" pitchFamily="34" charset="-122"/>
+                <a:cs typeface="Calibri" pitchFamily="34" charset="-120"/>
+              </a:rPr>
+              <a:t>A velocity field v</a:t>
             </a:r>
             <a:pPr indent="0" marL="0">
               <a:buNone/>
@@ -3300,7 +3409,7 @@
                 <a:ea typeface="Calibri" pitchFamily="34" charset="-122"/>
                 <a:cs typeface="Calibri" pitchFamily="34" charset="-120"/>
               </a:rPr>
-              <a:t>1</a:t>
+              <a:t>θ</a:t>
             </a:r>
             <a:pPr indent="0" marL="0">
               <a:buNone/>
@@ -3314,63 +3423,7 @@
                 <a:ea typeface="Calibri" pitchFamily="34" charset="-122"/>
                 <a:cs typeface="Calibri" pitchFamily="34" charset="-120"/>
               </a:rPr>
-              <a:t> ∈ {−1,+1}</a:t>
-            </a:r>
-            <a:pPr indent="0" marL="0">
-              <a:buNone/>
-            </a:pPr>
-            <a:r>
-              <a:rPr lang="en-US" sz="1750" baseline="30000" dirty="0">
-                <a:solidFill>
-                  <a:srgbClr val="12202E"/>
-                </a:solidFill>
-                <a:latin typeface="Calibri" pitchFamily="34" charset="0"/>
-                <a:ea typeface="Calibri" pitchFamily="34" charset="-122"/>
-                <a:cs typeface="Calibri" pitchFamily="34" charset="-120"/>
-              </a:rPr>
-              <a:t>164</a:t>
-            </a:r>
-            <a:pPr indent="0" marL="0">
-              <a:buNone/>
-            </a:pPr>
-            <a:r>
-              <a:rPr lang="en-US" sz="1750" dirty="0">
-                <a:solidFill>
-                  <a:srgbClr val="12202E"/>
-                </a:solidFill>
-                <a:latin typeface="Calibri" pitchFamily="34" charset="0"/>
-                <a:ea typeface="Calibri" pitchFamily="34" charset="-122"/>
-                <a:cs typeface="Calibri" pitchFamily="34" charset="-120"/>
-              </a:rPr>
-              <a:t> the target genes. A velocity field v</a:t>
-            </a:r>
-            <a:pPr indent="0" marL="0">
-              <a:buNone/>
-            </a:pPr>
-            <a:r>
-              <a:rPr lang="en-US" sz="1750" baseline="-40000" dirty="0">
-                <a:solidFill>
-                  <a:srgbClr val="12202E"/>
-                </a:solidFill>
-                <a:latin typeface="Calibri" pitchFamily="34" charset="0"/>
-                <a:ea typeface="Calibri" pitchFamily="34" charset="-122"/>
-                <a:cs typeface="Calibri" pitchFamily="34" charset="-120"/>
-              </a:rPr>
-              <a:t>θ</a:t>
-            </a:r>
-            <a:pPr indent="0" marL="0">
-              <a:buNone/>
-            </a:pPr>
-            <a:r>
-              <a:rPr lang="en-US" sz="1750" dirty="0">
-                <a:solidFill>
-                  <a:srgbClr val="12202E"/>
-                </a:solidFill>
-                <a:latin typeface="Calibri" pitchFamily="34" charset="0"/>
-                <a:ea typeface="Calibri" pitchFamily="34" charset="-122"/>
-                <a:cs typeface="Calibri" pitchFamily="34" charset="-120"/>
-              </a:rPr>
-              <a:t> is trained along the linear path between Gaussian noise and data:</a:t>
+              <a:t> ([architecture]) is regressed onto the straight-line path between Gaussian noise and data:</a:t>
             </a:r>
             <a:endParaRPr lang="en-US" sz="1750" dirty="0"/>
           </a:p>
@@ -3378,13 +3431,13 @@
       </p:sp>
       <p:sp>
         <p:nvSpPr>
-          <p:cNvPr id="28" name="Shape 25"/>
+          <p:cNvPr id="29" name="Shape 26"/>
           <p:cNvSpPr/>
           <p:nvPr/>
         </p:nvSpPr>
         <p:spPr>
           <a:xfrm>
-            <a:off x="8966052" y="6588506"/>
+            <a:off x="8966052" y="8178737"/>
             <a:ext cx="7873344" cy="960120"/>
           </a:xfrm>
           <a:prstGeom prst="rect">
@@ -3398,13 +3451,13 @@
       </p:sp>
       <p:sp>
         <p:nvSpPr>
-          <p:cNvPr id="29" name="Text 26"/>
+          <p:cNvPr id="30" name="Text 27"/>
           <p:cNvSpPr txBox="1"/>
           <p:nvPr/>
         </p:nvSpPr>
         <p:spPr>
           <a:xfrm>
-            <a:off x="8966052" y="6698234"/>
+            <a:off x="8966052" y="8288465"/>
             <a:ext cx="7873344" cy="740664"/>
           </a:xfrm>
           <a:prstGeom prst="rect">
@@ -3732,13 +3785,13 @@
       </p:sp>
       <p:sp>
         <p:nvSpPr>
-          <p:cNvPr id="30" name="Shape 27"/>
+          <p:cNvPr id="31" name="Shape 28"/>
           <p:cNvSpPr/>
           <p:nvPr/>
         </p:nvSpPr>
         <p:spPr>
           <a:xfrm>
-            <a:off x="8966052" y="7822946"/>
+            <a:off x="8966052" y="9413177"/>
             <a:ext cx="2153105" cy="685800"/>
           </a:xfrm>
           <a:prstGeom prst="rect">
@@ -3757,13 +3810,13 @@
       </p:sp>
       <p:sp>
         <p:nvSpPr>
-          <p:cNvPr id="31" name="Text 28"/>
+          <p:cNvPr id="32" name="Text 29"/>
           <p:cNvSpPr txBox="1"/>
           <p:nvPr/>
         </p:nvSpPr>
         <p:spPr>
           <a:xfrm>
-            <a:off x="8966052" y="7822946"/>
+            <a:off x="8966052" y="9413177"/>
             <a:ext cx="2153105" cy="685800"/>
           </a:xfrm>
           <a:prstGeom prst="rect">
@@ -3824,13 +3877,13 @@
       </p:sp>
       <p:sp>
         <p:nvSpPr>
-          <p:cNvPr id="32" name="Text 29"/>
+          <p:cNvPr id="33" name="Text 30"/>
           <p:cNvSpPr txBox="1"/>
           <p:nvPr/>
         </p:nvSpPr>
         <p:spPr>
           <a:xfrm>
-            <a:off x="11119157" y="7822946"/>
+            <a:off x="11119157" y="9413177"/>
             <a:ext cx="384048" cy="685800"/>
           </a:xfrm>
           <a:prstGeom prst="rect">
@@ -3863,13 +3916,13 @@
       </p:sp>
       <p:sp>
         <p:nvSpPr>
-          <p:cNvPr id="33" name="Shape 30"/>
+          <p:cNvPr id="34" name="Shape 31"/>
           <p:cNvSpPr/>
           <p:nvPr/>
         </p:nvSpPr>
         <p:spPr>
           <a:xfrm>
-            <a:off x="11503205" y="7822946"/>
+            <a:off x="11503205" y="9413177"/>
             <a:ext cx="2799037" cy="685800"/>
           </a:xfrm>
           <a:prstGeom prst="rect">
@@ -3883,13 +3936,13 @@
       </p:sp>
       <p:sp>
         <p:nvSpPr>
-          <p:cNvPr id="34" name="Text 31"/>
+          <p:cNvPr id="35" name="Text 32"/>
           <p:cNvSpPr txBox="1"/>
           <p:nvPr/>
         </p:nvSpPr>
         <p:spPr>
           <a:xfrm>
-            <a:off x="11503205" y="7822946"/>
+            <a:off x="11503205" y="9413177"/>
             <a:ext cx="2799037" cy="685800"/>
           </a:xfrm>
           <a:prstGeom prst="rect">
@@ -3978,13 +4031,13 @@
       </p:sp>
       <p:sp>
         <p:nvSpPr>
-          <p:cNvPr id="35" name="Text 32"/>
+          <p:cNvPr id="36" name="Text 33"/>
           <p:cNvSpPr txBox="1"/>
           <p:nvPr/>
         </p:nvSpPr>
         <p:spPr>
           <a:xfrm>
-            <a:off x="14302243" y="7822946"/>
+            <a:off x="14302243" y="9413177"/>
             <a:ext cx="384048" cy="685800"/>
           </a:xfrm>
           <a:prstGeom prst="rect">
@@ -4017,13 +4070,13 @@
       </p:sp>
       <p:sp>
         <p:nvSpPr>
-          <p:cNvPr id="36" name="Shape 33"/>
+          <p:cNvPr id="37" name="Shape 34"/>
           <p:cNvSpPr/>
           <p:nvPr/>
         </p:nvSpPr>
         <p:spPr>
           <a:xfrm>
-            <a:off x="14686291" y="7822946"/>
+            <a:off x="14686291" y="9413177"/>
             <a:ext cx="2153105" cy="685800"/>
           </a:xfrm>
           <a:prstGeom prst="rect">
@@ -4042,13 +4095,13 @@
       </p:sp>
       <p:sp>
         <p:nvSpPr>
-          <p:cNvPr id="37" name="Text 34"/>
+          <p:cNvPr id="38" name="Text 35"/>
           <p:cNvSpPr txBox="1"/>
           <p:nvPr/>
         </p:nvSpPr>
         <p:spPr>
           <a:xfrm>
-            <a:off x="14686291" y="7822946"/>
+            <a:off x="14686291" y="9413177"/>
             <a:ext cx="2153105" cy="685800"/>
           </a:xfrm>
           <a:prstGeom prst="rect">
@@ -4123,13 +4176,13 @@
       </p:sp>
       <p:sp>
         <p:nvSpPr>
-          <p:cNvPr id="38" name="Shape 35"/>
+          <p:cNvPr id="39" name="Shape 36"/>
           <p:cNvSpPr/>
           <p:nvPr/>
         </p:nvSpPr>
         <p:spPr>
           <a:xfrm>
-            <a:off x="10068320" y="8645906"/>
+            <a:off x="10068320" y="10236137"/>
             <a:ext cx="5668808" cy="457200"/>
           </a:xfrm>
           <a:prstGeom prst="rect">
@@ -4143,13 +4196,13 @@
       </p:sp>
       <p:sp>
         <p:nvSpPr>
-          <p:cNvPr id="39" name="Text 36"/>
+          <p:cNvPr id="40" name="Text 37"/>
           <p:cNvSpPr txBox="1"/>
           <p:nvPr/>
         </p:nvSpPr>
         <p:spPr>
           <a:xfrm>
-            <a:off x="10068320" y="8645906"/>
+            <a:off x="10068320" y="10236137"/>
             <a:ext cx="5668808" cy="457200"/>
           </a:xfrm>
           <a:prstGeom prst="rect">
@@ -4182,14 +4235,14 @@
       </p:sp>
       <p:sp>
         <p:nvSpPr>
-          <p:cNvPr id="40" name="Text 37"/>
+          <p:cNvPr id="41" name="Text 38"/>
           <p:cNvSpPr txBox="1"/>
           <p:nvPr/>
         </p:nvSpPr>
         <p:spPr>
           <a:xfrm>
-            <a:off x="8966052" y="9212834"/>
-            <a:ext cx="7873344" cy="481076"/>
+            <a:off x="8966052" y="10803065"/>
+            <a:ext cx="7873344" cy="703326"/>
           </a:xfrm>
           <a:prstGeom prst="rect">
             <a:avLst/>
@@ -4227,7 +4280,7 @@
                 <a:ea typeface="Calibri" pitchFamily="34" charset="-122"/>
                 <a:cs typeface="Calibri" pitchFamily="34" charset="-120"/>
               </a:rPr>
-              <a:t>Inference: the learned ODE transports noise to a completed 164-gene profile conditioned on the observed panel.</a:t>
+              <a:t>Sampling: the learned ODE, integrated from t = 0 to 1 ([solver, N steps]), transports noise to a completed 164-gene profile conditioned on the observed panel.</a:t>
             </a:r>
             <a:endParaRPr lang="en-US" sz="1400" dirty="0"/>
           </a:p>
@@ -4235,14 +4288,14 @@
       </p:sp>
       <p:sp>
         <p:nvSpPr>
-          <p:cNvPr id="41" name="Text 38"/>
+          <p:cNvPr id="42" name="Text 39"/>
           <p:cNvSpPr txBox="1"/>
           <p:nvPr/>
         </p:nvSpPr>
         <p:spPr>
           <a:xfrm>
-            <a:off x="8966052" y="9968230"/>
-            <a:ext cx="7873344" cy="1425639"/>
+            <a:off x="8966052" y="11780711"/>
+            <a:ext cx="7873344" cy="1703451"/>
           </a:xfrm>
           <a:prstGeom prst="rect">
             <a:avLst/>
@@ -4266,7 +4319,7 @@
                 <a:ea typeface="Calibri" pitchFamily="34" charset="-122"/>
                 <a:cs typeface="Calibri" pitchFamily="34" charset="-120"/>
               </a:rPr>
-              <a:t>3.2 Probability read-out. </a:t>
+              <a:t>3.3 Probability read-out. </a:t>
             </a:r>
             <a:pPr indent="0" marL="0">
               <a:buNone/>
@@ -4280,7 +4333,7 @@
                 <a:ea typeface="Calibri" pitchFamily="34" charset="-122"/>
                 <a:cs typeface="Calibri" pitchFamily="34" charset="-120"/>
               </a:rPr>
-              <a:t>At t = 0 the path is independent of x₁, so the optimal field satisfies v*(x₀, 0 | c) = 𝔼[x₁ | c] − x₀. Marginal alteration probabilities follow from a single evaluation, p̂ = ½(1 + x₀ + v_θ(x₀, 0 | c)), avoiding Monte Carlo ties at ~1% prevalence.</a:t>
+              <a:t>At t = 0 the path is independent of x₁, so the optimal field satisfies v*(x₀, 0 | c) = 𝔼[x₁ | c] − x₀. Per-gene probabilities p̂ = ½(1 + x₀ + vθ(x₀, 0 | c)), averaged over K noise draws, equal the infinite-sample Monte Carlo estimate without its 1/S resolution limit, which at ~1% prevalence ties most pairs at 0. [state read-out used]</a:t>
             </a:r>
             <a:endParaRPr lang="en-US" sz="1750" dirty="0"/>
           </a:p>
@@ -4288,14 +4341,14 @@
       </p:sp>
       <p:sp>
         <p:nvSpPr>
-          <p:cNvPr id="42" name="Text 39"/>
+          <p:cNvPr id="43" name="Text 40"/>
           <p:cNvSpPr txBox="1"/>
           <p:nvPr/>
         </p:nvSpPr>
         <p:spPr>
           <a:xfrm>
-            <a:off x="8966052" y="11622469"/>
-            <a:ext cx="7873344" cy="1981264"/>
+            <a:off x="8966052" y="13712762"/>
+            <a:ext cx="7873344" cy="2814701"/>
           </a:xfrm>
           <a:prstGeom prst="rect">
             <a:avLst/>
@@ -4319,7 +4372,7 @@
                 <a:ea typeface="Calibri" pitchFamily="34" charset="-122"/>
                 <a:cs typeface="Calibri" pitchFamily="34" charset="-120"/>
               </a:rPr>
-              <a:t>3.3 Statistical analysis. </a:t>
+              <a:t>3.4 Evaluation. </a:t>
             </a:r>
             <a:pPr indent="0" marL="0">
               <a:buNone/>
@@ -4333,7 +4386,7 @@
                 <a:ea typeface="Calibri" pitchFamily="34" charset="-122"/>
                 <a:cs typeface="Calibri" pitchFamily="34" charset="-120"/>
               </a:rPr>
-              <a:t>Primary endpoint: AUROC on held-out patients, pooled over gene–patient pairs. Secondary: per-gene AUROC (mean over genes with ≥10 events), for which a prevalence-only predictor scores exactly 0.50. Comparators on identical splits: prevalence only; burden + locus (log mutation/CNA counts and copy-number state of the nearest assayed gene); L2-regularised logistic regression. 95% CIs by patient-level bootstrap (200 resamples).</a:t>
+              <a:t>Discrimination: AUROC pooled over gene–patient pairs (primary) and per gene (genes with ≥5 test events), where a prevalence-only predictor scores exactly 0.50. Class imbalance: AUPRC against the prevalence of 0.012. Calibration: Brier skill score and observed:expected ratio. Joint fidelity, the property that justifies a generative model: energy score of sampled profiles versus independent Bernoulli draws from the same marginals. Comparators on identical splits: prevalence; burden + locus (3 burden counts and copy-number state of the nearest assayed gene); L2 logistic regression. 95% CIs and paired differences by patient-level bootstrap.</a:t>
             </a:r>
             <a:endParaRPr lang="en-US" sz="1750" dirty="0"/>
           </a:p>
@@ -4341,13 +4394,13 @@
       </p:sp>
       <p:sp>
         <p:nvSpPr>
-          <p:cNvPr id="43" name="Text 40"/>
+          <p:cNvPr id="44" name="Text 41"/>
           <p:cNvSpPr txBox="1"/>
           <p:nvPr/>
         </p:nvSpPr>
         <p:spPr>
           <a:xfrm>
-            <a:off x="8966052" y="13832332"/>
+            <a:off x="8966052" y="16756063"/>
             <a:ext cx="7873344" cy="870014"/>
           </a:xfrm>
           <a:prstGeom prst="rect">
@@ -4372,7 +4425,7 @@
                 <a:ea typeface="Calibri" pitchFamily="34" charset="-122"/>
                 <a:cs typeface="Calibri" pitchFamily="34" charset="-120"/>
               </a:rPr>
-              <a:t>3.4 External replicate. </a:t>
+              <a:t>3.5 External replicate. </a:t>
             </a:r>
             <a:pPr indent="0" marL="0">
               <a:buNone/>
@@ -4386,7 +4439,7 @@
                 <a:ea typeface="Calibri" pitchFamily="34" charset="-122"/>
                 <a:cs typeface="Calibri" pitchFamily="34" charset="-120"/>
               </a:rPr>
-              <a:t>MSK-IMPACT 2017 (cBioPortal, ODbL): IMPACT341 → 69 IMPACT410-only genes in 1,215 NSCLC patients, 3 × 5-fold patient-level cross-validation with fold-stratified AUROC.</a:t>
+              <a:t>MSK-IMPACT 2017 (cBioPortal, ODbL): IMPACT341 → 69 IMPACT410-only genes in 1,215 NSCLC patients; 3 × 5-fold patient-level cross-validation, AUROC computed within folds.</a:t>
             </a:r>
             <a:endParaRPr lang="en-US" sz="1750" dirty="0"/>
           </a:p>
@@ -4394,7 +4447,7 @@
       </p:sp>
       <p:sp>
         <p:nvSpPr>
-          <p:cNvPr id="44" name="Shape 41"/>
+          <p:cNvPr id="45" name="Shape 42"/>
           <p:cNvSpPr/>
           <p:nvPr/>
         </p:nvSpPr>
@@ -4417,7 +4470,7 @@
       </p:sp>
       <p:sp>
         <p:nvSpPr>
-          <p:cNvPr id="45" name="Text 42"/>
+          <p:cNvPr id="46" name="Text 43"/>
           <p:cNvSpPr txBox="1"/>
           <p:nvPr/>
         </p:nvSpPr>
@@ -4456,14 +4509,14 @@
       </p:sp>
       <p:sp>
         <p:nvSpPr>
-          <p:cNvPr id="46" name="Text 43"/>
+          <p:cNvPr id="47" name="Text 44"/>
           <p:cNvSpPr txBox="1"/>
           <p:nvPr/>
         </p:nvSpPr>
         <p:spPr>
           <a:xfrm>
             <a:off x="17360604" y="5212080"/>
-            <a:ext cx="7873344" cy="1147826"/>
+            <a:ext cx="7873344" cy="870014"/>
           </a:xfrm>
           <a:prstGeom prst="rect">
             <a:avLst/>
@@ -4501,7 +4554,7 @@
                 <a:ea typeface="Calibri" pitchFamily="34" charset="-122"/>
                 <a:cs typeface="Calibri" pitchFamily="34" charset="-120"/>
               </a:rPr>
-              <a:t>Across network architectures and training paradigms, the flow model reached a pooled AUROC of 0.77–0.79 on held-out patients, exceeding the prevalence-only baseline in all variants (Table 2).</a:t>
+              <a:t>Across architectures and training paradigms, the flow model reached a pooled test AUROC of 0.77–0.79, above the prevalence-only baseline in every variant (Table 2).</a:t>
             </a:r>
             <a:endParaRPr lang="en-US" sz="1750" dirty="0"/>
           </a:p>
@@ -4509,14 +4562,14 @@
       </p:sp>
       <p:sp>
         <p:nvSpPr>
-          <p:cNvPr id="47" name="Text 44"/>
+          <p:cNvPr id="48" name="Text 45"/>
           <p:cNvSpPr txBox="1"/>
           <p:nvPr/>
         </p:nvSpPr>
         <p:spPr>
           <a:xfrm>
-            <a:off x="17360604" y="6588506"/>
-            <a:ext cx="7873344" cy="258826"/>
+            <a:off x="17360604" y="6310694"/>
+            <a:ext cx="7873344" cy="481076"/>
           </a:xfrm>
           <a:prstGeom prst="rect">
             <a:avLst/>
@@ -4554,7 +4607,7 @@
                 <a:ea typeface="Calibri" pitchFamily="34" charset="-122"/>
                 <a:cs typeface="Calibri" pitchFamily="34" charset="-120"/>
               </a:rPr>
-              <a:t>Discrimination on the MSK-CHORD test set. AUROC (95% CI).</a:t>
+              <a:t>MSK-CHORD test set: AUROC pooled and per gene, and AUPRC (chance level = prevalence, 0.012); point estimate (95% CI).</a:t>
             </a:r>
             <a:endParaRPr lang="en-US" sz="1400" dirty="0"/>
           </a:p>
@@ -4575,7 +4628,7 @@
           </p:nvPr>
         </p:nvGraphicFramePr>
         <p:xfrm>
-          <a:off x="17360604" y="6957060"/>
+          <a:off x="17360604" y="6901498"/>
           <a:ext cx="7873344" cy="914400"/>
         </p:xfrm>
         <a:graphic>
@@ -4583,9 +4636,10 @@
             <a:tbl>
               <a:tblPr/>
               <a:tblGrid>
-                <a:gridCol w="3936672"/>
-                <a:gridCol w="1968336"/>
-                <a:gridCol w="1968336"/>
+                <a:gridCol w="3149338"/>
+                <a:gridCol w="1574669"/>
+                <a:gridCol w="1732136"/>
+                <a:gridCol w="1417202"/>
               </a:tblGrid>
               <a:tr h="420624">
                 <a:tc>
@@ -4597,7 +4651,7 @@
                         <a:buNone/>
                       </a:pPr>
                       <a:r>
-                        <a:rPr lang="en-US" sz="1600" b="1" dirty="0">
+                        <a:rPr lang="en-US" sz="1500" b="1" dirty="0">
                           <a:solidFill>
                             <a:srgbClr val="12202E"/>
                           </a:solidFill>
@@ -4607,7 +4661,7 @@
                         </a:rPr>
                         <a:t>Model</a:t>
                       </a:r>
-                      <a:endParaRPr lang="en-US" sz="1600" dirty="0">
+                      <a:endParaRPr lang="en-US" sz="1500" dirty="0">
                         <a:latin typeface="Calibri" charset="0"/>
                         <a:ea typeface="Calibri" charset="0"/>
                         <a:cs typeface="Calibri" charset="0"/>
@@ -4662,7 +4716,7 @@
                         <a:buNone/>
                       </a:pPr>
                       <a:r>
-                        <a:rPr lang="en-US" sz="1600" b="1" dirty="0">
+                        <a:rPr lang="en-US" sz="1500" b="1" dirty="0">
                           <a:solidFill>
                             <a:srgbClr val="12202E"/>
                           </a:solidFill>
@@ -4672,7 +4726,7 @@
                         </a:rPr>
                         <a:t>Pooled</a:t>
                       </a:r>
-                      <a:endParaRPr lang="en-US" sz="1600" dirty="0">
+                      <a:endParaRPr lang="en-US" sz="1500" dirty="0">
                         <a:latin typeface="Calibri" charset="0"/>
                         <a:ea typeface="Calibri" charset="0"/>
                         <a:cs typeface="Calibri" charset="0"/>
@@ -4727,7 +4781,7 @@
                         <a:buNone/>
                       </a:pPr>
                       <a:r>
-                        <a:rPr lang="en-US" sz="1600" b="1" dirty="0">
+                        <a:rPr lang="en-US" sz="1500" b="1" dirty="0">
                           <a:solidFill>
                             <a:srgbClr val="12202E"/>
                           </a:solidFill>
@@ -4737,7 +4791,72 @@
                         </a:rPr>
                         <a:t>Per gene</a:t>
                       </a:r>
-                      <a:endParaRPr lang="en-US" sz="1600" dirty="0">
+                      <a:endParaRPr lang="en-US" sz="1500" dirty="0">
+                        <a:latin typeface="Calibri" charset="0"/>
+                        <a:ea typeface="Calibri" charset="0"/>
+                        <a:cs typeface="Calibri" charset="0"/>
+                      </a:endParaRPr>
+                    </a:p>
+                  </a:txBody>
+                  <a:tcPr marL="0" marR="0" marT="45720" marB="45720">
+                    <a:lnL w="9525" cap="flat" cmpd="sng" algn="ctr">
+                      <a:solidFill>
+                        <a:srgbClr val="C9D0D7"/>
+                      </a:solidFill>
+                      <a:prstDash val="solid"/>
+                      <a:round/>
+                      <a:headEnd type="none" w="med" len="med"/>
+                      <a:tailEnd type="none" w="med" len="med"/>
+                    </a:lnL>
+                    <a:lnR w="9525" cap="flat" cmpd="sng" algn="ctr">
+                      <a:solidFill>
+                        <a:srgbClr val="C9D0D7"/>
+                      </a:solidFill>
+                      <a:prstDash val="solid"/>
+                      <a:round/>
+                      <a:headEnd type="none" w="med" len="med"/>
+                      <a:tailEnd type="none" w="med" len="med"/>
+                    </a:lnR>
+                    <a:lnT w="9525" cap="flat" cmpd="sng" algn="ctr">
+                      <a:solidFill>
+                        <a:srgbClr val="C9D0D7"/>
+                      </a:solidFill>
+                      <a:prstDash val="solid"/>
+                      <a:round/>
+                      <a:headEnd type="none" w="med" len="med"/>
+                      <a:tailEnd type="none" w="med" len="med"/>
+                    </a:lnT>
+                    <a:lnB w="9525" cap="flat" cmpd="sng" algn="ctr">
+                      <a:solidFill>
+                        <a:srgbClr val="C9D0D7"/>
+                      </a:solidFill>
+                      <a:prstDash val="solid"/>
+                      <a:round/>
+                      <a:headEnd type="none" w="med" len="med"/>
+                      <a:tailEnd type="none" w="med" len="med"/>
+                    </a:lnB>
+                  </a:tcPr>
+                </a:tc>
+                <a:tc>
+                  <a:txBody>
+                    <a:bodyPr/>
+                    <a:lstStyle/>
+                    <a:p>
+                      <a:pPr algn="r" indent="0" marL="0">
+                        <a:buNone/>
+                      </a:pPr>
+                      <a:r>
+                        <a:rPr lang="en-US" sz="1500" b="1" dirty="0">
+                          <a:solidFill>
+                            <a:srgbClr val="12202E"/>
+                          </a:solidFill>
+                          <a:latin typeface="Calibri" pitchFamily="34" charset="0"/>
+                          <a:ea typeface="Calibri" pitchFamily="34" charset="-122"/>
+                          <a:cs typeface="Calibri" pitchFamily="34" charset="-120"/>
+                        </a:rPr>
+                        <a:t>AUPRC</a:t>
+                      </a:r>
+                      <a:endParaRPr lang="en-US" sz="1500" dirty="0">
                         <a:latin typeface="Calibri" charset="0"/>
                         <a:ea typeface="Calibri" charset="0"/>
                         <a:cs typeface="Calibri" charset="0"/>
@@ -4794,7 +4913,7 @@
                         <a:buNone/>
                       </a:pPr>
                       <a:r>
-                        <a:rPr lang="en-US" sz="1600" dirty="0">
+                        <a:rPr lang="en-US" sz="1500" dirty="0">
                           <a:solidFill>
                             <a:srgbClr val="12202E"/>
                           </a:solidFill>
@@ -4804,7 +4923,7 @@
                         </a:rPr>
                         <a:t>Prevalence only</a:t>
                       </a:r>
-                      <a:endParaRPr lang="en-US" sz="1600" dirty="0">
+                      <a:endParaRPr lang="en-US" sz="1500" dirty="0">
                         <a:latin typeface="Calibri" charset="0"/>
                         <a:ea typeface="Calibri" charset="0"/>
                         <a:cs typeface="Calibri" charset="0"/>
@@ -4859,7 +4978,7 @@
                         <a:buNone/>
                       </a:pPr>
                       <a:r>
-                        <a:rPr lang="en-US" sz="1600" dirty="0">
+                        <a:rPr lang="en-US" sz="1500" dirty="0">
                           <a:solidFill>
                             <a:srgbClr val="A3410F"/>
                           </a:solidFill>
@@ -4869,7 +4988,7 @@
                         </a:rPr>
                         <a:t>[ ]</a:t>
                       </a:r>
-                      <a:endParaRPr lang="en-US" sz="1600" dirty="0">
+                      <a:endParaRPr lang="en-US" sz="1500" dirty="0">
                         <a:latin typeface="Calibri" charset="0"/>
                         <a:ea typeface="Calibri" charset="0"/>
                         <a:cs typeface="Calibri" charset="0"/>
@@ -4924,7 +5043,7 @@
                         <a:buNone/>
                       </a:pPr>
                       <a:r>
-                        <a:rPr lang="en-US" sz="1600" dirty="0">
+                        <a:rPr lang="en-US" sz="1500" dirty="0">
                           <a:solidFill>
                             <a:srgbClr val="12202E"/>
                           </a:solidFill>
@@ -4934,7 +5053,72 @@
                         </a:rPr>
                         <a:t>0.50</a:t>
                       </a:r>
-                      <a:endParaRPr lang="en-US" sz="1600" dirty="0">
+                      <a:endParaRPr lang="en-US" sz="1500" dirty="0">
+                        <a:latin typeface="Calibri" charset="0"/>
+                        <a:ea typeface="Calibri" charset="0"/>
+                        <a:cs typeface="Calibri" charset="0"/>
+                      </a:endParaRPr>
+                    </a:p>
+                  </a:txBody>
+                  <a:tcPr marL="0" marR="0" marT="45720" marB="45720">
+                    <a:lnL w="9525" cap="flat" cmpd="sng" algn="ctr">
+                      <a:solidFill>
+                        <a:srgbClr val="C9D0D7"/>
+                      </a:solidFill>
+                      <a:prstDash val="solid"/>
+                      <a:round/>
+                      <a:headEnd type="none" w="med" len="med"/>
+                      <a:tailEnd type="none" w="med" len="med"/>
+                    </a:lnL>
+                    <a:lnR w="9525" cap="flat" cmpd="sng" algn="ctr">
+                      <a:solidFill>
+                        <a:srgbClr val="C9D0D7"/>
+                      </a:solidFill>
+                      <a:prstDash val="solid"/>
+                      <a:round/>
+                      <a:headEnd type="none" w="med" len="med"/>
+                      <a:tailEnd type="none" w="med" len="med"/>
+                    </a:lnR>
+                    <a:lnT w="9525" cap="flat" cmpd="sng" algn="ctr">
+                      <a:solidFill>
+                        <a:srgbClr val="C9D0D7"/>
+                      </a:solidFill>
+                      <a:prstDash val="solid"/>
+                      <a:round/>
+                      <a:headEnd type="none" w="med" len="med"/>
+                      <a:tailEnd type="none" w="med" len="med"/>
+                    </a:lnT>
+                    <a:lnB w="9525" cap="flat" cmpd="sng" algn="ctr">
+                      <a:solidFill>
+                        <a:srgbClr val="C9D0D7"/>
+                      </a:solidFill>
+                      <a:prstDash val="solid"/>
+                      <a:round/>
+                      <a:headEnd type="none" w="med" len="med"/>
+                      <a:tailEnd type="none" w="med" len="med"/>
+                    </a:lnB>
+                  </a:tcPr>
+                </a:tc>
+                <a:tc>
+                  <a:txBody>
+                    <a:bodyPr/>
+                    <a:lstStyle/>
+                    <a:p>
+                      <a:pPr algn="r" indent="0" marL="0">
+                        <a:buNone/>
+                      </a:pPr>
+                      <a:r>
+                        <a:rPr lang="en-US" sz="1500" dirty="0">
+                          <a:solidFill>
+                            <a:srgbClr val="A3410F"/>
+                          </a:solidFill>
+                          <a:latin typeface="Calibri" pitchFamily="34" charset="0"/>
+                          <a:ea typeface="Calibri" pitchFamily="34" charset="-122"/>
+                          <a:cs typeface="Calibri" pitchFamily="34" charset="-120"/>
+                        </a:rPr>
+                        <a:t>[ ]</a:t>
+                      </a:r>
+                      <a:endParaRPr lang="en-US" sz="1500" dirty="0">
                         <a:latin typeface="Calibri" charset="0"/>
                         <a:ea typeface="Calibri" charset="0"/>
                         <a:cs typeface="Calibri" charset="0"/>
@@ -4991,7 +5175,7 @@
                         <a:buNone/>
                       </a:pPr>
                       <a:r>
-                        <a:rPr lang="en-US" sz="1600" dirty="0">
+                        <a:rPr lang="en-US" sz="1500" dirty="0">
                           <a:solidFill>
                             <a:srgbClr val="12202E"/>
                           </a:solidFill>
@@ -5001,7 +5185,7 @@
                         </a:rPr>
                         <a:t>Burden + locus</a:t>
                       </a:r>
-                      <a:endParaRPr lang="en-US" sz="1600" dirty="0">
+                      <a:endParaRPr lang="en-US" sz="1500" dirty="0">
                         <a:latin typeface="Calibri" charset="0"/>
                         <a:ea typeface="Calibri" charset="0"/>
                         <a:cs typeface="Calibri" charset="0"/>
@@ -5056,7 +5240,7 @@
                         <a:buNone/>
                       </a:pPr>
                       <a:r>
-                        <a:rPr lang="en-US" sz="1600" dirty="0">
+                        <a:rPr lang="en-US" sz="1500" dirty="0">
                           <a:solidFill>
                             <a:srgbClr val="A3410F"/>
                           </a:solidFill>
@@ -5066,7 +5250,7 @@
                         </a:rPr>
                         <a:t>[ ]</a:t>
                       </a:r>
-                      <a:endParaRPr lang="en-US" sz="1600" dirty="0">
+                      <a:endParaRPr lang="en-US" sz="1500" dirty="0">
                         <a:latin typeface="Calibri" charset="0"/>
                         <a:ea typeface="Calibri" charset="0"/>
                         <a:cs typeface="Calibri" charset="0"/>
@@ -5121,7 +5305,7 @@
                         <a:buNone/>
                       </a:pPr>
                       <a:r>
-                        <a:rPr lang="en-US" sz="1600" dirty="0">
+                        <a:rPr lang="en-US" sz="1500" dirty="0">
                           <a:solidFill>
                             <a:srgbClr val="A3410F"/>
                           </a:solidFill>
@@ -5131,7 +5315,72 @@
                         </a:rPr>
                         <a:t>[ ]</a:t>
                       </a:r>
-                      <a:endParaRPr lang="en-US" sz="1600" dirty="0">
+                      <a:endParaRPr lang="en-US" sz="1500" dirty="0">
+                        <a:latin typeface="Calibri" charset="0"/>
+                        <a:ea typeface="Calibri" charset="0"/>
+                        <a:cs typeface="Calibri" charset="0"/>
+                      </a:endParaRPr>
+                    </a:p>
+                  </a:txBody>
+                  <a:tcPr marL="0" marR="0" marT="45720" marB="45720">
+                    <a:lnL w="9525" cap="flat" cmpd="sng" algn="ctr">
+                      <a:solidFill>
+                        <a:srgbClr val="C9D0D7"/>
+                      </a:solidFill>
+                      <a:prstDash val="solid"/>
+                      <a:round/>
+                      <a:headEnd type="none" w="med" len="med"/>
+                      <a:tailEnd type="none" w="med" len="med"/>
+                    </a:lnL>
+                    <a:lnR w="9525" cap="flat" cmpd="sng" algn="ctr">
+                      <a:solidFill>
+                        <a:srgbClr val="C9D0D7"/>
+                      </a:solidFill>
+                      <a:prstDash val="solid"/>
+                      <a:round/>
+                      <a:headEnd type="none" w="med" len="med"/>
+                      <a:tailEnd type="none" w="med" len="med"/>
+                    </a:lnR>
+                    <a:lnT w="9525" cap="flat" cmpd="sng" algn="ctr">
+                      <a:solidFill>
+                        <a:srgbClr val="C9D0D7"/>
+                      </a:solidFill>
+                      <a:prstDash val="solid"/>
+                      <a:round/>
+                      <a:headEnd type="none" w="med" len="med"/>
+                      <a:tailEnd type="none" w="med" len="med"/>
+                    </a:lnT>
+                    <a:lnB w="9525" cap="flat" cmpd="sng" algn="ctr">
+                      <a:solidFill>
+                        <a:srgbClr val="C9D0D7"/>
+                      </a:solidFill>
+                      <a:prstDash val="solid"/>
+                      <a:round/>
+                      <a:headEnd type="none" w="med" len="med"/>
+                      <a:tailEnd type="none" w="med" len="med"/>
+                    </a:lnB>
+                  </a:tcPr>
+                </a:tc>
+                <a:tc>
+                  <a:txBody>
+                    <a:bodyPr/>
+                    <a:lstStyle/>
+                    <a:p>
+                      <a:pPr algn="r" indent="0" marL="0">
+                        <a:buNone/>
+                      </a:pPr>
+                      <a:r>
+                        <a:rPr lang="en-US" sz="1500" dirty="0">
+                          <a:solidFill>
+                            <a:srgbClr val="A3410F"/>
+                          </a:solidFill>
+                          <a:latin typeface="Calibri" pitchFamily="34" charset="0"/>
+                          <a:ea typeface="Calibri" pitchFamily="34" charset="-122"/>
+                          <a:cs typeface="Calibri" pitchFamily="34" charset="-120"/>
+                        </a:rPr>
+                        <a:t>[ ]</a:t>
+                      </a:r>
+                      <a:endParaRPr lang="en-US" sz="1500" dirty="0">
                         <a:latin typeface="Calibri" charset="0"/>
                         <a:ea typeface="Calibri" charset="0"/>
                         <a:cs typeface="Calibri" charset="0"/>
@@ -5188,7 +5437,7 @@
                         <a:buNone/>
                       </a:pPr>
                       <a:r>
-                        <a:rPr lang="en-US" sz="1600" dirty="0">
+                        <a:rPr lang="en-US" sz="1500" dirty="0">
                           <a:solidFill>
                             <a:srgbClr val="12202E"/>
                           </a:solidFill>
@@ -5198,7 +5447,7 @@
                         </a:rPr>
                         <a:t>L2 logistic regression</a:t>
                       </a:r>
-                      <a:endParaRPr lang="en-US" sz="1600" dirty="0">
+                      <a:endParaRPr lang="en-US" sz="1500" dirty="0">
                         <a:latin typeface="Calibri" charset="0"/>
                         <a:ea typeface="Calibri" charset="0"/>
                         <a:cs typeface="Calibri" charset="0"/>
@@ -5253,7 +5502,7 @@
                         <a:buNone/>
                       </a:pPr>
                       <a:r>
-                        <a:rPr lang="en-US" sz="1600" dirty="0">
+                        <a:rPr lang="en-US" sz="1500" dirty="0">
                           <a:solidFill>
                             <a:srgbClr val="A3410F"/>
                           </a:solidFill>
@@ -5263,7 +5512,7 @@
                         </a:rPr>
                         <a:t>[ ]</a:t>
                       </a:r>
-                      <a:endParaRPr lang="en-US" sz="1600" dirty="0">
+                      <a:endParaRPr lang="en-US" sz="1500" dirty="0">
                         <a:latin typeface="Calibri" charset="0"/>
                         <a:ea typeface="Calibri" charset="0"/>
                         <a:cs typeface="Calibri" charset="0"/>
@@ -5318,7 +5567,7 @@
                         <a:buNone/>
                       </a:pPr>
                       <a:r>
-                        <a:rPr lang="en-US" sz="1600" dirty="0">
+                        <a:rPr lang="en-US" sz="1500" dirty="0">
                           <a:solidFill>
                             <a:srgbClr val="A3410F"/>
                           </a:solidFill>
@@ -5328,7 +5577,72 @@
                         </a:rPr>
                         <a:t>[ ]</a:t>
                       </a:r>
-                      <a:endParaRPr lang="en-US" sz="1600" dirty="0">
+                      <a:endParaRPr lang="en-US" sz="1500" dirty="0">
+                        <a:latin typeface="Calibri" charset="0"/>
+                        <a:ea typeface="Calibri" charset="0"/>
+                        <a:cs typeface="Calibri" charset="0"/>
+                      </a:endParaRPr>
+                    </a:p>
+                  </a:txBody>
+                  <a:tcPr marL="0" marR="0" marT="45720" marB="45720">
+                    <a:lnL w="9525" cap="flat" cmpd="sng" algn="ctr">
+                      <a:solidFill>
+                        <a:srgbClr val="C9D0D7"/>
+                      </a:solidFill>
+                      <a:prstDash val="solid"/>
+                      <a:round/>
+                      <a:headEnd type="none" w="med" len="med"/>
+                      <a:tailEnd type="none" w="med" len="med"/>
+                    </a:lnL>
+                    <a:lnR w="9525" cap="flat" cmpd="sng" algn="ctr">
+                      <a:solidFill>
+                        <a:srgbClr val="C9D0D7"/>
+                      </a:solidFill>
+                      <a:prstDash val="solid"/>
+                      <a:round/>
+                      <a:headEnd type="none" w="med" len="med"/>
+                      <a:tailEnd type="none" w="med" len="med"/>
+                    </a:lnR>
+                    <a:lnT w="9525" cap="flat" cmpd="sng" algn="ctr">
+                      <a:solidFill>
+                        <a:srgbClr val="C9D0D7"/>
+                      </a:solidFill>
+                      <a:prstDash val="solid"/>
+                      <a:round/>
+                      <a:headEnd type="none" w="med" len="med"/>
+                      <a:tailEnd type="none" w="med" len="med"/>
+                    </a:lnT>
+                    <a:lnB w="9525" cap="flat" cmpd="sng" algn="ctr">
+                      <a:solidFill>
+                        <a:srgbClr val="C9D0D7"/>
+                      </a:solidFill>
+                      <a:prstDash val="solid"/>
+                      <a:round/>
+                      <a:headEnd type="none" w="med" len="med"/>
+                      <a:tailEnd type="none" w="med" len="med"/>
+                    </a:lnB>
+                  </a:tcPr>
+                </a:tc>
+                <a:tc>
+                  <a:txBody>
+                    <a:bodyPr/>
+                    <a:lstStyle/>
+                    <a:p>
+                      <a:pPr algn="r" indent="0" marL="0">
+                        <a:buNone/>
+                      </a:pPr>
+                      <a:r>
+                        <a:rPr lang="en-US" sz="1500" dirty="0">
+                          <a:solidFill>
+                            <a:srgbClr val="A3410F"/>
+                          </a:solidFill>
+                          <a:latin typeface="Calibri" pitchFamily="34" charset="0"/>
+                          <a:ea typeface="Calibri" pitchFamily="34" charset="-122"/>
+                          <a:cs typeface="Calibri" pitchFamily="34" charset="-120"/>
+                        </a:rPr>
+                        <a:t>[ ]</a:t>
+                      </a:r>
+                      <a:endParaRPr lang="en-US" sz="1500" dirty="0">
                         <a:latin typeface="Calibri" charset="0"/>
                         <a:ea typeface="Calibri" charset="0"/>
                         <a:cs typeface="Calibri" charset="0"/>
@@ -5385,7 +5699,7 @@
                         <a:buNone/>
                       </a:pPr>
                       <a:r>
-                        <a:rPr lang="en-US" sz="1600" b="1" dirty="0">
+                        <a:rPr lang="en-US" sz="1500" b="1" dirty="0">
                           <a:solidFill>
                             <a:srgbClr val="12202E"/>
                           </a:solidFill>
@@ -5395,7 +5709,7 @@
                         </a:rPr>
                         <a:t>Flow matching</a:t>
                       </a:r>
-                      <a:endParaRPr lang="en-US" sz="1600" dirty="0">
+                      <a:endParaRPr lang="en-US" sz="1500" dirty="0">
                         <a:latin typeface="Calibri" charset="0"/>
                         <a:ea typeface="Calibri" charset="0"/>
                         <a:cs typeface="Calibri" charset="0"/>
@@ -5450,7 +5764,7 @@
                         <a:buNone/>
                       </a:pPr>
                       <a:r>
-                        <a:rPr lang="en-US" sz="1600" b="1" dirty="0">
+                        <a:rPr lang="en-US" sz="1500" b="1" dirty="0">
                           <a:solidFill>
                             <a:srgbClr val="12202E"/>
                           </a:solidFill>
@@ -5460,7 +5774,7 @@
                         </a:rPr>
                         <a:t>0.77–0.79</a:t>
                       </a:r>
-                      <a:endParaRPr lang="en-US" sz="1600" dirty="0">
+                      <a:endParaRPr lang="en-US" sz="1500" dirty="0">
                         <a:latin typeface="Calibri" charset="0"/>
                         <a:ea typeface="Calibri" charset="0"/>
                         <a:cs typeface="Calibri" charset="0"/>
@@ -5515,7 +5829,7 @@
                         <a:buNone/>
                       </a:pPr>
                       <a:r>
-                        <a:rPr lang="en-US" sz="1600" b="1" dirty="0">
+                        <a:rPr lang="en-US" sz="1500" b="1" dirty="0">
                           <a:solidFill>
                             <a:srgbClr val="A3410F"/>
                           </a:solidFill>
@@ -5525,7 +5839,7 @@
                         </a:rPr>
                         <a:t>[ ]</a:t>
                       </a:r>
-                      <a:endParaRPr lang="en-US" sz="1600" dirty="0">
+                      <a:endParaRPr lang="en-US" sz="1500" dirty="0">
                         <a:latin typeface="Calibri" charset="0"/>
                         <a:ea typeface="Calibri" charset="0"/>
                         <a:cs typeface="Calibri" charset="0"/>
@@ -5571,6 +5885,71 @@
                     </a:lnB>
                   </a:tcPr>
                 </a:tc>
+                <a:tc>
+                  <a:txBody>
+                    <a:bodyPr/>
+                    <a:lstStyle/>
+                    <a:p>
+                      <a:pPr algn="r" indent="0" marL="0">
+                        <a:buNone/>
+                      </a:pPr>
+                      <a:r>
+                        <a:rPr lang="en-US" sz="1500" b="1" dirty="0">
+                          <a:solidFill>
+                            <a:srgbClr val="A3410F"/>
+                          </a:solidFill>
+                          <a:latin typeface="Calibri" pitchFamily="34" charset="0"/>
+                          <a:ea typeface="Calibri" pitchFamily="34" charset="-122"/>
+                          <a:cs typeface="Calibri" pitchFamily="34" charset="-120"/>
+                        </a:rPr>
+                        <a:t>[ ]</a:t>
+                      </a:r>
+                      <a:endParaRPr lang="en-US" sz="1500" dirty="0">
+                        <a:latin typeface="Calibri" charset="0"/>
+                        <a:ea typeface="Calibri" charset="0"/>
+                        <a:cs typeface="Calibri" charset="0"/>
+                      </a:endParaRPr>
+                    </a:p>
+                  </a:txBody>
+                  <a:tcPr marL="0" marR="0" marT="45720" marB="45720">
+                    <a:lnL w="9525" cap="flat" cmpd="sng" algn="ctr">
+                      <a:solidFill>
+                        <a:srgbClr val="C9D0D7"/>
+                      </a:solidFill>
+                      <a:prstDash val="solid"/>
+                      <a:round/>
+                      <a:headEnd type="none" w="med" len="med"/>
+                      <a:tailEnd type="none" w="med" len="med"/>
+                    </a:lnL>
+                    <a:lnR w="9525" cap="flat" cmpd="sng" algn="ctr">
+                      <a:solidFill>
+                        <a:srgbClr val="C9D0D7"/>
+                      </a:solidFill>
+                      <a:prstDash val="solid"/>
+                      <a:round/>
+                      <a:headEnd type="none" w="med" len="med"/>
+                      <a:tailEnd type="none" w="med" len="med"/>
+                    </a:lnR>
+                    <a:lnT w="9525" cap="flat" cmpd="sng" algn="ctr">
+                      <a:solidFill>
+                        <a:srgbClr val="C9D0D7"/>
+                      </a:solidFill>
+                      <a:prstDash val="solid"/>
+                      <a:round/>
+                      <a:headEnd type="none" w="med" len="med"/>
+                      <a:tailEnd type="none" w="med" len="med"/>
+                    </a:lnT>
+                    <a:lnB w="9525" cap="flat" cmpd="sng" algn="ctr">
+                      <a:solidFill>
+                        <a:srgbClr val="C9D0D7"/>
+                      </a:solidFill>
+                      <a:prstDash val="solid"/>
+                      <a:round/>
+                      <a:headEnd type="none" w="med" len="med"/>
+                      <a:tailEnd type="none" w="med" len="med"/>
+                    </a:lnB>
+                  </a:tcPr>
+                </a:tc>
               </a:tr>
             </a:tbl>
           </a:graphicData>
@@ -5578,13 +5957,13 @@
       </p:graphicFrame>
       <p:sp>
         <p:nvSpPr>
-          <p:cNvPr id="49" name="Shape 45"/>
+          <p:cNvPr id="50" name="Shape 46"/>
           <p:cNvSpPr/>
           <p:nvPr/>
         </p:nvSpPr>
         <p:spPr>
           <a:xfrm>
-            <a:off x="17360604" y="6957060"/>
+            <a:off x="17360604" y="6901498"/>
             <a:ext cx="7873344" cy="0"/>
           </a:xfrm>
           <a:prstGeom prst="line">
@@ -5601,13 +5980,13 @@
       </p:sp>
       <p:sp>
         <p:nvSpPr>
-          <p:cNvPr id="50" name="Shape 46"/>
+          <p:cNvPr id="51" name="Shape 47"/>
           <p:cNvSpPr/>
           <p:nvPr/>
         </p:nvSpPr>
         <p:spPr>
           <a:xfrm>
-            <a:off x="17360604" y="7377684"/>
+            <a:off x="17360604" y="7322122"/>
             <a:ext cx="7873344" cy="0"/>
           </a:xfrm>
           <a:prstGeom prst="line">
@@ -5624,13 +6003,13 @@
       </p:sp>
       <p:sp>
         <p:nvSpPr>
-          <p:cNvPr id="51" name="Shape 47"/>
+          <p:cNvPr id="52" name="Shape 48"/>
           <p:cNvSpPr/>
           <p:nvPr/>
         </p:nvSpPr>
         <p:spPr>
           <a:xfrm>
-            <a:off x="17360604" y="9060180"/>
+            <a:off x="17360604" y="9004618"/>
             <a:ext cx="7873344" cy="0"/>
           </a:xfrm>
           <a:prstGeom prst="line">
@@ -5647,14 +6026,14 @@
       </p:sp>
       <p:sp>
         <p:nvSpPr>
-          <p:cNvPr id="52" name="Text 48"/>
+          <p:cNvPr id="53" name="Text 49"/>
           <p:cNvSpPr txBox="1"/>
           <p:nvPr/>
         </p:nvSpPr>
         <p:spPr>
           <a:xfrm>
-            <a:off x="17360604" y="9380220"/>
-            <a:ext cx="7873344" cy="870014"/>
+            <a:off x="17360604" y="9233218"/>
+            <a:ext cx="7873344" cy="592201"/>
           </a:xfrm>
           <a:prstGeom prst="rect">
             <a:avLst/>
@@ -5678,6 +6057,115 @@
                 <a:ea typeface="Calibri" pitchFamily="34" charset="-122"/>
                 <a:cs typeface="Calibri" pitchFamily="34" charset="-120"/>
               </a:rPr>
+              <a:t>Calibration and joint fidelity: </a:t>
+            </a:r>
+            <a:pPr indent="0" marL="0">
+              <a:buNone/>
+            </a:pPr>
+            <a:r>
+              <a:rPr lang="en-US" sz="1750" dirty="0">
+                <a:solidFill>
+                  <a:srgbClr val="12202E"/>
+                </a:solidFill>
+                <a:latin typeface="Calibri" pitchFamily="34" charset="0"/>
+                <a:ea typeface="Calibri" pitchFamily="34" charset="-122"/>
+                <a:cs typeface="Calibri" pitchFamily="34" charset="-120"/>
+              </a:rPr>
+              <a:t>Brier skill </a:t>
+            </a:r>
+            <a:pPr indent="0" marL="0">
+              <a:buNone/>
+            </a:pPr>
+            <a:r>
+              <a:rPr lang="en-US" sz="1750" dirty="0">
+                <a:solidFill>
+                  <a:srgbClr val="A3410F"/>
+                </a:solidFill>
+                <a:latin typeface="Calibri" pitchFamily="34" charset="0"/>
+                <a:ea typeface="Calibri" pitchFamily="34" charset="-122"/>
+                <a:cs typeface="Calibri" pitchFamily="34" charset="-120"/>
+              </a:rPr>
+              <a:t>[ ]</a:t>
+            </a:r>
+            <a:pPr indent="0" marL="0">
+              <a:buNone/>
+            </a:pPr>
+            <a:r>
+              <a:rPr lang="en-US" sz="1750" dirty="0">
+                <a:solidFill>
+                  <a:srgbClr val="12202E"/>
+                </a:solidFill>
+                <a:latin typeface="Calibri" pitchFamily="34" charset="0"/>
+                <a:ea typeface="Calibri" pitchFamily="34" charset="-122"/>
+                <a:cs typeface="Calibri" pitchFamily="34" charset="-120"/>
+              </a:rPr>
+              <a:t>; energy score, flow samples vs independent draws </a:t>
+            </a:r>
+            <a:pPr indent="0" marL="0">
+              <a:buNone/>
+            </a:pPr>
+            <a:r>
+              <a:rPr lang="en-US" sz="1750" dirty="0">
+                <a:solidFill>
+                  <a:srgbClr val="A3410F"/>
+                </a:solidFill>
+                <a:latin typeface="Calibri" pitchFamily="34" charset="0"/>
+                <a:ea typeface="Calibri" pitchFamily="34" charset="-122"/>
+                <a:cs typeface="Calibri" pitchFamily="34" charset="-120"/>
+              </a:rPr>
+              <a:t>[ ] vs [ ]</a:t>
+            </a:r>
+            <a:pPr indent="0" marL="0">
+              <a:buNone/>
+            </a:pPr>
+            <a:r>
+              <a:rPr lang="en-US" sz="1750" dirty="0">
+                <a:solidFill>
+                  <a:srgbClr val="12202E"/>
+                </a:solidFill>
+                <a:latin typeface="Calibri" pitchFamily="34" charset="0"/>
+                <a:ea typeface="Calibri" pitchFamily="34" charset="-122"/>
+                <a:cs typeface="Calibri" pitchFamily="34" charset="-120"/>
+              </a:rPr>
+              <a:t>.</a:t>
+            </a:r>
+            <a:endParaRPr lang="en-US" sz="1750" dirty="0"/>
+          </a:p>
+        </p:txBody>
+      </p:sp>
+      <p:sp>
+        <p:nvSpPr>
+          <p:cNvPr id="54" name="Text 50"/>
+          <p:cNvSpPr txBox="1"/>
+          <p:nvPr/>
+        </p:nvSpPr>
+        <p:spPr>
+          <a:xfrm>
+            <a:off x="17360604" y="10099739"/>
+            <a:ext cx="7873344" cy="1425639"/>
+          </a:xfrm>
+          <a:prstGeom prst="rect">
+            <a:avLst/>
+          </a:prstGeom>
+          <a:noFill/>
+          <a:ln/>
+        </p:spPr>
+        <p:txBody>
+          <a:bodyPr wrap="square" lIns="0" tIns="0" rIns="0" bIns="0" rtlCol="0" anchor="t"/>
+          <a:lstStyle/>
+          <a:p>
+            <a:pPr indent="0" marL="0">
+              <a:buNone/>
+            </a:pPr>
+            <a:r>
+              <a:rPr lang="en-US" sz="1750" b="1" dirty="0">
+                <a:solidFill>
+                  <a:srgbClr val="12202E"/>
+                </a:solidFill>
+                <a:latin typeface="Calibri" pitchFamily="34" charset="0"/>
+                <a:ea typeface="Calibri" pitchFamily="34" charset="-122"/>
+                <a:cs typeface="Calibri" pitchFamily="34" charset="-120"/>
+              </a:rPr>
               <a:t>4.2 Benchmark on public data. </a:t>
             </a:r>
             <a:pPr indent="0" marL="0">
@@ -5692,7 +6180,7 @@
                 <a:ea typeface="Calibri" pitchFamily="34" charset="-122"/>
                 <a:cs typeface="Calibri" pitchFamily="34" charset="-120"/>
               </a:rPr>
-              <a:t>In the replicate, gene frequency alone yields a pooled AUROC of 0.715; per-gene AUROC isolates patient-specific information (Figure 3).</a:t>
+              <a:t>Pooled AUROC compares pairs across genes, so ranking genes by training frequency alone scores 0.715. Per gene, a 7-feature model matches 1,026-feature logistic regression (0.760 vs 0.728), and pan-cancer training adds +0.039 (95% CI 0.024–0.057; Figure 3).</a:t>
             </a:r>
             <a:endParaRPr lang="en-US" sz="1750" dirty="0"/>
           </a:p>
@@ -5700,13 +6188,13 @@
       </p:sp>
       <p:sp>
         <p:nvSpPr>
-          <p:cNvPr id="53" name="Shape 49"/>
+          <p:cNvPr id="55" name="Shape 51"/>
           <p:cNvSpPr/>
           <p:nvPr/>
         </p:nvSpPr>
         <p:spPr>
           <a:xfrm>
-            <a:off x="17360604" y="10533698"/>
+            <a:off x="17360604" y="11808841"/>
             <a:ext cx="146304" cy="146304"/>
           </a:xfrm>
           <a:prstGeom prst="ellipse">
@@ -5720,13 +6208,13 @@
       </p:sp>
       <p:sp>
         <p:nvSpPr>
-          <p:cNvPr id="54" name="Text 50"/>
+          <p:cNvPr id="56" name="Text 52"/>
           <p:cNvSpPr txBox="1"/>
           <p:nvPr/>
         </p:nvSpPr>
         <p:spPr>
           <a:xfrm>
-            <a:off x="17580060" y="10478834"/>
+            <a:off x="17580060" y="11753977"/>
             <a:ext cx="2011680" cy="274320"/>
           </a:xfrm>
           <a:prstGeom prst="rect">
@@ -5759,13 +6247,13 @@
       </p:sp>
       <p:sp>
         <p:nvSpPr>
-          <p:cNvPr id="55" name="Shape 51"/>
+          <p:cNvPr id="57" name="Shape 53"/>
           <p:cNvSpPr/>
           <p:nvPr/>
         </p:nvSpPr>
         <p:spPr>
           <a:xfrm>
-            <a:off x="19646604" y="10542842"/>
+            <a:off x="19646604" y="11817985"/>
             <a:ext cx="128016" cy="128016"/>
           </a:xfrm>
           <a:prstGeom prst="rect">
@@ -5779,13 +6267,13 @@
       </p:sp>
       <p:sp>
         <p:nvSpPr>
-          <p:cNvPr id="56" name="Text 52"/>
+          <p:cNvPr id="58" name="Text 54"/>
           <p:cNvSpPr txBox="1"/>
           <p:nvPr/>
         </p:nvSpPr>
         <p:spPr>
           <a:xfrm>
-            <a:off x="19847772" y="10478834"/>
+            <a:off x="19847772" y="11753977"/>
             <a:ext cx="2103120" cy="274320"/>
           </a:xfrm>
           <a:prstGeom prst="rect">
@@ -5818,13 +6306,13 @@
       </p:sp>
       <p:sp>
         <p:nvSpPr>
-          <p:cNvPr id="57" name="Text 53"/>
+          <p:cNvPr id="59" name="Text 55"/>
           <p:cNvSpPr txBox="1"/>
           <p:nvPr/>
         </p:nvSpPr>
         <p:spPr>
           <a:xfrm>
-            <a:off x="22024044" y="10478834"/>
+            <a:off x="22024044" y="11753977"/>
             <a:ext cx="2103120" cy="274320"/>
           </a:xfrm>
           <a:prstGeom prst="rect">
@@ -5857,13 +6345,13 @@
       </p:sp>
       <p:sp>
         <p:nvSpPr>
-          <p:cNvPr id="58" name="Text 54"/>
+          <p:cNvPr id="60" name="Text 56"/>
           <p:cNvSpPr txBox="1"/>
           <p:nvPr/>
         </p:nvSpPr>
         <p:spPr>
           <a:xfrm>
-            <a:off x="17360604" y="10890313"/>
+            <a:off x="17360604" y="12165457"/>
             <a:ext cx="2240280" cy="676656"/>
           </a:xfrm>
           <a:prstGeom prst="rect">
@@ -5896,13 +6384,13 @@
       </p:sp>
       <p:sp>
         <p:nvSpPr>
-          <p:cNvPr id="59" name="Shape 55"/>
+          <p:cNvPr id="61" name="Shape 57"/>
           <p:cNvSpPr/>
           <p:nvPr/>
         </p:nvSpPr>
         <p:spPr>
           <a:xfrm>
-            <a:off x="22544246" y="11091482"/>
+            <a:off x="22544246" y="12366625"/>
             <a:ext cx="537377" cy="0"/>
           </a:xfrm>
           <a:prstGeom prst="line">
@@ -5919,13 +6407,13 @@
       </p:sp>
       <p:sp>
         <p:nvSpPr>
-          <p:cNvPr id="60" name="Shape 56"/>
+          <p:cNvPr id="62" name="Shape 58"/>
           <p:cNvSpPr/>
           <p:nvPr/>
         </p:nvSpPr>
         <p:spPr>
           <a:xfrm>
-            <a:off x="22759637" y="11013757"/>
+            <a:off x="22759637" y="12288901"/>
             <a:ext cx="155448" cy="155448"/>
           </a:xfrm>
           <a:prstGeom prst="ellipse">
@@ -5939,13 +6427,13 @@
       </p:sp>
       <p:sp>
         <p:nvSpPr>
-          <p:cNvPr id="61" name="Text 57"/>
+          <p:cNvPr id="63" name="Text 59"/>
           <p:cNvSpPr txBox="1"/>
           <p:nvPr/>
         </p:nvSpPr>
         <p:spPr>
           <a:xfrm>
-            <a:off x="23136487" y="10981754"/>
+            <a:off x="23136487" y="12256897"/>
             <a:ext cx="640080" cy="219456"/>
           </a:xfrm>
           <a:prstGeom prst="rect">
@@ -5978,13 +6466,13 @@
       </p:sp>
       <p:sp>
         <p:nvSpPr>
-          <p:cNvPr id="62" name="Shape 58"/>
+          <p:cNvPr id="64" name="Shape 60"/>
           <p:cNvSpPr/>
           <p:nvPr/>
         </p:nvSpPr>
         <p:spPr>
           <a:xfrm>
-            <a:off x="20147532" y="11301793"/>
+            <a:off x="20147532" y="12576937"/>
             <a:ext cx="128016" cy="128016"/>
           </a:xfrm>
           <a:prstGeom prst="rect">
@@ -5998,13 +6486,13 @@
       </p:sp>
       <p:sp>
         <p:nvSpPr>
-          <p:cNvPr id="63" name="Text 59"/>
+          <p:cNvPr id="65" name="Text 61"/>
           <p:cNvSpPr txBox="1"/>
           <p:nvPr/>
         </p:nvSpPr>
         <p:spPr>
           <a:xfrm>
-            <a:off x="20330412" y="11256073"/>
+            <a:off x="20330412" y="12531217"/>
             <a:ext cx="640080" cy="219456"/>
           </a:xfrm>
           <a:prstGeom prst="rect">
@@ -6037,13 +6525,13 @@
       </p:sp>
       <p:sp>
         <p:nvSpPr>
-          <p:cNvPr id="64" name="Shape 60"/>
+          <p:cNvPr id="66" name="Shape 62"/>
           <p:cNvSpPr/>
           <p:nvPr/>
         </p:nvSpPr>
         <p:spPr>
           <a:xfrm>
-            <a:off x="17360604" y="11566969"/>
+            <a:off x="17360604" y="12842113"/>
             <a:ext cx="7873344" cy="0"/>
           </a:xfrm>
           <a:prstGeom prst="line">
@@ -6060,13 +6548,13 @@
       </p:sp>
       <p:sp>
         <p:nvSpPr>
-          <p:cNvPr id="65" name="Text 61"/>
+          <p:cNvPr id="67" name="Text 63"/>
           <p:cNvSpPr txBox="1"/>
           <p:nvPr/>
         </p:nvSpPr>
         <p:spPr>
           <a:xfrm>
-            <a:off x="17360604" y="11566969"/>
+            <a:off x="17360604" y="12842113"/>
             <a:ext cx="2240280" cy="676656"/>
           </a:xfrm>
           <a:prstGeom prst="rect">
@@ -6099,13 +6587,13 @@
       </p:sp>
       <p:sp>
         <p:nvSpPr>
-          <p:cNvPr id="66" name="Shape 62"/>
+          <p:cNvPr id="68" name="Shape 64"/>
           <p:cNvSpPr/>
           <p:nvPr/>
         </p:nvSpPr>
         <p:spPr>
           <a:xfrm>
-            <a:off x="23081623" y="11768138"/>
+            <a:off x="23081623" y="13043281"/>
             <a:ext cx="537377" cy="0"/>
           </a:xfrm>
           <a:prstGeom prst="line">
@@ -6122,13 +6610,13 @@
       </p:sp>
       <p:sp>
         <p:nvSpPr>
-          <p:cNvPr id="67" name="Shape 63"/>
+          <p:cNvPr id="69" name="Shape 65"/>
           <p:cNvSpPr/>
           <p:nvPr/>
         </p:nvSpPr>
         <p:spPr>
           <a:xfrm>
-            <a:off x="23309227" y="11690413"/>
+            <a:off x="23309227" y="12965557"/>
             <a:ext cx="155448" cy="155448"/>
           </a:xfrm>
           <a:prstGeom prst="ellipse">
@@ -6142,13 +6630,13 @@
       </p:sp>
       <p:sp>
         <p:nvSpPr>
-          <p:cNvPr id="68" name="Text 64"/>
+          <p:cNvPr id="70" name="Text 66"/>
           <p:cNvSpPr txBox="1"/>
           <p:nvPr/>
         </p:nvSpPr>
         <p:spPr>
           <a:xfrm>
-            <a:off x="23673864" y="11658410"/>
+            <a:off x="23673864" y="12933553"/>
             <a:ext cx="640080" cy="219456"/>
           </a:xfrm>
           <a:prstGeom prst="rect">
@@ -6181,13 +6669,13 @@
       </p:sp>
       <p:sp>
         <p:nvSpPr>
-          <p:cNvPr id="69" name="Shape 65"/>
+          <p:cNvPr id="71" name="Shape 67"/>
           <p:cNvSpPr/>
           <p:nvPr/>
         </p:nvSpPr>
         <p:spPr>
           <a:xfrm>
-            <a:off x="23093836" y="12042457"/>
+            <a:off x="23093836" y="13317601"/>
             <a:ext cx="598443" cy="0"/>
           </a:xfrm>
           <a:prstGeom prst="line">
@@ -6204,13 +6692,13 @@
       </p:sp>
       <p:sp>
         <p:nvSpPr>
-          <p:cNvPr id="70" name="Shape 66"/>
+          <p:cNvPr id="72" name="Shape 68"/>
           <p:cNvSpPr/>
           <p:nvPr/>
         </p:nvSpPr>
         <p:spPr>
           <a:xfrm>
-            <a:off x="23322943" y="11978449"/>
+            <a:off x="23322943" y="13253593"/>
             <a:ext cx="128016" cy="128016"/>
           </a:xfrm>
           <a:prstGeom prst="rect">
@@ -6224,13 +6712,13 @@
       </p:sp>
       <p:sp>
         <p:nvSpPr>
-          <p:cNvPr id="71" name="Text 67"/>
+          <p:cNvPr id="73" name="Text 69"/>
           <p:cNvSpPr txBox="1"/>
           <p:nvPr/>
         </p:nvSpPr>
         <p:spPr>
           <a:xfrm>
-            <a:off x="23747143" y="11932730"/>
+            <a:off x="23747143" y="13207873"/>
             <a:ext cx="640080" cy="219456"/>
           </a:xfrm>
           <a:prstGeom prst="rect">
@@ -6263,13 +6751,13 @@
       </p:sp>
       <p:sp>
         <p:nvSpPr>
-          <p:cNvPr id="72" name="Shape 68"/>
+          <p:cNvPr id="74" name="Shape 70"/>
           <p:cNvSpPr/>
           <p:nvPr/>
         </p:nvSpPr>
         <p:spPr>
           <a:xfrm>
-            <a:off x="17360604" y="12243626"/>
+            <a:off x="17360604" y="13518769"/>
             <a:ext cx="7873344" cy="0"/>
           </a:xfrm>
           <a:prstGeom prst="line">
@@ -6286,13 +6774,13 @@
       </p:sp>
       <p:sp>
         <p:nvSpPr>
-          <p:cNvPr id="73" name="Text 69"/>
+          <p:cNvPr id="75" name="Text 71"/>
           <p:cNvSpPr txBox="1"/>
           <p:nvPr/>
         </p:nvSpPr>
         <p:spPr>
           <a:xfrm>
-            <a:off x="17360604" y="12243626"/>
+            <a:off x="17360604" y="13518769"/>
             <a:ext cx="2240280" cy="676656"/>
           </a:xfrm>
           <a:prstGeom prst="rect">
@@ -6325,13 +6813,13 @@
       </p:sp>
       <p:sp>
         <p:nvSpPr>
-          <p:cNvPr id="74" name="Shape 70"/>
+          <p:cNvPr id="76" name="Shape 72"/>
           <p:cNvSpPr/>
           <p:nvPr/>
         </p:nvSpPr>
         <p:spPr>
           <a:xfrm>
-            <a:off x="23313672" y="12444794"/>
+            <a:off x="23313672" y="13719937"/>
             <a:ext cx="512951" cy="0"/>
           </a:xfrm>
           <a:prstGeom prst="line">
@@ -6348,13 +6836,13 @@
       </p:sp>
       <p:sp>
         <p:nvSpPr>
-          <p:cNvPr id="75" name="Shape 71"/>
+          <p:cNvPr id="77" name="Shape 73"/>
           <p:cNvSpPr/>
           <p:nvPr/>
         </p:nvSpPr>
         <p:spPr>
           <a:xfrm>
-            <a:off x="23529063" y="12367069"/>
+            <a:off x="23529063" y="13642213"/>
             <a:ext cx="155448" cy="155448"/>
           </a:xfrm>
           <a:prstGeom prst="ellipse">
@@ -6368,13 +6856,13 @@
       </p:sp>
       <p:sp>
         <p:nvSpPr>
-          <p:cNvPr id="76" name="Text 72"/>
+          <p:cNvPr id="78" name="Text 74"/>
           <p:cNvSpPr txBox="1"/>
           <p:nvPr/>
         </p:nvSpPr>
         <p:spPr>
           <a:xfrm>
-            <a:off x="23881488" y="12335066"/>
+            <a:off x="23881488" y="13610209"/>
             <a:ext cx="640080" cy="219456"/>
           </a:xfrm>
           <a:prstGeom prst="rect">
@@ -6407,13 +6895,13 @@
       </p:sp>
       <p:sp>
         <p:nvSpPr>
-          <p:cNvPr id="77" name="Shape 73"/>
+          <p:cNvPr id="79" name="Shape 75"/>
           <p:cNvSpPr/>
           <p:nvPr/>
         </p:nvSpPr>
         <p:spPr>
           <a:xfrm>
-            <a:off x="22715230" y="12719113"/>
+            <a:off x="22715230" y="13994257"/>
             <a:ext cx="586230" cy="0"/>
           </a:xfrm>
           <a:prstGeom prst="line">
@@ -6430,13 +6918,13 @@
       </p:sp>
       <p:sp>
         <p:nvSpPr>
-          <p:cNvPr id="78" name="Shape 74"/>
+          <p:cNvPr id="80" name="Shape 76"/>
           <p:cNvSpPr/>
           <p:nvPr/>
         </p:nvSpPr>
         <p:spPr>
           <a:xfrm>
-            <a:off x="22932123" y="12655105"/>
+            <a:off x="22932123" y="13930249"/>
             <a:ext cx="128016" cy="128016"/>
           </a:xfrm>
           <a:prstGeom prst="rect">
@@ -6450,13 +6938,13 @@
       </p:sp>
       <p:sp>
         <p:nvSpPr>
-          <p:cNvPr id="79" name="Text 75"/>
+          <p:cNvPr id="81" name="Text 77"/>
           <p:cNvSpPr txBox="1"/>
           <p:nvPr/>
         </p:nvSpPr>
         <p:spPr>
           <a:xfrm>
-            <a:off x="23356323" y="12609386"/>
+            <a:off x="23356323" y="13884529"/>
             <a:ext cx="640080" cy="219456"/>
           </a:xfrm>
           <a:prstGeom prst="rect">
@@ -6489,13 +6977,13 @@
       </p:sp>
       <p:sp>
         <p:nvSpPr>
-          <p:cNvPr id="80" name="Shape 76"/>
+          <p:cNvPr id="82" name="Shape 78"/>
           <p:cNvSpPr/>
           <p:nvPr/>
         </p:nvSpPr>
         <p:spPr>
           <a:xfrm>
-            <a:off x="17360604" y="12920282"/>
+            <a:off x="17360604" y="14195425"/>
             <a:ext cx="7873344" cy="0"/>
           </a:xfrm>
           <a:prstGeom prst="line">
@@ -6512,13 +7000,13 @@
       </p:sp>
       <p:sp>
         <p:nvSpPr>
-          <p:cNvPr id="81" name="Text 77"/>
+          <p:cNvPr id="83" name="Text 79"/>
           <p:cNvSpPr txBox="1"/>
           <p:nvPr/>
         </p:nvSpPr>
         <p:spPr>
           <a:xfrm>
-            <a:off x="17360604" y="12920282"/>
+            <a:off x="17360604" y="14195425"/>
             <a:ext cx="2240280" cy="676656"/>
           </a:xfrm>
           <a:prstGeom prst="rect">
@@ -6551,13 +7039,13 @@
       </p:sp>
       <p:sp>
         <p:nvSpPr>
-          <p:cNvPr id="82" name="Shape 78"/>
+          <p:cNvPr id="84" name="Shape 80"/>
           <p:cNvSpPr/>
           <p:nvPr/>
         </p:nvSpPr>
         <p:spPr>
           <a:xfrm>
-            <a:off x="23765558" y="13121450"/>
+            <a:off x="23765558" y="14396593"/>
             <a:ext cx="464099" cy="0"/>
           </a:xfrm>
           <a:prstGeom prst="line">
@@ -6574,13 +7062,13 @@
       </p:sp>
       <p:sp>
         <p:nvSpPr>
-          <p:cNvPr id="83" name="Shape 79"/>
+          <p:cNvPr id="85" name="Shape 81"/>
           <p:cNvSpPr/>
           <p:nvPr/>
         </p:nvSpPr>
         <p:spPr>
           <a:xfrm>
-            <a:off x="23895457" y="13043726"/>
+            <a:off x="23895457" y="14318869"/>
             <a:ext cx="155448" cy="155448"/>
           </a:xfrm>
           <a:prstGeom prst="ellipse">
@@ -6594,13 +7082,13 @@
       </p:sp>
       <p:sp>
         <p:nvSpPr>
-          <p:cNvPr id="84" name="Text 80"/>
+          <p:cNvPr id="86" name="Text 82"/>
           <p:cNvSpPr txBox="1"/>
           <p:nvPr/>
         </p:nvSpPr>
         <p:spPr>
           <a:xfrm>
-            <a:off x="24284520" y="13011722"/>
+            <a:off x="24284520" y="14286865"/>
             <a:ext cx="640080" cy="219456"/>
           </a:xfrm>
           <a:prstGeom prst="rect">
@@ -6633,13 +7121,13 @@
       </p:sp>
       <p:sp>
         <p:nvSpPr>
-          <p:cNvPr id="85" name="Shape 81"/>
+          <p:cNvPr id="87" name="Shape 83"/>
           <p:cNvSpPr/>
           <p:nvPr/>
         </p:nvSpPr>
         <p:spPr>
           <a:xfrm>
-            <a:off x="23154902" y="13395769"/>
+            <a:off x="23154902" y="14670913"/>
             <a:ext cx="598443" cy="0"/>
           </a:xfrm>
           <a:prstGeom prst="line">
@@ -6656,13 +7144,13 @@
       </p:sp>
       <p:sp>
         <p:nvSpPr>
-          <p:cNvPr id="86" name="Shape 82"/>
+          <p:cNvPr id="88" name="Shape 84"/>
           <p:cNvSpPr/>
           <p:nvPr/>
         </p:nvSpPr>
         <p:spPr>
           <a:xfrm>
-            <a:off x="23408435" y="13331761"/>
+            <a:off x="23408435" y="14606905"/>
             <a:ext cx="128016" cy="128016"/>
           </a:xfrm>
           <a:prstGeom prst="rect">
@@ -6676,13 +7164,13 @@
       </p:sp>
       <p:sp>
         <p:nvSpPr>
-          <p:cNvPr id="87" name="Text 83"/>
+          <p:cNvPr id="89" name="Text 85"/>
           <p:cNvSpPr txBox="1"/>
           <p:nvPr/>
         </p:nvSpPr>
         <p:spPr>
           <a:xfrm>
-            <a:off x="23808209" y="13286042"/>
+            <a:off x="23808209" y="14561185"/>
             <a:ext cx="640080" cy="219456"/>
           </a:xfrm>
           <a:prstGeom prst="rect">
@@ -6715,13 +7203,13 @@
       </p:sp>
       <p:sp>
         <p:nvSpPr>
-          <p:cNvPr id="88" name="Shape 84"/>
+          <p:cNvPr id="90" name="Shape 86"/>
           <p:cNvSpPr/>
           <p:nvPr/>
         </p:nvSpPr>
         <p:spPr>
           <a:xfrm>
-            <a:off x="17360604" y="13596938"/>
+            <a:off x="17360604" y="14872081"/>
             <a:ext cx="7873344" cy="0"/>
           </a:xfrm>
           <a:prstGeom prst="line">
@@ -6738,13 +7226,13 @@
       </p:sp>
       <p:sp>
         <p:nvSpPr>
-          <p:cNvPr id="89" name="Shape 85"/>
+          <p:cNvPr id="91" name="Shape 87"/>
           <p:cNvSpPr/>
           <p:nvPr/>
         </p:nvSpPr>
         <p:spPr>
           <a:xfrm>
-            <a:off x="20211540" y="10890313"/>
+            <a:off x="20211540" y="12165457"/>
             <a:ext cx="0" cy="2706624"/>
           </a:xfrm>
           <a:prstGeom prst="line">
@@ -6761,13 +7249,13 @@
       </p:sp>
       <p:sp>
         <p:nvSpPr>
-          <p:cNvPr id="90" name="Text 86"/>
+          <p:cNvPr id="92" name="Text 88"/>
           <p:cNvSpPr txBox="1"/>
           <p:nvPr/>
         </p:nvSpPr>
         <p:spPr>
           <a:xfrm>
-            <a:off x="19937220" y="13642658"/>
+            <a:off x="19937220" y="14917801"/>
             <a:ext cx="548640" cy="228600"/>
           </a:xfrm>
           <a:prstGeom prst="rect">
@@ -6800,13 +7288,13 @@
       </p:sp>
       <p:sp>
         <p:nvSpPr>
-          <p:cNvPr id="91" name="Shape 87"/>
+          <p:cNvPr id="93" name="Shape 89"/>
           <p:cNvSpPr/>
           <p:nvPr/>
         </p:nvSpPr>
         <p:spPr>
           <a:xfrm>
-            <a:off x="21432852" y="10890313"/>
+            <a:off x="21432852" y="12165457"/>
             <a:ext cx="0" cy="2706624"/>
           </a:xfrm>
           <a:prstGeom prst="line">
@@ -6823,13 +7311,13 @@
       </p:sp>
       <p:sp>
         <p:nvSpPr>
-          <p:cNvPr id="92" name="Text 88"/>
+          <p:cNvPr id="94" name="Text 90"/>
           <p:cNvSpPr txBox="1"/>
           <p:nvPr/>
         </p:nvSpPr>
         <p:spPr>
           <a:xfrm>
-            <a:off x="21158532" y="13642658"/>
+            <a:off x="21158532" y="14917801"/>
             <a:ext cx="548640" cy="228600"/>
           </a:xfrm>
           <a:prstGeom prst="rect">
@@ -6862,13 +7350,13 @@
       </p:sp>
       <p:sp>
         <p:nvSpPr>
-          <p:cNvPr id="93" name="Shape 89"/>
+          <p:cNvPr id="95" name="Shape 91"/>
           <p:cNvSpPr/>
           <p:nvPr/>
         </p:nvSpPr>
         <p:spPr>
           <a:xfrm>
-            <a:off x="22654164" y="10890313"/>
+            <a:off x="22654164" y="12165457"/>
             <a:ext cx="0" cy="2706624"/>
           </a:xfrm>
           <a:prstGeom prst="line">
@@ -6885,13 +7373,13 @@
       </p:sp>
       <p:sp>
         <p:nvSpPr>
-          <p:cNvPr id="94" name="Text 90"/>
+          <p:cNvPr id="96" name="Text 92"/>
           <p:cNvSpPr txBox="1"/>
           <p:nvPr/>
         </p:nvSpPr>
         <p:spPr>
           <a:xfrm>
-            <a:off x="22379844" y="13642658"/>
+            <a:off x="22379844" y="14917801"/>
             <a:ext cx="548640" cy="228600"/>
           </a:xfrm>
           <a:prstGeom prst="rect">
@@ -6924,13 +7412,13 @@
       </p:sp>
       <p:sp>
         <p:nvSpPr>
-          <p:cNvPr id="95" name="Shape 91"/>
+          <p:cNvPr id="97" name="Shape 93"/>
           <p:cNvSpPr/>
           <p:nvPr/>
         </p:nvSpPr>
         <p:spPr>
           <a:xfrm>
-            <a:off x="23875476" y="10890313"/>
+            <a:off x="23875476" y="12165457"/>
             <a:ext cx="0" cy="2706624"/>
           </a:xfrm>
           <a:prstGeom prst="line">
@@ -6947,13 +7435,13 @@
       </p:sp>
       <p:sp>
         <p:nvSpPr>
-          <p:cNvPr id="96" name="Text 92"/>
+          <p:cNvPr id="98" name="Text 94"/>
           <p:cNvSpPr txBox="1"/>
           <p:nvPr/>
         </p:nvSpPr>
         <p:spPr>
           <a:xfrm>
-            <a:off x="23601156" y="13642658"/>
+            <a:off x="23601156" y="14917801"/>
             <a:ext cx="548640" cy="228600"/>
           </a:xfrm>
           <a:prstGeom prst="rect">
@@ -6986,13 +7474,13 @@
       </p:sp>
       <p:sp>
         <p:nvSpPr>
-          <p:cNvPr id="97" name="Shape 93"/>
+          <p:cNvPr id="99" name="Shape 95"/>
           <p:cNvSpPr/>
           <p:nvPr/>
         </p:nvSpPr>
         <p:spPr>
           <a:xfrm>
-            <a:off x="25096788" y="10890313"/>
+            <a:off x="25096788" y="12165457"/>
             <a:ext cx="0" cy="2706624"/>
           </a:xfrm>
           <a:prstGeom prst="line">
@@ -7009,13 +7497,13 @@
       </p:sp>
       <p:sp>
         <p:nvSpPr>
-          <p:cNvPr id="98" name="Text 94"/>
+          <p:cNvPr id="100" name="Text 96"/>
           <p:cNvSpPr txBox="1"/>
           <p:nvPr/>
         </p:nvSpPr>
         <p:spPr>
           <a:xfrm>
-            <a:off x="24822468" y="13642658"/>
+            <a:off x="24822468" y="14917801"/>
             <a:ext cx="548640" cy="228600"/>
           </a:xfrm>
           <a:prstGeom prst="rect">
@@ -7048,13 +7536,13 @@
       </p:sp>
       <p:sp>
         <p:nvSpPr>
-          <p:cNvPr id="99" name="Text 95"/>
+          <p:cNvPr id="101" name="Text 97"/>
           <p:cNvSpPr txBox="1"/>
           <p:nvPr/>
         </p:nvSpPr>
         <p:spPr>
           <a:xfrm>
-            <a:off x="17360604" y="13962698"/>
+            <a:off x="17360604" y="15237841"/>
             <a:ext cx="7873344" cy="481076"/>
           </a:xfrm>
           <a:prstGeom prst="rect">
@@ -7101,7 +7589,7 @@
       </p:sp>
       <p:sp>
         <p:nvSpPr>
-          <p:cNvPr id="100" name="Shape 96"/>
+          <p:cNvPr id="102" name="Shape 98"/>
           <p:cNvSpPr/>
           <p:nvPr/>
         </p:nvSpPr>
@@ -7124,14 +7612,14 @@
       </p:sp>
       <p:sp>
         <p:nvSpPr>
-          <p:cNvPr id="101" name="Text 97"/>
+          <p:cNvPr id="103" name="Text 99"/>
           <p:cNvSpPr txBox="1"/>
           <p:nvPr/>
         </p:nvSpPr>
         <p:spPr>
           <a:xfrm>
             <a:off x="25755156" y="4480560"/>
-            <a:ext cx="7873344" cy="1147826"/>
+            <a:ext cx="7873344" cy="1425639"/>
           </a:xfrm>
           <a:prstGeom prst="rect">
             <a:avLst/>
@@ -7169,7 +7657,7 @@
                 <a:ea typeface="Calibri" pitchFamily="34" charset="-122"/>
                 <a:cs typeface="Calibri" pitchFamily="34" charset="-120"/>
               </a:rPr>
-              <a:t>Amplifications were recovered almost completely through co-amplification with neighbouring assayed genes (e.g. NFKBIA with NKX2-1 in 39/39 cases); mutation prediction matched a model using only three burden counts (Figure 4).</a:t>
+              <a:t>Amplifications were highly discriminable (AUROC 0.95), explained largely by co-amplification with neighbouring assayed genes (NFKBIA with NKX2-1 in 39/39 cases). Mutations reached 0.73, no better than three mutational-burden counts alone (Figure 4).</a:t>
             </a:r>
             <a:endParaRPr lang="en-US" sz="1750" dirty="0"/>
           </a:p>
@@ -7177,13 +7665,13 @@
       </p:sp>
       <p:graphicFrame>
         <p:nvGraphicFramePr>
-          <p:cNvPr id="102" name="Chart 0" descr=""/>
+          <p:cNvPr id="104" name="Chart 0" descr=""/>
           <p:cNvGraphicFramePr/>
           <p:nvPr/>
         </p:nvGraphicFramePr>
         <p:xfrm>
-          <a:off x="25755156" y="5856986"/>
-          <a:ext cx="7873344" cy="2377440"/>
+          <a:off x="25755156" y="6134799"/>
+          <a:ext cx="7873344" cy="2057400"/>
         </p:xfrm>
         <a:graphic xmlns:a="http://schemas.openxmlformats.org/drawingml/2006/main">
           <a:graphicData uri="http://schemas.openxmlformats.org/drawingml/2006/chart">
@@ -7193,13 +7681,13 @@
       </p:graphicFrame>
       <p:sp>
         <p:nvSpPr>
-          <p:cNvPr id="103" name="Text 98"/>
+          <p:cNvPr id="105" name="Text 100"/>
           <p:cNvSpPr txBox="1"/>
           <p:nvPr/>
         </p:nvSpPr>
         <p:spPr>
           <a:xfrm>
-            <a:off x="25755156" y="8307578"/>
+            <a:off x="25755156" y="8265351"/>
             <a:ext cx="7873344" cy="481076"/>
           </a:xfrm>
           <a:prstGeom prst="rect">
@@ -7246,14 +7734,14 @@
       </p:sp>
       <p:sp>
         <p:nvSpPr>
-          <p:cNvPr id="104" name="Text 99"/>
+          <p:cNvPr id="106" name="Text 101"/>
           <p:cNvSpPr txBox="1"/>
           <p:nvPr/>
         </p:nvSpPr>
         <p:spPr>
           <a:xfrm>
-            <a:off x="25755156" y="9062974"/>
-            <a:ext cx="7873344" cy="870014"/>
+            <a:off x="25755156" y="9020747"/>
+            <a:ext cx="7873344" cy="1425639"/>
           </a:xfrm>
           <a:prstGeom prst="rect">
             <a:avLst/>
@@ -7291,7 +7779,7 @@
                 <a:ea typeface="Calibri" pitchFamily="34" charset="-122"/>
                 <a:cs typeface="Calibri" pitchFamily="34" charset="-120"/>
               </a:rPr>
-              <a:t>In 167 patients sequenced on both panels, input from the separate IMPACT341 assay reduced discrimination relative to the masked large panel (Figure 5).</a:t>
+              <a:t>In 167 patients sequenced on both panels, taking the input from the separate IMPACT341 assay rather than masking the IMPACT410 sample lowered AUROC. The paired samples also differ in specimen and time, so the gap combines assay shift and tumour heterogeneity (Figure 5).</a:t>
             </a:r>
             <a:endParaRPr lang="en-US" sz="1750" dirty="0"/>
           </a:p>
@@ -7299,13 +7787,13 @@
       </p:sp>
       <p:graphicFrame>
         <p:nvGraphicFramePr>
-          <p:cNvPr id="105" name="Chart 1" descr=""/>
+          <p:cNvPr id="107" name="Chart 1" descr=""/>
           <p:cNvGraphicFramePr/>
           <p:nvPr/>
         </p:nvGraphicFramePr>
         <p:xfrm>
-          <a:off x="25755156" y="10161588"/>
-          <a:ext cx="7873344" cy="2377440"/>
+          <a:off x="25755156" y="10674985"/>
+          <a:ext cx="7873344" cy="2057400"/>
         </p:xfrm>
         <a:graphic xmlns:a="http://schemas.openxmlformats.org/drawingml/2006/main">
           <a:graphicData uri="http://schemas.openxmlformats.org/drawingml/2006/chart">
@@ -7315,13 +7803,13 @@
       </p:graphicFrame>
       <p:sp>
         <p:nvSpPr>
-          <p:cNvPr id="106" name="Text 100"/>
+          <p:cNvPr id="108" name="Text 102"/>
           <p:cNvSpPr txBox="1"/>
           <p:nvPr/>
         </p:nvSpPr>
         <p:spPr>
           <a:xfrm>
-            <a:off x="25755156" y="12612179"/>
+            <a:off x="25755156" y="12805537"/>
             <a:ext cx="7873344" cy="481076"/>
           </a:xfrm>
           <a:prstGeom prst="rect">
@@ -7360,7 +7848,7 @@
                 <a:ea typeface="Calibri" pitchFamily="34" charset="-122"/>
                 <a:cs typeface="Calibri" pitchFamily="34" charset="-120"/>
               </a:rPr>
-              <a:t>Replicate: AUROC with simulated (masked IMPACT410) versus real (IMPACT341 assay) input; axis origin 0.50.</a:t>
+              <a:t>Replicate, pan-cancer logistic regression trained on all other patients: simulated (masked IMPACT410) versus real (IMPACT341 assay) input; axis origin 0.50.</a:t>
             </a:r>
             <a:endParaRPr lang="en-US" sz="1400" dirty="0"/>
           </a:p>
@@ -7368,13 +7856,13 @@
       </p:sp>
       <p:sp>
         <p:nvSpPr>
-          <p:cNvPr id="107" name="Shape 101"/>
+          <p:cNvPr id="109" name="Shape 103"/>
           <p:cNvSpPr/>
           <p:nvPr/>
         </p:nvSpPr>
         <p:spPr>
           <a:xfrm>
-            <a:off x="25755156" y="13367575"/>
+            <a:off x="25755156" y="13560933"/>
             <a:ext cx="7873344" cy="0"/>
           </a:xfrm>
           <a:prstGeom prst="line">
@@ -7391,13 +7879,13 @@
       </p:sp>
       <p:sp>
         <p:nvSpPr>
-          <p:cNvPr id="108" name="Text 102"/>
+          <p:cNvPr id="110" name="Text 104"/>
           <p:cNvSpPr txBox="1"/>
           <p:nvPr/>
         </p:nvSpPr>
         <p:spPr>
           <a:xfrm>
-            <a:off x="25755156" y="13459015"/>
+            <a:off x="25755156" y="13652373"/>
             <a:ext cx="7873344" cy="566928"/>
           </a:xfrm>
           <a:prstGeom prst="rect">
@@ -7430,14 +7918,14 @@
       </p:sp>
       <p:sp>
         <p:nvSpPr>
-          <p:cNvPr id="109" name="Text 103"/>
+          <p:cNvPr id="111" name="Text 105"/>
           <p:cNvSpPr txBox="1"/>
           <p:nvPr/>
         </p:nvSpPr>
         <p:spPr>
           <a:xfrm>
-            <a:off x="25755156" y="14236255"/>
-            <a:ext cx="7873344" cy="2920937"/>
+            <a:off x="25755156" y="14429613"/>
+            <a:ext cx="7873344" cy="2920936"/>
           </a:xfrm>
           <a:prstGeom prst="rect">
             <a:avLst/>
@@ -7465,7 +7953,7 @@
                 <a:ea typeface="Calibri" pitchFamily="34" charset="-122"/>
                 <a:cs typeface="Calibri" pitchFamily="34" charset="-120"/>
               </a:rPr>
-              <a:t>A targeted panel contains recoverable information on genes outside its assayed set (pooled AUROC 0.77–0.79).</a:t>
+              <a:t>A targeted panel carries predictive information on unassayed genes; per-gene AUROC and simple baselines, not pooled AUROC alone, measure how much.</a:t>
             </a:r>
             <a:endParaRPr lang="en-US" sz="1750" dirty="0"/>
           </a:p>
@@ -7486,7 +7974,7 @@
                 <a:ea typeface="Calibri" pitchFamily="34" charset="-122"/>
                 <a:cs typeface="Calibri" pitchFamily="34" charset="-120"/>
               </a:rPr>
-              <a:t>This information derives mainly from copy-number co-location and mutational burden.</a:t>
+              <a:t>The signal is mainly copy-number co-location and mutational burden; a generative model must add joint fidelity to justify its complexity.</a:t>
             </a:r>
             <a:endParaRPr lang="en-US" sz="1750" dirty="0"/>
           </a:p>
@@ -7507,7 +7995,7 @@
                 <a:ea typeface="Calibri" pitchFamily="34" charset="-122"/>
                 <a:cs typeface="Calibri" pitchFamily="34" charset="-120"/>
               </a:rPr>
-              <a:t>Limitations: simulated masking overestimates performance on real assays; single test split; actionable-gene subset not yet evaluated.</a:t>
+              <a:t>Limitations: masked-panel evaluation is an upper bound; single split; actionable-gene subset not yet evaluated.</a:t>
             </a:r>
             <a:endParaRPr lang="en-US" sz="1750" dirty="0"/>
           </a:p>
@@ -7528,7 +8016,7 @@
                 <a:ea typeface="Calibri" pitchFamily="34" charset="-122"/>
                 <a:cs typeface="Calibri" pitchFamily="34" charset="-120"/>
               </a:rPr>
-              <a:t>Such models may prioritise patients for broad CGP; they do not replace it.</a:t>
+              <a:t>At ~1% prevalence, use is triage for broad CGP, not replacement.</a:t>
             </a:r>
             <a:endParaRPr lang="en-US" sz="1750" dirty="0"/>
           </a:p>
@@ -7536,7 +8024,7 @@
       </p:sp>
       <p:sp>
         <p:nvSpPr>
-          <p:cNvPr id="110" name="Shape 104"/>
+          <p:cNvPr id="112" name="Shape 106"/>
           <p:cNvSpPr/>
           <p:nvPr/>
         </p:nvSpPr>
@@ -7559,7 +8047,7 @@
       </p:sp>
       <p:sp>
         <p:nvSpPr>
-          <p:cNvPr id="111" name="Text 105"/>
+          <p:cNvPr id="113" name="Text 107"/>
           <p:cNvSpPr txBox="1"/>
           <p:nvPr/>
         </p:nvSpPr>
@@ -7649,7 +8137,7 @@
       </p:sp>
       <p:sp>
         <p:nvSpPr>
-          <p:cNvPr id="112" name="Text 106"/>
+          <p:cNvPr id="114" name="Text 108"/>
           <p:cNvSpPr txBox="1"/>
           <p:nvPr/>
         </p:nvSpPr>
@@ -7719,7 +8207,7 @@
       </p:sp>
       <p:sp>
         <p:nvSpPr>
-          <p:cNvPr id="113" name="Text 107"/>
+          <p:cNvPr id="115" name="Text 109"/>
           <p:cNvSpPr txBox="1"/>
           <p:nvPr/>
         </p:nvSpPr>
@@ -7792,7 +8280,7 @@
       </p:sp>
       <p:sp>
         <p:nvSpPr>
-          <p:cNvPr id="114" name="Shape 108"/>
+          <p:cNvPr id="116" name="Shape 110"/>
           <p:cNvSpPr/>
           <p:nvPr/>
         </p:nvSpPr>
@@ -7817,7 +8305,7 @@
       </p:sp>
       <p:sp>
         <p:nvSpPr>
-          <p:cNvPr id="115" name="Text 109"/>
+          <p:cNvPr id="117" name="Text 111"/>
           <p:cNvSpPr txBox="1"/>
           <p:nvPr/>
         </p:nvSpPr>

</xml_diff>

<commit_message>
Add ESMO EBAI class B assessment to P305 poster
New section and Figure 5 grade the panel-completion model against the EBAI
class B requirements; operating-point and calibration values come from the
MSK-IMPACT 2017 replicate (Se 0.90, NPV 0.86, LR- 0.22; slope 0.97, O:E 1.08).

Co-Authored-By: Claude Opus 5.5 <noreply@anthropic.com>
Claude-Session: https://claude.ai/code/session_01XfxNdpDPmWZQpH5ScSMkJ1
</commit_message>
<xml_diff>
--- a/docs/poster/ESMO_P305_poster.pptx
+++ b/docs/poster/ESMO_P305_poster.pptx
@@ -247,299 +247,6 @@
                 </c:pt>
                 <c:pt idx="3">
                   <c:v>0.711</c:v>
-                </c:pt>
-              </c:numCache>
-            </c:numRef>
-          </c:val>
-        </c:ser>
-        <c:dLbls>
-          <c:numFmt formatCode="0.00" sourceLinked="0"/>
-          <c:txPr>
-            <a:bodyPr/>
-            <a:lstStyle/>
-            <a:p>
-              <a:pPr>
-                <a:defRPr b="0" i="0" strike="noStrike" sz="1500" u="none">
-                  <a:solidFill>
-                    <a:srgbClr val="12202E"/>
-                  </a:solidFill>
-                  <a:latin typeface="Arial"/>
-                </a:defRPr>
-              </a:pPr>
-            </a:p>
-          </c:txPr>
-          <c:showLegendKey val="0"/>
-          <c:showVal val="1"/>
-          <c:showCatName val="0"/>
-          <c:showSerName val="0"/>
-          <c:showPercent val="0"/>
-          <c:showBubbleSize val="0"/>
-          <c:showLeaderLines val="0"/>
-        </c:dLbls>
-        <c:gapWidth val="45"/>
-        <c:overlap val="0"/>
-        <c:axId val="2094734554"/>
-        <c:axId val="2094734552"/>
-        <c:axId val="2094734556"/>
-      </c:barChart>
-      <c:catAx>
-        <c:axId val="2094734554"/>
-        <c:scaling>
-          <c:orientation val="maxMin"/>
-        </c:scaling>
-        <c:delete val="0"/>
-        <c:axPos val="l"/>
-        <c:numFmt formatCode="General" sourceLinked="1"/>
-        <c:majorTickMark val="out"/>
-        <c:minorTickMark val="none"/>
-        <c:tickLblPos val="nextTo"/>
-        <c:spPr>
-          <a:ln w="12700" cap="flat">
-            <a:solidFill>
-              <a:srgbClr val="888888"/>
-            </a:solidFill>
-            <a:prstDash val="solid"/>
-            <a:round/>
-          </a:ln>
-        </c:spPr>
-        <c:txPr>
-          <a:bodyPr/>
-          <a:lstStyle/>
-          <a:p>
-            <a:pPr>
-              <a:defRPr sz="1500" b="0" i="0" u="none" strike="noStrike">
-                <a:solidFill>
-                  <a:srgbClr val="12202E"/>
-                </a:solidFill>
-                <a:latin typeface="Calibri"/>
-              </a:defRPr>
-            </a:pPr>
-            <a:endParaRPr lang="en-US"/>
-          </a:p>
-        </c:txPr>
-        <c:crossAx val="2094734552"/>
-        <c:crosses val="autoZero"/>
-        <c:auto val="1"/>
-        <c:lblAlgn val="ctr"/>
-        <c:noMultiLvlLbl val="1"/>
-      </c:catAx>
-      <c:valAx>
-        <c:axId val="2094734552"/>
-        <c:scaling>
-          <c:orientation val="minMax"/>
-          <c:max val="1"/>
-          <c:min val="0.5"/>
-        </c:scaling>
-        <c:delete val="0"/>
-        <c:axPos val="b"/>
-        <c:majorGridlines>
-          <c:spPr>
-            <a:ln w="9525" cap="flat">
-              <a:solidFill>
-                <a:srgbClr val="E0E4E8"/>
-              </a:solidFill>
-              <a:prstDash val="solid"/>
-              <a:round/>
-            </a:ln>
-          </c:spPr>
-        </c:majorGridlines>
-        <c:numFmt formatCode="0.0#" sourceLinked="0"/>
-        <c:majorTickMark val="out"/>
-        <c:minorTickMark val="none"/>
-        <c:tickLblPos val="low"/>
-        <c:spPr>
-          <a:ln w="12700" cap="flat">
-            <a:solidFill>
-              <a:srgbClr val="888888"/>
-            </a:solidFill>
-            <a:prstDash val="solid"/>
-            <a:round/>
-          </a:ln>
-        </c:spPr>
-        <c:txPr>
-          <a:bodyPr/>
-          <a:lstStyle/>
-          <a:p>
-            <a:pPr>
-              <a:defRPr sz="1200" b="0" i="0" u="none" strike="noStrike">
-                <a:solidFill>
-                  <a:srgbClr val="3F4B57"/>
-                </a:solidFill>
-                <a:latin typeface="Calibri"/>
-              </a:defRPr>
-            </a:pPr>
-            <a:endParaRPr lang="en-US"/>
-          </a:p>
-        </c:txPr>
-        <c:crossAx val="2094734554"/>
-        <c:crosses val="autoZero"/>
-        <c:crossBetween val="between"/>
-        <c:majorUnit val="0.1"/>
-      </c:valAx>
-      <c:spPr>
-        <a:noFill/>
-        <a:ln>
-          <a:noFill/>
-        </a:ln>
-        <a:effectLst/>
-      </c:spPr>
-    </c:plotArea>
-    <c:plotVisOnly val="1"/>
-    <c:dispBlanksAs val="span"/>
-  </c:chart>
-  <c:spPr>
-    <a:noFill/>
-    <a:ln>
-      <a:noFill/>
-    </a:ln>
-    <a:effectLst/>
-  </c:spPr>
-  <c:externalData r:id="rId1">
-    <c:autoUpdate val="0"/>
-  </c:externalData>
-</c:chartSpace>
-</file>
-
-<file path=ppt/charts/chart2.xml><?xml version="1.0" encoding="utf-8"?>
-<c:chartSpace xmlns:c="http://schemas.openxmlformats.org/drawingml/2006/chart" xmlns:a="http://schemas.openxmlformats.org/drawingml/2006/main" xmlns:r="http://schemas.openxmlformats.org/officeDocument/2006/relationships">
-  <c:date1904 val="0"/>
-  <c:roundedCorners val="1"/>
-  <c:chart>
-    <c:autoTitleDeleted val="1"/>
-    <c:plotArea>
-      <c:layout/>
-      <c:barChart>
-        <c:barDir val="bar"/>
-        <c:grouping val="clustered"/>
-        <c:varyColors val="0"/>
-        <c:ser>
-          <c:idx val="0"/>
-          <c:order val="0"/>
-          <c:tx>
-            <c:strRef>
-              <c:f>Sheet1!$B$1</c:f>
-              <c:strCache>
-                <c:ptCount val="1"/>
-                <c:pt idx="0">
-                  <c:v>AUROC</c:v>
-                </c:pt>
-              </c:strCache>
-            </c:strRef>
-          </c:tx>
-          <c:spPr>
-            <a:solidFill>
-              <a:srgbClr val="2A6FD6"/>
-            </a:solidFill>
-            <a:effectLst/>
-          </c:spPr>
-          <c:invertIfNegative val="0"/>
-          <c:dLbls>
-            <c:numFmt formatCode="0.00" sourceLinked="0"/>
-            <c:txPr>
-              <a:bodyPr/>
-              <a:lstStyle/>
-              <a:p>
-                <a:pPr>
-                  <a:defRPr b="0" i="0" strike="noStrike" sz="1500" u="none">
-                    <a:solidFill>
-                      <a:srgbClr val="12202E"/>
-                    </a:solidFill>
-                    <a:latin typeface="Arial"/>
-                  </a:defRPr>
-                </a:pPr>
-              </a:p>
-            </c:txPr>
-            <c:showLegendKey val="0"/>
-            <c:showVal val="1"/>
-            <c:showCatName val="0"/>
-            <c:showSerName val="0"/>
-            <c:showPercent val="0"/>
-            <c:showBubbleSize val="0"/>
-            <c:showLeaderLines val="0"/>
-          </c:dLbls>
-          <c:dPt>
-            <c:idx val="0"/>
-            <c:invertIfNegative val="0"/>
-            <c:bubble3D val="0"/>
-            <c:spPr>
-              <a:solidFill>
-                <a:srgbClr val="2A6FD6"/>
-              </a:solidFill>
-              <a:effectLst/>
-            </c:spPr>
-          </c:dPt>
-          <c:dPt>
-            <c:idx val="1"/>
-            <c:invertIfNegative val="0"/>
-            <c:bubble3D val="0"/>
-            <c:spPr>
-              <a:solidFill>
-                <a:srgbClr val="C4501B"/>
-              </a:solidFill>
-              <a:effectLst/>
-            </c:spPr>
-          </c:dPt>
-          <c:dPt>
-            <c:idx val="2"/>
-            <c:invertIfNegative val="0"/>
-            <c:bubble3D val="0"/>
-            <c:spPr>
-              <a:solidFill>
-                <a:srgbClr val="2A6FD6"/>
-              </a:solidFill>
-              <a:effectLst/>
-            </c:spPr>
-          </c:dPt>
-          <c:dPt>
-            <c:idx val="3"/>
-            <c:invertIfNegative val="0"/>
-            <c:bubble3D val="0"/>
-            <c:spPr>
-              <a:solidFill>
-                <a:srgbClr val="C4501B"/>
-              </a:solidFill>
-              <a:effectLst/>
-            </c:spPr>
-          </c:dPt>
-          <c:cat>
-            <c:multiLvlStrRef>
-              <c:f>Sheet1!$A$2:$A$5</c:f>
-              <c:multiLvlStrCache>
-                <c:ptCount val="4"/>
-                <c:lvl>
-                  <c:pt idx="0">
-                    <c:v>Masked panel, pooled</c:v>
-                  </c:pt>
-                  <c:pt idx="1">
-                    <c:v>Real assay, pooled</c:v>
-                  </c:pt>
-                  <c:pt idx="2">
-                    <c:v>Masked panel, per gene</c:v>
-                  </c:pt>
-                  <c:pt idx="3">
-                    <c:v>Real assay, per gene</c:v>
-                  </c:pt>
-                </c:lvl>
-              </c:multiLvlStrCache>
-            </c:multiLvlStrRef>
-          </c:cat>
-          <c:val>
-            <c:numRef>
-              <c:f>Sheet1!$B$2:$B$5</c:f>
-              <c:numCache>
-                <c:formatCode>General</c:formatCode>
-                <c:ptCount val="4"/>
-                <c:pt idx="0">
-                  <c:v>0.84</c:v>
-                </c:pt>
-                <c:pt idx="1">
-                  <c:v>0.7</c:v>
-                </c:pt>
-                <c:pt idx="2">
-                  <c:v>0.8</c:v>
-                </c:pt>
-                <c:pt idx="3">
-                  <c:v>0.61</c:v>
                 </c:pt>
               </c:numCache>
             </c:numRef>
@@ -1854,7 +1561,7 @@
         <p:spPr>
           <a:xfrm>
             <a:off x="571500" y="5212080"/>
-            <a:ext cx="7873344" cy="1147826"/>
+            <a:ext cx="7873344" cy="1084326"/>
           </a:xfrm>
           <a:prstGeom prst="rect">
             <a:avLst/>
@@ -1870,7 +1577,7 @@
               <a:buNone/>
             </a:pPr>
             <a:r>
-              <a:rPr lang="en-US" sz="1750" dirty="0">
+              <a:rPr lang="en-US" sz="1650" dirty="0">
                 <a:solidFill>
                   <a:srgbClr val="12202E"/>
                 </a:solidFill>
@@ -1880,7 +1587,7 @@
               </a:rPr>
               <a:t>Comprehensive genomic profiling (CGP) underpins treatment selection in NSCLC, yet panel content varies widely across institutions and health-care systems. Smaller targeted panels reduce cost and turnaround time but leave part of the tumour genome unmeasured.</a:t>
             </a:r>
-            <a:endParaRPr lang="en-US" sz="1750" dirty="0"/>
+            <a:endParaRPr lang="en-US" sz="1650" dirty="0"/>
           </a:p>
         </p:txBody>
       </p:sp>
@@ -1892,8 +1599,8 @@
         </p:nvSpPr>
         <p:spPr>
           <a:xfrm>
-            <a:off x="571500" y="6588506"/>
-            <a:ext cx="7873344" cy="1147826"/>
+            <a:off x="571500" y="6525006"/>
+            <a:ext cx="7873344" cy="1084326"/>
           </a:xfrm>
           <a:prstGeom prst="rect">
             <a:avLst/>
@@ -1909,7 +1616,7 @@
               <a:buNone/>
             </a:pPr>
             <a:r>
-              <a:rPr lang="en-US" sz="1750" b="1" dirty="0">
+              <a:rPr lang="en-US" sz="1650" b="1" dirty="0">
                 <a:solidFill>
                   <a:srgbClr val="12202E"/>
                 </a:solidFill>
@@ -1923,7 +1630,7 @@
               <a:buNone/>
             </a:pPr>
             <a:r>
-              <a:rPr lang="en-US" sz="1750" dirty="0">
+              <a:rPr lang="en-US" sz="1650" dirty="0">
                 <a:solidFill>
                   <a:srgbClr val="12202E"/>
                 </a:solidFill>
@@ -1933,7 +1640,7 @@
               </a:rPr>
               <a:t>To learn the conditional distribution of alterations in genes absent from a targeted panel given the genes it measures, to benchmark it against simple statistical baselines, and to identify which signals make the missing genes predictable.</a:t>
             </a:r>
-            <a:endParaRPr lang="en-US" sz="1750" dirty="0"/>
+            <a:endParaRPr lang="en-US" sz="1650" dirty="0"/>
           </a:p>
         </p:txBody>
       </p:sp>
@@ -1945,7 +1652,7 @@
         </p:nvSpPr>
         <p:spPr>
           <a:xfrm>
-            <a:off x="571500" y="8056372"/>
+            <a:off x="571500" y="7929372"/>
             <a:ext cx="7873344" cy="0"/>
           </a:xfrm>
           <a:prstGeom prst="line">
@@ -1968,7 +1675,7 @@
         </p:nvSpPr>
         <p:spPr>
           <a:xfrm>
-            <a:off x="571500" y="8147812"/>
+            <a:off x="571500" y="8020812"/>
             <a:ext cx="7873344" cy="566928"/>
           </a:xfrm>
           <a:prstGeom prst="rect">
@@ -2007,7 +1714,7 @@
         </p:nvSpPr>
         <p:spPr>
           <a:xfrm>
-            <a:off x="571500" y="8925052"/>
+            <a:off x="571500" y="8798052"/>
             <a:ext cx="5314507" cy="566928"/>
           </a:xfrm>
           <a:prstGeom prst="rect">
@@ -2027,7 +1734,7 @@
         </p:nvSpPr>
         <p:spPr>
           <a:xfrm>
-            <a:off x="571500" y="8925052"/>
+            <a:off x="571500" y="8798052"/>
             <a:ext cx="5314507" cy="566928"/>
           </a:xfrm>
           <a:prstGeom prst="rect">
@@ -2066,7 +1773,7 @@
         </p:nvSpPr>
         <p:spPr>
           <a:xfrm>
-            <a:off x="5886007" y="8925052"/>
+            <a:off x="5886007" y="8798052"/>
             <a:ext cx="2558837" cy="566928"/>
           </a:xfrm>
           <a:prstGeom prst="rect">
@@ -2091,7 +1798,7 @@
         </p:nvSpPr>
         <p:spPr>
           <a:xfrm>
-            <a:off x="5886007" y="8925052"/>
+            <a:off x="5886007" y="8798052"/>
             <a:ext cx="2558837" cy="566928"/>
           </a:xfrm>
           <a:prstGeom prst="rect">
@@ -2130,8 +1837,8 @@
         </p:nvSpPr>
         <p:spPr>
           <a:xfrm>
-            <a:off x="571500" y="9601708"/>
-            <a:ext cx="7873344" cy="481076"/>
+            <a:off x="571500" y="9474708"/>
+            <a:ext cx="7873344" cy="465201"/>
           </a:xfrm>
           <a:prstGeom prst="rect">
             <a:avLst/>
@@ -2147,7 +1854,7 @@
               <a:buNone/>
             </a:pPr>
             <a:r>
-              <a:rPr lang="en-US" sz="1400" b="1" dirty="0">
+              <a:rPr lang="en-US" sz="1350" b="1" dirty="0">
                 <a:solidFill>
                   <a:srgbClr val="3F4B57"/>
                 </a:solidFill>
@@ -2161,7 +1868,7 @@
               <a:buNone/>
             </a:pPr>
             <a:r>
-              <a:rPr lang="en-US" sz="1400" dirty="0">
+              <a:rPr lang="en-US" sz="1350" dirty="0">
                 <a:solidFill>
                   <a:srgbClr val="3F4B57"/>
                 </a:solidFill>
@@ -2171,7 +1878,7 @@
               </a:rPr>
               <a:t>Task definition. IMPACT341 ⊂ IMPACT505; the 164 genes present only in IMPACT505 are masked from the input and predicted.</a:t>
             </a:r>
-            <a:endParaRPr lang="en-US" sz="1400" dirty="0"/>
+            <a:endParaRPr lang="en-US" sz="1350" dirty="0"/>
           </a:p>
         </p:txBody>
       </p:sp>
@@ -2183,8 +1890,8 @@
         </p:nvSpPr>
         <p:spPr>
           <a:xfrm>
-            <a:off x="571500" y="10357104"/>
-            <a:ext cx="7873344" cy="258826"/>
+            <a:off x="571500" y="10214229"/>
+            <a:ext cx="7873344" cy="250888"/>
           </a:xfrm>
           <a:prstGeom prst="rect">
             <a:avLst/>
@@ -2200,7 +1907,7 @@
               <a:buNone/>
             </a:pPr>
             <a:r>
-              <a:rPr lang="en-US" sz="1400" b="1" dirty="0">
+              <a:rPr lang="en-US" sz="1350" b="1" dirty="0">
                 <a:solidFill>
                   <a:srgbClr val="3F4B57"/>
                 </a:solidFill>
@@ -2214,7 +1921,7 @@
               <a:buNone/>
             </a:pPr>
             <a:r>
-              <a:rPr lang="en-US" sz="1400" dirty="0">
+              <a:rPr lang="en-US" sz="1350" dirty="0">
                 <a:solidFill>
                   <a:srgbClr val="3F4B57"/>
                 </a:solidFill>
@@ -2224,7 +1931,7 @@
               </a:rPr>
               <a:t>Cohort and target characteristics (MSK-CHORD).</a:t>
             </a:r>
-            <a:endParaRPr lang="en-US" sz="1400" dirty="0"/>
+            <a:endParaRPr lang="en-US" sz="1350" dirty="0"/>
           </a:p>
         </p:txBody>
       </p:sp>
@@ -2243,7 +1950,7 @@
           </p:nvPr>
         </p:nvGraphicFramePr>
         <p:xfrm>
-          <a:off x="571500" y="10725658"/>
+          <a:off x="571500" y="10574846"/>
           <a:ext cx="7873344" cy="914400"/>
         </p:xfrm>
         <a:graphic>
@@ -3058,7 +2765,7 @@
         </p:nvSpPr>
         <p:spPr>
           <a:xfrm>
-            <a:off x="571500" y="10725658"/>
+            <a:off x="571500" y="10574846"/>
             <a:ext cx="7873344" cy="0"/>
           </a:xfrm>
           <a:prstGeom prst="line">
@@ -3081,7 +2788,7 @@
         </p:nvSpPr>
         <p:spPr>
           <a:xfrm>
-            <a:off x="571500" y="13029946"/>
+            <a:off x="571500" y="12879134"/>
             <a:ext cx="7873344" cy="0"/>
           </a:xfrm>
           <a:prstGeom prst="line">
@@ -3104,8 +2811,8 @@
         </p:nvSpPr>
         <p:spPr>
           <a:xfrm>
-            <a:off x="571500" y="13304266"/>
-            <a:ext cx="7873344" cy="1703451"/>
+            <a:off x="571500" y="13153454"/>
+            <a:ext cx="7873344" cy="1608201"/>
           </a:xfrm>
           <a:prstGeom prst="rect">
             <a:avLst/>
@@ -3121,7 +2828,7 @@
               <a:buNone/>
             </a:pPr>
             <a:r>
-              <a:rPr lang="en-US" sz="1750" b="1" dirty="0">
+              <a:rPr lang="en-US" sz="1650" b="1" dirty="0">
                 <a:solidFill>
                   <a:srgbClr val="12202E"/>
                 </a:solidFill>
@@ -3135,7 +2842,7 @@
               <a:buNone/>
             </a:pPr>
             <a:r>
-              <a:rPr lang="en-US" sz="1750" dirty="0">
+              <a:rPr lang="en-US" sz="1650" dirty="0">
                 <a:solidFill>
                   <a:srgbClr val="12202E"/>
                 </a:solidFill>
@@ -3145,7 +2852,7 @@
               </a:rPr>
               <a:t>Target: one binary event per gene and patient (non-synonymous mutation, amplification or deep deletion; [state VUS and structural-variant handling]). Input: separate mutation, amplification and deletion indicators for the 341 assayed genes. One sample per patient. Genes not covered by a sample's panel are treated as missing, never as wild type.</a:t>
             </a:r>
-            <a:endParaRPr lang="en-US" sz="1750" dirty="0"/>
+            <a:endParaRPr lang="en-US" sz="1650" dirty="0"/>
           </a:p>
         </p:txBody>
       </p:sp>
@@ -3220,7 +2927,7 @@
         <p:spPr>
           <a:xfrm>
             <a:off x="8966052" y="5212080"/>
-            <a:ext cx="7873344" cy="1703451"/>
+            <a:ext cx="7873344" cy="1608201"/>
           </a:xfrm>
           <a:prstGeom prst="rect">
             <a:avLst/>
@@ -3236,7 +2943,7 @@
               <a:buNone/>
             </a:pPr>
             <a:r>
-              <a:rPr lang="en-US" sz="1750" b="1" dirty="0">
+              <a:rPr lang="en-US" sz="1650" b="1" dirty="0">
                 <a:solidFill>
                   <a:srgbClr val="12202E"/>
                 </a:solidFill>
@@ -3250,7 +2957,7 @@
               <a:buNone/>
             </a:pPr>
             <a:r>
-              <a:rPr lang="en-US" sz="1750" dirty="0">
+              <a:rPr lang="en-US" sz="1650" dirty="0">
                 <a:solidFill>
                   <a:srgbClr val="12202E"/>
                 </a:solidFill>
@@ -3264,7 +2971,7 @@
               <a:buNone/>
             </a:pPr>
             <a:r>
-              <a:rPr lang="en-US" sz="1750" baseline="-40000" dirty="0">
+              <a:rPr lang="en-US" sz="1650" baseline="-40000" dirty="0">
                 <a:solidFill>
                   <a:srgbClr val="12202E"/>
                 </a:solidFill>
@@ -3278,7 +2985,7 @@
               <a:buNone/>
             </a:pPr>
             <a:r>
-              <a:rPr lang="en-US" sz="1750" dirty="0">
+              <a:rPr lang="en-US" sz="1650" dirty="0">
                 <a:solidFill>
                   <a:srgbClr val="12202E"/>
                 </a:solidFill>
@@ -3292,7 +2999,7 @@
               <a:buNone/>
             </a:pPr>
             <a:r>
-              <a:rPr lang="en-US" sz="1750" baseline="-40000" dirty="0">
+              <a:rPr lang="en-US" sz="1650" baseline="-40000" dirty="0">
                 <a:solidFill>
                   <a:srgbClr val="12202E"/>
                 </a:solidFill>
@@ -3306,7 +3013,7 @@
               <a:buNone/>
             </a:pPr>
             <a:r>
-              <a:rPr lang="en-US" sz="1750" dirty="0">
+              <a:rPr lang="en-US" sz="1650" dirty="0">
                 <a:solidFill>
                   <a:srgbClr val="12202E"/>
                 </a:solidFill>
@@ -3320,7 +3027,7 @@
               <a:buNone/>
             </a:pPr>
             <a:r>
-              <a:rPr lang="en-US" sz="1750" baseline="30000" dirty="0">
+              <a:rPr lang="en-US" sz="1650" baseline="30000" dirty="0">
                 <a:solidFill>
                   <a:srgbClr val="12202E"/>
                 </a:solidFill>
@@ -3334,7 +3041,7 @@
               <a:buNone/>
             </a:pPr>
             <a:r>
-              <a:rPr lang="en-US" sz="1750" dirty="0">
+              <a:rPr lang="en-US" sz="1650" dirty="0">
                 <a:solidFill>
                   <a:srgbClr val="12202E"/>
                 </a:solidFill>
@@ -3344,7 +3051,7 @@
               </a:rPr>
               <a:t> (continuous relaxation); generated profiles are binarised by sign. Data were split by patient into 70% training, 15% validation (all model and hyper-parameter selection) and 15% test, evaluated once.</a:t>
             </a:r>
-            <a:endParaRPr lang="en-US" sz="1750" dirty="0"/>
+            <a:endParaRPr lang="en-US" sz="1650" dirty="0"/>
           </a:p>
         </p:txBody>
       </p:sp>
@@ -3356,8 +3063,8 @@
         </p:nvSpPr>
         <p:spPr>
           <a:xfrm>
-            <a:off x="8966052" y="7144131"/>
-            <a:ext cx="7873344" cy="870014"/>
+            <a:off x="8966052" y="7048881"/>
+            <a:ext cx="7873344" cy="822389"/>
           </a:xfrm>
           <a:prstGeom prst="rect">
             <a:avLst/>
@@ -3373,7 +3080,7 @@
               <a:buNone/>
             </a:pPr>
             <a:r>
-              <a:rPr lang="en-US" sz="1750" b="1" dirty="0">
+              <a:rPr lang="en-US" sz="1650" b="1" dirty="0">
                 <a:solidFill>
                   <a:srgbClr val="12202E"/>
                 </a:solidFill>
@@ -3387,7 +3094,7 @@
               <a:buNone/>
             </a:pPr>
             <a:r>
-              <a:rPr lang="en-US" sz="1750" dirty="0">
+              <a:rPr lang="en-US" sz="1650" dirty="0">
                 <a:solidFill>
                   <a:srgbClr val="12202E"/>
                 </a:solidFill>
@@ -3401,7 +3108,7 @@
               <a:buNone/>
             </a:pPr>
             <a:r>
-              <a:rPr lang="en-US" sz="1750" baseline="-40000" dirty="0">
+              <a:rPr lang="en-US" sz="1650" baseline="-40000" dirty="0">
                 <a:solidFill>
                   <a:srgbClr val="12202E"/>
                 </a:solidFill>
@@ -3415,7 +3122,7 @@
               <a:buNone/>
             </a:pPr>
             <a:r>
-              <a:rPr lang="en-US" sz="1750" dirty="0">
+              <a:rPr lang="en-US" sz="1650" dirty="0">
                 <a:solidFill>
                   <a:srgbClr val="12202E"/>
                 </a:solidFill>
@@ -3425,7 +3132,7 @@
               </a:rPr>
               <a:t> ([architecture]) is regressed onto the straight-line path between Gaussian noise and data:</a:t>
             </a:r>
-            <a:endParaRPr lang="en-US" sz="1750" dirty="0"/>
+            <a:endParaRPr lang="en-US" sz="1650" dirty="0"/>
           </a:p>
         </p:txBody>
       </p:sp>
@@ -3437,7 +3144,7 @@
         </p:nvSpPr>
         <p:spPr>
           <a:xfrm>
-            <a:off x="8966052" y="8178737"/>
+            <a:off x="8966052" y="8035862"/>
             <a:ext cx="7873344" cy="960120"/>
           </a:xfrm>
           <a:prstGeom prst="rect">
@@ -3457,7 +3164,7 @@
         </p:nvSpPr>
         <p:spPr>
           <a:xfrm>
-            <a:off x="8966052" y="8288465"/>
+            <a:off x="8966052" y="8145590"/>
             <a:ext cx="7873344" cy="740664"/>
           </a:xfrm>
           <a:prstGeom prst="rect">
@@ -3791,7 +3498,7 @@
         </p:nvSpPr>
         <p:spPr>
           <a:xfrm>
-            <a:off x="8966052" y="9413177"/>
+            <a:off x="8966052" y="9270302"/>
             <a:ext cx="2153105" cy="685800"/>
           </a:xfrm>
           <a:prstGeom prst="rect">
@@ -3816,7 +3523,7 @@
         </p:nvSpPr>
         <p:spPr>
           <a:xfrm>
-            <a:off x="8966052" y="9413177"/>
+            <a:off x="8966052" y="9270302"/>
             <a:ext cx="2153105" cy="685800"/>
           </a:xfrm>
           <a:prstGeom prst="rect">
@@ -3883,7 +3590,7 @@
         </p:nvSpPr>
         <p:spPr>
           <a:xfrm>
-            <a:off x="11119157" y="9413177"/>
+            <a:off x="11119157" y="9270302"/>
             <a:ext cx="384048" cy="685800"/>
           </a:xfrm>
           <a:prstGeom prst="rect">
@@ -3922,7 +3629,7 @@
         </p:nvSpPr>
         <p:spPr>
           <a:xfrm>
-            <a:off x="11503205" y="9413177"/>
+            <a:off x="11503205" y="9270302"/>
             <a:ext cx="2799037" cy="685800"/>
           </a:xfrm>
           <a:prstGeom prst="rect">
@@ -3942,7 +3649,7 @@
         </p:nvSpPr>
         <p:spPr>
           <a:xfrm>
-            <a:off x="11503205" y="9413177"/>
+            <a:off x="11503205" y="9270302"/>
             <a:ext cx="2799037" cy="685800"/>
           </a:xfrm>
           <a:prstGeom prst="rect">
@@ -4037,7 +3744,7 @@
         </p:nvSpPr>
         <p:spPr>
           <a:xfrm>
-            <a:off x="14302243" y="9413177"/>
+            <a:off x="14302243" y="9270302"/>
             <a:ext cx="384048" cy="685800"/>
           </a:xfrm>
           <a:prstGeom prst="rect">
@@ -4076,7 +3783,7 @@
         </p:nvSpPr>
         <p:spPr>
           <a:xfrm>
-            <a:off x="14686291" y="9413177"/>
+            <a:off x="14686291" y="9270302"/>
             <a:ext cx="2153105" cy="685800"/>
           </a:xfrm>
           <a:prstGeom prst="rect">
@@ -4101,7 +3808,7 @@
         </p:nvSpPr>
         <p:spPr>
           <a:xfrm>
-            <a:off x="14686291" y="9413177"/>
+            <a:off x="14686291" y="9270302"/>
             <a:ext cx="2153105" cy="685800"/>
           </a:xfrm>
           <a:prstGeom prst="rect">
@@ -4182,7 +3889,7 @@
         </p:nvSpPr>
         <p:spPr>
           <a:xfrm>
-            <a:off x="10068320" y="10236137"/>
+            <a:off x="10068320" y="10093262"/>
             <a:ext cx="5668808" cy="457200"/>
           </a:xfrm>
           <a:prstGeom prst="rect">
@@ -4202,7 +3909,7 @@
         </p:nvSpPr>
         <p:spPr>
           <a:xfrm>
-            <a:off x="10068320" y="10236137"/>
+            <a:off x="10068320" y="10093262"/>
             <a:ext cx="5668808" cy="457200"/>
           </a:xfrm>
           <a:prstGeom prst="rect">
@@ -4241,8 +3948,8 @@
         </p:nvSpPr>
         <p:spPr>
           <a:xfrm>
-            <a:off x="8966052" y="10803065"/>
-            <a:ext cx="7873344" cy="703326"/>
+            <a:off x="8966052" y="10660190"/>
+            <a:ext cx="7873344" cy="465201"/>
           </a:xfrm>
           <a:prstGeom prst="rect">
             <a:avLst/>
@@ -4258,7 +3965,7 @@
               <a:buNone/>
             </a:pPr>
             <a:r>
-              <a:rPr lang="en-US" sz="1400" b="1" dirty="0">
+              <a:rPr lang="en-US" sz="1350" b="1" dirty="0">
                 <a:solidFill>
                   <a:srgbClr val="3F4B57"/>
                 </a:solidFill>
@@ -4272,7 +3979,7 @@
               <a:buNone/>
             </a:pPr>
             <a:r>
-              <a:rPr lang="en-US" sz="1400" dirty="0">
+              <a:rPr lang="en-US" sz="1350" dirty="0">
                 <a:solidFill>
                   <a:srgbClr val="3F4B57"/>
                 </a:solidFill>
@@ -4282,7 +3989,7 @@
               </a:rPr>
               <a:t>Sampling: the learned ODE, integrated from t = 0 to 1 ([solver, N steps]), transports noise to a completed 164-gene profile conditioned on the observed panel.</a:t>
             </a:r>
-            <a:endParaRPr lang="en-US" sz="1400" dirty="0"/>
+            <a:endParaRPr lang="en-US" sz="1350" dirty="0"/>
           </a:p>
         </p:txBody>
       </p:sp>
@@ -4294,8 +4001,8 @@
         </p:nvSpPr>
         <p:spPr>
           <a:xfrm>
-            <a:off x="8966052" y="11780711"/>
-            <a:ext cx="7873344" cy="1703451"/>
+            <a:off x="8966052" y="11399711"/>
+            <a:ext cx="7873344" cy="1608201"/>
           </a:xfrm>
           <a:prstGeom prst="rect">
             <a:avLst/>
@@ -4311,7 +4018,7 @@
               <a:buNone/>
             </a:pPr>
             <a:r>
-              <a:rPr lang="en-US" sz="1750" b="1" dirty="0">
+              <a:rPr lang="en-US" sz="1650" b="1" dirty="0">
                 <a:solidFill>
                   <a:srgbClr val="12202E"/>
                 </a:solidFill>
@@ -4325,7 +4032,7 @@
               <a:buNone/>
             </a:pPr>
             <a:r>
-              <a:rPr lang="en-US" sz="1750" dirty="0">
+              <a:rPr lang="en-US" sz="1650" dirty="0">
                 <a:solidFill>
                   <a:srgbClr val="12202E"/>
                 </a:solidFill>
@@ -4335,7 +4042,7 @@
               </a:rPr>
               <a:t>At t = 0 the path is independent of x₁, so the optimal field satisfies v*(x₀, 0 | c) = 𝔼[x₁ | c] − x₀. Per-gene probabilities p̂ = ½(1 + x₀ + vθ(x₀, 0 | c)), averaged over K noise draws, equal the infinite-sample Monte Carlo estimate without its 1/S resolution limit, which at ~1% prevalence ties most pairs at 0. [state read-out used]</a:t>
             </a:r>
-            <a:endParaRPr lang="en-US" sz="1750" dirty="0"/>
+            <a:endParaRPr lang="en-US" sz="1650" dirty="0"/>
           </a:p>
         </p:txBody>
       </p:sp>
@@ -4347,8 +4054,8 @@
         </p:nvSpPr>
         <p:spPr>
           <a:xfrm>
-            <a:off x="8966052" y="13712762"/>
-            <a:ext cx="7873344" cy="2814701"/>
+            <a:off x="8966052" y="13236512"/>
+            <a:ext cx="7873344" cy="3179826"/>
           </a:xfrm>
           <a:prstGeom prst="rect">
             <a:avLst/>
@@ -4364,7 +4071,7 @@
               <a:buNone/>
             </a:pPr>
             <a:r>
-              <a:rPr lang="en-US" sz="1750" b="1" dirty="0">
+              <a:rPr lang="en-US" sz="1650" b="1" dirty="0">
                 <a:solidFill>
                   <a:srgbClr val="12202E"/>
                 </a:solidFill>
@@ -4378,17 +4085,17 @@
               <a:buNone/>
             </a:pPr>
             <a:r>
-              <a:rPr lang="en-US" sz="1750" dirty="0">
-                <a:solidFill>
-                  <a:srgbClr val="12202E"/>
-                </a:solidFill>
-                <a:latin typeface="Calibri" pitchFamily="34" charset="0"/>
-                <a:ea typeface="Calibri" pitchFamily="34" charset="-122"/>
-                <a:cs typeface="Calibri" pitchFamily="34" charset="-120"/>
-              </a:rPr>
-              <a:t>Discrimination: AUROC pooled over gene–patient pairs (primary) and per gene (genes with ≥5 test events), where a prevalence-only predictor scores exactly 0.50. Class imbalance: AUPRC against the prevalence of 0.012. Calibration: Brier skill score and observed:expected ratio. Joint fidelity, the property that justifies a generative model: energy score of sampled profiles versus independent Bernoulli draws from the same marginals. Comparators on identical splits: prevalence; burden + locus (3 burden counts and copy-number state of the nearest assayed gene); L2 logistic regression. 95% CIs and paired differences by patient-level bootstrap.</a:t>
-            </a:r>
-            <a:endParaRPr lang="en-US" sz="1750" dirty="0"/>
+              <a:rPr lang="en-US" sz="1650" dirty="0">
+                <a:solidFill>
+                  <a:srgbClr val="12202E"/>
+                </a:solidFill>
+                <a:latin typeface="Calibri" pitchFamily="34" charset="0"/>
+                <a:ea typeface="Calibri" pitchFamily="34" charset="-122"/>
+                <a:cs typeface="Calibri" pitchFamily="34" charset="-120"/>
+              </a:rPr>
+              <a:t>Discrimination: AUROC pooled over gene–patient pairs (primary) and per gene (genes with ≥5 test events), where a prevalence-only predictor scores exactly 0.50. Class imbalance: AUPRC against the prevalence of 0.012. Calibration: slope, intercept, observed:expected (O:E) ratio and Brier skill score. Intended-use operating point (EBAI class B): sensitivity, specificity, PPV, NPV and LR± for ≥1 altered target gene. Joint fidelity, the property that justifies a generative model: energy score of sampled profiles versus independent Bernoulli draws from the same marginals. Comparators on identical splits: prevalence; burden + locus (3 burden counts and copy-number state of the nearest assayed gene); L2 logistic regression. 95% CIs and paired differences by patient-level bootstrap.</a:t>
+            </a:r>
+            <a:endParaRPr lang="en-US" sz="1650" dirty="0"/>
           </a:p>
         </p:txBody>
       </p:sp>
@@ -4400,8 +4107,8 @@
         </p:nvSpPr>
         <p:spPr>
           <a:xfrm>
-            <a:off x="8966052" y="16756063"/>
-            <a:ext cx="7873344" cy="870014"/>
+            <a:off x="8966052" y="16644938"/>
+            <a:ext cx="7873344" cy="822389"/>
           </a:xfrm>
           <a:prstGeom prst="rect">
             <a:avLst/>
@@ -4417,7 +4124,7 @@
               <a:buNone/>
             </a:pPr>
             <a:r>
-              <a:rPr lang="en-US" sz="1750" b="1" dirty="0">
+              <a:rPr lang="en-US" sz="1650" b="1" dirty="0">
                 <a:solidFill>
                   <a:srgbClr val="12202E"/>
                 </a:solidFill>
@@ -4431,7 +4138,7 @@
               <a:buNone/>
             </a:pPr>
             <a:r>
-              <a:rPr lang="en-US" sz="1750" dirty="0">
+              <a:rPr lang="en-US" sz="1650" dirty="0">
                 <a:solidFill>
                   <a:srgbClr val="12202E"/>
                 </a:solidFill>
@@ -4441,7 +4148,7 @@
               </a:rPr>
               <a:t>MSK-IMPACT 2017 (cBioPortal, ODbL): IMPACT341 → 69 IMPACT410-only genes in 1,215 NSCLC patients; 3 × 5-fold patient-level cross-validation, AUROC computed within folds.</a:t>
             </a:r>
-            <a:endParaRPr lang="en-US" sz="1750" dirty="0"/>
+            <a:endParaRPr lang="en-US" sz="1650" dirty="0"/>
           </a:p>
         </p:txBody>
       </p:sp>
@@ -4516,7 +4223,7 @@
         <p:spPr>
           <a:xfrm>
             <a:off x="17360604" y="5212080"/>
-            <a:ext cx="7873344" cy="870014"/>
+            <a:ext cx="7873344" cy="822389"/>
           </a:xfrm>
           <a:prstGeom prst="rect">
             <a:avLst/>
@@ -4532,7 +4239,7 @@
               <a:buNone/>
             </a:pPr>
             <a:r>
-              <a:rPr lang="en-US" sz="1750" b="1" dirty="0">
+              <a:rPr lang="en-US" sz="1650" b="1" dirty="0">
                 <a:solidFill>
                   <a:srgbClr val="12202E"/>
                 </a:solidFill>
@@ -4546,7 +4253,7 @@
               <a:buNone/>
             </a:pPr>
             <a:r>
-              <a:rPr lang="en-US" sz="1750" dirty="0">
+              <a:rPr lang="en-US" sz="1650" dirty="0">
                 <a:solidFill>
                   <a:srgbClr val="12202E"/>
                 </a:solidFill>
@@ -4556,7 +4263,7 @@
               </a:rPr>
               <a:t>Across architectures and training paradigms, the flow model reached a pooled test AUROC of 0.77–0.79, above the prevalence-only baseline in every variant (Table 2).</a:t>
             </a:r>
-            <a:endParaRPr lang="en-US" sz="1750" dirty="0"/>
+            <a:endParaRPr lang="en-US" sz="1650" dirty="0"/>
           </a:p>
         </p:txBody>
       </p:sp>
@@ -4568,8 +4275,8 @@
         </p:nvSpPr>
         <p:spPr>
           <a:xfrm>
-            <a:off x="17360604" y="6310694"/>
-            <a:ext cx="7873344" cy="481076"/>
+            <a:off x="17360604" y="6263069"/>
+            <a:ext cx="7873344" cy="465201"/>
           </a:xfrm>
           <a:prstGeom prst="rect">
             <a:avLst/>
@@ -4585,7 +4292,7 @@
               <a:buNone/>
             </a:pPr>
             <a:r>
-              <a:rPr lang="en-US" sz="1400" b="1" dirty="0">
+              <a:rPr lang="en-US" sz="1350" b="1" dirty="0">
                 <a:solidFill>
                   <a:srgbClr val="3F4B57"/>
                 </a:solidFill>
@@ -4599,7 +4306,7 @@
               <a:buNone/>
             </a:pPr>
             <a:r>
-              <a:rPr lang="en-US" sz="1400" dirty="0">
+              <a:rPr lang="en-US" sz="1350" dirty="0">
                 <a:solidFill>
                   <a:srgbClr val="3F4B57"/>
                 </a:solidFill>
@@ -4609,7 +4316,7 @@
               </a:rPr>
               <a:t>MSK-CHORD test set: AUROC pooled and per gene, and AUPRC (chance level = prevalence, 0.012); point estimate (95% CI).</a:t>
             </a:r>
-            <a:endParaRPr lang="en-US" sz="1400" dirty="0"/>
+            <a:endParaRPr lang="en-US" sz="1350" dirty="0"/>
           </a:p>
         </p:txBody>
       </p:sp>
@@ -4628,7 +4335,7 @@
           </p:nvPr>
         </p:nvGraphicFramePr>
         <p:xfrm>
-          <a:off x="17360604" y="6901498"/>
+          <a:off x="17360604" y="6837998"/>
           <a:ext cx="7873344" cy="914400"/>
         </p:xfrm>
         <a:graphic>
@@ -5963,7 +5670,7 @@
         </p:nvSpPr>
         <p:spPr>
           <a:xfrm>
-            <a:off x="17360604" y="6901498"/>
+            <a:off x="17360604" y="6837998"/>
             <a:ext cx="7873344" cy="0"/>
           </a:xfrm>
           <a:prstGeom prst="line">
@@ -5986,7 +5693,7 @@
         </p:nvSpPr>
         <p:spPr>
           <a:xfrm>
-            <a:off x="17360604" y="7322122"/>
+            <a:off x="17360604" y="7258622"/>
             <a:ext cx="7873344" cy="0"/>
           </a:xfrm>
           <a:prstGeom prst="line">
@@ -6009,7 +5716,7 @@
         </p:nvSpPr>
         <p:spPr>
           <a:xfrm>
-            <a:off x="17360604" y="9004618"/>
+            <a:off x="17360604" y="8941118"/>
             <a:ext cx="7873344" cy="0"/>
           </a:xfrm>
           <a:prstGeom prst="line">
@@ -6032,8 +5739,8 @@
         </p:nvSpPr>
         <p:spPr>
           <a:xfrm>
-            <a:off x="17360604" y="9233218"/>
-            <a:ext cx="7873344" cy="592201"/>
+            <a:off x="17360604" y="9169718"/>
+            <a:ext cx="7873344" cy="560451"/>
           </a:xfrm>
           <a:prstGeom prst="rect">
             <a:avLst/>
@@ -6049,7 +5756,7 @@
               <a:buNone/>
             </a:pPr>
             <a:r>
-              <a:rPr lang="en-US" sz="1750" b="1" dirty="0">
+              <a:rPr lang="en-US" sz="1650" b="1" dirty="0">
                 <a:solidFill>
                   <a:srgbClr val="12202E"/>
                 </a:solidFill>
@@ -6063,7 +5770,7 @@
               <a:buNone/>
             </a:pPr>
             <a:r>
-              <a:rPr lang="en-US" sz="1750" dirty="0">
+              <a:rPr lang="en-US" sz="1650" dirty="0">
                 <a:solidFill>
                   <a:srgbClr val="12202E"/>
                 </a:solidFill>
@@ -6077,7 +5784,7 @@
               <a:buNone/>
             </a:pPr>
             <a:r>
-              <a:rPr lang="en-US" sz="1750" dirty="0">
+              <a:rPr lang="en-US" sz="1650" dirty="0">
                 <a:solidFill>
                   <a:srgbClr val="A3410F"/>
                 </a:solidFill>
@@ -6091,7 +5798,7 @@
               <a:buNone/>
             </a:pPr>
             <a:r>
-              <a:rPr lang="en-US" sz="1750" dirty="0">
+              <a:rPr lang="en-US" sz="1650" dirty="0">
                 <a:solidFill>
                   <a:srgbClr val="12202E"/>
                 </a:solidFill>
@@ -6105,7 +5812,7 @@
               <a:buNone/>
             </a:pPr>
             <a:r>
-              <a:rPr lang="en-US" sz="1750" dirty="0">
+              <a:rPr lang="en-US" sz="1650" dirty="0">
                 <a:solidFill>
                   <a:srgbClr val="A3410F"/>
                 </a:solidFill>
@@ -6119,7 +5826,7 @@
               <a:buNone/>
             </a:pPr>
             <a:r>
-              <a:rPr lang="en-US" sz="1750" dirty="0">
+              <a:rPr lang="en-US" sz="1650" dirty="0">
                 <a:solidFill>
                   <a:srgbClr val="12202E"/>
                 </a:solidFill>
@@ -6129,7 +5836,7 @@
               </a:rPr>
               <a:t>.</a:t>
             </a:r>
-            <a:endParaRPr lang="en-US" sz="1750" dirty="0"/>
+            <a:endParaRPr lang="en-US" sz="1650" dirty="0"/>
           </a:p>
         </p:txBody>
       </p:sp>
@@ -6141,8 +5848,8 @@
         </p:nvSpPr>
         <p:spPr>
           <a:xfrm>
-            <a:off x="17360604" y="10099739"/>
-            <a:ext cx="7873344" cy="1425639"/>
+            <a:off x="17360604" y="10004489"/>
+            <a:ext cx="7873344" cy="1346264"/>
           </a:xfrm>
           <a:prstGeom prst="rect">
             <a:avLst/>
@@ -6158,7 +5865,7 @@
               <a:buNone/>
             </a:pPr>
             <a:r>
-              <a:rPr lang="en-US" sz="1750" b="1" dirty="0">
+              <a:rPr lang="en-US" sz="1650" b="1" dirty="0">
                 <a:solidFill>
                   <a:srgbClr val="12202E"/>
                 </a:solidFill>
@@ -6172,7 +5879,7 @@
               <a:buNone/>
             </a:pPr>
             <a:r>
-              <a:rPr lang="en-US" sz="1750" dirty="0">
+              <a:rPr lang="en-US" sz="1650" dirty="0">
                 <a:solidFill>
                   <a:srgbClr val="12202E"/>
                 </a:solidFill>
@@ -6182,7 +5889,7 @@
               </a:rPr>
               <a:t>Pooled AUROC compares pairs across genes, so ranking genes by training frequency alone scores 0.715. Per gene, a 7-feature model matches 1,026-feature logistic regression (0.760 vs 0.728), and pan-cancer training adds +0.039 (95% CI 0.024–0.057; Figure 3).</a:t>
             </a:r>
-            <a:endParaRPr lang="en-US" sz="1750" dirty="0"/>
+            <a:endParaRPr lang="en-US" sz="1650" dirty="0"/>
           </a:p>
         </p:txBody>
       </p:sp>
@@ -6194,7 +5901,7 @@
         </p:nvSpPr>
         <p:spPr>
           <a:xfrm>
-            <a:off x="17360604" y="11808841"/>
+            <a:off x="17360604" y="11634216"/>
             <a:ext cx="146304" cy="146304"/>
           </a:xfrm>
           <a:prstGeom prst="ellipse">
@@ -6214,7 +5921,7 @@
         </p:nvSpPr>
         <p:spPr>
           <a:xfrm>
-            <a:off x="17580060" y="11753977"/>
+            <a:off x="17580060" y="11579352"/>
             <a:ext cx="2011680" cy="274320"/>
           </a:xfrm>
           <a:prstGeom prst="rect">
@@ -6253,7 +5960,7 @@
         </p:nvSpPr>
         <p:spPr>
           <a:xfrm>
-            <a:off x="19646604" y="11817985"/>
+            <a:off x="19646604" y="11643360"/>
             <a:ext cx="128016" cy="128016"/>
           </a:xfrm>
           <a:prstGeom prst="rect">
@@ -6273,7 +5980,7 @@
         </p:nvSpPr>
         <p:spPr>
           <a:xfrm>
-            <a:off x="19847772" y="11753977"/>
+            <a:off x="19847772" y="11579352"/>
             <a:ext cx="2103120" cy="274320"/>
           </a:xfrm>
           <a:prstGeom prst="rect">
@@ -6312,7 +6019,7 @@
         </p:nvSpPr>
         <p:spPr>
           <a:xfrm>
-            <a:off x="22024044" y="11753977"/>
+            <a:off x="22024044" y="11579352"/>
             <a:ext cx="2103120" cy="274320"/>
           </a:xfrm>
           <a:prstGeom prst="rect">
@@ -6351,7 +6058,7 @@
         </p:nvSpPr>
         <p:spPr>
           <a:xfrm>
-            <a:off x="17360604" y="12165457"/>
+            <a:off x="17360604" y="11990832"/>
             <a:ext cx="2240280" cy="676656"/>
           </a:xfrm>
           <a:prstGeom prst="rect">
@@ -6390,7 +6097,7 @@
         </p:nvSpPr>
         <p:spPr>
           <a:xfrm>
-            <a:off x="22544246" y="12366625"/>
+            <a:off x="22544246" y="12192000"/>
             <a:ext cx="537377" cy="0"/>
           </a:xfrm>
           <a:prstGeom prst="line">
@@ -6413,7 +6120,7 @@
         </p:nvSpPr>
         <p:spPr>
           <a:xfrm>
-            <a:off x="22759637" y="12288901"/>
+            <a:off x="22759637" y="12114276"/>
             <a:ext cx="155448" cy="155448"/>
           </a:xfrm>
           <a:prstGeom prst="ellipse">
@@ -6433,7 +6140,7 @@
         </p:nvSpPr>
         <p:spPr>
           <a:xfrm>
-            <a:off x="23136487" y="12256897"/>
+            <a:off x="23136487" y="12082272"/>
             <a:ext cx="640080" cy="219456"/>
           </a:xfrm>
           <a:prstGeom prst="rect">
@@ -6472,7 +6179,7 @@
         </p:nvSpPr>
         <p:spPr>
           <a:xfrm>
-            <a:off x="20147532" y="12576937"/>
+            <a:off x="20147532" y="12402312"/>
             <a:ext cx="128016" cy="128016"/>
           </a:xfrm>
           <a:prstGeom prst="rect">
@@ -6492,7 +6199,7 @@
         </p:nvSpPr>
         <p:spPr>
           <a:xfrm>
-            <a:off x="20330412" y="12531217"/>
+            <a:off x="20330412" y="12356592"/>
             <a:ext cx="640080" cy="219456"/>
           </a:xfrm>
           <a:prstGeom prst="rect">
@@ -6531,7 +6238,7 @@
         </p:nvSpPr>
         <p:spPr>
           <a:xfrm>
-            <a:off x="17360604" y="12842113"/>
+            <a:off x="17360604" y="12667488"/>
             <a:ext cx="7873344" cy="0"/>
           </a:xfrm>
           <a:prstGeom prst="line">
@@ -6554,7 +6261,7 @@
         </p:nvSpPr>
         <p:spPr>
           <a:xfrm>
-            <a:off x="17360604" y="12842113"/>
+            <a:off x="17360604" y="12667488"/>
             <a:ext cx="2240280" cy="676656"/>
           </a:xfrm>
           <a:prstGeom prst="rect">
@@ -6593,7 +6300,7 @@
         </p:nvSpPr>
         <p:spPr>
           <a:xfrm>
-            <a:off x="23081623" y="13043281"/>
+            <a:off x="23081623" y="12868656"/>
             <a:ext cx="537377" cy="0"/>
           </a:xfrm>
           <a:prstGeom prst="line">
@@ -6616,7 +6323,7 @@
         </p:nvSpPr>
         <p:spPr>
           <a:xfrm>
-            <a:off x="23309227" y="12965557"/>
+            <a:off x="23309227" y="12790932"/>
             <a:ext cx="155448" cy="155448"/>
           </a:xfrm>
           <a:prstGeom prst="ellipse">
@@ -6636,7 +6343,7 @@
         </p:nvSpPr>
         <p:spPr>
           <a:xfrm>
-            <a:off x="23673864" y="12933553"/>
+            <a:off x="23673864" y="12758928"/>
             <a:ext cx="640080" cy="219456"/>
           </a:xfrm>
           <a:prstGeom prst="rect">
@@ -6675,7 +6382,7 @@
         </p:nvSpPr>
         <p:spPr>
           <a:xfrm>
-            <a:off x="23093836" y="13317601"/>
+            <a:off x="23093836" y="13142976"/>
             <a:ext cx="598443" cy="0"/>
           </a:xfrm>
           <a:prstGeom prst="line">
@@ -6698,7 +6405,7 @@
         </p:nvSpPr>
         <p:spPr>
           <a:xfrm>
-            <a:off x="23322943" y="13253593"/>
+            <a:off x="23322943" y="13078968"/>
             <a:ext cx="128016" cy="128016"/>
           </a:xfrm>
           <a:prstGeom prst="rect">
@@ -6718,7 +6425,7 @@
         </p:nvSpPr>
         <p:spPr>
           <a:xfrm>
-            <a:off x="23747143" y="13207873"/>
+            <a:off x="23747143" y="13033248"/>
             <a:ext cx="640080" cy="219456"/>
           </a:xfrm>
           <a:prstGeom prst="rect">
@@ -6757,7 +6464,7 @@
         </p:nvSpPr>
         <p:spPr>
           <a:xfrm>
-            <a:off x="17360604" y="13518769"/>
+            <a:off x="17360604" y="13344144"/>
             <a:ext cx="7873344" cy="0"/>
           </a:xfrm>
           <a:prstGeom prst="line">
@@ -6780,7 +6487,7 @@
         </p:nvSpPr>
         <p:spPr>
           <a:xfrm>
-            <a:off x="17360604" y="13518769"/>
+            <a:off x="17360604" y="13344144"/>
             <a:ext cx="2240280" cy="676656"/>
           </a:xfrm>
           <a:prstGeom prst="rect">
@@ -6819,7 +6526,7 @@
         </p:nvSpPr>
         <p:spPr>
           <a:xfrm>
-            <a:off x="23313672" y="13719937"/>
+            <a:off x="23313672" y="13545312"/>
             <a:ext cx="512951" cy="0"/>
           </a:xfrm>
           <a:prstGeom prst="line">
@@ -6842,7 +6549,7 @@
         </p:nvSpPr>
         <p:spPr>
           <a:xfrm>
-            <a:off x="23529063" y="13642213"/>
+            <a:off x="23529063" y="13467588"/>
             <a:ext cx="155448" cy="155448"/>
           </a:xfrm>
           <a:prstGeom prst="ellipse">
@@ -6862,7 +6569,7 @@
         </p:nvSpPr>
         <p:spPr>
           <a:xfrm>
-            <a:off x="23881488" y="13610209"/>
+            <a:off x="23881488" y="13435584"/>
             <a:ext cx="640080" cy="219456"/>
           </a:xfrm>
           <a:prstGeom prst="rect">
@@ -6901,7 +6608,7 @@
         </p:nvSpPr>
         <p:spPr>
           <a:xfrm>
-            <a:off x="22715230" y="13994257"/>
+            <a:off x="22715230" y="13819632"/>
             <a:ext cx="586230" cy="0"/>
           </a:xfrm>
           <a:prstGeom prst="line">
@@ -6924,7 +6631,7 @@
         </p:nvSpPr>
         <p:spPr>
           <a:xfrm>
-            <a:off x="22932123" y="13930249"/>
+            <a:off x="22932123" y="13755624"/>
             <a:ext cx="128016" cy="128016"/>
           </a:xfrm>
           <a:prstGeom prst="rect">
@@ -6944,7 +6651,7 @@
         </p:nvSpPr>
         <p:spPr>
           <a:xfrm>
-            <a:off x="23356323" y="13884529"/>
+            <a:off x="23356323" y="13709904"/>
             <a:ext cx="640080" cy="219456"/>
           </a:xfrm>
           <a:prstGeom prst="rect">
@@ -6983,7 +6690,7 @@
         </p:nvSpPr>
         <p:spPr>
           <a:xfrm>
-            <a:off x="17360604" y="14195425"/>
+            <a:off x="17360604" y="14020800"/>
             <a:ext cx="7873344" cy="0"/>
           </a:xfrm>
           <a:prstGeom prst="line">
@@ -7006,7 +6713,7 @@
         </p:nvSpPr>
         <p:spPr>
           <a:xfrm>
-            <a:off x="17360604" y="14195425"/>
+            <a:off x="17360604" y="14020800"/>
             <a:ext cx="2240280" cy="676656"/>
           </a:xfrm>
           <a:prstGeom prst="rect">
@@ -7045,7 +6752,7 @@
         </p:nvSpPr>
         <p:spPr>
           <a:xfrm>
-            <a:off x="23765558" y="14396593"/>
+            <a:off x="23765558" y="14221968"/>
             <a:ext cx="464099" cy="0"/>
           </a:xfrm>
           <a:prstGeom prst="line">
@@ -7068,7 +6775,7 @@
         </p:nvSpPr>
         <p:spPr>
           <a:xfrm>
-            <a:off x="23895457" y="14318869"/>
+            <a:off x="23895457" y="14144244"/>
             <a:ext cx="155448" cy="155448"/>
           </a:xfrm>
           <a:prstGeom prst="ellipse">
@@ -7088,7 +6795,7 @@
         </p:nvSpPr>
         <p:spPr>
           <a:xfrm>
-            <a:off x="24284520" y="14286865"/>
+            <a:off x="24284520" y="14112240"/>
             <a:ext cx="640080" cy="219456"/>
           </a:xfrm>
           <a:prstGeom prst="rect">
@@ -7127,7 +6834,7 @@
         </p:nvSpPr>
         <p:spPr>
           <a:xfrm>
-            <a:off x="23154902" y="14670913"/>
+            <a:off x="23154902" y="14496288"/>
             <a:ext cx="598443" cy="0"/>
           </a:xfrm>
           <a:prstGeom prst="line">
@@ -7150,7 +6857,7 @@
         </p:nvSpPr>
         <p:spPr>
           <a:xfrm>
-            <a:off x="23408435" y="14606905"/>
+            <a:off x="23408435" y="14432280"/>
             <a:ext cx="128016" cy="128016"/>
           </a:xfrm>
           <a:prstGeom prst="rect">
@@ -7170,7 +6877,7 @@
         </p:nvSpPr>
         <p:spPr>
           <a:xfrm>
-            <a:off x="23808209" y="14561185"/>
+            <a:off x="23808209" y="14386560"/>
             <a:ext cx="640080" cy="219456"/>
           </a:xfrm>
           <a:prstGeom prst="rect">
@@ -7209,7 +6916,7 @@
         </p:nvSpPr>
         <p:spPr>
           <a:xfrm>
-            <a:off x="17360604" y="14872081"/>
+            <a:off x="17360604" y="14697456"/>
             <a:ext cx="7873344" cy="0"/>
           </a:xfrm>
           <a:prstGeom prst="line">
@@ -7232,7 +6939,7 @@
         </p:nvSpPr>
         <p:spPr>
           <a:xfrm>
-            <a:off x="20211540" y="12165457"/>
+            <a:off x="20211540" y="11990832"/>
             <a:ext cx="0" cy="2706624"/>
           </a:xfrm>
           <a:prstGeom prst="line">
@@ -7255,7 +6962,7 @@
         </p:nvSpPr>
         <p:spPr>
           <a:xfrm>
-            <a:off x="19937220" y="14917801"/>
+            <a:off x="19937220" y="14743176"/>
             <a:ext cx="548640" cy="228600"/>
           </a:xfrm>
           <a:prstGeom prst="rect">
@@ -7294,7 +7001,7 @@
         </p:nvSpPr>
         <p:spPr>
           <a:xfrm>
-            <a:off x="21432852" y="12165457"/>
+            <a:off x="21432852" y="11990832"/>
             <a:ext cx="0" cy="2706624"/>
           </a:xfrm>
           <a:prstGeom prst="line">
@@ -7317,7 +7024,7 @@
         </p:nvSpPr>
         <p:spPr>
           <a:xfrm>
-            <a:off x="21158532" y="14917801"/>
+            <a:off x="21158532" y="14743176"/>
             <a:ext cx="548640" cy="228600"/>
           </a:xfrm>
           <a:prstGeom prst="rect">
@@ -7356,7 +7063,7 @@
         </p:nvSpPr>
         <p:spPr>
           <a:xfrm>
-            <a:off x="22654164" y="12165457"/>
+            <a:off x="22654164" y="11990832"/>
             <a:ext cx="0" cy="2706624"/>
           </a:xfrm>
           <a:prstGeom prst="line">
@@ -7379,7 +7086,7 @@
         </p:nvSpPr>
         <p:spPr>
           <a:xfrm>
-            <a:off x="22379844" y="14917801"/>
+            <a:off x="22379844" y="14743176"/>
             <a:ext cx="548640" cy="228600"/>
           </a:xfrm>
           <a:prstGeom prst="rect">
@@ -7418,7 +7125,7 @@
         </p:nvSpPr>
         <p:spPr>
           <a:xfrm>
-            <a:off x="23875476" y="12165457"/>
+            <a:off x="23875476" y="11990832"/>
             <a:ext cx="0" cy="2706624"/>
           </a:xfrm>
           <a:prstGeom prst="line">
@@ -7441,7 +7148,7 @@
         </p:nvSpPr>
         <p:spPr>
           <a:xfrm>
-            <a:off x="23601156" y="14917801"/>
+            <a:off x="23601156" y="14743176"/>
             <a:ext cx="548640" cy="228600"/>
           </a:xfrm>
           <a:prstGeom prst="rect">
@@ -7480,7 +7187,7 @@
         </p:nvSpPr>
         <p:spPr>
           <a:xfrm>
-            <a:off x="25096788" y="12165457"/>
+            <a:off x="25096788" y="11990832"/>
             <a:ext cx="0" cy="2706624"/>
           </a:xfrm>
           <a:prstGeom prst="line">
@@ -7503,7 +7210,7 @@
         </p:nvSpPr>
         <p:spPr>
           <a:xfrm>
-            <a:off x="24822468" y="14917801"/>
+            <a:off x="24822468" y="14743176"/>
             <a:ext cx="548640" cy="228600"/>
           </a:xfrm>
           <a:prstGeom prst="rect">
@@ -7542,8 +7249,8 @@
         </p:nvSpPr>
         <p:spPr>
           <a:xfrm>
-            <a:off x="17360604" y="15237841"/>
-            <a:ext cx="7873344" cy="481076"/>
+            <a:off x="17360604" y="15063216"/>
+            <a:ext cx="7873344" cy="465201"/>
           </a:xfrm>
           <a:prstGeom prst="rect">
             <a:avLst/>
@@ -7559,7 +7266,7 @@
               <a:buNone/>
             </a:pPr>
             <a:r>
-              <a:rPr lang="en-US" sz="1400" b="1" dirty="0">
+              <a:rPr lang="en-US" sz="1350" b="1" dirty="0">
                 <a:solidFill>
                   <a:srgbClr val="3F4B57"/>
                 </a:solidFill>
@@ -7573,7 +7280,7 @@
               <a:buNone/>
             </a:pPr>
             <a:r>
-              <a:rPr lang="en-US" sz="1400" dirty="0">
+              <a:rPr lang="en-US" sz="1350" dirty="0">
                 <a:solidFill>
                   <a:srgbClr val="3F4B57"/>
                 </a:solidFill>
@@ -7583,13 +7290,66 @@
               </a:rPr>
               <a:t>Replicate (n = 1,215): AUROC with patient-bootstrap 95% CI. Pan-cancer: trained on 7,773 patients with cancer type as covariate.</a:t>
             </a:r>
-            <a:endParaRPr lang="en-US" sz="1400" dirty="0"/>
+            <a:endParaRPr lang="en-US" sz="1350" dirty="0"/>
           </a:p>
         </p:txBody>
       </p:sp>
       <p:sp>
         <p:nvSpPr>
-          <p:cNvPr id="102" name="Shape 98"/>
+          <p:cNvPr id="102" name="Text 98"/>
+          <p:cNvSpPr txBox="1"/>
+          <p:nvPr/>
+        </p:nvSpPr>
+        <p:spPr>
+          <a:xfrm>
+            <a:off x="17360604" y="15802737"/>
+            <a:ext cx="7873344" cy="1608201"/>
+          </a:xfrm>
+          <a:prstGeom prst="rect">
+            <a:avLst/>
+          </a:prstGeom>
+          <a:noFill/>
+          <a:ln/>
+        </p:spPr>
+        <p:txBody>
+          <a:bodyPr wrap="square" lIns="0" tIns="0" rIns="0" bIns="0" rtlCol="0" anchor="t"/>
+          <a:lstStyle/>
+          <a:p>
+            <a:pPr indent="0" marL="0">
+              <a:buNone/>
+            </a:pPr>
+            <a:r>
+              <a:rPr lang="en-US" sz="1650" b="1" dirty="0">
+                <a:solidFill>
+                  <a:srgbClr val="12202E"/>
+                </a:solidFill>
+                <a:latin typeface="Calibri" pitchFamily="34" charset="0"/>
+                <a:ea typeface="Calibri" pitchFamily="34" charset="-122"/>
+                <a:cs typeface="Calibri" pitchFamily="34" charset="-120"/>
+              </a:rPr>
+              <a:t>4.3 Simulated versus real input. </a:t>
+            </a:r>
+            <a:pPr indent="0" marL="0">
+              <a:buNone/>
+            </a:pPr>
+            <a:r>
+              <a:rPr lang="en-US" sz="1650" dirty="0">
+                <a:solidFill>
+                  <a:srgbClr val="12202E"/>
+                </a:solidFill>
+                <a:latin typeface="Calibri" pitchFamily="34" charset="0"/>
+                <a:ea typeface="Calibri" pitchFamily="34" charset="-122"/>
+                <a:cs typeface="Calibri" pitchFamily="34" charset="-120"/>
+              </a:rPr>
+              <a:t>In 167 patients sequenced on both panels, taking the input from the separate IMPACT341 assay instead of masking the IMPACT410 sample lowered pooled AUROC from 0.84 to 0.70 and per-gene AUROC from 0.80 to 0.61 (pan-cancer logistic regression). The paired samples also differ in specimen and time, so the gap combines assay shift and tumour heterogeneity.</a:t>
+            </a:r>
+            <a:endParaRPr lang="en-US" sz="1650" dirty="0"/>
+          </a:p>
+        </p:txBody>
+      </p:sp>
+      <p:sp>
+        <p:nvSpPr>
+          <p:cNvPr id="103" name="Shape 99"/>
           <p:cNvSpPr/>
           <p:nvPr/>
         </p:nvSpPr>
@@ -7612,14 +7372,14 @@
       </p:sp>
       <p:sp>
         <p:nvSpPr>
-          <p:cNvPr id="103" name="Text 99"/>
+          <p:cNvPr id="104" name="Text 100"/>
           <p:cNvSpPr txBox="1"/>
           <p:nvPr/>
         </p:nvSpPr>
         <p:spPr>
           <a:xfrm>
             <a:off x="25755156" y="4480560"/>
-            <a:ext cx="7873344" cy="1425639"/>
+            <a:ext cx="7873344" cy="1084326"/>
           </a:xfrm>
           <a:prstGeom prst="rect">
             <a:avLst/>
@@ -7635,21 +7395,21 @@
               <a:buNone/>
             </a:pPr>
             <a:r>
-              <a:rPr lang="en-US" sz="1750" b="1" dirty="0">
-                <a:solidFill>
-                  <a:srgbClr val="12202E"/>
-                </a:solidFill>
-                <a:latin typeface="Calibri" pitchFamily="34" charset="0"/>
-                <a:ea typeface="Calibri" pitchFamily="34" charset="-122"/>
-                <a:cs typeface="Calibri" pitchFamily="34" charset="-120"/>
-              </a:rPr>
-              <a:t>4.3 Sources of signal. </a:t>
-            </a:r>
-            <a:pPr indent="0" marL="0">
-              <a:buNone/>
-            </a:pPr>
-            <a:r>
-              <a:rPr lang="en-US" sz="1750" dirty="0">
+              <a:rPr lang="en-US" sz="1650" b="1" dirty="0">
+                <a:solidFill>
+                  <a:srgbClr val="12202E"/>
+                </a:solidFill>
+                <a:latin typeface="Calibri" pitchFamily="34" charset="0"/>
+                <a:ea typeface="Calibri" pitchFamily="34" charset="-122"/>
+                <a:cs typeface="Calibri" pitchFamily="34" charset="-120"/>
+              </a:rPr>
+              <a:t>4.4 Sources of signal. </a:t>
+            </a:r>
+            <a:pPr indent="0" marL="0">
+              <a:buNone/>
+            </a:pPr>
+            <a:r>
+              <a:rPr lang="en-US" sz="1650" dirty="0">
                 <a:solidFill>
                   <a:srgbClr val="12202E"/>
                 </a:solidFill>
@@ -7659,18 +7419,18 @@
               </a:rPr>
               <a:t>Amplifications were highly discriminable (AUROC 0.95), explained largely by co-amplification with neighbouring assayed genes (NFKBIA with NKX2-1 in 39/39 cases). Mutations reached 0.73, no better than three mutational-burden counts alone (Figure 4).</a:t>
             </a:r>
-            <a:endParaRPr lang="en-US" sz="1750" dirty="0"/>
+            <a:endParaRPr lang="en-US" sz="1650" dirty="0"/>
           </a:p>
         </p:txBody>
       </p:sp>
       <p:graphicFrame>
         <p:nvGraphicFramePr>
-          <p:cNvPr id="104" name="Chart 0" descr=""/>
+          <p:cNvPr id="105" name="Chart 0" descr=""/>
           <p:cNvGraphicFramePr/>
           <p:nvPr/>
         </p:nvGraphicFramePr>
         <p:xfrm>
-          <a:off x="25755156" y="6134799"/>
+          <a:off x="25755156" y="5793486"/>
           <a:ext cx="7873344" cy="2057400"/>
         </p:xfrm>
         <a:graphic xmlns:a="http://schemas.openxmlformats.org/drawingml/2006/main">
@@ -7681,14 +7441,14 @@
       </p:graphicFrame>
       <p:sp>
         <p:nvSpPr>
-          <p:cNvPr id="105" name="Text 100"/>
+          <p:cNvPr id="106" name="Text 101"/>
           <p:cNvSpPr txBox="1"/>
           <p:nvPr/>
         </p:nvSpPr>
         <p:spPr>
           <a:xfrm>
-            <a:off x="25755156" y="8265351"/>
-            <a:ext cx="7873344" cy="481076"/>
+            <a:off x="25755156" y="7924038"/>
+            <a:ext cx="7873344" cy="465201"/>
           </a:xfrm>
           <a:prstGeom prst="rect">
             <a:avLst/>
@@ -7704,7 +7464,7 @@
               <a:buNone/>
             </a:pPr>
             <a:r>
-              <a:rPr lang="en-US" sz="1400" b="1" dirty="0">
+              <a:rPr lang="en-US" sz="1350" b="1" dirty="0">
                 <a:solidFill>
                   <a:srgbClr val="3F4B57"/>
                 </a:solidFill>
@@ -7718,7 +7478,7 @@
               <a:buNone/>
             </a:pPr>
             <a:r>
-              <a:rPr lang="en-US" sz="1400" dirty="0">
+              <a:rPr lang="en-US" sz="1350" dirty="0">
                 <a:solidFill>
                   <a:srgbClr val="3F4B57"/>
                 </a:solidFill>
@@ -7728,141 +7488,19 @@
               </a:rPr>
               <a:t>Replicate: per-gene AUROC by event type (positives-weighted mean; axis origin 0.50), pan-cancer logistic regression.</a:t>
             </a:r>
-            <a:endParaRPr lang="en-US" sz="1400" dirty="0"/>
+            <a:endParaRPr lang="en-US" sz="1350" dirty="0"/>
           </a:p>
         </p:txBody>
       </p:sp>
       <p:sp>
         <p:nvSpPr>
-          <p:cNvPr id="106" name="Text 101"/>
-          <p:cNvSpPr txBox="1"/>
-          <p:nvPr/>
-        </p:nvSpPr>
-        <p:spPr>
-          <a:xfrm>
-            <a:off x="25755156" y="9020747"/>
-            <a:ext cx="7873344" cy="1425639"/>
-          </a:xfrm>
-          <a:prstGeom prst="rect">
-            <a:avLst/>
-          </a:prstGeom>
-          <a:noFill/>
-          <a:ln/>
-        </p:spPr>
-        <p:txBody>
-          <a:bodyPr wrap="square" lIns="0" tIns="0" rIns="0" bIns="0" rtlCol="0" anchor="t"/>
-          <a:lstStyle/>
-          <a:p>
-            <a:pPr indent="0" marL="0">
-              <a:buNone/>
-            </a:pPr>
-            <a:r>
-              <a:rPr lang="en-US" sz="1750" b="1" dirty="0">
-                <a:solidFill>
-                  <a:srgbClr val="12202E"/>
-                </a:solidFill>
-                <a:latin typeface="Calibri" pitchFamily="34" charset="0"/>
-                <a:ea typeface="Calibri" pitchFamily="34" charset="-122"/>
-                <a:cs typeface="Calibri" pitchFamily="34" charset="-120"/>
-              </a:rPr>
-              <a:t>4.4 Simulated versus real input. </a:t>
-            </a:r>
-            <a:pPr indent="0" marL="0">
-              <a:buNone/>
-            </a:pPr>
-            <a:r>
-              <a:rPr lang="en-US" sz="1750" dirty="0">
-                <a:solidFill>
-                  <a:srgbClr val="12202E"/>
-                </a:solidFill>
-                <a:latin typeface="Calibri" pitchFamily="34" charset="0"/>
-                <a:ea typeface="Calibri" pitchFamily="34" charset="-122"/>
-                <a:cs typeface="Calibri" pitchFamily="34" charset="-120"/>
-              </a:rPr>
-              <a:t>In 167 patients sequenced on both panels, taking the input from the separate IMPACT341 assay rather than masking the IMPACT410 sample lowered AUROC. The paired samples also differ in specimen and time, so the gap combines assay shift and tumour heterogeneity (Figure 5).</a:t>
-            </a:r>
-            <a:endParaRPr lang="en-US" sz="1750" dirty="0"/>
-          </a:p>
-        </p:txBody>
-      </p:sp>
-      <p:graphicFrame>
-        <p:nvGraphicFramePr>
-          <p:cNvPr id="107" name="Chart 1" descr=""/>
-          <p:cNvGraphicFramePr/>
-          <p:nvPr/>
-        </p:nvGraphicFramePr>
-        <p:xfrm>
-          <a:off x="25755156" y="10674985"/>
-          <a:ext cx="7873344" cy="2057400"/>
-        </p:xfrm>
-        <a:graphic xmlns:a="http://schemas.openxmlformats.org/drawingml/2006/main">
-          <a:graphicData uri="http://schemas.openxmlformats.org/drawingml/2006/chart">
-            <c:chart xmlns:c="http://schemas.openxmlformats.org/drawingml/2006/chart" r:id="rId2"/>
-          </a:graphicData>
-        </a:graphic>
-      </p:graphicFrame>
-      <p:sp>
-        <p:nvSpPr>
-          <p:cNvPr id="108" name="Text 102"/>
-          <p:cNvSpPr txBox="1"/>
-          <p:nvPr/>
-        </p:nvSpPr>
-        <p:spPr>
-          <a:xfrm>
-            <a:off x="25755156" y="12805537"/>
-            <a:ext cx="7873344" cy="481076"/>
-          </a:xfrm>
-          <a:prstGeom prst="rect">
-            <a:avLst/>
-          </a:prstGeom>
-          <a:noFill/>
-          <a:ln/>
-        </p:spPr>
-        <p:txBody>
-          <a:bodyPr wrap="square" lIns="0" tIns="0" rIns="0" bIns="0" rtlCol="0" anchor="t"/>
-          <a:lstStyle/>
-          <a:p>
-            <a:pPr indent="0" marL="0">
-              <a:buNone/>
-            </a:pPr>
-            <a:r>
-              <a:rPr lang="en-US" sz="1400" b="1" dirty="0">
-                <a:solidFill>
-                  <a:srgbClr val="3F4B57"/>
-                </a:solidFill>
-                <a:latin typeface="Calibri" pitchFamily="34" charset="0"/>
-                <a:ea typeface="Calibri" pitchFamily="34" charset="-122"/>
-                <a:cs typeface="Calibri" pitchFamily="34" charset="-120"/>
-              </a:rPr>
-              <a:t>Figure 5. </a:t>
-            </a:r>
-            <a:pPr indent="0" marL="0">
-              <a:buNone/>
-            </a:pPr>
-            <a:r>
-              <a:rPr lang="en-US" sz="1400" dirty="0">
-                <a:solidFill>
-                  <a:srgbClr val="3F4B57"/>
-                </a:solidFill>
-                <a:latin typeface="Calibri" pitchFamily="34" charset="0"/>
-                <a:ea typeface="Calibri" pitchFamily="34" charset="-122"/>
-                <a:cs typeface="Calibri" pitchFamily="34" charset="-120"/>
-              </a:rPr>
-              <a:t>Replicate, pan-cancer logistic regression trained on all other patients: simulated (masked IMPACT410) versus real (IMPACT341 assay) input; axis origin 0.50.</a:t>
-            </a:r>
-            <a:endParaRPr lang="en-US" sz="1400" dirty="0"/>
-          </a:p>
-        </p:txBody>
-      </p:sp>
-      <p:sp>
-        <p:nvSpPr>
-          <p:cNvPr id="109" name="Shape 103"/>
+          <p:cNvPr id="107" name="Shape 102"/>
           <p:cNvSpPr/>
           <p:nvPr/>
         </p:nvSpPr>
         <p:spPr>
           <a:xfrm>
-            <a:off x="25755156" y="13560933"/>
+            <a:off x="25755156" y="8663559"/>
             <a:ext cx="7873344" cy="0"/>
           </a:xfrm>
           <a:prstGeom prst="line">
@@ -7879,13 +7517,13 @@
       </p:sp>
       <p:sp>
         <p:nvSpPr>
-          <p:cNvPr id="110" name="Text 104"/>
+          <p:cNvPr id="108" name="Text 103"/>
           <p:cNvSpPr txBox="1"/>
           <p:nvPr/>
         </p:nvSpPr>
         <p:spPr>
           <a:xfrm>
-            <a:off x="25755156" y="13652373"/>
+            <a:off x="25755156" y="8754999"/>
             <a:ext cx="7873344" cy="566928"/>
           </a:xfrm>
           <a:prstGeom prst="rect">
@@ -7910,7 +7548,7 @@
                 <a:ea typeface="Cambria" pitchFamily="34" charset="-122"/>
                 <a:cs typeface="Cambria" pitchFamily="34" charset="-120"/>
               </a:rPr>
-              <a:t>5  Discussion</a:t>
+              <a:t>5  EBAI assessment</a:t>
             </a:r>
             <a:endParaRPr lang="en-US" sz="3200" dirty="0"/>
           </a:p>
@@ -7918,14 +7556,1589 @@
       </p:sp>
       <p:sp>
         <p:nvSpPr>
-          <p:cNvPr id="111" name="Text 105"/>
+          <p:cNvPr id="109" name="Shape 104"/>
+          <p:cNvSpPr/>
+          <p:nvPr/>
+        </p:nvSpPr>
+        <p:spPr>
+          <a:xfrm>
+            <a:off x="25755156" y="9532239"/>
+            <a:ext cx="7873344" cy="420624"/>
+          </a:xfrm>
+          <a:prstGeom prst="rect">
+            <a:avLst/>
+          </a:prstGeom>
+          <a:solidFill>
+            <a:srgbClr val="12202E"/>
+          </a:solidFill>
+          <a:ln/>
+        </p:spPr>
+      </p:sp>
+      <p:sp>
+        <p:nvSpPr>
+          <p:cNvPr id="110" name="Text 105"/>
           <p:cNvSpPr txBox="1"/>
           <p:nvPr/>
         </p:nvSpPr>
         <p:spPr>
           <a:xfrm>
-            <a:off x="25755156" y="14429613"/>
-            <a:ext cx="7873344" cy="2920936"/>
+            <a:off x="25864884" y="9532239"/>
+            <a:ext cx="7653888" cy="420624"/>
+          </a:xfrm>
+          <a:prstGeom prst="rect">
+            <a:avLst/>
+          </a:prstGeom>
+          <a:noFill/>
+          <a:ln/>
+        </p:spPr>
+        <p:txBody>
+          <a:bodyPr wrap="square" lIns="0" tIns="0" rIns="0" bIns="0" rtlCol="0" anchor="ctr"/>
+          <a:lstStyle/>
+          <a:p>
+            <a:pPr indent="0" marL="0">
+              <a:buNone/>
+            </a:pPr>
+            <a:r>
+              <a:rPr lang="en-US" sz="1300" b="1" dirty="0">
+                <a:solidFill>
+                  <a:srgbClr val="FFFFFF"/>
+                </a:solidFill>
+                <a:latin typeface="Calibri" pitchFamily="34" charset="0"/>
+                <a:ea typeface="Calibri" pitchFamily="34" charset="-122"/>
+                <a:cs typeface="Calibri" pitchFamily="34" charset="-120"/>
+              </a:rPr>
+              <a:t>EBAI class B · indirect measure of existing biomarkers · use: pre-screening</a:t>
+            </a:r>
+            <a:endParaRPr lang="en-US" sz="1300" dirty="0"/>
+          </a:p>
+        </p:txBody>
+      </p:sp>
+      <p:sp>
+        <p:nvSpPr>
+          <p:cNvPr id="111" name="Text 106"/>
+          <p:cNvSpPr txBox="1"/>
+          <p:nvPr/>
+        </p:nvSpPr>
+        <p:spPr>
+          <a:xfrm>
+            <a:off x="25755156" y="9989439"/>
+            <a:ext cx="2011680" cy="338328"/>
+          </a:xfrm>
+          <a:prstGeom prst="rect">
+            <a:avLst/>
+          </a:prstGeom>
+          <a:noFill/>
+          <a:ln/>
+        </p:spPr>
+        <p:txBody>
+          <a:bodyPr wrap="square" lIns="0" tIns="0" rIns="0" bIns="0" rtlCol="0" anchor="ctr"/>
+          <a:lstStyle/>
+          <a:p>
+            <a:pPr indent="0" marL="0">
+              <a:buNone/>
+            </a:pPr>
+            <a:r>
+              <a:rPr lang="en-US" sz="1300" b="1" dirty="0">
+                <a:solidFill>
+                  <a:srgbClr val="12202E"/>
+                </a:solidFill>
+                <a:latin typeface="Calibri" pitchFamily="34" charset="0"/>
+                <a:ea typeface="Calibri" pitchFamily="34" charset="-122"/>
+                <a:cs typeface="Calibri" pitchFamily="34" charset="-120"/>
+              </a:rPr>
+              <a:t>Ground truth</a:t>
+            </a:r>
+            <a:endParaRPr lang="en-US" sz="1300" dirty="0"/>
+          </a:p>
+        </p:txBody>
+      </p:sp>
+      <p:sp>
+        <p:nvSpPr>
+          <p:cNvPr id="112" name="Shape 107"/>
+          <p:cNvSpPr/>
+          <p:nvPr/>
+        </p:nvSpPr>
+        <p:spPr>
+          <a:xfrm>
+            <a:off x="27766836" y="10044303"/>
+            <a:ext cx="896112" cy="228600"/>
+          </a:xfrm>
+          <a:prstGeom prst="roundRect">
+            <a:avLst>
+              <a:gd name="adj" fmla="val 20000"/>
+            </a:avLst>
+          </a:prstGeom>
+          <a:solidFill>
+            <a:srgbClr val="2A6FD6"/>
+          </a:solidFill>
+          <a:ln w="12700">
+            <a:solidFill>
+              <a:srgbClr val="2A6FD6"/>
+            </a:solidFill>
+            <a:prstDash val="solid"/>
+          </a:ln>
+        </p:spPr>
+      </p:sp>
+      <p:sp>
+        <p:nvSpPr>
+          <p:cNvPr id="113" name="Text 108"/>
+          <p:cNvSpPr txBox="1"/>
+          <p:nvPr/>
+        </p:nvSpPr>
+        <p:spPr>
+          <a:xfrm>
+            <a:off x="27766836" y="10044303"/>
+            <a:ext cx="896112" cy="228600"/>
+          </a:xfrm>
+          <a:prstGeom prst="rect">
+            <a:avLst/>
+          </a:prstGeom>
+          <a:noFill/>
+          <a:ln/>
+        </p:spPr>
+        <p:txBody>
+          <a:bodyPr wrap="square" lIns="0" tIns="0" rIns="0" bIns="0" rtlCol="0" anchor="ctr"/>
+          <a:lstStyle/>
+          <a:p>
+            <a:pPr algn="ctr" indent="0" marL="0">
+              <a:buNone/>
+            </a:pPr>
+            <a:r>
+              <a:rPr lang="en-US" sz="1150" b="1" dirty="0">
+                <a:solidFill>
+                  <a:srgbClr val="FFFFFF"/>
+                </a:solidFill>
+                <a:latin typeface="Calibri" pitchFamily="34" charset="0"/>
+                <a:ea typeface="Calibri" pitchFamily="34" charset="-122"/>
+                <a:cs typeface="Calibri" pitchFamily="34" charset="-120"/>
+              </a:rPr>
+              <a:t>Met</a:t>
+            </a:r>
+            <a:endParaRPr lang="en-US" sz="1150" dirty="0"/>
+          </a:p>
+        </p:txBody>
+      </p:sp>
+      <p:sp>
+        <p:nvSpPr>
+          <p:cNvPr id="114" name="Text 109"/>
+          <p:cNvSpPr txBox="1"/>
+          <p:nvPr/>
+        </p:nvSpPr>
+        <p:spPr>
+          <a:xfrm>
+            <a:off x="28772676" y="9989439"/>
+            <a:ext cx="4855824" cy="338328"/>
+          </a:xfrm>
+          <a:prstGeom prst="rect">
+            <a:avLst/>
+          </a:prstGeom>
+          <a:noFill/>
+          <a:ln/>
+        </p:spPr>
+        <p:txBody>
+          <a:bodyPr wrap="square" lIns="0" tIns="0" rIns="0" bIns="0" rtlCol="0" anchor="ctr"/>
+          <a:lstStyle/>
+          <a:p>
+            <a:pPr indent="0" marL="0">
+              <a:buNone/>
+            </a:pPr>
+            <a:r>
+              <a:rPr lang="en-US" sz="1300" dirty="0">
+                <a:solidFill>
+                  <a:srgbClr val="12202E"/>
+                </a:solidFill>
+                <a:latin typeface="Calibri" pitchFamily="34" charset="0"/>
+                <a:ea typeface="Calibri" pitchFamily="34" charset="-122"/>
+                <a:cs typeface="Calibri" pitchFamily="34" charset="-120"/>
+              </a:rPr>
+              <a:t>IMPACT505 NGS on the same sample</a:t>
+            </a:r>
+            <a:endParaRPr lang="en-US" sz="1300" dirty="0"/>
+          </a:p>
+        </p:txBody>
+      </p:sp>
+      <p:sp>
+        <p:nvSpPr>
+          <p:cNvPr id="115" name="Shape 110"/>
+          <p:cNvSpPr/>
+          <p:nvPr/>
+        </p:nvSpPr>
+        <p:spPr>
+          <a:xfrm>
+            <a:off x="25755156" y="10327767"/>
+            <a:ext cx="7873344" cy="0"/>
+          </a:xfrm>
+          <a:prstGeom prst="line">
+            <a:avLst/>
+          </a:prstGeom>
+          <a:noFill/>
+          <a:ln w="9525">
+            <a:solidFill>
+              <a:srgbClr val="E0E4E8"/>
+            </a:solidFill>
+            <a:prstDash val="solid"/>
+          </a:ln>
+        </p:spPr>
+      </p:sp>
+      <p:sp>
+        <p:nvSpPr>
+          <p:cNvPr id="116" name="Text 111"/>
+          <p:cNvSpPr txBox="1"/>
+          <p:nvPr/>
+        </p:nvSpPr>
+        <p:spPr>
+          <a:xfrm>
+            <a:off x="25755156" y="10327767"/>
+            <a:ext cx="2011680" cy="338328"/>
+          </a:xfrm>
+          <a:prstGeom prst="rect">
+            <a:avLst/>
+          </a:prstGeom>
+          <a:noFill/>
+          <a:ln/>
+        </p:spPr>
+        <p:txBody>
+          <a:bodyPr wrap="square" lIns="0" tIns="0" rIns="0" bIns="0" rtlCol="0" anchor="ctr"/>
+          <a:lstStyle/>
+          <a:p>
+            <a:pPr indent="0" marL="0">
+              <a:buNone/>
+            </a:pPr>
+            <a:r>
+              <a:rPr lang="en-US" sz="1300" b="1" dirty="0">
+                <a:solidFill>
+                  <a:srgbClr val="12202E"/>
+                </a:solidFill>
+                <a:latin typeface="Calibri" pitchFamily="34" charset="0"/>
+                <a:ea typeface="Calibri" pitchFamily="34" charset="-122"/>
+                <a:cs typeface="Calibri" pitchFamily="34" charset="-120"/>
+              </a:rPr>
+              <a:t>Discrimination</a:t>
+            </a:r>
+            <a:endParaRPr lang="en-US" sz="1300" dirty="0"/>
+          </a:p>
+        </p:txBody>
+      </p:sp>
+      <p:sp>
+        <p:nvSpPr>
+          <p:cNvPr id="117" name="Shape 112"/>
+          <p:cNvSpPr/>
+          <p:nvPr/>
+        </p:nvSpPr>
+        <p:spPr>
+          <a:xfrm>
+            <a:off x="27766836" y="10382631"/>
+            <a:ext cx="896112" cy="228600"/>
+          </a:xfrm>
+          <a:prstGeom prst="roundRect">
+            <a:avLst>
+              <a:gd name="adj" fmla="val 20000"/>
+            </a:avLst>
+          </a:prstGeom>
+          <a:solidFill>
+            <a:srgbClr val="2A6FD6"/>
+          </a:solidFill>
+          <a:ln w="12700">
+            <a:solidFill>
+              <a:srgbClr val="2A6FD6"/>
+            </a:solidFill>
+            <a:prstDash val="solid"/>
+          </a:ln>
+        </p:spPr>
+      </p:sp>
+      <p:sp>
+        <p:nvSpPr>
+          <p:cNvPr id="118" name="Text 113"/>
+          <p:cNvSpPr txBox="1"/>
+          <p:nvPr/>
+        </p:nvSpPr>
+        <p:spPr>
+          <a:xfrm>
+            <a:off x="27766836" y="10382631"/>
+            <a:ext cx="896112" cy="228600"/>
+          </a:xfrm>
+          <a:prstGeom prst="rect">
+            <a:avLst/>
+          </a:prstGeom>
+          <a:noFill/>
+          <a:ln/>
+        </p:spPr>
+        <p:txBody>
+          <a:bodyPr wrap="square" lIns="0" tIns="0" rIns="0" bIns="0" rtlCol="0" anchor="ctr"/>
+          <a:lstStyle/>
+          <a:p>
+            <a:pPr algn="ctr" indent="0" marL="0">
+              <a:buNone/>
+            </a:pPr>
+            <a:r>
+              <a:rPr lang="en-US" sz="1150" b="1" dirty="0">
+                <a:solidFill>
+                  <a:srgbClr val="FFFFFF"/>
+                </a:solidFill>
+                <a:latin typeface="Calibri" pitchFamily="34" charset="0"/>
+                <a:ea typeface="Calibri" pitchFamily="34" charset="-122"/>
+                <a:cs typeface="Calibri" pitchFamily="34" charset="-120"/>
+              </a:rPr>
+              <a:t>Met</a:t>
+            </a:r>
+            <a:endParaRPr lang="en-US" sz="1150" dirty="0"/>
+          </a:p>
+        </p:txBody>
+      </p:sp>
+      <p:sp>
+        <p:nvSpPr>
+          <p:cNvPr id="119" name="Text 114"/>
+          <p:cNvSpPr txBox="1"/>
+          <p:nvPr/>
+        </p:nvSpPr>
+        <p:spPr>
+          <a:xfrm>
+            <a:off x="28772676" y="10327767"/>
+            <a:ext cx="4855824" cy="338328"/>
+          </a:xfrm>
+          <a:prstGeom prst="rect">
+            <a:avLst/>
+          </a:prstGeom>
+          <a:noFill/>
+          <a:ln/>
+        </p:spPr>
+        <p:txBody>
+          <a:bodyPr wrap="square" lIns="0" tIns="0" rIns="0" bIns="0" rtlCol="0" anchor="ctr"/>
+          <a:lstStyle/>
+          <a:p>
+            <a:pPr indent="0" marL="0">
+              <a:buNone/>
+            </a:pPr>
+            <a:r>
+              <a:rPr lang="en-US" sz="1300" dirty="0">
+                <a:solidFill>
+                  <a:srgbClr val="12202E"/>
+                </a:solidFill>
+                <a:latin typeface="Calibri" pitchFamily="34" charset="0"/>
+                <a:ea typeface="Calibri" pitchFamily="34" charset="-122"/>
+                <a:cs typeface="Calibri" pitchFamily="34" charset="-120"/>
+              </a:rPr>
+              <a:t>Pooled AUROC 0.77–0.79; per gene </a:t>
+            </a:r>
+            <a:pPr indent="0" marL="0">
+              <a:buNone/>
+            </a:pPr>
+            <a:r>
+              <a:rPr lang="en-US" sz="1300" dirty="0">
+                <a:solidFill>
+                  <a:srgbClr val="A3410F"/>
+                </a:solidFill>
+                <a:latin typeface="Calibri" pitchFamily="34" charset="0"/>
+                <a:ea typeface="Calibri" pitchFamily="34" charset="-122"/>
+                <a:cs typeface="Calibri" pitchFamily="34" charset="-120"/>
+              </a:rPr>
+              <a:t>[ ]</a:t>
+            </a:r>
+            <a:endParaRPr lang="en-US" sz="1300" dirty="0"/>
+          </a:p>
+        </p:txBody>
+      </p:sp>
+      <p:sp>
+        <p:nvSpPr>
+          <p:cNvPr id="120" name="Shape 115"/>
+          <p:cNvSpPr/>
+          <p:nvPr/>
+        </p:nvSpPr>
+        <p:spPr>
+          <a:xfrm>
+            <a:off x="25755156" y="10666095"/>
+            <a:ext cx="7873344" cy="0"/>
+          </a:xfrm>
+          <a:prstGeom prst="line">
+            <a:avLst/>
+          </a:prstGeom>
+          <a:noFill/>
+          <a:ln w="9525">
+            <a:solidFill>
+              <a:srgbClr val="E0E4E8"/>
+            </a:solidFill>
+            <a:prstDash val="solid"/>
+          </a:ln>
+        </p:spPr>
+      </p:sp>
+      <p:sp>
+        <p:nvSpPr>
+          <p:cNvPr id="121" name="Text 116"/>
+          <p:cNvSpPr txBox="1"/>
+          <p:nvPr/>
+        </p:nvSpPr>
+        <p:spPr>
+          <a:xfrm>
+            <a:off x="25755156" y="10666095"/>
+            <a:ext cx="2011680" cy="338328"/>
+          </a:xfrm>
+          <a:prstGeom prst="rect">
+            <a:avLst/>
+          </a:prstGeom>
+          <a:noFill/>
+          <a:ln/>
+        </p:spPr>
+        <p:txBody>
+          <a:bodyPr wrap="square" lIns="0" tIns="0" rIns="0" bIns="0" rtlCol="0" anchor="ctr"/>
+          <a:lstStyle/>
+          <a:p>
+            <a:pPr indent="0" marL="0">
+              <a:buNone/>
+            </a:pPr>
+            <a:r>
+              <a:rPr lang="en-US" sz="1300" b="1" dirty="0">
+                <a:solidFill>
+                  <a:srgbClr val="12202E"/>
+                </a:solidFill>
+                <a:latin typeface="Calibri" pitchFamily="34" charset="0"/>
+                <a:ea typeface="Calibri" pitchFamily="34" charset="-122"/>
+                <a:cs typeface="Calibri" pitchFamily="34" charset="-120"/>
+              </a:rPr>
+              <a:t>Operating point</a:t>
+            </a:r>
+            <a:endParaRPr lang="en-US" sz="1300" dirty="0"/>
+          </a:p>
+        </p:txBody>
+      </p:sp>
+      <p:sp>
+        <p:nvSpPr>
+          <p:cNvPr id="122" name="Shape 117"/>
+          <p:cNvSpPr/>
+          <p:nvPr/>
+        </p:nvSpPr>
+        <p:spPr>
+          <a:xfrm>
+            <a:off x="27766836" y="10720959"/>
+            <a:ext cx="896112" cy="228600"/>
+          </a:xfrm>
+          <a:prstGeom prst="roundRect">
+            <a:avLst>
+              <a:gd name="adj" fmla="val 20000"/>
+            </a:avLst>
+          </a:prstGeom>
+          <a:solidFill>
+            <a:srgbClr val="FBE3D5"/>
+          </a:solidFill>
+          <a:ln w="12700">
+            <a:solidFill>
+              <a:srgbClr val="C4501B"/>
+            </a:solidFill>
+            <a:prstDash val="solid"/>
+          </a:ln>
+        </p:spPr>
+      </p:sp>
+      <p:sp>
+        <p:nvSpPr>
+          <p:cNvPr id="123" name="Text 118"/>
+          <p:cNvSpPr txBox="1"/>
+          <p:nvPr/>
+        </p:nvSpPr>
+        <p:spPr>
+          <a:xfrm>
+            <a:off x="27766836" y="10720959"/>
+            <a:ext cx="896112" cy="228600"/>
+          </a:xfrm>
+          <a:prstGeom prst="rect">
+            <a:avLst/>
+          </a:prstGeom>
+          <a:noFill/>
+          <a:ln/>
+        </p:spPr>
+        <p:txBody>
+          <a:bodyPr wrap="square" lIns="0" tIns="0" rIns="0" bIns="0" rtlCol="0" anchor="ctr"/>
+          <a:lstStyle/>
+          <a:p>
+            <a:pPr algn="ctr" indent="0" marL="0">
+              <a:buNone/>
+            </a:pPr>
+            <a:r>
+              <a:rPr lang="en-US" sz="1150" b="1" dirty="0">
+                <a:solidFill>
+                  <a:srgbClr val="7A2E0B"/>
+                </a:solidFill>
+                <a:latin typeface="Calibri" pitchFamily="34" charset="0"/>
+                <a:ea typeface="Calibri" pitchFamily="34" charset="-122"/>
+                <a:cs typeface="Calibri" pitchFamily="34" charset="-120"/>
+              </a:rPr>
+              <a:t>Partial</a:t>
+            </a:r>
+            <a:endParaRPr lang="en-US" sz="1150" dirty="0"/>
+          </a:p>
+        </p:txBody>
+      </p:sp>
+      <p:sp>
+        <p:nvSpPr>
+          <p:cNvPr id="124" name="Text 119"/>
+          <p:cNvSpPr txBox="1"/>
+          <p:nvPr/>
+        </p:nvSpPr>
+        <p:spPr>
+          <a:xfrm>
+            <a:off x="28772676" y="10666095"/>
+            <a:ext cx="4855824" cy="338328"/>
+          </a:xfrm>
+          <a:prstGeom prst="rect">
+            <a:avLst/>
+          </a:prstGeom>
+          <a:noFill/>
+          <a:ln/>
+        </p:spPr>
+        <p:txBody>
+          <a:bodyPr wrap="square" lIns="0" tIns="0" rIns="0" bIns="0" rtlCol="0" anchor="ctr"/>
+          <a:lstStyle/>
+          <a:p>
+            <a:pPr indent="0" marL="0">
+              <a:buNone/>
+            </a:pPr>
+            <a:r>
+              <a:rPr lang="en-US" sz="1300" dirty="0">
+                <a:solidFill>
+                  <a:srgbClr val="12202E"/>
+                </a:solidFill>
+                <a:latin typeface="Calibri" pitchFamily="34" charset="0"/>
+                <a:ea typeface="Calibri" pitchFamily="34" charset="-122"/>
+                <a:cs typeface="Calibri" pitchFamily="34" charset="-120"/>
+              </a:rPr>
+              <a:t>Replicate: Se 0.90, NPV 0.86, LR− 0.22; cohort </a:t>
+            </a:r>
+            <a:pPr indent="0" marL="0">
+              <a:buNone/>
+            </a:pPr>
+            <a:r>
+              <a:rPr lang="en-US" sz="1300" dirty="0">
+                <a:solidFill>
+                  <a:srgbClr val="A3410F"/>
+                </a:solidFill>
+                <a:latin typeface="Calibri" pitchFamily="34" charset="0"/>
+                <a:ea typeface="Calibri" pitchFamily="34" charset="-122"/>
+                <a:cs typeface="Calibri" pitchFamily="34" charset="-120"/>
+              </a:rPr>
+              <a:t>[ ]</a:t>
+            </a:r>
+            <a:endParaRPr lang="en-US" sz="1300" dirty="0"/>
+          </a:p>
+        </p:txBody>
+      </p:sp>
+      <p:sp>
+        <p:nvSpPr>
+          <p:cNvPr id="125" name="Shape 120"/>
+          <p:cNvSpPr/>
+          <p:nvPr/>
+        </p:nvSpPr>
+        <p:spPr>
+          <a:xfrm>
+            <a:off x="25755156" y="11004423"/>
+            <a:ext cx="7873344" cy="0"/>
+          </a:xfrm>
+          <a:prstGeom prst="line">
+            <a:avLst/>
+          </a:prstGeom>
+          <a:noFill/>
+          <a:ln w="9525">
+            <a:solidFill>
+              <a:srgbClr val="E0E4E8"/>
+            </a:solidFill>
+            <a:prstDash val="solid"/>
+          </a:ln>
+        </p:spPr>
+      </p:sp>
+      <p:sp>
+        <p:nvSpPr>
+          <p:cNvPr id="126" name="Text 121"/>
+          <p:cNvSpPr txBox="1"/>
+          <p:nvPr/>
+        </p:nvSpPr>
+        <p:spPr>
+          <a:xfrm>
+            <a:off x="25755156" y="11004423"/>
+            <a:ext cx="2011680" cy="338328"/>
+          </a:xfrm>
+          <a:prstGeom prst="rect">
+            <a:avLst/>
+          </a:prstGeom>
+          <a:noFill/>
+          <a:ln/>
+        </p:spPr>
+        <p:txBody>
+          <a:bodyPr wrap="square" lIns="0" tIns="0" rIns="0" bIns="0" rtlCol="0" anchor="ctr"/>
+          <a:lstStyle/>
+          <a:p>
+            <a:pPr indent="0" marL="0">
+              <a:buNone/>
+            </a:pPr>
+            <a:r>
+              <a:rPr lang="en-US" sz="1300" b="1" dirty="0">
+                <a:solidFill>
+                  <a:srgbClr val="12202E"/>
+                </a:solidFill>
+                <a:latin typeface="Calibri" pitchFamily="34" charset="0"/>
+                <a:ea typeface="Calibri" pitchFamily="34" charset="-122"/>
+                <a:cs typeface="Calibri" pitchFamily="34" charset="-120"/>
+              </a:rPr>
+              <a:t>Calibration</a:t>
+            </a:r>
+            <a:endParaRPr lang="en-US" sz="1300" dirty="0"/>
+          </a:p>
+        </p:txBody>
+      </p:sp>
+      <p:sp>
+        <p:nvSpPr>
+          <p:cNvPr id="127" name="Shape 122"/>
+          <p:cNvSpPr/>
+          <p:nvPr/>
+        </p:nvSpPr>
+        <p:spPr>
+          <a:xfrm>
+            <a:off x="27766836" y="11059287"/>
+            <a:ext cx="896112" cy="228600"/>
+          </a:xfrm>
+          <a:prstGeom prst="roundRect">
+            <a:avLst>
+              <a:gd name="adj" fmla="val 20000"/>
+            </a:avLst>
+          </a:prstGeom>
+          <a:solidFill>
+            <a:srgbClr val="FBE3D5"/>
+          </a:solidFill>
+          <a:ln w="12700">
+            <a:solidFill>
+              <a:srgbClr val="C4501B"/>
+            </a:solidFill>
+            <a:prstDash val="solid"/>
+          </a:ln>
+        </p:spPr>
+      </p:sp>
+      <p:sp>
+        <p:nvSpPr>
+          <p:cNvPr id="128" name="Text 123"/>
+          <p:cNvSpPr txBox="1"/>
+          <p:nvPr/>
+        </p:nvSpPr>
+        <p:spPr>
+          <a:xfrm>
+            <a:off x="27766836" y="11059287"/>
+            <a:ext cx="896112" cy="228600"/>
+          </a:xfrm>
+          <a:prstGeom prst="rect">
+            <a:avLst/>
+          </a:prstGeom>
+          <a:noFill/>
+          <a:ln/>
+        </p:spPr>
+        <p:txBody>
+          <a:bodyPr wrap="square" lIns="0" tIns="0" rIns="0" bIns="0" rtlCol="0" anchor="ctr"/>
+          <a:lstStyle/>
+          <a:p>
+            <a:pPr algn="ctr" indent="0" marL="0">
+              <a:buNone/>
+            </a:pPr>
+            <a:r>
+              <a:rPr lang="en-US" sz="1150" b="1" dirty="0">
+                <a:solidFill>
+                  <a:srgbClr val="7A2E0B"/>
+                </a:solidFill>
+                <a:latin typeface="Calibri" pitchFamily="34" charset="0"/>
+                <a:ea typeface="Calibri" pitchFamily="34" charset="-122"/>
+                <a:cs typeface="Calibri" pitchFamily="34" charset="-120"/>
+              </a:rPr>
+              <a:t>Partial</a:t>
+            </a:r>
+            <a:endParaRPr lang="en-US" sz="1150" dirty="0"/>
+          </a:p>
+        </p:txBody>
+      </p:sp>
+      <p:sp>
+        <p:nvSpPr>
+          <p:cNvPr id="129" name="Text 124"/>
+          <p:cNvSpPr txBox="1"/>
+          <p:nvPr/>
+        </p:nvSpPr>
+        <p:spPr>
+          <a:xfrm>
+            <a:off x="28772676" y="11004423"/>
+            <a:ext cx="4855824" cy="338328"/>
+          </a:xfrm>
+          <a:prstGeom prst="rect">
+            <a:avLst/>
+          </a:prstGeom>
+          <a:noFill/>
+          <a:ln/>
+        </p:spPr>
+        <p:txBody>
+          <a:bodyPr wrap="square" lIns="0" tIns="0" rIns="0" bIns="0" rtlCol="0" anchor="ctr"/>
+          <a:lstStyle/>
+          <a:p>
+            <a:pPr indent="0" marL="0">
+              <a:buNone/>
+            </a:pPr>
+            <a:r>
+              <a:rPr lang="en-US" sz="1300" dirty="0">
+                <a:solidFill>
+                  <a:srgbClr val="12202E"/>
+                </a:solidFill>
+                <a:latin typeface="Calibri" pitchFamily="34" charset="0"/>
+                <a:ea typeface="Calibri" pitchFamily="34" charset="-122"/>
+                <a:cs typeface="Calibri" pitchFamily="34" charset="-120"/>
+              </a:rPr>
+              <a:t>Replicate: slope 0.97, O:E 1.08; cohort </a:t>
+            </a:r>
+            <a:pPr indent="0" marL="0">
+              <a:buNone/>
+            </a:pPr>
+            <a:r>
+              <a:rPr lang="en-US" sz="1300" dirty="0">
+                <a:solidFill>
+                  <a:srgbClr val="A3410F"/>
+                </a:solidFill>
+                <a:latin typeface="Calibri" pitchFamily="34" charset="0"/>
+                <a:ea typeface="Calibri" pitchFamily="34" charset="-122"/>
+                <a:cs typeface="Calibri" pitchFamily="34" charset="-120"/>
+              </a:rPr>
+              <a:t>[ ]</a:t>
+            </a:r>
+            <a:endParaRPr lang="en-US" sz="1300" dirty="0"/>
+          </a:p>
+        </p:txBody>
+      </p:sp>
+      <p:sp>
+        <p:nvSpPr>
+          <p:cNvPr id="130" name="Shape 125"/>
+          <p:cNvSpPr/>
+          <p:nvPr/>
+        </p:nvSpPr>
+        <p:spPr>
+          <a:xfrm>
+            <a:off x="25755156" y="11342751"/>
+            <a:ext cx="7873344" cy="0"/>
+          </a:xfrm>
+          <a:prstGeom prst="line">
+            <a:avLst/>
+          </a:prstGeom>
+          <a:noFill/>
+          <a:ln w="9525">
+            <a:solidFill>
+              <a:srgbClr val="E0E4E8"/>
+            </a:solidFill>
+            <a:prstDash val="solid"/>
+          </a:ln>
+        </p:spPr>
+      </p:sp>
+      <p:sp>
+        <p:nvSpPr>
+          <p:cNvPr id="131" name="Text 126"/>
+          <p:cNvSpPr txBox="1"/>
+          <p:nvPr/>
+        </p:nvSpPr>
+        <p:spPr>
+          <a:xfrm>
+            <a:off x="25755156" y="11342751"/>
+            <a:ext cx="2011680" cy="338328"/>
+          </a:xfrm>
+          <a:prstGeom prst="rect">
+            <a:avLst/>
+          </a:prstGeom>
+          <a:noFill/>
+          <a:ln/>
+        </p:spPr>
+        <p:txBody>
+          <a:bodyPr wrap="square" lIns="0" tIns="0" rIns="0" bIns="0" rtlCol="0" anchor="ctr"/>
+          <a:lstStyle/>
+          <a:p>
+            <a:pPr indent="0" marL="0">
+              <a:buNone/>
+            </a:pPr>
+            <a:r>
+              <a:rPr lang="en-US" sz="1300" b="1" dirty="0">
+                <a:solidFill>
+                  <a:srgbClr val="12202E"/>
+                </a:solidFill>
+                <a:latin typeface="Calibri" pitchFamily="34" charset="0"/>
+                <a:ea typeface="Calibri" pitchFamily="34" charset="-122"/>
+                <a:cs typeface="Calibri" pitchFamily="34" charset="-120"/>
+              </a:rPr>
+              <a:t>Independent cohort</a:t>
+            </a:r>
+            <a:endParaRPr lang="en-US" sz="1300" dirty="0"/>
+          </a:p>
+        </p:txBody>
+      </p:sp>
+      <p:sp>
+        <p:nvSpPr>
+          <p:cNvPr id="132" name="Shape 127"/>
+          <p:cNvSpPr/>
+          <p:nvPr/>
+        </p:nvSpPr>
+        <p:spPr>
+          <a:xfrm>
+            <a:off x="27766836" y="11397615"/>
+            <a:ext cx="896112" cy="228600"/>
+          </a:xfrm>
+          <a:prstGeom prst="roundRect">
+            <a:avLst>
+              <a:gd name="adj" fmla="val 20000"/>
+            </a:avLst>
+          </a:prstGeom>
+          <a:solidFill>
+            <a:srgbClr val="FFFFFF"/>
+          </a:solidFill>
+          <a:ln w="12700">
+            <a:solidFill>
+              <a:srgbClr val="6B7682"/>
+            </a:solidFill>
+            <a:prstDash val="solid"/>
+          </a:ln>
+        </p:spPr>
+      </p:sp>
+      <p:sp>
+        <p:nvSpPr>
+          <p:cNvPr id="133" name="Text 128"/>
+          <p:cNvSpPr txBox="1"/>
+          <p:nvPr/>
+        </p:nvSpPr>
+        <p:spPr>
+          <a:xfrm>
+            <a:off x="27766836" y="11397615"/>
+            <a:ext cx="896112" cy="228600"/>
+          </a:xfrm>
+          <a:prstGeom prst="rect">
+            <a:avLst/>
+          </a:prstGeom>
+          <a:noFill/>
+          <a:ln/>
+        </p:spPr>
+        <p:txBody>
+          <a:bodyPr wrap="square" lIns="0" tIns="0" rIns="0" bIns="0" rtlCol="0" anchor="ctr"/>
+          <a:lstStyle/>
+          <a:p>
+            <a:pPr algn="ctr" indent="0" marL="0">
+              <a:buNone/>
+            </a:pPr>
+            <a:r>
+              <a:rPr lang="en-US" sz="1150" b="1" dirty="0">
+                <a:solidFill>
+                  <a:srgbClr val="3F4B57"/>
+                </a:solidFill>
+                <a:latin typeface="Calibri" pitchFamily="34" charset="0"/>
+                <a:ea typeface="Calibri" pitchFamily="34" charset="-122"/>
+                <a:cs typeface="Calibri" pitchFamily="34" charset="-120"/>
+              </a:rPr>
+              <a:t>Not yet</a:t>
+            </a:r>
+            <a:endParaRPr lang="en-US" sz="1150" dirty="0"/>
+          </a:p>
+        </p:txBody>
+      </p:sp>
+      <p:sp>
+        <p:nvSpPr>
+          <p:cNvPr id="134" name="Text 129"/>
+          <p:cNvSpPr txBox="1"/>
+          <p:nvPr/>
+        </p:nvSpPr>
+        <p:spPr>
+          <a:xfrm>
+            <a:off x="28772676" y="11342751"/>
+            <a:ext cx="4855824" cy="338328"/>
+          </a:xfrm>
+          <a:prstGeom prst="rect">
+            <a:avLst/>
+          </a:prstGeom>
+          <a:noFill/>
+          <a:ln/>
+        </p:spPr>
+        <p:txBody>
+          <a:bodyPr wrap="square" lIns="0" tIns="0" rIns="0" bIns="0" rtlCol="0" anchor="ctr"/>
+          <a:lstStyle/>
+          <a:p>
+            <a:pPr indent="0" marL="0">
+              <a:buNone/>
+            </a:pPr>
+            <a:r>
+              <a:rPr lang="en-US" sz="1300" dirty="0">
+                <a:solidFill>
+                  <a:srgbClr val="12202E"/>
+                </a:solidFill>
+                <a:latin typeface="Calibri" pitchFamily="34" charset="0"/>
+                <a:ea typeface="Calibri" pitchFamily="34" charset="-122"/>
+                <a:cs typeface="Calibri" pitchFamily="34" charset="-120"/>
+              </a:rPr>
+              <a:t>Single institution; non-MSK validation needed</a:t>
+            </a:r>
+            <a:endParaRPr lang="en-US" sz="1300" dirty="0"/>
+          </a:p>
+        </p:txBody>
+      </p:sp>
+      <p:sp>
+        <p:nvSpPr>
+          <p:cNvPr id="135" name="Shape 130"/>
+          <p:cNvSpPr/>
+          <p:nvPr/>
+        </p:nvSpPr>
+        <p:spPr>
+          <a:xfrm>
+            <a:off x="25755156" y="11681079"/>
+            <a:ext cx="7873344" cy="0"/>
+          </a:xfrm>
+          <a:prstGeom prst="line">
+            <a:avLst/>
+          </a:prstGeom>
+          <a:noFill/>
+          <a:ln w="9525">
+            <a:solidFill>
+              <a:srgbClr val="E0E4E8"/>
+            </a:solidFill>
+            <a:prstDash val="solid"/>
+          </a:ln>
+        </p:spPr>
+      </p:sp>
+      <p:sp>
+        <p:nvSpPr>
+          <p:cNvPr id="136" name="Text 131"/>
+          <p:cNvSpPr txBox="1"/>
+          <p:nvPr/>
+        </p:nvSpPr>
+        <p:spPr>
+          <a:xfrm>
+            <a:off x="25755156" y="11681079"/>
+            <a:ext cx="2011680" cy="338328"/>
+          </a:xfrm>
+          <a:prstGeom prst="rect">
+            <a:avLst/>
+          </a:prstGeom>
+          <a:noFill/>
+          <a:ln/>
+        </p:spPr>
+        <p:txBody>
+          <a:bodyPr wrap="square" lIns="0" tIns="0" rIns="0" bIns="0" rtlCol="0" anchor="ctr"/>
+          <a:lstStyle/>
+          <a:p>
+            <a:pPr indent="0" marL="0">
+              <a:buNone/>
+            </a:pPr>
+            <a:r>
+              <a:rPr lang="en-US" sz="1300" b="1" dirty="0">
+                <a:solidFill>
+                  <a:srgbClr val="12202E"/>
+                </a:solidFill>
+                <a:latin typeface="Calibri" pitchFamily="34" charset="0"/>
+                <a:ea typeface="Calibri" pitchFamily="34" charset="-122"/>
+                <a:cs typeface="Calibri" pitchFamily="34" charset="-120"/>
+              </a:rPr>
+              <a:t>Assay shift</a:t>
+            </a:r>
+            <a:endParaRPr lang="en-US" sz="1300" dirty="0"/>
+          </a:p>
+        </p:txBody>
+      </p:sp>
+      <p:sp>
+        <p:nvSpPr>
+          <p:cNvPr id="137" name="Shape 132"/>
+          <p:cNvSpPr/>
+          <p:nvPr/>
+        </p:nvSpPr>
+        <p:spPr>
+          <a:xfrm>
+            <a:off x="27766836" y="11735943"/>
+            <a:ext cx="896112" cy="228600"/>
+          </a:xfrm>
+          <a:prstGeom prst="roundRect">
+            <a:avLst>
+              <a:gd name="adj" fmla="val 20000"/>
+            </a:avLst>
+          </a:prstGeom>
+          <a:solidFill>
+            <a:srgbClr val="FBE3D5"/>
+          </a:solidFill>
+          <a:ln w="12700">
+            <a:solidFill>
+              <a:srgbClr val="C4501B"/>
+            </a:solidFill>
+            <a:prstDash val="solid"/>
+          </a:ln>
+        </p:spPr>
+      </p:sp>
+      <p:sp>
+        <p:nvSpPr>
+          <p:cNvPr id="138" name="Text 133"/>
+          <p:cNvSpPr txBox="1"/>
+          <p:nvPr/>
+        </p:nvSpPr>
+        <p:spPr>
+          <a:xfrm>
+            <a:off x="27766836" y="11735943"/>
+            <a:ext cx="896112" cy="228600"/>
+          </a:xfrm>
+          <a:prstGeom prst="rect">
+            <a:avLst/>
+          </a:prstGeom>
+          <a:noFill/>
+          <a:ln/>
+        </p:spPr>
+        <p:txBody>
+          <a:bodyPr wrap="square" lIns="0" tIns="0" rIns="0" bIns="0" rtlCol="0" anchor="ctr"/>
+          <a:lstStyle/>
+          <a:p>
+            <a:pPr algn="ctr" indent="0" marL="0">
+              <a:buNone/>
+            </a:pPr>
+            <a:r>
+              <a:rPr lang="en-US" sz="1150" b="1" dirty="0">
+                <a:solidFill>
+                  <a:srgbClr val="7A2E0B"/>
+                </a:solidFill>
+                <a:latin typeface="Calibri" pitchFamily="34" charset="0"/>
+                <a:ea typeface="Calibri" pitchFamily="34" charset="-122"/>
+                <a:cs typeface="Calibri" pitchFamily="34" charset="-120"/>
+              </a:rPr>
+              <a:t>Partial</a:t>
+            </a:r>
+            <a:endParaRPr lang="en-US" sz="1150" dirty="0"/>
+          </a:p>
+        </p:txBody>
+      </p:sp>
+      <p:sp>
+        <p:nvSpPr>
+          <p:cNvPr id="139" name="Text 134"/>
+          <p:cNvSpPr txBox="1"/>
+          <p:nvPr/>
+        </p:nvSpPr>
+        <p:spPr>
+          <a:xfrm>
+            <a:off x="28772676" y="11681079"/>
+            <a:ext cx="4855824" cy="338328"/>
+          </a:xfrm>
+          <a:prstGeom prst="rect">
+            <a:avLst/>
+          </a:prstGeom>
+          <a:noFill/>
+          <a:ln/>
+        </p:spPr>
+        <p:txBody>
+          <a:bodyPr wrap="square" lIns="0" tIns="0" rIns="0" bIns="0" rtlCol="0" anchor="ctr"/>
+          <a:lstStyle/>
+          <a:p>
+            <a:pPr indent="0" marL="0">
+              <a:buNone/>
+            </a:pPr>
+            <a:r>
+              <a:rPr lang="en-US" sz="1300" dirty="0">
+                <a:solidFill>
+                  <a:srgbClr val="12202E"/>
+                </a:solidFill>
+                <a:latin typeface="Calibri" pitchFamily="34" charset="0"/>
+                <a:ea typeface="Calibri" pitchFamily="34" charset="-122"/>
+                <a:cs typeface="Calibri" pitchFamily="34" charset="-120"/>
+              </a:rPr>
+              <a:t>Real IMPACT341 input: AUROC 0.84 → 0.70</a:t>
+            </a:r>
+            <a:endParaRPr lang="en-US" sz="1300" dirty="0"/>
+          </a:p>
+        </p:txBody>
+      </p:sp>
+      <p:sp>
+        <p:nvSpPr>
+          <p:cNvPr id="140" name="Shape 135"/>
+          <p:cNvSpPr/>
+          <p:nvPr/>
+        </p:nvSpPr>
+        <p:spPr>
+          <a:xfrm>
+            <a:off x="25755156" y="12019407"/>
+            <a:ext cx="7873344" cy="0"/>
+          </a:xfrm>
+          <a:prstGeom prst="line">
+            <a:avLst/>
+          </a:prstGeom>
+          <a:noFill/>
+          <a:ln w="9525">
+            <a:solidFill>
+              <a:srgbClr val="E0E4E8"/>
+            </a:solidFill>
+            <a:prstDash val="solid"/>
+          </a:ln>
+        </p:spPr>
+      </p:sp>
+      <p:sp>
+        <p:nvSpPr>
+          <p:cNvPr id="141" name="Text 136"/>
+          <p:cNvSpPr txBox="1"/>
+          <p:nvPr/>
+        </p:nvSpPr>
+        <p:spPr>
+          <a:xfrm>
+            <a:off x="25755156" y="12019407"/>
+            <a:ext cx="2011680" cy="338328"/>
+          </a:xfrm>
+          <a:prstGeom prst="rect">
+            <a:avLst/>
+          </a:prstGeom>
+          <a:noFill/>
+          <a:ln/>
+        </p:spPr>
+        <p:txBody>
+          <a:bodyPr wrap="square" lIns="0" tIns="0" rIns="0" bIns="0" rtlCol="0" anchor="ctr"/>
+          <a:lstStyle/>
+          <a:p>
+            <a:pPr indent="0" marL="0">
+              <a:buNone/>
+            </a:pPr>
+            <a:r>
+              <a:rPr lang="en-US" sz="1300" b="1" dirty="0">
+                <a:solidFill>
+                  <a:srgbClr val="12202E"/>
+                </a:solidFill>
+                <a:latin typeface="Calibri" pitchFamily="34" charset="0"/>
+                <a:ea typeface="Calibri" pitchFamily="34" charset="-122"/>
+                <a:cs typeface="Calibri" pitchFamily="34" charset="-120"/>
+              </a:rPr>
+              <a:t>Fairness</a:t>
+            </a:r>
+            <a:endParaRPr lang="en-US" sz="1300" dirty="0"/>
+          </a:p>
+        </p:txBody>
+      </p:sp>
+      <p:sp>
+        <p:nvSpPr>
+          <p:cNvPr id="142" name="Shape 137"/>
+          <p:cNvSpPr/>
+          <p:nvPr/>
+        </p:nvSpPr>
+        <p:spPr>
+          <a:xfrm>
+            <a:off x="27766836" y="12074271"/>
+            <a:ext cx="896112" cy="228600"/>
+          </a:xfrm>
+          <a:prstGeom prst="roundRect">
+            <a:avLst>
+              <a:gd name="adj" fmla="val 20000"/>
+            </a:avLst>
+          </a:prstGeom>
+          <a:solidFill>
+            <a:srgbClr val="FFFFFF"/>
+          </a:solidFill>
+          <a:ln w="12700">
+            <a:solidFill>
+              <a:srgbClr val="6B7682"/>
+            </a:solidFill>
+            <a:prstDash val="solid"/>
+          </a:ln>
+        </p:spPr>
+      </p:sp>
+      <p:sp>
+        <p:nvSpPr>
+          <p:cNvPr id="143" name="Text 138"/>
+          <p:cNvSpPr txBox="1"/>
+          <p:nvPr/>
+        </p:nvSpPr>
+        <p:spPr>
+          <a:xfrm>
+            <a:off x="27766836" y="12074271"/>
+            <a:ext cx="896112" cy="228600"/>
+          </a:xfrm>
+          <a:prstGeom prst="rect">
+            <a:avLst/>
+          </a:prstGeom>
+          <a:noFill/>
+          <a:ln/>
+        </p:spPr>
+        <p:txBody>
+          <a:bodyPr wrap="square" lIns="0" tIns="0" rIns="0" bIns="0" rtlCol="0" anchor="ctr"/>
+          <a:lstStyle/>
+          <a:p>
+            <a:pPr algn="ctr" indent="0" marL="0">
+              <a:buNone/>
+            </a:pPr>
+            <a:r>
+              <a:rPr lang="en-US" sz="1150" b="1" dirty="0">
+                <a:solidFill>
+                  <a:srgbClr val="3F4B57"/>
+                </a:solidFill>
+                <a:latin typeface="Calibri" pitchFamily="34" charset="0"/>
+                <a:ea typeface="Calibri" pitchFamily="34" charset="-122"/>
+                <a:cs typeface="Calibri" pitchFamily="34" charset="-120"/>
+              </a:rPr>
+              <a:t>Not yet</a:t>
+            </a:r>
+            <a:endParaRPr lang="en-US" sz="1150" dirty="0"/>
+          </a:p>
+        </p:txBody>
+      </p:sp>
+      <p:sp>
+        <p:nvSpPr>
+          <p:cNvPr id="144" name="Text 139"/>
+          <p:cNvSpPr txBox="1"/>
+          <p:nvPr/>
+        </p:nvSpPr>
+        <p:spPr>
+          <a:xfrm>
+            <a:off x="28772676" y="12019407"/>
+            <a:ext cx="4855824" cy="338328"/>
+          </a:xfrm>
+          <a:prstGeom prst="rect">
+            <a:avLst/>
+          </a:prstGeom>
+          <a:noFill/>
+          <a:ln/>
+        </p:spPr>
+        <p:txBody>
+          <a:bodyPr wrap="square" lIns="0" tIns="0" rIns="0" bIns="0" rtlCol="0" anchor="ctr"/>
+          <a:lstStyle/>
+          <a:p>
+            <a:pPr indent="0" marL="0">
+              <a:buNone/>
+            </a:pPr>
+            <a:r>
+              <a:rPr lang="en-US" sz="1300" dirty="0">
+                <a:solidFill>
+                  <a:srgbClr val="12202E"/>
+                </a:solidFill>
+                <a:latin typeface="Calibri" pitchFamily="34" charset="0"/>
+                <a:ea typeface="Calibri" pitchFamily="34" charset="-122"/>
+                <a:cs typeface="Calibri" pitchFamily="34" charset="-120"/>
+              </a:rPr>
+              <a:t>Sex, ancestry, smoking, histology subgroups</a:t>
+            </a:r>
+            <a:endParaRPr lang="en-US" sz="1300" dirty="0"/>
+          </a:p>
+        </p:txBody>
+      </p:sp>
+      <p:sp>
+        <p:nvSpPr>
+          <p:cNvPr id="145" name="Shape 140"/>
+          <p:cNvSpPr/>
+          <p:nvPr/>
+        </p:nvSpPr>
+        <p:spPr>
+          <a:xfrm>
+            <a:off x="25755156" y="12357735"/>
+            <a:ext cx="7873344" cy="0"/>
+          </a:xfrm>
+          <a:prstGeom prst="line">
+            <a:avLst/>
+          </a:prstGeom>
+          <a:noFill/>
+          <a:ln w="9525">
+            <a:solidFill>
+              <a:srgbClr val="E0E4E8"/>
+            </a:solidFill>
+            <a:prstDash val="solid"/>
+          </a:ln>
+        </p:spPr>
+      </p:sp>
+      <p:sp>
+        <p:nvSpPr>
+          <p:cNvPr id="146" name="Text 141"/>
+          <p:cNvSpPr txBox="1"/>
+          <p:nvPr/>
+        </p:nvSpPr>
+        <p:spPr>
+          <a:xfrm>
+            <a:off x="25755156" y="12357735"/>
+            <a:ext cx="2011680" cy="338328"/>
+          </a:xfrm>
+          <a:prstGeom prst="rect">
+            <a:avLst/>
+          </a:prstGeom>
+          <a:noFill/>
+          <a:ln/>
+        </p:spPr>
+        <p:txBody>
+          <a:bodyPr wrap="square" lIns="0" tIns="0" rIns="0" bIns="0" rtlCol="0" anchor="ctr"/>
+          <a:lstStyle/>
+          <a:p>
+            <a:pPr indent="0" marL="0">
+              <a:buNone/>
+            </a:pPr>
+            <a:r>
+              <a:rPr lang="en-US" sz="1300" b="1" dirty="0">
+                <a:solidFill>
+                  <a:srgbClr val="12202E"/>
+                </a:solidFill>
+                <a:latin typeface="Calibri" pitchFamily="34" charset="0"/>
+                <a:ea typeface="Calibri" pitchFamily="34" charset="-122"/>
+                <a:cs typeface="Calibri" pitchFamily="34" charset="-120"/>
+              </a:rPr>
+              <a:t>Explainability</a:t>
+            </a:r>
+            <a:endParaRPr lang="en-US" sz="1300" dirty="0"/>
+          </a:p>
+        </p:txBody>
+      </p:sp>
+      <p:sp>
+        <p:nvSpPr>
+          <p:cNvPr id="147" name="Shape 142"/>
+          <p:cNvSpPr/>
+          <p:nvPr/>
+        </p:nvSpPr>
+        <p:spPr>
+          <a:xfrm>
+            <a:off x="27766836" y="12412599"/>
+            <a:ext cx="896112" cy="228600"/>
+          </a:xfrm>
+          <a:prstGeom prst="roundRect">
+            <a:avLst>
+              <a:gd name="adj" fmla="val 20000"/>
+            </a:avLst>
+          </a:prstGeom>
+          <a:solidFill>
+            <a:srgbClr val="2A6FD6"/>
+          </a:solidFill>
+          <a:ln w="12700">
+            <a:solidFill>
+              <a:srgbClr val="2A6FD6"/>
+            </a:solidFill>
+            <a:prstDash val="solid"/>
+          </a:ln>
+        </p:spPr>
+      </p:sp>
+      <p:sp>
+        <p:nvSpPr>
+          <p:cNvPr id="148" name="Text 143"/>
+          <p:cNvSpPr txBox="1"/>
+          <p:nvPr/>
+        </p:nvSpPr>
+        <p:spPr>
+          <a:xfrm>
+            <a:off x="27766836" y="12412599"/>
+            <a:ext cx="896112" cy="228600"/>
+          </a:xfrm>
+          <a:prstGeom prst="rect">
+            <a:avLst/>
+          </a:prstGeom>
+          <a:noFill/>
+          <a:ln/>
+        </p:spPr>
+        <p:txBody>
+          <a:bodyPr wrap="square" lIns="0" tIns="0" rIns="0" bIns="0" rtlCol="0" anchor="ctr"/>
+          <a:lstStyle/>
+          <a:p>
+            <a:pPr algn="ctr" indent="0" marL="0">
+              <a:buNone/>
+            </a:pPr>
+            <a:r>
+              <a:rPr lang="en-US" sz="1150" b="1" dirty="0">
+                <a:solidFill>
+                  <a:srgbClr val="FFFFFF"/>
+                </a:solidFill>
+                <a:latin typeface="Calibri" pitchFamily="34" charset="0"/>
+                <a:ea typeface="Calibri" pitchFamily="34" charset="-122"/>
+                <a:cs typeface="Calibri" pitchFamily="34" charset="-120"/>
+              </a:rPr>
+              <a:t>Met</a:t>
+            </a:r>
+            <a:endParaRPr lang="en-US" sz="1150" dirty="0"/>
+          </a:p>
+        </p:txBody>
+      </p:sp>
+      <p:sp>
+        <p:nvSpPr>
+          <p:cNvPr id="149" name="Text 144"/>
+          <p:cNvSpPr txBox="1"/>
+          <p:nvPr/>
+        </p:nvSpPr>
+        <p:spPr>
+          <a:xfrm>
+            <a:off x="28772676" y="12357735"/>
+            <a:ext cx="4855824" cy="338328"/>
+          </a:xfrm>
+          <a:prstGeom prst="rect">
+            <a:avLst/>
+          </a:prstGeom>
+          <a:noFill/>
+          <a:ln/>
+        </p:spPr>
+        <p:txBody>
+          <a:bodyPr wrap="square" lIns="0" tIns="0" rIns="0" bIns="0" rtlCol="0" anchor="ctr"/>
+          <a:lstStyle/>
+          <a:p>
+            <a:pPr indent="0" marL="0">
+              <a:buNone/>
+            </a:pPr>
+            <a:r>
+              <a:rPr lang="en-US" sz="1300" dirty="0">
+                <a:solidFill>
+                  <a:srgbClr val="12202E"/>
+                </a:solidFill>
+                <a:latin typeface="Calibri" pitchFamily="34" charset="0"/>
+                <a:ea typeface="Calibri" pitchFamily="34" charset="-122"/>
+                <a:cs typeface="Calibri" pitchFamily="34" charset="-120"/>
+              </a:rPr>
+              <a:t>Signal = copy-number locus + mutational burden</a:t>
+            </a:r>
+            <a:endParaRPr lang="en-US" sz="1300" dirty="0"/>
+          </a:p>
+        </p:txBody>
+      </p:sp>
+      <p:sp>
+        <p:nvSpPr>
+          <p:cNvPr id="150" name="Shape 145"/>
+          <p:cNvSpPr/>
+          <p:nvPr/>
+        </p:nvSpPr>
+        <p:spPr>
+          <a:xfrm>
+            <a:off x="25755156" y="12696063"/>
+            <a:ext cx="7873344" cy="0"/>
+          </a:xfrm>
+          <a:prstGeom prst="line">
+            <a:avLst/>
+          </a:prstGeom>
+          <a:noFill/>
+          <a:ln w="9525">
+            <a:solidFill>
+              <a:srgbClr val="E0E4E8"/>
+            </a:solidFill>
+            <a:prstDash val="solid"/>
+          </a:ln>
+        </p:spPr>
+      </p:sp>
+      <p:sp>
+        <p:nvSpPr>
+          <p:cNvPr id="151" name="Shape 146"/>
+          <p:cNvSpPr/>
+          <p:nvPr/>
+        </p:nvSpPr>
+        <p:spPr>
+          <a:xfrm>
+            <a:off x="25755156" y="12696063"/>
+            <a:ext cx="7873344" cy="0"/>
+          </a:xfrm>
+          <a:prstGeom prst="line">
+            <a:avLst/>
+          </a:prstGeom>
+          <a:noFill/>
+          <a:ln w="19050">
+            <a:solidFill>
+              <a:srgbClr val="12202E"/>
+            </a:solidFill>
+            <a:prstDash val="solid"/>
+          </a:ln>
+        </p:spPr>
+      </p:sp>
+      <p:sp>
+        <p:nvSpPr>
+          <p:cNvPr id="152" name="Text 147"/>
+          <p:cNvSpPr txBox="1"/>
+          <p:nvPr/>
+        </p:nvSpPr>
+        <p:spPr>
+          <a:xfrm>
+            <a:off x="25755156" y="12787503"/>
+            <a:ext cx="7873344" cy="679514"/>
+          </a:xfrm>
+          <a:prstGeom prst="rect">
+            <a:avLst/>
+          </a:prstGeom>
+          <a:noFill/>
+          <a:ln/>
+        </p:spPr>
+        <p:txBody>
+          <a:bodyPr wrap="square" lIns="0" tIns="0" rIns="0" bIns="0" rtlCol="0" anchor="t"/>
+          <a:lstStyle/>
+          <a:p>
+            <a:pPr indent="0" marL="0">
+              <a:buNone/>
+            </a:pPr>
+            <a:r>
+              <a:rPr lang="en-US" sz="1350" b="1" dirty="0">
+                <a:solidFill>
+                  <a:srgbClr val="3F4B57"/>
+                </a:solidFill>
+                <a:latin typeface="Calibri" pitchFamily="34" charset="0"/>
+                <a:ea typeface="Calibri" pitchFamily="34" charset="-122"/>
+                <a:cs typeface="Calibri" pitchFamily="34" charset="-120"/>
+              </a:rPr>
+              <a:t>Figure 5. </a:t>
+            </a:r>
+            <a:pPr indent="0" marL="0">
+              <a:buNone/>
+            </a:pPr>
+            <a:r>
+              <a:rPr lang="en-US" sz="1350" dirty="0">
+                <a:solidFill>
+                  <a:srgbClr val="3F4B57"/>
+                </a:solidFill>
+                <a:latin typeface="Calibri" pitchFamily="34" charset="0"/>
+                <a:ea typeface="Calibri" pitchFamily="34" charset="-122"/>
+                <a:cs typeface="Calibri" pitchFamily="34" charset="-120"/>
+              </a:rPr>
+              <a:t>Assessment against the ESMO EBAI class B requirements. Replicate values from MSK-IMPACT 2017; [ ] to be computed on MSK-CHORD. Se, sensitivity for ≥1 altered target gene.</a:t>
+            </a:r>
+            <a:endParaRPr lang="en-US" sz="1350" dirty="0"/>
+          </a:p>
+        </p:txBody>
+      </p:sp>
+      <p:sp>
+        <p:nvSpPr>
+          <p:cNvPr id="153" name="Shape 148"/>
+          <p:cNvSpPr/>
+          <p:nvPr/>
+        </p:nvSpPr>
+        <p:spPr>
+          <a:xfrm>
+            <a:off x="25755156" y="13741336"/>
+            <a:ext cx="7873344" cy="0"/>
+          </a:xfrm>
+          <a:prstGeom prst="line">
+            <a:avLst/>
+          </a:prstGeom>
+          <a:noFill/>
+          <a:ln w="28575">
+            <a:solidFill>
+              <a:srgbClr val="12202E"/>
+            </a:solidFill>
+            <a:prstDash val="solid"/>
+          </a:ln>
+        </p:spPr>
+      </p:sp>
+      <p:sp>
+        <p:nvSpPr>
+          <p:cNvPr id="154" name="Text 149"/>
+          <p:cNvSpPr txBox="1"/>
+          <p:nvPr/>
+        </p:nvSpPr>
+        <p:spPr>
+          <a:xfrm>
+            <a:off x="25755156" y="13832776"/>
+            <a:ext cx="7873344" cy="566928"/>
+          </a:xfrm>
+          <a:prstGeom prst="rect">
+            <a:avLst/>
+          </a:prstGeom>
+          <a:noFill/>
+          <a:ln/>
+        </p:spPr>
+        <p:txBody>
+          <a:bodyPr wrap="square" lIns="0" tIns="0" rIns="0" bIns="0" rtlCol="0" anchor="t"/>
+          <a:lstStyle/>
+          <a:p>
+            <a:pPr indent="0" marL="0">
+              <a:buNone/>
+            </a:pPr>
+            <a:r>
+              <a:rPr lang="en-US" sz="3200" b="1" dirty="0">
+                <a:solidFill>
+                  <a:srgbClr val="12202E"/>
+                </a:solidFill>
+                <a:latin typeface="Cambria" pitchFamily="34" charset="0"/>
+                <a:ea typeface="Cambria" pitchFamily="34" charset="-122"/>
+                <a:cs typeface="Cambria" pitchFamily="34" charset="-120"/>
+              </a:rPr>
+              <a:t>6  Discussion</a:t>
+            </a:r>
+            <a:endParaRPr lang="en-US" sz="3200" dirty="0"/>
+          </a:p>
+        </p:txBody>
+      </p:sp>
+      <p:sp>
+        <p:nvSpPr>
+          <p:cNvPr id="155" name="Text 150"/>
+          <p:cNvSpPr txBox="1"/>
+          <p:nvPr/>
+        </p:nvSpPr>
+        <p:spPr>
+          <a:xfrm>
+            <a:off x="25755156" y="14610016"/>
+            <a:ext cx="7873344" cy="3039999"/>
           </a:xfrm>
           <a:prstGeom prst="rect">
             <a:avLst/>
@@ -7945,7 +9158,7 @@
               <a:buChar char="•"/>
             </a:pPr>
             <a:r>
-              <a:rPr lang="en-US" sz="1750" dirty="0">
+              <a:rPr lang="en-US" sz="1650" dirty="0">
                 <a:solidFill>
                   <a:srgbClr val="12202E"/>
                 </a:solidFill>
@@ -7955,7 +9168,7 @@
               </a:rPr>
               <a:t>A targeted panel carries predictive information on unassayed genes; per-gene AUROC and simple baselines, not pooled AUROC alone, measure how much.</a:t>
             </a:r>
-            <a:endParaRPr lang="en-US" sz="1750" dirty="0"/>
+            <a:endParaRPr lang="en-US" sz="1650" dirty="0"/>
           </a:p>
           <a:p>
             <a:pPr marL="342900" indent="-342900">
@@ -7966,7 +9179,7 @@
               <a:buChar char="•"/>
             </a:pPr>
             <a:r>
-              <a:rPr lang="en-US" sz="1750" dirty="0">
+              <a:rPr lang="en-US" sz="1650" dirty="0">
                 <a:solidFill>
                   <a:srgbClr val="12202E"/>
                 </a:solidFill>
@@ -7976,7 +9189,7 @@
               </a:rPr>
               <a:t>The signal is mainly copy-number co-location and mutational burden; a generative model must add joint fidelity to justify its complexity.</a:t>
             </a:r>
-            <a:endParaRPr lang="en-US" sz="1750" dirty="0"/>
+            <a:endParaRPr lang="en-US" sz="1650" dirty="0"/>
           </a:p>
           <a:p>
             <a:pPr marL="342900" indent="-342900">
@@ -7987,17 +9200,17 @@
               <a:buChar char="•"/>
             </a:pPr>
             <a:r>
-              <a:rPr lang="en-US" sz="1750" dirty="0">
-                <a:solidFill>
-                  <a:srgbClr val="12202E"/>
-                </a:solidFill>
-                <a:latin typeface="Calibri" pitchFamily="34" charset="0"/>
-                <a:ea typeface="Calibri" pitchFamily="34" charset="-122"/>
-                <a:cs typeface="Calibri" pitchFamily="34" charset="-120"/>
-              </a:rPr>
-              <a:t>Limitations: masked-panel evaluation is an upper bound; single split; actionable-gene subset not yet evaluated.</a:t>
-            </a:r>
-            <a:endParaRPr lang="en-US" sz="1750" dirty="0"/>
+              <a:rPr lang="en-US" sz="1650" dirty="0">
+                <a:solidFill>
+                  <a:srgbClr val="12202E"/>
+                </a:solidFill>
+                <a:latin typeface="Calibri" pitchFamily="34" charset="0"/>
+                <a:ea typeface="Calibri" pitchFamily="34" charset="-122"/>
+                <a:cs typeface="Calibri" pitchFamily="34" charset="-120"/>
+              </a:rPr>
+              <a:t>Limitations: masked-panel evaluation is an upper bound; single institution and split; fairness and actionable genes not yet evaluated.</a:t>
+            </a:r>
+            <a:endParaRPr lang="en-US" sz="1650" dirty="0"/>
           </a:p>
           <a:p>
             <a:pPr marL="342900" indent="-342900">
@@ -8008,23 +9221,23 @@
               <a:buChar char="•"/>
             </a:pPr>
             <a:r>
-              <a:rPr lang="en-US" sz="1750" dirty="0">
-                <a:solidFill>
-                  <a:srgbClr val="12202E"/>
-                </a:solidFill>
-                <a:latin typeface="Calibri" pitchFamily="34" charset="0"/>
-                <a:ea typeface="Calibri" pitchFamily="34" charset="-122"/>
-                <a:cs typeface="Calibri" pitchFamily="34" charset="-120"/>
-              </a:rPr>
-              <a:t>At ~1% prevalence, use is triage for broad CGP, not replacement.</a:t>
-            </a:r>
-            <a:endParaRPr lang="en-US" sz="1750" dirty="0"/>
+              <a:rPr lang="en-US" sz="1650" dirty="0">
+                <a:solidFill>
+                  <a:srgbClr val="12202E"/>
+                </a:solidFill>
+                <a:latin typeface="Calibri" pitchFamily="34" charset="0"/>
+                <a:ea typeface="Calibri" pitchFamily="34" charset="-122"/>
+                <a:cs typeface="Calibri" pitchFamily="34" charset="-120"/>
+              </a:rPr>
+              <a:t>As an EBAI class B pre-screening tool, negatives still require confirmatory CGP (NPV 0.86 at 90% sensitivity).</a:t>
+            </a:r>
+            <a:endParaRPr lang="en-US" sz="1650" dirty="0"/>
           </a:p>
         </p:txBody>
       </p:sp>
       <p:sp>
         <p:nvSpPr>
-          <p:cNvPr id="112" name="Shape 106"/>
+          <p:cNvPr id="156" name="Shape 151"/>
           <p:cNvSpPr/>
           <p:nvPr/>
         </p:nvSpPr>
@@ -8047,7 +9260,7 @@
       </p:sp>
       <p:sp>
         <p:nvSpPr>
-          <p:cNvPr id="113" name="Text 107"/>
+          <p:cNvPr id="157" name="Text 152"/>
           <p:cNvSpPr txBox="1"/>
           <p:nvPr/>
         </p:nvSpPr>
@@ -8133,11 +9346,28 @@
             </a:r>
             <a:endParaRPr lang="en-US" sz="1250" dirty="0"/>
           </a:p>
+          <a:p>
+            <a:pPr indent="0" marL="0">
+              <a:buNone/>
+            </a:pPr>
+            <a:r>
+              <a:rPr lang="en-US" sz="1250" dirty="0">
+                <a:solidFill>
+                  <a:srgbClr val="2C3A47"/>
+                </a:solidFill>
+                <a:latin typeface="Calibri" pitchFamily="34" charset="0"/>
+                <a:ea typeface="Calibri" pitchFamily="34" charset="-122"/>
+                <a:cs typeface="Calibri" pitchFamily="34" charset="-120"/>
+              </a:rPr>
+              <a:t>5. Aldea M, et al. ESMO basic requirements for AI-based biomarkers in oncology (EBAI). Ann Oncol 2026;37:414–25.</a:t>
+            </a:r>
+            <a:endParaRPr lang="en-US" sz="1250" dirty="0"/>
+          </a:p>
         </p:txBody>
       </p:sp>
       <p:sp>
         <p:nvSpPr>
-          <p:cNvPr id="114" name="Text 108"/>
+          <p:cNvPr id="158" name="Text 153"/>
           <p:cNvSpPr txBox="1"/>
           <p:nvPr/>
         </p:nvSpPr>
@@ -8207,7 +9437,7 @@
       </p:sp>
       <p:sp>
         <p:nvSpPr>
-          <p:cNvPr id="115" name="Text 109"/>
+          <p:cNvPr id="159" name="Text 154"/>
           <p:cNvSpPr txBox="1"/>
           <p:nvPr/>
         </p:nvSpPr>
@@ -8280,7 +9510,7 @@
       </p:sp>
       <p:sp>
         <p:nvSpPr>
-          <p:cNvPr id="116" name="Shape 110"/>
+          <p:cNvPr id="160" name="Shape 155"/>
           <p:cNvSpPr/>
           <p:nvPr/>
         </p:nvSpPr>
@@ -8305,7 +9535,7 @@
       </p:sp>
       <p:sp>
         <p:nvSpPr>
-          <p:cNvPr id="117" name="Text 111"/>
+          <p:cNvPr id="161" name="Text 156"/>
           <p:cNvSpPr txBox="1"/>
           <p:nvPr/>
         </p:nvSpPr>

</xml_diff>

<commit_message>
Frame P305 poster as an EBAI class B biomarker
Background now states the class B rationale (alternative input, enrichment vs
rule-out); Methods lists the EBAI validation requirements with a post hoc
precision estimate; Figure 5 grades all seven EBAI dimensions plus validation
and post-adoption requirements.

Co-Authored-By: Claude Opus 5.5 <noreply@anthropic.com>
Claude-Session: https://claude.ai/code/session_01XfxNdpDPmWZQpH5ScSMkJ1
</commit_message>
<xml_diff>
--- a/docs/poster/ESMO_P305_poster.pptx
+++ b/docs/poster/ESMO_P305_poster.pptx
@@ -1546,7 +1546,7 @@
                 <a:ea typeface="Cambria" pitchFamily="34" charset="-122"/>
                 <a:cs typeface="Cambria" pitchFamily="34" charset="-120"/>
               </a:rPr>
-              <a:t>1  Introduction</a:t>
+              <a:t>1  Background</a:t>
             </a:r>
             <a:endParaRPr lang="en-US" sz="3200" dirty="0"/>
           </a:p>
@@ -1585,7 +1585,7 @@
                 <a:ea typeface="Calibri" pitchFamily="34" charset="-122"/>
                 <a:cs typeface="Calibri" pitchFamily="34" charset="-120"/>
               </a:rPr>
-              <a:t>Comprehensive genomic profiling (CGP) underpins treatment selection in NSCLC, yet panel content varies widely across institutions and health-care systems. Smaller targeted panels reduce cost and turnaround time but leave part of the tumour genome unmeasured.</a:t>
+              <a:t>Comprehensive genomic profiling (CGP) guides treatment in NSCLC, but panel content, cost and turnaround time differ widely between institutions, and smaller targeted panels leave part of the tumour genome unmeasured.</a:t>
             </a:r>
             <a:endParaRPr lang="en-US" sz="1650" dirty="0"/>
           </a:p>
@@ -1600,7 +1600,7 @@
         <p:spPr>
           <a:xfrm>
             <a:off x="571500" y="6525006"/>
-            <a:ext cx="7873344" cy="1084326"/>
+            <a:ext cx="7873344" cy="2394014"/>
           </a:xfrm>
           <a:prstGeom prst="rect">
             <a:avLst/>
@@ -1624,6 +1624,115 @@
                 <a:ea typeface="Calibri" pitchFamily="34" charset="-122"/>
                 <a:cs typeface="Calibri" pitchFamily="34" charset="-120"/>
               </a:rPr>
+              <a:t>EBAI class B. </a:t>
+            </a:r>
+            <a:pPr indent="0" marL="0">
+              <a:buNone/>
+            </a:pPr>
+            <a:r>
+              <a:rPr lang="en-US" sz="1650" dirty="0">
+                <a:solidFill>
+                  <a:srgbClr val="12202E"/>
+                </a:solidFill>
+                <a:latin typeface="Calibri" pitchFamily="34" charset="0"/>
+                <a:ea typeface="Calibri" pitchFamily="34" charset="-122"/>
+                <a:cs typeface="Calibri" pitchFamily="34" charset="-120"/>
+              </a:rPr>
+              <a:t>Under the ESMO basic requirements for AI-based biomarkers (EBAI), a model that predicts an established biomarker from an input different from the gold-standard test is class B; here the input is the smaller panel itself. Because the input differs from the reference test, risk and complexity exceed class A. Such tools may predict only a subset of alterations with sufficient sensitivity and specificity, and usually aim to </a:t>
+            </a:r>
+            <a:pPr indent="0" marL="0">
+              <a:buNone/>
+            </a:pPr>
+            <a:r>
+              <a:rPr lang="en-US" sz="1650" b="1" dirty="0">
+                <a:solidFill>
+                  <a:srgbClr val="12202E"/>
+                </a:solidFill>
+                <a:latin typeface="Calibri" pitchFamily="34" charset="0"/>
+                <a:ea typeface="Calibri" pitchFamily="34" charset="-122"/>
+                <a:cs typeface="Calibri" pitchFamily="34" charset="-120"/>
+              </a:rPr>
+              <a:t>enrich</a:t>
+            </a:r>
+            <a:pPr indent="0" marL="0">
+              <a:buNone/>
+            </a:pPr>
+            <a:r>
+              <a:rPr lang="en-US" sz="1650" dirty="0">
+                <a:solidFill>
+                  <a:srgbClr val="12202E"/>
+                </a:solidFill>
+                <a:latin typeface="Calibri" pitchFamily="34" charset="0"/>
+                <a:ea typeface="Calibri" pitchFamily="34" charset="-122"/>
+                <a:cs typeface="Calibri" pitchFamily="34" charset="-120"/>
+              </a:rPr>
+              <a:t> a population for confirmatory testing, or, where a negative result reliably excludes the alteration, to </a:t>
+            </a:r>
+            <a:pPr indent="0" marL="0">
+              <a:buNone/>
+            </a:pPr>
+            <a:r>
+              <a:rPr lang="en-US" sz="1650" b="1" dirty="0">
+                <a:solidFill>
+                  <a:srgbClr val="12202E"/>
+                </a:solidFill>
+                <a:latin typeface="Calibri" pitchFamily="34" charset="0"/>
+                <a:ea typeface="Calibri" pitchFamily="34" charset="-122"/>
+                <a:cs typeface="Calibri" pitchFamily="34" charset="-120"/>
+              </a:rPr>
+              <a:t>rule out</a:t>
+            </a:r>
+            <a:pPr indent="0" marL="0">
+              <a:buNone/>
+            </a:pPr>
+            <a:r>
+              <a:rPr lang="en-US" sz="1650" dirty="0">
+                <a:solidFill>
+                  <a:srgbClr val="12202E"/>
+                </a:solidFill>
+                <a:latin typeface="Calibri" pitchFamily="34" charset="0"/>
+                <a:ea typeface="Calibri" pitchFamily="34" charset="-122"/>
+                <a:cs typeface="Calibri" pitchFamily="34" charset="-120"/>
+              </a:rPr>
+              <a:t> testing. They do not substitute an established genomic test.</a:t>
+            </a:r>
+            <a:endParaRPr lang="en-US" sz="1650" dirty="0"/>
+          </a:p>
+        </p:txBody>
+      </p:sp>
+      <p:sp>
+        <p:nvSpPr>
+          <p:cNvPr id="13" name="Text 11"/>
+          <p:cNvSpPr txBox="1"/>
+          <p:nvPr/>
+        </p:nvSpPr>
+        <p:spPr>
+          <a:xfrm>
+            <a:off x="571500" y="9147620"/>
+            <a:ext cx="7873344" cy="1346264"/>
+          </a:xfrm>
+          <a:prstGeom prst="rect">
+            <a:avLst/>
+          </a:prstGeom>
+          <a:noFill/>
+          <a:ln/>
+        </p:spPr>
+        <p:txBody>
+          <a:bodyPr wrap="square" lIns="0" tIns="0" rIns="0" bIns="0" rtlCol="0" anchor="t"/>
+          <a:lstStyle/>
+          <a:p>
+            <a:pPr indent="0" marL="0">
+              <a:buNone/>
+            </a:pPr>
+            <a:r>
+              <a:rPr lang="en-US" sz="1650" b="1" dirty="0">
+                <a:solidFill>
+                  <a:srgbClr val="12202E"/>
+                </a:solidFill>
+                <a:latin typeface="Calibri" pitchFamily="34" charset="0"/>
+                <a:ea typeface="Calibri" pitchFamily="34" charset="-122"/>
+                <a:cs typeface="Calibri" pitchFamily="34" charset="-120"/>
+              </a:rPr>
               <a:t>Objective. </a:t>
             </a:r>
             <a:pPr indent="0" marL="0">
@@ -1638,7 +1747,7 @@
                 <a:ea typeface="Calibri" pitchFamily="34" charset="-122"/>
                 <a:cs typeface="Calibri" pitchFamily="34" charset="-120"/>
               </a:rPr>
-              <a:t>To learn the conditional distribution of alterations in genes absent from a targeted panel given the genes it measures, to benchmark it against simple statistical baselines, and to identify which signals make the missing genes predictable.</a:t>
+              <a:t>To learn the conditional distribution of alterations in genes absent from a targeted panel given the genes it measures, benchmark it against simple baselines, and evaluate it along the seven EBAI dimensions: comparator, performance, generalisability, fairness, explainability, cost and turnaround time.</a:t>
             </a:r>
             <a:endParaRPr lang="en-US" sz="1650" dirty="0"/>
           </a:p>
@@ -1646,13 +1755,13 @@
       </p:sp>
       <p:sp>
         <p:nvSpPr>
-          <p:cNvPr id="13" name="Shape 11"/>
+          <p:cNvPr id="14" name="Shape 12"/>
           <p:cNvSpPr/>
           <p:nvPr/>
         </p:nvSpPr>
         <p:spPr>
           <a:xfrm>
-            <a:off x="571500" y="7929372"/>
+            <a:off x="571500" y="10813923"/>
             <a:ext cx="7873344" cy="0"/>
           </a:xfrm>
           <a:prstGeom prst="line">
@@ -1669,13 +1778,13 @@
       </p:sp>
       <p:sp>
         <p:nvSpPr>
-          <p:cNvPr id="14" name="Text 12"/>
+          <p:cNvPr id="15" name="Text 13"/>
           <p:cNvSpPr txBox="1"/>
           <p:nvPr/>
         </p:nvSpPr>
         <p:spPr>
           <a:xfrm>
-            <a:off x="571500" y="8020812"/>
+            <a:off x="571500" y="10905363"/>
             <a:ext cx="7873344" cy="566928"/>
           </a:xfrm>
           <a:prstGeom prst="rect">
@@ -1708,13 +1817,13 @@
       </p:sp>
       <p:sp>
         <p:nvSpPr>
-          <p:cNvPr id="15" name="Shape 13"/>
+          <p:cNvPr id="16" name="Shape 14"/>
           <p:cNvSpPr/>
           <p:nvPr/>
         </p:nvSpPr>
         <p:spPr>
           <a:xfrm>
-            <a:off x="571500" y="8798052"/>
+            <a:off x="571500" y="11682603"/>
             <a:ext cx="5314507" cy="566928"/>
           </a:xfrm>
           <a:prstGeom prst="rect">
@@ -1728,13 +1837,13 @@
       </p:sp>
       <p:sp>
         <p:nvSpPr>
-          <p:cNvPr id="16" name="Text 14"/>
+          <p:cNvPr id="17" name="Text 15"/>
           <p:cNvSpPr txBox="1"/>
           <p:nvPr/>
         </p:nvSpPr>
         <p:spPr>
           <a:xfrm>
-            <a:off x="571500" y="8798052"/>
+            <a:off x="571500" y="11682603"/>
             <a:ext cx="5314507" cy="566928"/>
           </a:xfrm>
           <a:prstGeom prst="rect">
@@ -1767,13 +1876,13 @@
       </p:sp>
       <p:sp>
         <p:nvSpPr>
-          <p:cNvPr id="17" name="Shape 15"/>
+          <p:cNvPr id="18" name="Shape 16"/>
           <p:cNvSpPr/>
           <p:nvPr/>
         </p:nvSpPr>
         <p:spPr>
           <a:xfrm>
-            <a:off x="5886007" y="8798052"/>
+            <a:off x="5886007" y="11682603"/>
             <a:ext cx="2558837" cy="566928"/>
           </a:xfrm>
           <a:prstGeom prst="rect">
@@ -1792,93 +1901,40 @@
       </p:sp>
       <p:sp>
         <p:nvSpPr>
-          <p:cNvPr id="18" name="Text 16"/>
-          <p:cNvSpPr txBox="1"/>
-          <p:nvPr/>
-        </p:nvSpPr>
-        <p:spPr>
-          <a:xfrm>
-            <a:off x="5886007" y="8798052"/>
-            <a:ext cx="2558837" cy="566928"/>
-          </a:xfrm>
-          <a:prstGeom prst="rect">
-            <a:avLst/>
-          </a:prstGeom>
-          <a:noFill/>
-          <a:ln/>
-        </p:spPr>
-        <p:txBody>
-          <a:bodyPr wrap="square" lIns="0" tIns="0" rIns="0" bIns="0" rtlCol="0" anchor="ctr"/>
-          <a:lstStyle/>
-          <a:p>
-            <a:pPr algn="ctr" indent="0" marL="0">
-              <a:buNone/>
-            </a:pPr>
-            <a:r>
-              <a:rPr lang="en-US" sz="1500" b="1" dirty="0">
-                <a:solidFill>
-                  <a:srgbClr val="7A2E0B"/>
-                </a:solidFill>
-                <a:latin typeface="Calibri" pitchFamily="34" charset="0"/>
-                <a:ea typeface="Calibri" pitchFamily="34" charset="-122"/>
-                <a:cs typeface="Calibri" pitchFamily="34" charset="-120"/>
-              </a:rPr>
-              <a:t>164 genes (target)</a:t>
-            </a:r>
-            <a:endParaRPr lang="en-US" sz="1500" dirty="0"/>
-          </a:p>
-        </p:txBody>
-      </p:sp>
-      <p:sp>
-        <p:nvSpPr>
           <p:cNvPr id="19" name="Text 17"/>
           <p:cNvSpPr txBox="1"/>
           <p:nvPr/>
         </p:nvSpPr>
         <p:spPr>
           <a:xfrm>
-            <a:off x="571500" y="9474708"/>
-            <a:ext cx="7873344" cy="465201"/>
-          </a:xfrm>
-          <a:prstGeom prst="rect">
-            <a:avLst/>
-          </a:prstGeom>
-          <a:noFill/>
-          <a:ln/>
-        </p:spPr>
-        <p:txBody>
-          <a:bodyPr wrap="square" lIns="0" tIns="0" rIns="0" bIns="0" rtlCol="0" anchor="t"/>
-          <a:lstStyle/>
-          <a:p>
-            <a:pPr indent="0" marL="0">
-              <a:buNone/>
-            </a:pPr>
-            <a:r>
-              <a:rPr lang="en-US" sz="1350" b="1" dirty="0">
-                <a:solidFill>
-                  <a:srgbClr val="3F4B57"/>
-                </a:solidFill>
-                <a:latin typeface="Calibri" pitchFamily="34" charset="0"/>
-                <a:ea typeface="Calibri" pitchFamily="34" charset="-122"/>
-                <a:cs typeface="Calibri" pitchFamily="34" charset="-120"/>
-              </a:rPr>
-              <a:t>Figure 1. </a:t>
-            </a:r>
-            <a:pPr indent="0" marL="0">
-              <a:buNone/>
-            </a:pPr>
-            <a:r>
-              <a:rPr lang="en-US" sz="1350" dirty="0">
-                <a:solidFill>
-                  <a:srgbClr val="3F4B57"/>
-                </a:solidFill>
-                <a:latin typeface="Calibri" pitchFamily="34" charset="0"/>
-                <a:ea typeface="Calibri" pitchFamily="34" charset="-122"/>
-                <a:cs typeface="Calibri" pitchFamily="34" charset="-120"/>
-              </a:rPr>
-              <a:t>Task definition. IMPACT341 ⊂ IMPACT505; the 164 genes present only in IMPACT505 are masked from the input and predicted.</a:t>
-            </a:r>
-            <a:endParaRPr lang="en-US" sz="1350" dirty="0"/>
+            <a:off x="5886007" y="11682603"/>
+            <a:ext cx="2558837" cy="566928"/>
+          </a:xfrm>
+          <a:prstGeom prst="rect">
+            <a:avLst/>
+          </a:prstGeom>
+          <a:noFill/>
+          <a:ln/>
+        </p:spPr>
+        <p:txBody>
+          <a:bodyPr wrap="square" lIns="0" tIns="0" rIns="0" bIns="0" rtlCol="0" anchor="ctr"/>
+          <a:lstStyle/>
+          <a:p>
+            <a:pPr algn="ctr" indent="0" marL="0">
+              <a:buNone/>
+            </a:pPr>
+            <a:r>
+              <a:rPr lang="en-US" sz="1500" b="1" dirty="0">
+                <a:solidFill>
+                  <a:srgbClr val="7A2E0B"/>
+                </a:solidFill>
+                <a:latin typeface="Calibri" pitchFamily="34" charset="0"/>
+                <a:ea typeface="Calibri" pitchFamily="34" charset="-122"/>
+                <a:cs typeface="Calibri" pitchFamily="34" charset="-120"/>
+              </a:rPr>
+              <a:t>164 genes (target)</a:t>
+            </a:r>
+            <a:endParaRPr lang="en-US" sz="1500" dirty="0"/>
           </a:p>
         </p:txBody>
       </p:sp>
@@ -1890,7 +1946,60 @@
         </p:nvSpPr>
         <p:spPr>
           <a:xfrm>
-            <a:off x="571500" y="10214229"/>
+            <a:off x="571500" y="12359259"/>
+            <a:ext cx="7873344" cy="465201"/>
+          </a:xfrm>
+          <a:prstGeom prst="rect">
+            <a:avLst/>
+          </a:prstGeom>
+          <a:noFill/>
+          <a:ln/>
+        </p:spPr>
+        <p:txBody>
+          <a:bodyPr wrap="square" lIns="0" tIns="0" rIns="0" bIns="0" rtlCol="0" anchor="t"/>
+          <a:lstStyle/>
+          <a:p>
+            <a:pPr indent="0" marL="0">
+              <a:buNone/>
+            </a:pPr>
+            <a:r>
+              <a:rPr lang="en-US" sz="1350" b="1" dirty="0">
+                <a:solidFill>
+                  <a:srgbClr val="3F4B57"/>
+                </a:solidFill>
+                <a:latin typeface="Calibri" pitchFamily="34" charset="0"/>
+                <a:ea typeface="Calibri" pitchFamily="34" charset="-122"/>
+                <a:cs typeface="Calibri" pitchFamily="34" charset="-120"/>
+              </a:rPr>
+              <a:t>Figure 1. </a:t>
+            </a:r>
+            <a:pPr indent="0" marL="0">
+              <a:buNone/>
+            </a:pPr>
+            <a:r>
+              <a:rPr lang="en-US" sz="1350" dirty="0">
+                <a:solidFill>
+                  <a:srgbClr val="3F4B57"/>
+                </a:solidFill>
+                <a:latin typeface="Calibri" pitchFamily="34" charset="0"/>
+                <a:ea typeface="Calibri" pitchFamily="34" charset="-122"/>
+                <a:cs typeface="Calibri" pitchFamily="34" charset="-120"/>
+              </a:rPr>
+              <a:t>Task definition. IMPACT341 ⊂ IMPACT505; the 164 genes present only in IMPACT505 are masked from the input and predicted.</a:t>
+            </a:r>
+            <a:endParaRPr lang="en-US" sz="1350" dirty="0"/>
+          </a:p>
+        </p:txBody>
+      </p:sp>
+      <p:sp>
+        <p:nvSpPr>
+          <p:cNvPr id="21" name="Text 19"/>
+          <p:cNvSpPr txBox="1"/>
+          <p:nvPr/>
+        </p:nvSpPr>
+        <p:spPr>
+          <a:xfrm>
+            <a:off x="571500" y="13098780"/>
             <a:ext cx="7873344" cy="250888"/>
           </a:xfrm>
           <a:prstGeom prst="rect">
@@ -1950,7 +2059,7 @@
           </p:nvPr>
         </p:nvGraphicFramePr>
         <p:xfrm>
-          <a:off x="571500" y="10574846"/>
+          <a:off x="571500" y="13459397"/>
           <a:ext cx="7873344" cy="914400"/>
         </p:xfrm>
         <a:graphic>
@@ -2759,13 +2868,13 @@
       </p:graphicFrame>
       <p:sp>
         <p:nvSpPr>
-          <p:cNvPr id="22" name="Shape 19"/>
+          <p:cNvPr id="23" name="Shape 20"/>
           <p:cNvSpPr/>
           <p:nvPr/>
         </p:nvSpPr>
         <p:spPr>
           <a:xfrm>
-            <a:off x="571500" y="10574846"/>
+            <a:off x="571500" y="13459397"/>
             <a:ext cx="7873344" cy="0"/>
           </a:xfrm>
           <a:prstGeom prst="line">
@@ -2782,13 +2891,13 @@
       </p:sp>
       <p:sp>
         <p:nvSpPr>
-          <p:cNvPr id="23" name="Shape 20"/>
+          <p:cNvPr id="24" name="Shape 21"/>
           <p:cNvSpPr/>
           <p:nvPr/>
         </p:nvSpPr>
         <p:spPr>
           <a:xfrm>
-            <a:off x="571500" y="12879134"/>
+            <a:off x="571500" y="15763685"/>
             <a:ext cx="7873344" cy="0"/>
           </a:xfrm>
           <a:prstGeom prst="line">
@@ -2805,13 +2914,13 @@
       </p:sp>
       <p:sp>
         <p:nvSpPr>
-          <p:cNvPr id="24" name="Text 21"/>
+          <p:cNvPr id="25" name="Text 22"/>
           <p:cNvSpPr txBox="1"/>
           <p:nvPr/>
         </p:nvSpPr>
         <p:spPr>
           <a:xfrm>
-            <a:off x="571500" y="13153454"/>
+            <a:off x="571500" y="16038005"/>
             <a:ext cx="7873344" cy="1608201"/>
           </a:xfrm>
           <a:prstGeom prst="rect">
@@ -2858,7 +2967,7 @@
       </p:sp>
       <p:sp>
         <p:nvSpPr>
-          <p:cNvPr id="25" name="Shape 22"/>
+          <p:cNvPr id="26" name="Shape 23"/>
           <p:cNvSpPr/>
           <p:nvPr/>
         </p:nvSpPr>
@@ -2881,7 +2990,7 @@
       </p:sp>
       <p:sp>
         <p:nvSpPr>
-          <p:cNvPr id="26" name="Text 23"/>
+          <p:cNvPr id="27" name="Text 24"/>
           <p:cNvSpPr txBox="1"/>
           <p:nvPr/>
         </p:nvSpPr>
@@ -2920,7 +3029,7 @@
       </p:sp>
       <p:sp>
         <p:nvSpPr>
-          <p:cNvPr id="27" name="Text 24"/>
+          <p:cNvPr id="28" name="Text 25"/>
           <p:cNvSpPr txBox="1"/>
           <p:nvPr/>
         </p:nvSpPr>
@@ -3057,7 +3166,7 @@
       </p:sp>
       <p:sp>
         <p:nvSpPr>
-          <p:cNvPr id="28" name="Text 25"/>
+          <p:cNvPr id="29" name="Text 26"/>
           <p:cNvSpPr txBox="1"/>
           <p:nvPr/>
         </p:nvSpPr>
@@ -3138,7 +3247,7 @@
       </p:sp>
       <p:sp>
         <p:nvSpPr>
-          <p:cNvPr id="29" name="Shape 26"/>
+          <p:cNvPr id="30" name="Shape 27"/>
           <p:cNvSpPr/>
           <p:nvPr/>
         </p:nvSpPr>
@@ -3158,7 +3267,7 @@
       </p:sp>
       <p:sp>
         <p:nvSpPr>
-          <p:cNvPr id="30" name="Text 27"/>
+          <p:cNvPr id="31" name="Text 28"/>
           <p:cNvSpPr txBox="1"/>
           <p:nvPr/>
         </p:nvSpPr>
@@ -3492,7 +3601,7 @@
       </p:sp>
       <p:sp>
         <p:nvSpPr>
-          <p:cNvPr id="31" name="Shape 28"/>
+          <p:cNvPr id="32" name="Shape 29"/>
           <p:cNvSpPr/>
           <p:nvPr/>
         </p:nvSpPr>
@@ -3517,7 +3626,7 @@
       </p:sp>
       <p:sp>
         <p:nvSpPr>
-          <p:cNvPr id="32" name="Text 29"/>
+          <p:cNvPr id="33" name="Text 30"/>
           <p:cNvSpPr txBox="1"/>
           <p:nvPr/>
         </p:nvSpPr>
@@ -3584,7 +3693,7 @@
       </p:sp>
       <p:sp>
         <p:nvSpPr>
-          <p:cNvPr id="33" name="Text 30"/>
+          <p:cNvPr id="34" name="Text 31"/>
           <p:cNvSpPr txBox="1"/>
           <p:nvPr/>
         </p:nvSpPr>
@@ -3623,7 +3732,7 @@
       </p:sp>
       <p:sp>
         <p:nvSpPr>
-          <p:cNvPr id="34" name="Shape 31"/>
+          <p:cNvPr id="35" name="Shape 32"/>
           <p:cNvSpPr/>
           <p:nvPr/>
         </p:nvSpPr>
@@ -3643,7 +3752,7 @@
       </p:sp>
       <p:sp>
         <p:nvSpPr>
-          <p:cNvPr id="35" name="Text 32"/>
+          <p:cNvPr id="36" name="Text 33"/>
           <p:cNvSpPr txBox="1"/>
           <p:nvPr/>
         </p:nvSpPr>
@@ -3738,7 +3847,7 @@
       </p:sp>
       <p:sp>
         <p:nvSpPr>
-          <p:cNvPr id="36" name="Text 33"/>
+          <p:cNvPr id="37" name="Text 34"/>
           <p:cNvSpPr txBox="1"/>
           <p:nvPr/>
         </p:nvSpPr>
@@ -3777,7 +3886,7 @@
       </p:sp>
       <p:sp>
         <p:nvSpPr>
-          <p:cNvPr id="37" name="Shape 34"/>
+          <p:cNvPr id="38" name="Shape 35"/>
           <p:cNvSpPr/>
           <p:nvPr/>
         </p:nvSpPr>
@@ -3802,7 +3911,7 @@
       </p:sp>
       <p:sp>
         <p:nvSpPr>
-          <p:cNvPr id="38" name="Text 35"/>
+          <p:cNvPr id="39" name="Text 36"/>
           <p:cNvSpPr txBox="1"/>
           <p:nvPr/>
         </p:nvSpPr>
@@ -3883,7 +3992,7 @@
       </p:sp>
       <p:sp>
         <p:nvSpPr>
-          <p:cNvPr id="39" name="Shape 36"/>
+          <p:cNvPr id="40" name="Shape 37"/>
           <p:cNvSpPr/>
           <p:nvPr/>
         </p:nvSpPr>
@@ -3903,7 +4012,7 @@
       </p:sp>
       <p:sp>
         <p:nvSpPr>
-          <p:cNvPr id="40" name="Text 37"/>
+          <p:cNvPr id="41" name="Text 38"/>
           <p:cNvSpPr txBox="1"/>
           <p:nvPr/>
         </p:nvSpPr>
@@ -3942,7 +4051,7 @@
       </p:sp>
       <p:sp>
         <p:nvSpPr>
-          <p:cNvPr id="41" name="Text 38"/>
+          <p:cNvPr id="42" name="Text 39"/>
           <p:cNvSpPr txBox="1"/>
           <p:nvPr/>
         </p:nvSpPr>
@@ -3995,67 +4104,14 @@
       </p:sp>
       <p:sp>
         <p:nvSpPr>
-          <p:cNvPr id="42" name="Text 39"/>
-          <p:cNvSpPr txBox="1"/>
-          <p:nvPr/>
-        </p:nvSpPr>
-        <p:spPr>
-          <a:xfrm>
-            <a:off x="8966052" y="11399711"/>
-            <a:ext cx="7873344" cy="1608201"/>
-          </a:xfrm>
-          <a:prstGeom prst="rect">
-            <a:avLst/>
-          </a:prstGeom>
-          <a:noFill/>
-          <a:ln/>
-        </p:spPr>
-        <p:txBody>
-          <a:bodyPr wrap="square" lIns="0" tIns="0" rIns="0" bIns="0" rtlCol="0" anchor="t"/>
-          <a:lstStyle/>
-          <a:p>
-            <a:pPr indent="0" marL="0">
-              <a:buNone/>
-            </a:pPr>
-            <a:r>
-              <a:rPr lang="en-US" sz="1650" b="1" dirty="0">
-                <a:solidFill>
-                  <a:srgbClr val="12202E"/>
-                </a:solidFill>
-                <a:latin typeface="Calibri" pitchFamily="34" charset="0"/>
-                <a:ea typeface="Calibri" pitchFamily="34" charset="-122"/>
-                <a:cs typeface="Calibri" pitchFamily="34" charset="-120"/>
-              </a:rPr>
-              <a:t>3.3 Probability read-out. </a:t>
-            </a:r>
-            <a:pPr indent="0" marL="0">
-              <a:buNone/>
-            </a:pPr>
-            <a:r>
-              <a:rPr lang="en-US" sz="1650" dirty="0">
-                <a:solidFill>
-                  <a:srgbClr val="12202E"/>
-                </a:solidFill>
-                <a:latin typeface="Calibri" pitchFamily="34" charset="0"/>
-                <a:ea typeface="Calibri" pitchFamily="34" charset="-122"/>
-                <a:cs typeface="Calibri" pitchFamily="34" charset="-120"/>
-              </a:rPr>
-              <a:t>At t = 0 the path is independent of x₁, so the optimal field satisfies v*(x₀, 0 | c) = 𝔼[x₁ | c] − x₀. Per-gene probabilities p̂ = ½(1 + x₀ + vθ(x₀, 0 | c)), averaged over K noise draws, equal the infinite-sample Monte Carlo estimate without its 1/S resolution limit, which at ~1% prevalence ties most pairs at 0. [state read-out used]</a:t>
-            </a:r>
-            <a:endParaRPr lang="en-US" sz="1650" dirty="0"/>
-          </a:p>
-        </p:txBody>
-      </p:sp>
-      <p:sp>
-        <p:nvSpPr>
           <p:cNvPr id="43" name="Text 40"/>
           <p:cNvSpPr txBox="1"/>
           <p:nvPr/>
         </p:nvSpPr>
         <p:spPr>
           <a:xfrm>
-            <a:off x="8966052" y="13236512"/>
-            <a:ext cx="7873344" cy="3179826"/>
+            <a:off x="8966052" y="11399711"/>
+            <a:ext cx="7873344" cy="1084326"/>
           </a:xfrm>
           <a:prstGeom prst="rect">
             <a:avLst/>
@@ -4079,7 +4135,7 @@
                 <a:ea typeface="Calibri" pitchFamily="34" charset="-122"/>
                 <a:cs typeface="Calibri" pitchFamily="34" charset="-120"/>
               </a:rPr>
-              <a:t>3.4 Evaluation. </a:t>
+              <a:t>3.3 Probability read-out. </a:t>
             </a:r>
             <a:pPr indent="0" marL="0">
               <a:buNone/>
@@ -4093,7 +4149,7 @@
                 <a:ea typeface="Calibri" pitchFamily="34" charset="-122"/>
                 <a:cs typeface="Calibri" pitchFamily="34" charset="-120"/>
               </a:rPr>
-              <a:t>Discrimination: AUROC pooled over gene–patient pairs (primary) and per gene (genes with ≥5 test events), where a prevalence-only predictor scores exactly 0.50. Class imbalance: AUPRC against the prevalence of 0.012. Calibration: slope, intercept, observed:expected (O:E) ratio and Brier skill score. Intended-use operating point (EBAI class B): sensitivity, specificity, PPV, NPV and LR± for ≥1 altered target gene. Joint fidelity, the property that justifies a generative model: energy score of sampled profiles versus independent Bernoulli draws from the same marginals. Comparators on identical splits: prevalence; burden + locus (3 burden counts and copy-number state of the nearest assayed gene); L2 logistic regression. 95% CIs and paired differences by patient-level bootstrap.</a:t>
+              <a:t>At t = 0, xₜ is independent of x₁, so v*(x₀, 0 | c) = 𝔼[x₁ | c] − x₀ and p̂ = ½(1 + x₀ + vθ(x₀, 0 | c)), averaged over K noise draws. This avoids Monte Carlo ties at ~1% prevalence. [state read-out used]</a:t>
             </a:r>
             <a:endParaRPr lang="en-US" sz="1650" dirty="0"/>
           </a:p>
@@ -4107,7 +4163,88 @@
         </p:nvSpPr>
         <p:spPr>
           <a:xfrm>
-            <a:off x="8966052" y="16644938"/>
+            <a:off x="8966052" y="12712637"/>
+            <a:ext cx="7873344" cy="3179826"/>
+          </a:xfrm>
+          <a:prstGeom prst="rect">
+            <a:avLst/>
+          </a:prstGeom>
+          <a:noFill/>
+          <a:ln/>
+        </p:spPr>
+        <p:txBody>
+          <a:bodyPr wrap="square" lIns="0" tIns="0" rIns="0" bIns="0" rtlCol="0" anchor="t"/>
+          <a:lstStyle/>
+          <a:p>
+            <a:pPr indent="0" marL="0">
+              <a:buNone/>
+            </a:pPr>
+            <a:r>
+              <a:rPr lang="en-US" sz="1650" b="1" dirty="0">
+                <a:solidFill>
+                  <a:srgbClr val="12202E"/>
+                </a:solidFill>
+                <a:latin typeface="Calibri" pitchFamily="34" charset="0"/>
+                <a:ea typeface="Calibri" pitchFamily="34" charset="-122"/>
+                <a:cs typeface="Calibri" pitchFamily="34" charset="-120"/>
+              </a:rPr>
+              <a:t>3.4 Evaluation (EBAI). </a:t>
+            </a:r>
+            <a:pPr indent="0" marL="0">
+              <a:buNone/>
+            </a:pPr>
+            <a:r>
+              <a:rPr lang="en-US" sz="1650" dirty="0">
+                <a:solidFill>
+                  <a:srgbClr val="12202E"/>
+                </a:solidFill>
+                <a:latin typeface="Calibri" pitchFamily="34" charset="0"/>
+                <a:ea typeface="Calibri" pitchFamily="34" charset="-122"/>
+                <a:cs typeface="Calibri" pitchFamily="34" charset="-120"/>
+              </a:rPr>
+              <a:t>Pre-specified primary endpoint: pooled AUROC. Secondary: per-gene AUROC (genes with ≥5 test events; prevalence-only = 0.50); AUPRC (chance = 0.012); calibration plot, slope, intercept, O:E and Brier skill; at the intended-use threshold for ≥1 altered target gene, sensitivity, specificity, PPV, NPV and LR±; NRI over the burden + locus model and decision-curve analysis; joint fidelity (energy score versus independent Bernoulli draws). Comparators on identical splits: prevalence, burden + locus, L2 logistic regression. 95% CIs and paired differences by patient bootstrap. </a:t>
+            </a:r>
+            <a:pPr indent="0" marL="0">
+              <a:buNone/>
+            </a:pPr>
+            <a:r>
+              <a:rPr lang="en-US" sz="1650" b="1" dirty="0">
+                <a:solidFill>
+                  <a:srgbClr val="12202E"/>
+                </a:solidFill>
+                <a:latin typeface="Calibri" pitchFamily="34" charset="0"/>
+                <a:ea typeface="Calibri" pitchFamily="34" charset="-122"/>
+                <a:cs typeface="Calibri" pitchFamily="34" charset="-120"/>
+              </a:rPr>
+              <a:t>Sample size (post hoc; EBAI asks a priori): </a:t>
+            </a:r>
+            <a:pPr indent="0" marL="0">
+              <a:buNone/>
+            </a:pPr>
+            <a:r>
+              <a:rPr lang="en-US" sz="1650" dirty="0">
+                <a:solidFill>
+                  <a:srgbClr val="12202E"/>
+                </a:solidFill>
+                <a:latin typeface="Calibri" pitchFamily="34" charset="0"/>
+                <a:ea typeface="Calibri" pitchFamily="34" charset="-122"/>
+                <a:cs typeface="Calibri" pitchFamily="34" charset="-120"/>
+              </a:rPr>
+              <a:t>~334 test patients give a 95% CI half-width of ≈ ±0.05 for a patient-level AUROC of 0.79 (Hanley–McNeil, 43% prevalence assumed).</a:t>
+            </a:r>
+            <a:endParaRPr lang="en-US" sz="1650" dirty="0"/>
+          </a:p>
+        </p:txBody>
+      </p:sp>
+      <p:sp>
+        <p:nvSpPr>
+          <p:cNvPr id="45" name="Text 42"/>
+          <p:cNvSpPr txBox="1"/>
+          <p:nvPr/>
+        </p:nvSpPr>
+        <p:spPr>
+          <a:xfrm>
+            <a:off x="8966052" y="16121062"/>
             <a:ext cx="7873344" cy="822389"/>
           </a:xfrm>
           <a:prstGeom prst="rect">
@@ -4154,7 +4291,7 @@
       </p:sp>
       <p:sp>
         <p:nvSpPr>
-          <p:cNvPr id="45" name="Shape 42"/>
+          <p:cNvPr id="46" name="Shape 43"/>
           <p:cNvSpPr/>
           <p:nvPr/>
         </p:nvSpPr>
@@ -4177,7 +4314,7 @@
       </p:sp>
       <p:sp>
         <p:nvSpPr>
-          <p:cNvPr id="46" name="Text 43"/>
+          <p:cNvPr id="47" name="Text 44"/>
           <p:cNvSpPr txBox="1"/>
           <p:nvPr/>
         </p:nvSpPr>
@@ -4216,7 +4353,7 @@
       </p:sp>
       <p:sp>
         <p:nvSpPr>
-          <p:cNvPr id="47" name="Text 44"/>
+          <p:cNvPr id="48" name="Text 45"/>
           <p:cNvSpPr txBox="1"/>
           <p:nvPr/>
         </p:nvSpPr>
@@ -4269,7 +4406,7 @@
       </p:sp>
       <p:sp>
         <p:nvSpPr>
-          <p:cNvPr id="48" name="Text 45"/>
+          <p:cNvPr id="49" name="Text 46"/>
           <p:cNvSpPr txBox="1"/>
           <p:nvPr/>
         </p:nvSpPr>
@@ -5664,7 +5801,7 @@
       </p:graphicFrame>
       <p:sp>
         <p:nvSpPr>
-          <p:cNvPr id="50" name="Shape 46"/>
+          <p:cNvPr id="51" name="Shape 47"/>
           <p:cNvSpPr/>
           <p:nvPr/>
         </p:nvSpPr>
@@ -5687,7 +5824,7 @@
       </p:sp>
       <p:sp>
         <p:nvSpPr>
-          <p:cNvPr id="51" name="Shape 47"/>
+          <p:cNvPr id="52" name="Shape 48"/>
           <p:cNvSpPr/>
           <p:nvPr/>
         </p:nvSpPr>
@@ -5710,7 +5847,7 @@
       </p:sp>
       <p:sp>
         <p:nvSpPr>
-          <p:cNvPr id="52" name="Shape 48"/>
+          <p:cNvPr id="53" name="Shape 49"/>
           <p:cNvSpPr/>
           <p:nvPr/>
         </p:nvSpPr>
@@ -5733,7 +5870,7 @@
       </p:sp>
       <p:sp>
         <p:nvSpPr>
-          <p:cNvPr id="53" name="Text 49"/>
+          <p:cNvPr id="54" name="Text 50"/>
           <p:cNvSpPr txBox="1"/>
           <p:nvPr/>
         </p:nvSpPr>
@@ -5842,7 +5979,7 @@
       </p:sp>
       <p:sp>
         <p:nvSpPr>
-          <p:cNvPr id="54" name="Text 50"/>
+          <p:cNvPr id="55" name="Text 51"/>
           <p:cNvSpPr txBox="1"/>
           <p:nvPr/>
         </p:nvSpPr>
@@ -5895,7 +6032,7 @@
       </p:sp>
       <p:sp>
         <p:nvSpPr>
-          <p:cNvPr id="55" name="Shape 51"/>
+          <p:cNvPr id="56" name="Shape 52"/>
           <p:cNvSpPr/>
           <p:nvPr/>
         </p:nvSpPr>
@@ -5915,7 +6052,7 @@
       </p:sp>
       <p:sp>
         <p:nvSpPr>
-          <p:cNvPr id="56" name="Text 52"/>
+          <p:cNvPr id="57" name="Text 53"/>
           <p:cNvSpPr txBox="1"/>
           <p:nvPr/>
         </p:nvSpPr>
@@ -5954,7 +6091,7 @@
       </p:sp>
       <p:sp>
         <p:nvSpPr>
-          <p:cNvPr id="57" name="Shape 53"/>
+          <p:cNvPr id="58" name="Shape 54"/>
           <p:cNvSpPr/>
           <p:nvPr/>
         </p:nvSpPr>
@@ -5974,7 +6111,7 @@
       </p:sp>
       <p:sp>
         <p:nvSpPr>
-          <p:cNvPr id="58" name="Text 54"/>
+          <p:cNvPr id="59" name="Text 55"/>
           <p:cNvSpPr txBox="1"/>
           <p:nvPr/>
         </p:nvSpPr>
@@ -6013,7 +6150,7 @@
       </p:sp>
       <p:sp>
         <p:nvSpPr>
-          <p:cNvPr id="59" name="Text 55"/>
+          <p:cNvPr id="60" name="Text 56"/>
           <p:cNvSpPr txBox="1"/>
           <p:nvPr/>
         </p:nvSpPr>
@@ -6052,7 +6189,7 @@
       </p:sp>
       <p:sp>
         <p:nvSpPr>
-          <p:cNvPr id="60" name="Text 56"/>
+          <p:cNvPr id="61" name="Text 57"/>
           <p:cNvSpPr txBox="1"/>
           <p:nvPr/>
         </p:nvSpPr>
@@ -6091,7 +6228,7 @@
       </p:sp>
       <p:sp>
         <p:nvSpPr>
-          <p:cNvPr id="61" name="Shape 57"/>
+          <p:cNvPr id="62" name="Shape 58"/>
           <p:cNvSpPr/>
           <p:nvPr/>
         </p:nvSpPr>
@@ -6114,7 +6251,7 @@
       </p:sp>
       <p:sp>
         <p:nvSpPr>
-          <p:cNvPr id="62" name="Shape 58"/>
+          <p:cNvPr id="63" name="Shape 59"/>
           <p:cNvSpPr/>
           <p:nvPr/>
         </p:nvSpPr>
@@ -6134,7 +6271,7 @@
       </p:sp>
       <p:sp>
         <p:nvSpPr>
-          <p:cNvPr id="63" name="Text 59"/>
+          <p:cNvPr id="64" name="Text 60"/>
           <p:cNvSpPr txBox="1"/>
           <p:nvPr/>
         </p:nvSpPr>
@@ -6173,7 +6310,7 @@
       </p:sp>
       <p:sp>
         <p:nvSpPr>
-          <p:cNvPr id="64" name="Shape 60"/>
+          <p:cNvPr id="65" name="Shape 61"/>
           <p:cNvSpPr/>
           <p:nvPr/>
         </p:nvSpPr>
@@ -6193,7 +6330,7 @@
       </p:sp>
       <p:sp>
         <p:nvSpPr>
-          <p:cNvPr id="65" name="Text 61"/>
+          <p:cNvPr id="66" name="Text 62"/>
           <p:cNvSpPr txBox="1"/>
           <p:nvPr/>
         </p:nvSpPr>
@@ -6232,7 +6369,7 @@
       </p:sp>
       <p:sp>
         <p:nvSpPr>
-          <p:cNvPr id="66" name="Shape 62"/>
+          <p:cNvPr id="67" name="Shape 63"/>
           <p:cNvSpPr/>
           <p:nvPr/>
         </p:nvSpPr>
@@ -6255,7 +6392,7 @@
       </p:sp>
       <p:sp>
         <p:nvSpPr>
-          <p:cNvPr id="67" name="Text 63"/>
+          <p:cNvPr id="68" name="Text 64"/>
           <p:cNvSpPr txBox="1"/>
           <p:nvPr/>
         </p:nvSpPr>
@@ -6294,7 +6431,7 @@
       </p:sp>
       <p:sp>
         <p:nvSpPr>
-          <p:cNvPr id="68" name="Shape 64"/>
+          <p:cNvPr id="69" name="Shape 65"/>
           <p:cNvSpPr/>
           <p:nvPr/>
         </p:nvSpPr>
@@ -6317,7 +6454,7 @@
       </p:sp>
       <p:sp>
         <p:nvSpPr>
-          <p:cNvPr id="69" name="Shape 65"/>
+          <p:cNvPr id="70" name="Shape 66"/>
           <p:cNvSpPr/>
           <p:nvPr/>
         </p:nvSpPr>
@@ -6337,7 +6474,7 @@
       </p:sp>
       <p:sp>
         <p:nvSpPr>
-          <p:cNvPr id="70" name="Text 66"/>
+          <p:cNvPr id="71" name="Text 67"/>
           <p:cNvSpPr txBox="1"/>
           <p:nvPr/>
         </p:nvSpPr>
@@ -6376,7 +6513,7 @@
       </p:sp>
       <p:sp>
         <p:nvSpPr>
-          <p:cNvPr id="71" name="Shape 67"/>
+          <p:cNvPr id="72" name="Shape 68"/>
           <p:cNvSpPr/>
           <p:nvPr/>
         </p:nvSpPr>
@@ -6399,7 +6536,7 @@
       </p:sp>
       <p:sp>
         <p:nvSpPr>
-          <p:cNvPr id="72" name="Shape 68"/>
+          <p:cNvPr id="73" name="Shape 69"/>
           <p:cNvSpPr/>
           <p:nvPr/>
         </p:nvSpPr>
@@ -6419,7 +6556,7 @@
       </p:sp>
       <p:sp>
         <p:nvSpPr>
-          <p:cNvPr id="73" name="Text 69"/>
+          <p:cNvPr id="74" name="Text 70"/>
           <p:cNvSpPr txBox="1"/>
           <p:nvPr/>
         </p:nvSpPr>
@@ -6458,7 +6595,7 @@
       </p:sp>
       <p:sp>
         <p:nvSpPr>
-          <p:cNvPr id="74" name="Shape 70"/>
+          <p:cNvPr id="75" name="Shape 71"/>
           <p:cNvSpPr/>
           <p:nvPr/>
         </p:nvSpPr>
@@ -6481,7 +6618,7 @@
       </p:sp>
       <p:sp>
         <p:nvSpPr>
-          <p:cNvPr id="75" name="Text 71"/>
+          <p:cNvPr id="76" name="Text 72"/>
           <p:cNvSpPr txBox="1"/>
           <p:nvPr/>
         </p:nvSpPr>
@@ -6520,7 +6657,7 @@
       </p:sp>
       <p:sp>
         <p:nvSpPr>
-          <p:cNvPr id="76" name="Shape 72"/>
+          <p:cNvPr id="77" name="Shape 73"/>
           <p:cNvSpPr/>
           <p:nvPr/>
         </p:nvSpPr>
@@ -6543,7 +6680,7 @@
       </p:sp>
       <p:sp>
         <p:nvSpPr>
-          <p:cNvPr id="77" name="Shape 73"/>
+          <p:cNvPr id="78" name="Shape 74"/>
           <p:cNvSpPr/>
           <p:nvPr/>
         </p:nvSpPr>
@@ -6563,7 +6700,7 @@
       </p:sp>
       <p:sp>
         <p:nvSpPr>
-          <p:cNvPr id="78" name="Text 74"/>
+          <p:cNvPr id="79" name="Text 75"/>
           <p:cNvSpPr txBox="1"/>
           <p:nvPr/>
         </p:nvSpPr>
@@ -6602,7 +6739,7 @@
       </p:sp>
       <p:sp>
         <p:nvSpPr>
-          <p:cNvPr id="79" name="Shape 75"/>
+          <p:cNvPr id="80" name="Shape 76"/>
           <p:cNvSpPr/>
           <p:nvPr/>
         </p:nvSpPr>
@@ -6625,7 +6762,7 @@
       </p:sp>
       <p:sp>
         <p:nvSpPr>
-          <p:cNvPr id="80" name="Shape 76"/>
+          <p:cNvPr id="81" name="Shape 77"/>
           <p:cNvSpPr/>
           <p:nvPr/>
         </p:nvSpPr>
@@ -6645,7 +6782,7 @@
       </p:sp>
       <p:sp>
         <p:nvSpPr>
-          <p:cNvPr id="81" name="Text 77"/>
+          <p:cNvPr id="82" name="Text 78"/>
           <p:cNvSpPr txBox="1"/>
           <p:nvPr/>
         </p:nvSpPr>
@@ -6684,7 +6821,7 @@
       </p:sp>
       <p:sp>
         <p:nvSpPr>
-          <p:cNvPr id="82" name="Shape 78"/>
+          <p:cNvPr id="83" name="Shape 79"/>
           <p:cNvSpPr/>
           <p:nvPr/>
         </p:nvSpPr>
@@ -6707,7 +6844,7 @@
       </p:sp>
       <p:sp>
         <p:nvSpPr>
-          <p:cNvPr id="83" name="Text 79"/>
+          <p:cNvPr id="84" name="Text 80"/>
           <p:cNvSpPr txBox="1"/>
           <p:nvPr/>
         </p:nvSpPr>
@@ -6746,7 +6883,7 @@
       </p:sp>
       <p:sp>
         <p:nvSpPr>
-          <p:cNvPr id="84" name="Shape 80"/>
+          <p:cNvPr id="85" name="Shape 81"/>
           <p:cNvSpPr/>
           <p:nvPr/>
         </p:nvSpPr>
@@ -6769,7 +6906,7 @@
       </p:sp>
       <p:sp>
         <p:nvSpPr>
-          <p:cNvPr id="85" name="Shape 81"/>
+          <p:cNvPr id="86" name="Shape 82"/>
           <p:cNvSpPr/>
           <p:nvPr/>
         </p:nvSpPr>
@@ -6789,7 +6926,7 @@
       </p:sp>
       <p:sp>
         <p:nvSpPr>
-          <p:cNvPr id="86" name="Text 82"/>
+          <p:cNvPr id="87" name="Text 83"/>
           <p:cNvSpPr txBox="1"/>
           <p:nvPr/>
         </p:nvSpPr>
@@ -6828,7 +6965,7 @@
       </p:sp>
       <p:sp>
         <p:nvSpPr>
-          <p:cNvPr id="87" name="Shape 83"/>
+          <p:cNvPr id="88" name="Shape 84"/>
           <p:cNvSpPr/>
           <p:nvPr/>
         </p:nvSpPr>
@@ -6851,7 +6988,7 @@
       </p:sp>
       <p:sp>
         <p:nvSpPr>
-          <p:cNvPr id="88" name="Shape 84"/>
+          <p:cNvPr id="89" name="Shape 85"/>
           <p:cNvSpPr/>
           <p:nvPr/>
         </p:nvSpPr>
@@ -6871,7 +7008,7 @@
       </p:sp>
       <p:sp>
         <p:nvSpPr>
-          <p:cNvPr id="89" name="Text 85"/>
+          <p:cNvPr id="90" name="Text 86"/>
           <p:cNvSpPr txBox="1"/>
           <p:nvPr/>
         </p:nvSpPr>
@@ -6910,7 +7047,7 @@
       </p:sp>
       <p:sp>
         <p:nvSpPr>
-          <p:cNvPr id="90" name="Shape 86"/>
+          <p:cNvPr id="91" name="Shape 87"/>
           <p:cNvSpPr/>
           <p:nvPr/>
         </p:nvSpPr>
@@ -6933,7 +7070,7 @@
       </p:sp>
       <p:sp>
         <p:nvSpPr>
-          <p:cNvPr id="91" name="Shape 87"/>
+          <p:cNvPr id="92" name="Shape 88"/>
           <p:cNvSpPr/>
           <p:nvPr/>
         </p:nvSpPr>
@@ -6956,7 +7093,7 @@
       </p:sp>
       <p:sp>
         <p:nvSpPr>
-          <p:cNvPr id="92" name="Text 88"/>
+          <p:cNvPr id="93" name="Text 89"/>
           <p:cNvSpPr txBox="1"/>
           <p:nvPr/>
         </p:nvSpPr>
@@ -6995,7 +7132,7 @@
       </p:sp>
       <p:sp>
         <p:nvSpPr>
-          <p:cNvPr id="93" name="Shape 89"/>
+          <p:cNvPr id="94" name="Shape 90"/>
           <p:cNvSpPr/>
           <p:nvPr/>
         </p:nvSpPr>
@@ -7018,7 +7155,7 @@
       </p:sp>
       <p:sp>
         <p:nvSpPr>
-          <p:cNvPr id="94" name="Text 90"/>
+          <p:cNvPr id="95" name="Text 91"/>
           <p:cNvSpPr txBox="1"/>
           <p:nvPr/>
         </p:nvSpPr>
@@ -7057,7 +7194,7 @@
       </p:sp>
       <p:sp>
         <p:nvSpPr>
-          <p:cNvPr id="95" name="Shape 91"/>
+          <p:cNvPr id="96" name="Shape 92"/>
           <p:cNvSpPr/>
           <p:nvPr/>
         </p:nvSpPr>
@@ -7080,7 +7217,7 @@
       </p:sp>
       <p:sp>
         <p:nvSpPr>
-          <p:cNvPr id="96" name="Text 92"/>
+          <p:cNvPr id="97" name="Text 93"/>
           <p:cNvSpPr txBox="1"/>
           <p:nvPr/>
         </p:nvSpPr>
@@ -7119,7 +7256,7 @@
       </p:sp>
       <p:sp>
         <p:nvSpPr>
-          <p:cNvPr id="97" name="Shape 93"/>
+          <p:cNvPr id="98" name="Shape 94"/>
           <p:cNvSpPr/>
           <p:nvPr/>
         </p:nvSpPr>
@@ -7142,7 +7279,7 @@
       </p:sp>
       <p:sp>
         <p:nvSpPr>
-          <p:cNvPr id="98" name="Text 94"/>
+          <p:cNvPr id="99" name="Text 95"/>
           <p:cNvSpPr txBox="1"/>
           <p:nvPr/>
         </p:nvSpPr>
@@ -7181,7 +7318,7 @@
       </p:sp>
       <p:sp>
         <p:nvSpPr>
-          <p:cNvPr id="99" name="Shape 95"/>
+          <p:cNvPr id="100" name="Shape 96"/>
           <p:cNvSpPr/>
           <p:nvPr/>
         </p:nvSpPr>
@@ -7204,7 +7341,7 @@
       </p:sp>
       <p:sp>
         <p:nvSpPr>
-          <p:cNvPr id="100" name="Text 96"/>
+          <p:cNvPr id="101" name="Text 97"/>
           <p:cNvSpPr txBox="1"/>
           <p:nvPr/>
         </p:nvSpPr>
@@ -7243,7 +7380,7 @@
       </p:sp>
       <p:sp>
         <p:nvSpPr>
-          <p:cNvPr id="101" name="Text 97"/>
+          <p:cNvPr id="102" name="Text 98"/>
           <p:cNvSpPr txBox="1"/>
           <p:nvPr/>
         </p:nvSpPr>
@@ -7296,7 +7433,7 @@
       </p:sp>
       <p:sp>
         <p:nvSpPr>
-          <p:cNvPr id="102" name="Text 98"/>
+          <p:cNvPr id="103" name="Text 99"/>
           <p:cNvSpPr txBox="1"/>
           <p:nvPr/>
         </p:nvSpPr>
@@ -7349,7 +7486,7 @@
       </p:sp>
       <p:sp>
         <p:nvSpPr>
-          <p:cNvPr id="103" name="Shape 99"/>
+          <p:cNvPr id="104" name="Shape 100"/>
           <p:cNvSpPr/>
           <p:nvPr/>
         </p:nvSpPr>
@@ -7372,7 +7509,7 @@
       </p:sp>
       <p:sp>
         <p:nvSpPr>
-          <p:cNvPr id="104" name="Text 100"/>
+          <p:cNvPr id="105" name="Text 101"/>
           <p:cNvSpPr txBox="1"/>
           <p:nvPr/>
         </p:nvSpPr>
@@ -7425,13 +7562,13 @@
       </p:sp>
       <p:graphicFrame>
         <p:nvGraphicFramePr>
-          <p:cNvPr id="105" name="Chart 0" descr=""/>
+          <p:cNvPr id="106" name="Chart 0" descr=""/>
           <p:cNvGraphicFramePr/>
           <p:nvPr/>
         </p:nvGraphicFramePr>
         <p:xfrm>
           <a:off x="25755156" y="5793486"/>
-          <a:ext cx="7873344" cy="2057400"/>
+          <a:ext cx="7873344" cy="1691640"/>
         </p:xfrm>
         <a:graphic xmlns:a="http://schemas.openxmlformats.org/drawingml/2006/main">
           <a:graphicData uri="http://schemas.openxmlformats.org/drawingml/2006/chart">
@@ -7441,13 +7578,13 @@
       </p:graphicFrame>
       <p:sp>
         <p:nvSpPr>
-          <p:cNvPr id="106" name="Text 101"/>
+          <p:cNvPr id="107" name="Text 102"/>
           <p:cNvSpPr txBox="1"/>
           <p:nvPr/>
         </p:nvSpPr>
         <p:spPr>
           <a:xfrm>
-            <a:off x="25755156" y="7924038"/>
+            <a:off x="25755156" y="7558278"/>
             <a:ext cx="7873344" cy="465201"/>
           </a:xfrm>
           <a:prstGeom prst="rect">
@@ -7494,13 +7631,13 @@
       </p:sp>
       <p:sp>
         <p:nvSpPr>
-          <p:cNvPr id="107" name="Shape 102"/>
+          <p:cNvPr id="108" name="Shape 103"/>
           <p:cNvSpPr/>
           <p:nvPr/>
         </p:nvSpPr>
         <p:spPr>
           <a:xfrm>
-            <a:off x="25755156" y="8663559"/>
+            <a:off x="25755156" y="8297799"/>
             <a:ext cx="7873344" cy="0"/>
           </a:xfrm>
           <a:prstGeom prst="line">
@@ -7517,13 +7654,13 @@
       </p:sp>
       <p:sp>
         <p:nvSpPr>
-          <p:cNvPr id="108" name="Text 103"/>
+          <p:cNvPr id="109" name="Text 104"/>
           <p:cNvSpPr txBox="1"/>
           <p:nvPr/>
         </p:nvSpPr>
         <p:spPr>
           <a:xfrm>
-            <a:off x="25755156" y="8754999"/>
+            <a:off x="25755156" y="8389239"/>
             <a:ext cx="7873344" cy="566928"/>
           </a:xfrm>
           <a:prstGeom prst="rect">
@@ -7556,14 +7693,14 @@
       </p:sp>
       <p:sp>
         <p:nvSpPr>
-          <p:cNvPr id="109" name="Shape 104"/>
+          <p:cNvPr id="110" name="Shape 105"/>
           <p:cNvSpPr/>
           <p:nvPr/>
         </p:nvSpPr>
         <p:spPr>
           <a:xfrm>
-            <a:off x="25755156" y="9532239"/>
-            <a:ext cx="7873344" cy="420624"/>
+            <a:off x="25755156" y="9166479"/>
+            <a:ext cx="7873344" cy="402336"/>
           </a:xfrm>
           <a:prstGeom prst="rect">
             <a:avLst/>
@@ -7576,53 +7713,14 @@
       </p:sp>
       <p:sp>
         <p:nvSpPr>
-          <p:cNvPr id="110" name="Text 105"/>
-          <p:cNvSpPr txBox="1"/>
-          <p:nvPr/>
-        </p:nvSpPr>
-        <p:spPr>
-          <a:xfrm>
-            <a:off x="25864884" y="9532239"/>
-            <a:ext cx="7653888" cy="420624"/>
-          </a:xfrm>
-          <a:prstGeom prst="rect">
-            <a:avLst/>
-          </a:prstGeom>
-          <a:noFill/>
-          <a:ln/>
-        </p:spPr>
-        <p:txBody>
-          <a:bodyPr wrap="square" lIns="0" tIns="0" rIns="0" bIns="0" rtlCol="0" anchor="ctr"/>
-          <a:lstStyle/>
-          <a:p>
-            <a:pPr indent="0" marL="0">
-              <a:buNone/>
-            </a:pPr>
-            <a:r>
-              <a:rPr lang="en-US" sz="1300" b="1" dirty="0">
-                <a:solidFill>
-                  <a:srgbClr val="FFFFFF"/>
-                </a:solidFill>
-                <a:latin typeface="Calibri" pitchFamily="34" charset="0"/>
-                <a:ea typeface="Calibri" pitchFamily="34" charset="-122"/>
-                <a:cs typeface="Calibri" pitchFamily="34" charset="-120"/>
-              </a:rPr>
-              <a:t>EBAI class B · indirect measure of existing biomarkers · use: pre-screening</a:t>
-            </a:r>
-            <a:endParaRPr lang="en-US" sz="1300" dirty="0"/>
-          </a:p>
-        </p:txBody>
-      </p:sp>
-      <p:sp>
-        <p:nvSpPr>
           <p:cNvPr id="111" name="Text 106"/>
           <p:cNvSpPr txBox="1"/>
           <p:nvPr/>
         </p:nvSpPr>
         <p:spPr>
           <a:xfrm>
-            <a:off x="25755156" y="9989439"/>
-            <a:ext cx="2011680" cy="338328"/>
+            <a:off x="25864884" y="9166479"/>
+            <a:ext cx="7653888" cy="402336"/>
           </a:xfrm>
           <a:prstGeom prst="rect">
             <a:avLst/>
@@ -7638,34 +7736,112 @@
               <a:buNone/>
             </a:pPr>
             <a:r>
-              <a:rPr lang="en-US" sz="1300" b="1" dirty="0">
-                <a:solidFill>
-                  <a:srgbClr val="12202E"/>
-                </a:solidFill>
-                <a:latin typeface="Calibri" pitchFamily="34" charset="0"/>
-                <a:ea typeface="Calibri" pitchFamily="34" charset="-122"/>
-                <a:cs typeface="Calibri" pitchFamily="34" charset="-120"/>
-              </a:rPr>
-              <a:t>Ground truth</a:t>
-            </a:r>
-            <a:endParaRPr lang="en-US" sz="1300" dirty="0"/>
-          </a:p>
-        </p:txBody>
-      </p:sp>
-      <p:sp>
-        <p:nvSpPr>
-          <p:cNvPr id="112" name="Shape 107"/>
+              <a:rPr lang="en-US" sz="1250" b="1" dirty="0">
+                <a:solidFill>
+                  <a:srgbClr val="FFFFFF"/>
+                </a:solidFill>
+                <a:latin typeface="Calibri" pitchFamily="34" charset="0"/>
+                <a:ea typeface="Calibri" pitchFamily="34" charset="-122"/>
+                <a:cs typeface="Calibri" pitchFamily="34" charset="-120"/>
+              </a:rPr>
+              <a:t>EBAI class B · indirect measure of existing biomarkers · use: enrichment</a:t>
+            </a:r>
+            <a:endParaRPr lang="en-US" sz="1250" dirty="0"/>
+          </a:p>
+        </p:txBody>
+      </p:sp>
+      <p:sp>
+        <p:nvSpPr>
+          <p:cNvPr id="112" name="Text 107"/>
+          <p:cNvSpPr txBox="1"/>
+          <p:nvPr/>
+        </p:nvSpPr>
+        <p:spPr>
+          <a:xfrm>
+            <a:off x="25755156" y="9596247"/>
+            <a:ext cx="1325880" cy="288036"/>
+          </a:xfrm>
+          <a:prstGeom prst="rect">
+            <a:avLst/>
+          </a:prstGeom>
+          <a:noFill/>
+          <a:ln/>
+        </p:spPr>
+        <p:txBody>
+          <a:bodyPr wrap="square" lIns="0" tIns="0" rIns="0" bIns="0" rtlCol="0" anchor="ctr"/>
+          <a:lstStyle/>
+          <a:p>
+            <a:pPr indent="0" marL="0">
+              <a:buNone/>
+            </a:pPr>
+            <a:r>
+              <a:rPr lang="en-US" sz="1150" b="1" dirty="0">
+                <a:solidFill>
+                  <a:srgbClr val="3F4B57"/>
+                </a:solidFill>
+                <a:latin typeface="Calibri" pitchFamily="34" charset="0"/>
+                <a:ea typeface="Calibri" pitchFamily="34" charset="-122"/>
+                <a:cs typeface="Calibri" pitchFamily="34" charset="-120"/>
+              </a:rPr>
+              <a:t>Essential</a:t>
+            </a:r>
+            <a:endParaRPr lang="en-US" sz="1150" dirty="0"/>
+          </a:p>
+        </p:txBody>
+      </p:sp>
+      <p:sp>
+        <p:nvSpPr>
+          <p:cNvPr id="113" name="Text 108"/>
+          <p:cNvSpPr txBox="1"/>
+          <p:nvPr/>
+        </p:nvSpPr>
+        <p:spPr>
+          <a:xfrm>
+            <a:off x="27081036" y="9596247"/>
+            <a:ext cx="1691640" cy="288036"/>
+          </a:xfrm>
+          <a:prstGeom prst="rect">
+            <a:avLst/>
+          </a:prstGeom>
+          <a:noFill/>
+          <a:ln/>
+        </p:spPr>
+        <p:txBody>
+          <a:bodyPr wrap="square" lIns="0" tIns="0" rIns="0" bIns="0" rtlCol="0" anchor="ctr"/>
+          <a:lstStyle/>
+          <a:p>
+            <a:pPr indent="0" marL="0">
+              <a:buNone/>
+            </a:pPr>
+            <a:r>
+              <a:rPr lang="en-US" sz="1200" b="1" dirty="0">
+                <a:solidFill>
+                  <a:srgbClr val="12202E"/>
+                </a:solidFill>
+                <a:latin typeface="Calibri" pitchFamily="34" charset="0"/>
+                <a:ea typeface="Calibri" pitchFamily="34" charset="-122"/>
+                <a:cs typeface="Calibri" pitchFamily="34" charset="-120"/>
+              </a:rPr>
+              <a:t>Comparator</a:t>
+            </a:r>
+            <a:endParaRPr lang="en-US" sz="1200" dirty="0"/>
+          </a:p>
+        </p:txBody>
+      </p:sp>
+      <p:sp>
+        <p:nvSpPr>
+          <p:cNvPr id="114" name="Shape 109"/>
           <p:cNvSpPr/>
           <p:nvPr/>
         </p:nvSpPr>
         <p:spPr>
           <a:xfrm>
-            <a:off x="27766836" y="10044303"/>
-            <a:ext cx="896112" cy="228600"/>
+            <a:off x="28772676" y="9637395"/>
+            <a:ext cx="822960" cy="205740"/>
           </a:xfrm>
           <a:prstGeom prst="roundRect">
             <a:avLst>
-              <a:gd name="adj" fmla="val 20000"/>
+              <a:gd name="adj" fmla="val 17778"/>
             </a:avLst>
           </a:prstGeom>
           <a:solidFill>
@@ -7681,14 +7857,14 @@
       </p:sp>
       <p:sp>
         <p:nvSpPr>
-          <p:cNvPr id="113" name="Text 108"/>
+          <p:cNvPr id="115" name="Text 110"/>
           <p:cNvSpPr txBox="1"/>
           <p:nvPr/>
         </p:nvSpPr>
         <p:spPr>
           <a:xfrm>
-            <a:off x="27766836" y="10044303"/>
-            <a:ext cx="896112" cy="228600"/>
+            <a:off x="28772676" y="9637395"/>
+            <a:ext cx="822960" cy="205740"/>
           </a:xfrm>
           <a:prstGeom prst="rect">
             <a:avLst/>
@@ -7704,7 +7880,7 @@
               <a:buNone/>
             </a:pPr>
             <a:r>
-              <a:rPr lang="en-US" sz="1150" b="1" dirty="0">
+              <a:rPr lang="en-US" sz="1050" b="1" dirty="0">
                 <a:solidFill>
                   <a:srgbClr val="FFFFFF"/>
                 </a:solidFill>
@@ -7714,20 +7890,20 @@
               </a:rPr>
               <a:t>Met</a:t>
             </a:r>
-            <a:endParaRPr lang="en-US" sz="1150" dirty="0"/>
-          </a:p>
-        </p:txBody>
-      </p:sp>
-      <p:sp>
-        <p:nvSpPr>
-          <p:cNvPr id="114" name="Text 109"/>
+            <a:endParaRPr lang="en-US" sz="1050" dirty="0"/>
+          </a:p>
+        </p:txBody>
+      </p:sp>
+      <p:sp>
+        <p:nvSpPr>
+          <p:cNvPr id="116" name="Text 111"/>
           <p:cNvSpPr txBox="1"/>
           <p:nvPr/>
         </p:nvSpPr>
         <p:spPr>
           <a:xfrm>
-            <a:off x="28772676" y="9989439"/>
-            <a:ext cx="4855824" cy="338328"/>
+            <a:off x="29687076" y="9596247"/>
+            <a:ext cx="3941424" cy="288036"/>
           </a:xfrm>
           <a:prstGeom prst="rect">
             <a:avLst/>
@@ -7743,7 +7919,7 @@
               <a:buNone/>
             </a:pPr>
             <a:r>
-              <a:rPr lang="en-US" sz="1300" dirty="0">
+              <a:rPr lang="en-US" sz="1200" dirty="0">
                 <a:solidFill>
                   <a:srgbClr val="12202E"/>
                 </a:solidFill>
@@ -7753,20 +7929,20 @@
               </a:rPr>
               <a:t>IMPACT505 NGS on the same sample</a:t>
             </a:r>
-            <a:endParaRPr lang="en-US" sz="1300" dirty="0"/>
-          </a:p>
-        </p:txBody>
-      </p:sp>
-      <p:sp>
-        <p:nvSpPr>
-          <p:cNvPr id="115" name="Shape 110"/>
+            <a:endParaRPr lang="en-US" sz="1200" dirty="0"/>
+          </a:p>
+        </p:txBody>
+      </p:sp>
+      <p:sp>
+        <p:nvSpPr>
+          <p:cNvPr id="117" name="Shape 112"/>
           <p:cNvSpPr/>
           <p:nvPr/>
         </p:nvSpPr>
         <p:spPr>
           <a:xfrm>
-            <a:off x="25755156" y="10327767"/>
-            <a:ext cx="7873344" cy="0"/>
+            <a:off x="27081036" y="9884283"/>
+            <a:ext cx="6547464" cy="0"/>
           </a:xfrm>
           <a:prstGeom prst="line">
             <a:avLst/>
@@ -7782,14 +7958,14 @@
       </p:sp>
       <p:sp>
         <p:nvSpPr>
-          <p:cNvPr id="116" name="Text 111"/>
+          <p:cNvPr id="118" name="Text 113"/>
           <p:cNvSpPr txBox="1"/>
           <p:nvPr/>
         </p:nvSpPr>
         <p:spPr>
           <a:xfrm>
-            <a:off x="25755156" y="10327767"/>
-            <a:ext cx="2011680" cy="338328"/>
+            <a:off x="27081036" y="9884283"/>
+            <a:ext cx="1691640" cy="288036"/>
           </a:xfrm>
           <a:prstGeom prst="rect">
             <a:avLst/>
@@ -7805,7 +7981,7 @@
               <a:buNone/>
             </a:pPr>
             <a:r>
-              <a:rPr lang="en-US" sz="1300" b="1" dirty="0">
+              <a:rPr lang="en-US" sz="1200" b="1" dirty="0">
                 <a:solidFill>
                   <a:srgbClr val="12202E"/>
                 </a:solidFill>
@@ -7815,24 +7991,24 @@
               </a:rPr>
               <a:t>Discrimination</a:t>
             </a:r>
-            <a:endParaRPr lang="en-US" sz="1300" dirty="0"/>
-          </a:p>
-        </p:txBody>
-      </p:sp>
-      <p:sp>
-        <p:nvSpPr>
-          <p:cNvPr id="117" name="Shape 112"/>
+            <a:endParaRPr lang="en-US" sz="1200" dirty="0"/>
+          </a:p>
+        </p:txBody>
+      </p:sp>
+      <p:sp>
+        <p:nvSpPr>
+          <p:cNvPr id="119" name="Shape 114"/>
           <p:cNvSpPr/>
           <p:nvPr/>
         </p:nvSpPr>
         <p:spPr>
           <a:xfrm>
-            <a:off x="27766836" y="10382631"/>
-            <a:ext cx="896112" cy="228600"/>
+            <a:off x="28772676" y="9925431"/>
+            <a:ext cx="822960" cy="205740"/>
           </a:xfrm>
           <a:prstGeom prst="roundRect">
             <a:avLst>
-              <a:gd name="adj" fmla="val 20000"/>
+              <a:gd name="adj" fmla="val 17778"/>
             </a:avLst>
           </a:prstGeom>
           <a:solidFill>
@@ -7848,14 +8024,14 @@
       </p:sp>
       <p:sp>
         <p:nvSpPr>
-          <p:cNvPr id="118" name="Text 113"/>
+          <p:cNvPr id="120" name="Text 115"/>
           <p:cNvSpPr txBox="1"/>
           <p:nvPr/>
         </p:nvSpPr>
         <p:spPr>
           <a:xfrm>
-            <a:off x="27766836" y="10382631"/>
-            <a:ext cx="896112" cy="228600"/>
+            <a:off x="28772676" y="9925431"/>
+            <a:ext cx="822960" cy="205740"/>
           </a:xfrm>
           <a:prstGeom prst="rect">
             <a:avLst/>
@@ -7871,7 +8047,7 @@
               <a:buNone/>
             </a:pPr>
             <a:r>
-              <a:rPr lang="en-US" sz="1150" b="1" dirty="0">
+              <a:rPr lang="en-US" sz="1050" b="1" dirty="0">
                 <a:solidFill>
                   <a:srgbClr val="FFFFFF"/>
                 </a:solidFill>
@@ -7881,20 +8057,20 @@
               </a:rPr>
               <a:t>Met</a:t>
             </a:r>
-            <a:endParaRPr lang="en-US" sz="1150" dirty="0"/>
-          </a:p>
-        </p:txBody>
-      </p:sp>
-      <p:sp>
-        <p:nvSpPr>
-          <p:cNvPr id="119" name="Text 114"/>
+            <a:endParaRPr lang="en-US" sz="1050" dirty="0"/>
+          </a:p>
+        </p:txBody>
+      </p:sp>
+      <p:sp>
+        <p:nvSpPr>
+          <p:cNvPr id="121" name="Text 116"/>
           <p:cNvSpPr txBox="1"/>
           <p:nvPr/>
         </p:nvSpPr>
         <p:spPr>
           <a:xfrm>
-            <a:off x="28772676" y="10327767"/>
-            <a:ext cx="4855824" cy="338328"/>
+            <a:off x="29687076" y="9884283"/>
+            <a:ext cx="3941424" cy="288036"/>
           </a:xfrm>
           <a:prstGeom prst="rect">
             <a:avLst/>
@@ -7910,7 +8086,7 @@
               <a:buNone/>
             </a:pPr>
             <a:r>
-              <a:rPr lang="en-US" sz="1300" dirty="0">
+              <a:rPr lang="en-US" sz="1200" dirty="0">
                 <a:solidFill>
                   <a:srgbClr val="12202E"/>
                 </a:solidFill>
@@ -7924,7 +8100,7 @@
               <a:buNone/>
             </a:pPr>
             <a:r>
-              <a:rPr lang="en-US" sz="1300" dirty="0">
+              <a:rPr lang="en-US" sz="1200" dirty="0">
                 <a:solidFill>
                   <a:srgbClr val="A3410F"/>
                 </a:solidFill>
@@ -7934,20 +8110,20 @@
               </a:rPr>
               <a:t>[ ]</a:t>
             </a:r>
-            <a:endParaRPr lang="en-US" sz="1300" dirty="0"/>
-          </a:p>
-        </p:txBody>
-      </p:sp>
-      <p:sp>
-        <p:nvSpPr>
-          <p:cNvPr id="120" name="Shape 115"/>
+            <a:endParaRPr lang="en-US" sz="1200" dirty="0"/>
+          </a:p>
+        </p:txBody>
+      </p:sp>
+      <p:sp>
+        <p:nvSpPr>
+          <p:cNvPr id="122" name="Shape 117"/>
           <p:cNvSpPr/>
           <p:nvPr/>
         </p:nvSpPr>
         <p:spPr>
           <a:xfrm>
-            <a:off x="25755156" y="10666095"/>
-            <a:ext cx="7873344" cy="0"/>
+            <a:off x="27081036" y="10172319"/>
+            <a:ext cx="6547464" cy="0"/>
           </a:xfrm>
           <a:prstGeom prst="line">
             <a:avLst/>
@@ -7963,14 +8139,14 @@
       </p:sp>
       <p:sp>
         <p:nvSpPr>
-          <p:cNvPr id="121" name="Text 116"/>
+          <p:cNvPr id="123" name="Text 118"/>
           <p:cNvSpPr txBox="1"/>
           <p:nvPr/>
         </p:nvSpPr>
         <p:spPr>
           <a:xfrm>
-            <a:off x="25755156" y="10666095"/>
-            <a:ext cx="2011680" cy="338328"/>
+            <a:off x="27081036" y="10172319"/>
+            <a:ext cx="1691640" cy="288036"/>
           </a:xfrm>
           <a:prstGeom prst="rect">
             <a:avLst/>
@@ -7986,7 +8162,7 @@
               <a:buNone/>
             </a:pPr>
             <a:r>
-              <a:rPr lang="en-US" sz="1300" b="1" dirty="0">
+              <a:rPr lang="en-US" sz="1200" b="1" dirty="0">
                 <a:solidFill>
                   <a:srgbClr val="12202E"/>
                 </a:solidFill>
@@ -7996,24 +8172,24 @@
               </a:rPr>
               <a:t>Operating point</a:t>
             </a:r>
-            <a:endParaRPr lang="en-US" sz="1300" dirty="0"/>
-          </a:p>
-        </p:txBody>
-      </p:sp>
-      <p:sp>
-        <p:nvSpPr>
-          <p:cNvPr id="122" name="Shape 117"/>
+            <a:endParaRPr lang="en-US" sz="1200" dirty="0"/>
+          </a:p>
+        </p:txBody>
+      </p:sp>
+      <p:sp>
+        <p:nvSpPr>
+          <p:cNvPr id="124" name="Shape 119"/>
           <p:cNvSpPr/>
           <p:nvPr/>
         </p:nvSpPr>
         <p:spPr>
           <a:xfrm>
-            <a:off x="27766836" y="10720959"/>
-            <a:ext cx="896112" cy="228600"/>
+            <a:off x="28772676" y="10213467"/>
+            <a:ext cx="822960" cy="205740"/>
           </a:xfrm>
           <a:prstGeom prst="roundRect">
             <a:avLst>
-              <a:gd name="adj" fmla="val 20000"/>
+              <a:gd name="adj" fmla="val 17778"/>
             </a:avLst>
           </a:prstGeom>
           <a:solidFill>
@@ -8029,14 +8205,14 @@
       </p:sp>
       <p:sp>
         <p:nvSpPr>
-          <p:cNvPr id="123" name="Text 118"/>
+          <p:cNvPr id="125" name="Text 120"/>
           <p:cNvSpPr txBox="1"/>
           <p:nvPr/>
         </p:nvSpPr>
         <p:spPr>
           <a:xfrm>
-            <a:off x="27766836" y="10720959"/>
-            <a:ext cx="896112" cy="228600"/>
+            <a:off x="28772676" y="10213467"/>
+            <a:ext cx="822960" cy="205740"/>
           </a:xfrm>
           <a:prstGeom prst="rect">
             <a:avLst/>
@@ -8052,7 +8228,7 @@
               <a:buNone/>
             </a:pPr>
             <a:r>
-              <a:rPr lang="en-US" sz="1150" b="1" dirty="0">
+              <a:rPr lang="en-US" sz="1050" b="1" dirty="0">
                 <a:solidFill>
                   <a:srgbClr val="7A2E0B"/>
                 </a:solidFill>
@@ -8062,20 +8238,20 @@
               </a:rPr>
               <a:t>Partial</a:t>
             </a:r>
-            <a:endParaRPr lang="en-US" sz="1150" dirty="0"/>
-          </a:p>
-        </p:txBody>
-      </p:sp>
-      <p:sp>
-        <p:nvSpPr>
-          <p:cNvPr id="124" name="Text 119"/>
+            <a:endParaRPr lang="en-US" sz="1050" dirty="0"/>
+          </a:p>
+        </p:txBody>
+      </p:sp>
+      <p:sp>
+        <p:nvSpPr>
+          <p:cNvPr id="126" name="Text 121"/>
           <p:cNvSpPr txBox="1"/>
           <p:nvPr/>
         </p:nvSpPr>
         <p:spPr>
           <a:xfrm>
-            <a:off x="28772676" y="10666095"/>
-            <a:ext cx="4855824" cy="338328"/>
+            <a:off x="29687076" y="10172319"/>
+            <a:ext cx="3941424" cy="288036"/>
           </a:xfrm>
           <a:prstGeom prst="rect">
             <a:avLst/>
@@ -8091,44 +8267,30 @@
               <a:buNone/>
             </a:pPr>
             <a:r>
-              <a:rPr lang="en-US" sz="1300" dirty="0">
-                <a:solidFill>
-                  <a:srgbClr val="12202E"/>
-                </a:solidFill>
-                <a:latin typeface="Calibri" pitchFamily="34" charset="0"/>
-                <a:ea typeface="Calibri" pitchFamily="34" charset="-122"/>
-                <a:cs typeface="Calibri" pitchFamily="34" charset="-120"/>
-              </a:rPr>
-              <a:t>Replicate: Se 0.90, NPV 0.86, LR− 0.22; cohort </a:t>
-            </a:r>
-            <a:pPr indent="0" marL="0">
-              <a:buNone/>
-            </a:pPr>
-            <a:r>
-              <a:rPr lang="en-US" sz="1300" dirty="0">
-                <a:solidFill>
-                  <a:srgbClr val="A3410F"/>
-                </a:solidFill>
-                <a:latin typeface="Calibri" pitchFamily="34" charset="0"/>
-                <a:ea typeface="Calibri" pitchFamily="34" charset="-122"/>
-                <a:cs typeface="Calibri" pitchFamily="34" charset="-120"/>
-              </a:rPr>
-              <a:t>[ ]</a:t>
-            </a:r>
-            <a:endParaRPr lang="en-US" sz="1300" dirty="0"/>
-          </a:p>
-        </p:txBody>
-      </p:sp>
-      <p:sp>
-        <p:nvSpPr>
-          <p:cNvPr id="125" name="Shape 120"/>
+              <a:rPr lang="en-US" sz="1200" dirty="0">
+                <a:solidFill>
+                  <a:srgbClr val="12202E"/>
+                </a:solidFill>
+                <a:latin typeface="Calibri" pitchFamily="34" charset="0"/>
+                <a:ea typeface="Calibri" pitchFamily="34" charset="-122"/>
+                <a:cs typeface="Calibri" pitchFamily="34" charset="-120"/>
+              </a:rPr>
+              <a:t>Replicate: Se 0.90, NPV 0.86, LR− 0.22</a:t>
+            </a:r>
+            <a:endParaRPr lang="en-US" sz="1200" dirty="0"/>
+          </a:p>
+        </p:txBody>
+      </p:sp>
+      <p:sp>
+        <p:nvSpPr>
+          <p:cNvPr id="127" name="Shape 122"/>
           <p:cNvSpPr/>
           <p:nvPr/>
         </p:nvSpPr>
         <p:spPr>
           <a:xfrm>
-            <a:off x="25755156" y="11004423"/>
-            <a:ext cx="7873344" cy="0"/>
+            <a:off x="27081036" y="10460355"/>
+            <a:ext cx="6547464" cy="0"/>
           </a:xfrm>
           <a:prstGeom prst="line">
             <a:avLst/>
@@ -8144,14 +8306,14 @@
       </p:sp>
       <p:sp>
         <p:nvSpPr>
-          <p:cNvPr id="126" name="Text 121"/>
+          <p:cNvPr id="128" name="Text 123"/>
           <p:cNvSpPr txBox="1"/>
           <p:nvPr/>
         </p:nvSpPr>
         <p:spPr>
           <a:xfrm>
-            <a:off x="25755156" y="11004423"/>
-            <a:ext cx="2011680" cy="338328"/>
+            <a:off x="27081036" y="10460355"/>
+            <a:ext cx="1691640" cy="288036"/>
           </a:xfrm>
           <a:prstGeom prst="rect">
             <a:avLst/>
@@ -8167,7 +8329,7 @@
               <a:buNone/>
             </a:pPr>
             <a:r>
-              <a:rPr lang="en-US" sz="1300" b="1" dirty="0">
+              <a:rPr lang="en-US" sz="1200" b="1" dirty="0">
                 <a:solidFill>
                   <a:srgbClr val="12202E"/>
                 </a:solidFill>
@@ -8177,24 +8339,24 @@
               </a:rPr>
               <a:t>Calibration</a:t>
             </a:r>
-            <a:endParaRPr lang="en-US" sz="1300" dirty="0"/>
-          </a:p>
-        </p:txBody>
-      </p:sp>
-      <p:sp>
-        <p:nvSpPr>
-          <p:cNvPr id="127" name="Shape 122"/>
+            <a:endParaRPr lang="en-US" sz="1200" dirty="0"/>
+          </a:p>
+        </p:txBody>
+      </p:sp>
+      <p:sp>
+        <p:nvSpPr>
+          <p:cNvPr id="129" name="Shape 124"/>
           <p:cNvSpPr/>
           <p:nvPr/>
         </p:nvSpPr>
         <p:spPr>
           <a:xfrm>
-            <a:off x="27766836" y="11059287"/>
-            <a:ext cx="896112" cy="228600"/>
+            <a:off x="28772676" y="10501503"/>
+            <a:ext cx="822960" cy="205740"/>
           </a:xfrm>
           <a:prstGeom prst="roundRect">
             <a:avLst>
-              <a:gd name="adj" fmla="val 20000"/>
+              <a:gd name="adj" fmla="val 17778"/>
             </a:avLst>
           </a:prstGeom>
           <a:solidFill>
@@ -8210,14 +8372,14 @@
       </p:sp>
       <p:sp>
         <p:nvSpPr>
-          <p:cNvPr id="128" name="Text 123"/>
+          <p:cNvPr id="130" name="Text 125"/>
           <p:cNvSpPr txBox="1"/>
           <p:nvPr/>
         </p:nvSpPr>
         <p:spPr>
           <a:xfrm>
-            <a:off x="27766836" y="11059287"/>
-            <a:ext cx="896112" cy="228600"/>
+            <a:off x="28772676" y="10501503"/>
+            <a:ext cx="822960" cy="205740"/>
           </a:xfrm>
           <a:prstGeom prst="rect">
             <a:avLst/>
@@ -8233,7 +8395,7 @@
               <a:buNone/>
             </a:pPr>
             <a:r>
-              <a:rPr lang="en-US" sz="1150" b="1" dirty="0">
+              <a:rPr lang="en-US" sz="1050" b="1" dirty="0">
                 <a:solidFill>
                   <a:srgbClr val="7A2E0B"/>
                 </a:solidFill>
@@ -8243,20 +8405,20 @@
               </a:rPr>
               <a:t>Partial</a:t>
             </a:r>
-            <a:endParaRPr lang="en-US" sz="1150" dirty="0"/>
-          </a:p>
-        </p:txBody>
-      </p:sp>
-      <p:sp>
-        <p:nvSpPr>
-          <p:cNvPr id="129" name="Text 124"/>
+            <a:endParaRPr lang="en-US" sz="1050" dirty="0"/>
+          </a:p>
+        </p:txBody>
+      </p:sp>
+      <p:sp>
+        <p:nvSpPr>
+          <p:cNvPr id="131" name="Text 126"/>
           <p:cNvSpPr txBox="1"/>
           <p:nvPr/>
         </p:nvSpPr>
         <p:spPr>
           <a:xfrm>
-            <a:off x="28772676" y="11004423"/>
-            <a:ext cx="4855824" cy="338328"/>
+            <a:off x="29687076" y="10460355"/>
+            <a:ext cx="3941424" cy="288036"/>
           </a:xfrm>
           <a:prstGeom prst="rect">
             <a:avLst/>
@@ -8272,21 +8434,21 @@
               <a:buNone/>
             </a:pPr>
             <a:r>
-              <a:rPr lang="en-US" sz="1300" dirty="0">
-                <a:solidFill>
-                  <a:srgbClr val="12202E"/>
-                </a:solidFill>
-                <a:latin typeface="Calibri" pitchFamily="34" charset="0"/>
-                <a:ea typeface="Calibri" pitchFamily="34" charset="-122"/>
-                <a:cs typeface="Calibri" pitchFamily="34" charset="-120"/>
-              </a:rPr>
-              <a:t>Replicate: slope 0.97, O:E 1.08; cohort </a:t>
-            </a:r>
-            <a:pPr indent="0" marL="0">
-              <a:buNone/>
-            </a:pPr>
-            <a:r>
-              <a:rPr lang="en-US" sz="1300" dirty="0">
+              <a:rPr lang="en-US" sz="1200" dirty="0">
+                <a:solidFill>
+                  <a:srgbClr val="12202E"/>
+                </a:solidFill>
+                <a:latin typeface="Calibri" pitchFamily="34" charset="0"/>
+                <a:ea typeface="Calibri" pitchFamily="34" charset="-122"/>
+                <a:cs typeface="Calibri" pitchFamily="34" charset="-120"/>
+              </a:rPr>
+              <a:t>Replicate: slope 0.97, O:E 1.08; plot </a:t>
+            </a:r>
+            <a:pPr indent="0" marL="0">
+              <a:buNone/>
+            </a:pPr>
+            <a:r>
+              <a:rPr lang="en-US" sz="1200" dirty="0">
                 <a:solidFill>
                   <a:srgbClr val="A3410F"/>
                 </a:solidFill>
@@ -8296,20 +8458,20 @@
               </a:rPr>
               <a:t>[ ]</a:t>
             </a:r>
-            <a:endParaRPr lang="en-US" sz="1300" dirty="0"/>
-          </a:p>
-        </p:txBody>
-      </p:sp>
-      <p:sp>
-        <p:nvSpPr>
-          <p:cNvPr id="130" name="Shape 125"/>
+            <a:endParaRPr lang="en-US" sz="1200" dirty="0"/>
+          </a:p>
+        </p:txBody>
+      </p:sp>
+      <p:sp>
+        <p:nvSpPr>
+          <p:cNvPr id="132" name="Shape 127"/>
           <p:cNvSpPr/>
           <p:nvPr/>
         </p:nvSpPr>
         <p:spPr>
           <a:xfrm>
-            <a:off x="25755156" y="11342751"/>
-            <a:ext cx="7873344" cy="0"/>
+            <a:off x="27081036" y="10748391"/>
+            <a:ext cx="6547464" cy="0"/>
           </a:xfrm>
           <a:prstGeom prst="line">
             <a:avLst/>
@@ -8325,14 +8487,14 @@
       </p:sp>
       <p:sp>
         <p:nvSpPr>
-          <p:cNvPr id="131" name="Text 126"/>
+          <p:cNvPr id="133" name="Text 128"/>
           <p:cNvSpPr txBox="1"/>
           <p:nvPr/>
         </p:nvSpPr>
         <p:spPr>
           <a:xfrm>
-            <a:off x="25755156" y="11342751"/>
-            <a:ext cx="2011680" cy="338328"/>
+            <a:off x="27081036" y="10748391"/>
+            <a:ext cx="1691640" cy="288036"/>
           </a:xfrm>
           <a:prstGeom prst="rect">
             <a:avLst/>
@@ -8348,34 +8510,34 @@
               <a:buNone/>
             </a:pPr>
             <a:r>
-              <a:rPr lang="en-US" sz="1300" b="1" dirty="0">
-                <a:solidFill>
-                  <a:srgbClr val="12202E"/>
-                </a:solidFill>
-                <a:latin typeface="Calibri" pitchFamily="34" charset="0"/>
-                <a:ea typeface="Calibri" pitchFamily="34" charset="-122"/>
-                <a:cs typeface="Calibri" pitchFamily="34" charset="-120"/>
-              </a:rPr>
-              <a:t>Independent cohort</a:t>
-            </a:r>
-            <a:endParaRPr lang="en-US" sz="1300" dirty="0"/>
-          </a:p>
-        </p:txBody>
-      </p:sp>
-      <p:sp>
-        <p:nvSpPr>
-          <p:cNvPr id="132" name="Shape 127"/>
+              <a:rPr lang="en-US" sz="1200" b="1" dirty="0">
+                <a:solidFill>
+                  <a:srgbClr val="12202E"/>
+                </a:solidFill>
+                <a:latin typeface="Calibri" pitchFamily="34" charset="0"/>
+                <a:ea typeface="Calibri" pitchFamily="34" charset="-122"/>
+                <a:cs typeface="Calibri" pitchFamily="34" charset="-120"/>
+              </a:rPr>
+              <a:t>Indep. cohort</a:t>
+            </a:r>
+            <a:endParaRPr lang="en-US" sz="1200" dirty="0"/>
+          </a:p>
+        </p:txBody>
+      </p:sp>
+      <p:sp>
+        <p:nvSpPr>
+          <p:cNvPr id="134" name="Shape 129"/>
           <p:cNvSpPr/>
           <p:nvPr/>
         </p:nvSpPr>
         <p:spPr>
           <a:xfrm>
-            <a:off x="27766836" y="11397615"/>
-            <a:ext cx="896112" cy="228600"/>
+            <a:off x="28772676" y="10789539"/>
+            <a:ext cx="822960" cy="205740"/>
           </a:xfrm>
           <a:prstGeom prst="roundRect">
             <a:avLst>
-              <a:gd name="adj" fmla="val 20000"/>
+              <a:gd name="adj" fmla="val 17778"/>
             </a:avLst>
           </a:prstGeom>
           <a:solidFill>
@@ -8391,14 +8553,14 @@
       </p:sp>
       <p:sp>
         <p:nvSpPr>
-          <p:cNvPr id="133" name="Text 128"/>
+          <p:cNvPr id="135" name="Text 130"/>
           <p:cNvSpPr txBox="1"/>
           <p:nvPr/>
         </p:nvSpPr>
         <p:spPr>
           <a:xfrm>
-            <a:off x="27766836" y="11397615"/>
-            <a:ext cx="896112" cy="228600"/>
+            <a:off x="28772676" y="10789539"/>
+            <a:ext cx="822960" cy="205740"/>
           </a:xfrm>
           <a:prstGeom prst="rect">
             <a:avLst/>
@@ -8414,7 +8576,7 @@
               <a:buNone/>
             </a:pPr>
             <a:r>
-              <a:rPr lang="en-US" sz="1150" b="1" dirty="0">
+              <a:rPr lang="en-US" sz="1050" b="1" dirty="0">
                 <a:solidFill>
                   <a:srgbClr val="3F4B57"/>
                 </a:solidFill>
@@ -8424,20 +8586,20 @@
               </a:rPr>
               <a:t>Not yet</a:t>
             </a:r>
-            <a:endParaRPr lang="en-US" sz="1150" dirty="0"/>
-          </a:p>
-        </p:txBody>
-      </p:sp>
-      <p:sp>
-        <p:nvSpPr>
-          <p:cNvPr id="134" name="Text 129"/>
+            <a:endParaRPr lang="en-US" sz="1050" dirty="0"/>
+          </a:p>
+        </p:txBody>
+      </p:sp>
+      <p:sp>
+        <p:nvSpPr>
+          <p:cNvPr id="136" name="Text 131"/>
           <p:cNvSpPr txBox="1"/>
           <p:nvPr/>
         </p:nvSpPr>
         <p:spPr>
           <a:xfrm>
-            <a:off x="28772676" y="11342751"/>
-            <a:ext cx="4855824" cy="338328"/>
+            <a:off x="29687076" y="10748391"/>
+            <a:ext cx="3941424" cy="288036"/>
           </a:xfrm>
           <a:prstGeom prst="rect">
             <a:avLst/>
@@ -8453,30 +8615,30 @@
               <a:buNone/>
             </a:pPr>
             <a:r>
-              <a:rPr lang="en-US" sz="1300" dirty="0">
-                <a:solidFill>
-                  <a:srgbClr val="12202E"/>
-                </a:solidFill>
-                <a:latin typeface="Calibri" pitchFamily="34" charset="0"/>
-                <a:ea typeface="Calibri" pitchFamily="34" charset="-122"/>
-                <a:cs typeface="Calibri" pitchFamily="34" charset="-120"/>
-              </a:rPr>
-              <a:t>Single institution; non-MSK validation needed</a:t>
-            </a:r>
-            <a:endParaRPr lang="en-US" sz="1300" dirty="0"/>
-          </a:p>
-        </p:txBody>
-      </p:sp>
-      <p:sp>
-        <p:nvSpPr>
-          <p:cNvPr id="135" name="Shape 130"/>
+              <a:rPr lang="en-US" sz="1200" dirty="0">
+                <a:solidFill>
+                  <a:srgbClr val="12202E"/>
+                </a:solidFill>
+                <a:latin typeface="Calibri" pitchFamily="34" charset="0"/>
+                <a:ea typeface="Calibri" pitchFamily="34" charset="-122"/>
+                <a:cs typeface="Calibri" pitchFamily="34" charset="-120"/>
+              </a:rPr>
+              <a:t>Single institution; external cohort needed</a:t>
+            </a:r>
+            <a:endParaRPr lang="en-US" sz="1200" dirty="0"/>
+          </a:p>
+        </p:txBody>
+      </p:sp>
+      <p:sp>
+        <p:nvSpPr>
+          <p:cNvPr id="137" name="Shape 132"/>
           <p:cNvSpPr/>
           <p:nvPr/>
         </p:nvSpPr>
         <p:spPr>
           <a:xfrm>
-            <a:off x="25755156" y="11681079"/>
-            <a:ext cx="7873344" cy="0"/>
+            <a:off x="27081036" y="11036427"/>
+            <a:ext cx="6547464" cy="0"/>
           </a:xfrm>
           <a:prstGeom prst="line">
             <a:avLst/>
@@ -8492,14 +8654,14 @@
       </p:sp>
       <p:sp>
         <p:nvSpPr>
-          <p:cNvPr id="136" name="Text 131"/>
+          <p:cNvPr id="138" name="Text 133"/>
           <p:cNvSpPr txBox="1"/>
           <p:nvPr/>
         </p:nvSpPr>
         <p:spPr>
           <a:xfrm>
-            <a:off x="25755156" y="11681079"/>
-            <a:ext cx="2011680" cy="338328"/>
+            <a:off x="27081036" y="11036427"/>
+            <a:ext cx="1691640" cy="288036"/>
           </a:xfrm>
           <a:prstGeom prst="rect">
             <a:avLst/>
@@ -8515,34 +8677,34 @@
               <a:buNone/>
             </a:pPr>
             <a:r>
-              <a:rPr lang="en-US" sz="1300" b="1" dirty="0">
-                <a:solidFill>
-                  <a:srgbClr val="12202E"/>
-                </a:solidFill>
-                <a:latin typeface="Calibri" pitchFamily="34" charset="0"/>
-                <a:ea typeface="Calibri" pitchFamily="34" charset="-122"/>
-                <a:cs typeface="Calibri" pitchFamily="34" charset="-120"/>
-              </a:rPr>
-              <a:t>Assay shift</a:t>
-            </a:r>
-            <a:endParaRPr lang="en-US" sz="1300" dirty="0"/>
-          </a:p>
-        </p:txBody>
-      </p:sp>
-      <p:sp>
-        <p:nvSpPr>
-          <p:cNvPr id="137" name="Shape 132"/>
+              <a:rPr lang="en-US" sz="1200" b="1" dirty="0">
+                <a:solidFill>
+                  <a:srgbClr val="12202E"/>
+                </a:solidFill>
+                <a:latin typeface="Calibri" pitchFamily="34" charset="0"/>
+                <a:ea typeface="Calibri" pitchFamily="34" charset="-122"/>
+                <a:cs typeface="Calibri" pitchFamily="34" charset="-120"/>
+              </a:rPr>
+              <a:t>Assay variation</a:t>
+            </a:r>
+            <a:endParaRPr lang="en-US" sz="1200" dirty="0"/>
+          </a:p>
+        </p:txBody>
+      </p:sp>
+      <p:sp>
+        <p:nvSpPr>
+          <p:cNvPr id="139" name="Shape 134"/>
           <p:cNvSpPr/>
           <p:nvPr/>
         </p:nvSpPr>
         <p:spPr>
           <a:xfrm>
-            <a:off x="27766836" y="11735943"/>
-            <a:ext cx="896112" cy="228600"/>
+            <a:off x="28772676" y="11077575"/>
+            <a:ext cx="822960" cy="205740"/>
           </a:xfrm>
           <a:prstGeom prst="roundRect">
             <a:avLst>
-              <a:gd name="adj" fmla="val 20000"/>
+              <a:gd name="adj" fmla="val 17778"/>
             </a:avLst>
           </a:prstGeom>
           <a:solidFill>
@@ -8558,14 +8720,14 @@
       </p:sp>
       <p:sp>
         <p:nvSpPr>
-          <p:cNvPr id="138" name="Text 133"/>
+          <p:cNvPr id="140" name="Text 135"/>
           <p:cNvSpPr txBox="1"/>
           <p:nvPr/>
         </p:nvSpPr>
         <p:spPr>
           <a:xfrm>
-            <a:off x="27766836" y="11735943"/>
-            <a:ext cx="896112" cy="228600"/>
+            <a:off x="28772676" y="11077575"/>
+            <a:ext cx="822960" cy="205740"/>
           </a:xfrm>
           <a:prstGeom prst="rect">
             <a:avLst/>
@@ -8581,7 +8743,7 @@
               <a:buNone/>
             </a:pPr>
             <a:r>
-              <a:rPr lang="en-US" sz="1150" b="1" dirty="0">
+              <a:rPr lang="en-US" sz="1050" b="1" dirty="0">
                 <a:solidFill>
                   <a:srgbClr val="7A2E0B"/>
                 </a:solidFill>
@@ -8591,20 +8753,20 @@
               </a:rPr>
               <a:t>Partial</a:t>
             </a:r>
-            <a:endParaRPr lang="en-US" sz="1150" dirty="0"/>
-          </a:p>
-        </p:txBody>
-      </p:sp>
-      <p:sp>
-        <p:nvSpPr>
-          <p:cNvPr id="139" name="Text 134"/>
+            <a:endParaRPr lang="en-US" sz="1050" dirty="0"/>
+          </a:p>
+        </p:txBody>
+      </p:sp>
+      <p:sp>
+        <p:nvSpPr>
+          <p:cNvPr id="141" name="Text 136"/>
           <p:cNvSpPr txBox="1"/>
           <p:nvPr/>
         </p:nvSpPr>
         <p:spPr>
           <a:xfrm>
-            <a:off x="28772676" y="11681079"/>
-            <a:ext cx="4855824" cy="338328"/>
+            <a:off x="29687076" y="11036427"/>
+            <a:ext cx="3941424" cy="288036"/>
           </a:xfrm>
           <a:prstGeom prst="rect">
             <a:avLst/>
@@ -8620,7 +8782,7 @@
               <a:buNone/>
             </a:pPr>
             <a:r>
-              <a:rPr lang="en-US" sz="1300" dirty="0">
+              <a:rPr lang="en-US" sz="1200" dirty="0">
                 <a:solidFill>
                   <a:srgbClr val="12202E"/>
                 </a:solidFill>
@@ -8630,20 +8792,20 @@
               </a:rPr>
               <a:t>Real IMPACT341 input: AUROC 0.84 → 0.70</a:t>
             </a:r>
-            <a:endParaRPr lang="en-US" sz="1300" dirty="0"/>
-          </a:p>
-        </p:txBody>
-      </p:sp>
-      <p:sp>
-        <p:nvSpPr>
-          <p:cNvPr id="140" name="Shape 135"/>
+            <a:endParaRPr lang="en-US" sz="1200" dirty="0"/>
+          </a:p>
+        </p:txBody>
+      </p:sp>
+      <p:sp>
+        <p:nvSpPr>
+          <p:cNvPr id="142" name="Shape 137"/>
           <p:cNvSpPr/>
           <p:nvPr/>
         </p:nvSpPr>
         <p:spPr>
           <a:xfrm>
-            <a:off x="25755156" y="12019407"/>
-            <a:ext cx="7873344" cy="0"/>
+            <a:off x="27081036" y="11324463"/>
+            <a:ext cx="6547464" cy="0"/>
           </a:xfrm>
           <a:prstGeom prst="line">
             <a:avLst/>
@@ -8659,14 +8821,37 @@
       </p:sp>
       <p:sp>
         <p:nvSpPr>
-          <p:cNvPr id="141" name="Text 136"/>
+          <p:cNvPr id="143" name="Shape 138"/>
+          <p:cNvSpPr/>
+          <p:nvPr/>
+        </p:nvSpPr>
+        <p:spPr>
+          <a:xfrm>
+            <a:off x="25755156" y="11324463"/>
+            <a:ext cx="7873344" cy="0"/>
+          </a:xfrm>
+          <a:prstGeom prst="line">
+            <a:avLst/>
+          </a:prstGeom>
+          <a:noFill/>
+          <a:ln w="12700">
+            <a:solidFill>
+              <a:srgbClr val="12202E"/>
+            </a:solidFill>
+            <a:prstDash val="solid"/>
+          </a:ln>
+        </p:spPr>
+      </p:sp>
+      <p:sp>
+        <p:nvSpPr>
+          <p:cNvPr id="144" name="Text 139"/>
           <p:cNvSpPr txBox="1"/>
           <p:nvPr/>
         </p:nvSpPr>
         <p:spPr>
           <a:xfrm>
-            <a:off x="25755156" y="12019407"/>
-            <a:ext cx="2011680" cy="338328"/>
+            <a:off x="25755156" y="11324463"/>
+            <a:ext cx="1325880" cy="288036"/>
           </a:xfrm>
           <a:prstGeom prst="rect">
             <a:avLst/>
@@ -8682,7 +8867,46 @@
               <a:buNone/>
             </a:pPr>
             <a:r>
-              <a:rPr lang="en-US" sz="1300" b="1" dirty="0">
+              <a:rPr lang="en-US" sz="1150" b="1" dirty="0">
+                <a:solidFill>
+                  <a:srgbClr val="3F4B57"/>
+                </a:solidFill>
+                <a:latin typeface="Calibri" pitchFamily="34" charset="0"/>
+                <a:ea typeface="Calibri" pitchFamily="34" charset="-122"/>
+                <a:cs typeface="Calibri" pitchFamily="34" charset="-120"/>
+              </a:rPr>
+              <a:t>Recommended</a:t>
+            </a:r>
+            <a:endParaRPr lang="en-US" sz="1150" dirty="0"/>
+          </a:p>
+        </p:txBody>
+      </p:sp>
+      <p:sp>
+        <p:nvSpPr>
+          <p:cNvPr id="145" name="Text 140"/>
+          <p:cNvSpPr txBox="1"/>
+          <p:nvPr/>
+        </p:nvSpPr>
+        <p:spPr>
+          <a:xfrm>
+            <a:off x="27081036" y="11324463"/>
+            <a:ext cx="1691640" cy="288036"/>
+          </a:xfrm>
+          <a:prstGeom prst="rect">
+            <a:avLst/>
+          </a:prstGeom>
+          <a:noFill/>
+          <a:ln/>
+        </p:spPr>
+        <p:txBody>
+          <a:bodyPr wrap="square" lIns="0" tIns="0" rIns="0" bIns="0" rtlCol="0" anchor="ctr"/>
+          <a:lstStyle/>
+          <a:p>
+            <a:pPr indent="0" marL="0">
+              <a:buNone/>
+            </a:pPr>
+            <a:r>
+              <a:rPr lang="en-US" sz="1200" b="1" dirty="0">
                 <a:solidFill>
                   <a:srgbClr val="12202E"/>
                 </a:solidFill>
@@ -8692,24 +8916,24 @@
               </a:rPr>
               <a:t>Fairness</a:t>
             </a:r>
-            <a:endParaRPr lang="en-US" sz="1300" dirty="0"/>
-          </a:p>
-        </p:txBody>
-      </p:sp>
-      <p:sp>
-        <p:nvSpPr>
-          <p:cNvPr id="142" name="Shape 137"/>
+            <a:endParaRPr lang="en-US" sz="1200" dirty="0"/>
+          </a:p>
+        </p:txBody>
+      </p:sp>
+      <p:sp>
+        <p:nvSpPr>
+          <p:cNvPr id="146" name="Shape 141"/>
           <p:cNvSpPr/>
           <p:nvPr/>
         </p:nvSpPr>
         <p:spPr>
           <a:xfrm>
-            <a:off x="27766836" y="12074271"/>
-            <a:ext cx="896112" cy="228600"/>
+            <a:off x="28772676" y="11365611"/>
+            <a:ext cx="822960" cy="205740"/>
           </a:xfrm>
           <a:prstGeom prst="roundRect">
             <a:avLst>
-              <a:gd name="adj" fmla="val 20000"/>
+              <a:gd name="adj" fmla="val 17778"/>
             </a:avLst>
           </a:prstGeom>
           <a:solidFill>
@@ -8725,14 +8949,14 @@
       </p:sp>
       <p:sp>
         <p:nvSpPr>
-          <p:cNvPr id="143" name="Text 138"/>
+          <p:cNvPr id="147" name="Text 142"/>
           <p:cNvSpPr txBox="1"/>
           <p:nvPr/>
         </p:nvSpPr>
         <p:spPr>
           <a:xfrm>
-            <a:off x="27766836" y="12074271"/>
-            <a:ext cx="896112" cy="228600"/>
+            <a:off x="28772676" y="11365611"/>
+            <a:ext cx="822960" cy="205740"/>
           </a:xfrm>
           <a:prstGeom prst="rect">
             <a:avLst/>
@@ -8748,7 +8972,7 @@
               <a:buNone/>
             </a:pPr>
             <a:r>
-              <a:rPr lang="en-US" sz="1150" b="1" dirty="0">
+              <a:rPr lang="en-US" sz="1050" b="1" dirty="0">
                 <a:solidFill>
                   <a:srgbClr val="3F4B57"/>
                 </a:solidFill>
@@ -8758,20 +8982,20 @@
               </a:rPr>
               <a:t>Not yet</a:t>
             </a:r>
-            <a:endParaRPr lang="en-US" sz="1150" dirty="0"/>
-          </a:p>
-        </p:txBody>
-      </p:sp>
-      <p:sp>
-        <p:nvSpPr>
-          <p:cNvPr id="144" name="Text 139"/>
+            <a:endParaRPr lang="en-US" sz="1050" dirty="0"/>
+          </a:p>
+        </p:txBody>
+      </p:sp>
+      <p:sp>
+        <p:nvSpPr>
+          <p:cNvPr id="148" name="Text 143"/>
           <p:cNvSpPr txBox="1"/>
           <p:nvPr/>
         </p:nvSpPr>
         <p:spPr>
           <a:xfrm>
-            <a:off x="28772676" y="12019407"/>
-            <a:ext cx="4855824" cy="338328"/>
+            <a:off x="29687076" y="11324463"/>
+            <a:ext cx="3941424" cy="288036"/>
           </a:xfrm>
           <a:prstGeom prst="rect">
             <a:avLst/>
@@ -8787,30 +9011,30 @@
               <a:buNone/>
             </a:pPr>
             <a:r>
-              <a:rPr lang="en-US" sz="1300" dirty="0">
-                <a:solidFill>
-                  <a:srgbClr val="12202E"/>
-                </a:solidFill>
-                <a:latin typeface="Calibri" pitchFamily="34" charset="0"/>
-                <a:ea typeface="Calibri" pitchFamily="34" charset="-122"/>
-                <a:cs typeface="Calibri" pitchFamily="34" charset="-120"/>
-              </a:rPr>
-              <a:t>Sex, ancestry, smoking, histology subgroups</a:t>
-            </a:r>
-            <a:endParaRPr lang="en-US" sz="1300" dirty="0"/>
-          </a:p>
-        </p:txBody>
-      </p:sp>
-      <p:sp>
-        <p:nvSpPr>
-          <p:cNvPr id="145" name="Shape 140"/>
+              <a:rPr lang="en-US" sz="1200" dirty="0">
+                <a:solidFill>
+                  <a:srgbClr val="12202E"/>
+                </a:solidFill>
+                <a:latin typeface="Calibri" pitchFamily="34" charset="0"/>
+                <a:ea typeface="Calibri" pitchFamily="34" charset="-122"/>
+                <a:cs typeface="Calibri" pitchFamily="34" charset="-120"/>
+              </a:rPr>
+              <a:t>Sex, ancestry, smoking, histology</a:t>
+            </a:r>
+            <a:endParaRPr lang="en-US" sz="1200" dirty="0"/>
+          </a:p>
+        </p:txBody>
+      </p:sp>
+      <p:sp>
+        <p:nvSpPr>
+          <p:cNvPr id="149" name="Shape 144"/>
           <p:cNvSpPr/>
           <p:nvPr/>
         </p:nvSpPr>
         <p:spPr>
           <a:xfrm>
-            <a:off x="25755156" y="12357735"/>
-            <a:ext cx="7873344" cy="0"/>
+            <a:off x="27081036" y="11612499"/>
+            <a:ext cx="6547464" cy="0"/>
           </a:xfrm>
           <a:prstGeom prst="line">
             <a:avLst/>
@@ -8826,14 +9050,14 @@
       </p:sp>
       <p:sp>
         <p:nvSpPr>
-          <p:cNvPr id="146" name="Text 141"/>
+          <p:cNvPr id="150" name="Text 145"/>
           <p:cNvSpPr txBox="1"/>
           <p:nvPr/>
         </p:nvSpPr>
         <p:spPr>
           <a:xfrm>
-            <a:off x="25755156" y="12357735"/>
-            <a:ext cx="2011680" cy="338328"/>
+            <a:off x="27081036" y="11612499"/>
+            <a:ext cx="1691640" cy="288036"/>
           </a:xfrm>
           <a:prstGeom prst="rect">
             <a:avLst/>
@@ -8849,7 +9073,7 @@
               <a:buNone/>
             </a:pPr>
             <a:r>
-              <a:rPr lang="en-US" sz="1300" b="1" dirty="0">
+              <a:rPr lang="en-US" sz="1200" b="1" dirty="0">
                 <a:solidFill>
                   <a:srgbClr val="12202E"/>
                 </a:solidFill>
@@ -8859,24 +9083,24 @@
               </a:rPr>
               <a:t>Explainability</a:t>
             </a:r>
-            <a:endParaRPr lang="en-US" sz="1300" dirty="0"/>
-          </a:p>
-        </p:txBody>
-      </p:sp>
-      <p:sp>
-        <p:nvSpPr>
-          <p:cNvPr id="147" name="Shape 142"/>
+            <a:endParaRPr lang="en-US" sz="1200" dirty="0"/>
+          </a:p>
+        </p:txBody>
+      </p:sp>
+      <p:sp>
+        <p:nvSpPr>
+          <p:cNvPr id="151" name="Shape 146"/>
           <p:cNvSpPr/>
           <p:nvPr/>
         </p:nvSpPr>
         <p:spPr>
           <a:xfrm>
-            <a:off x="27766836" y="12412599"/>
-            <a:ext cx="896112" cy="228600"/>
+            <a:off x="28772676" y="11653647"/>
+            <a:ext cx="822960" cy="205740"/>
           </a:xfrm>
           <a:prstGeom prst="roundRect">
             <a:avLst>
-              <a:gd name="adj" fmla="val 20000"/>
+              <a:gd name="adj" fmla="val 17778"/>
             </a:avLst>
           </a:prstGeom>
           <a:solidFill>
@@ -8892,14 +9116,14 @@
       </p:sp>
       <p:sp>
         <p:nvSpPr>
-          <p:cNvPr id="148" name="Text 143"/>
+          <p:cNvPr id="152" name="Text 147"/>
           <p:cNvSpPr txBox="1"/>
           <p:nvPr/>
         </p:nvSpPr>
         <p:spPr>
           <a:xfrm>
-            <a:off x="27766836" y="12412599"/>
-            <a:ext cx="896112" cy="228600"/>
+            <a:off x="28772676" y="11653647"/>
+            <a:ext cx="822960" cy="205740"/>
           </a:xfrm>
           <a:prstGeom prst="rect">
             <a:avLst/>
@@ -8915,7 +9139,7 @@
               <a:buNone/>
             </a:pPr>
             <a:r>
-              <a:rPr lang="en-US" sz="1150" b="1" dirty="0">
+              <a:rPr lang="en-US" sz="1050" b="1" dirty="0">
                 <a:solidFill>
                   <a:srgbClr val="FFFFFF"/>
                 </a:solidFill>
@@ -8925,20 +9149,20 @@
               </a:rPr>
               <a:t>Met</a:t>
             </a:r>
-            <a:endParaRPr lang="en-US" sz="1150" dirty="0"/>
-          </a:p>
-        </p:txBody>
-      </p:sp>
-      <p:sp>
-        <p:nvSpPr>
-          <p:cNvPr id="149" name="Text 144"/>
+            <a:endParaRPr lang="en-US" sz="1050" dirty="0"/>
+          </a:p>
+        </p:txBody>
+      </p:sp>
+      <p:sp>
+        <p:nvSpPr>
+          <p:cNvPr id="153" name="Text 148"/>
           <p:cNvSpPr txBox="1"/>
           <p:nvPr/>
         </p:nvSpPr>
         <p:spPr>
           <a:xfrm>
-            <a:off x="28772676" y="12357735"/>
-            <a:ext cx="4855824" cy="338328"/>
+            <a:off x="29687076" y="11612499"/>
+            <a:ext cx="3941424" cy="288036"/>
           </a:xfrm>
           <a:prstGeom prst="rect">
             <a:avLst/>
@@ -8954,30 +9178,30 @@
               <a:buNone/>
             </a:pPr>
             <a:r>
-              <a:rPr lang="en-US" sz="1300" dirty="0">
-                <a:solidFill>
-                  <a:srgbClr val="12202E"/>
-                </a:solidFill>
-                <a:latin typeface="Calibri" pitchFamily="34" charset="0"/>
-                <a:ea typeface="Calibri" pitchFamily="34" charset="-122"/>
-                <a:cs typeface="Calibri" pitchFamily="34" charset="-120"/>
-              </a:rPr>
-              <a:t>Signal = copy-number locus + mutational burden</a:t>
-            </a:r>
-            <a:endParaRPr lang="en-US" sz="1300" dirty="0"/>
-          </a:p>
-        </p:txBody>
-      </p:sp>
-      <p:sp>
-        <p:nvSpPr>
-          <p:cNvPr id="150" name="Shape 145"/>
+              <a:rPr lang="en-US" sz="1200" dirty="0">
+                <a:solidFill>
+                  <a:srgbClr val="12202E"/>
+                </a:solidFill>
+                <a:latin typeface="Calibri" pitchFamily="34" charset="0"/>
+                <a:ea typeface="Calibri" pitchFamily="34" charset="-122"/>
+                <a:cs typeface="Calibri" pitchFamily="34" charset="-120"/>
+              </a:rPr>
+              <a:t>Ablation: CN locus + mutational burden</a:t>
+            </a:r>
+            <a:endParaRPr lang="en-US" sz="1200" dirty="0"/>
+          </a:p>
+        </p:txBody>
+      </p:sp>
+      <p:sp>
+        <p:nvSpPr>
+          <p:cNvPr id="154" name="Shape 149"/>
           <p:cNvSpPr/>
           <p:nvPr/>
         </p:nvSpPr>
         <p:spPr>
           <a:xfrm>
-            <a:off x="25755156" y="12696063"/>
-            <a:ext cx="7873344" cy="0"/>
+            <a:off x="27081036" y="11900535"/>
+            <a:ext cx="6547464" cy="0"/>
           </a:xfrm>
           <a:prstGeom prst="line">
             <a:avLst/>
@@ -8993,14 +9217,1307 @@
       </p:sp>
       <p:sp>
         <p:nvSpPr>
-          <p:cNvPr id="151" name="Shape 146"/>
+          <p:cNvPr id="155" name="Shape 150"/>
           <p:cNvSpPr/>
           <p:nvPr/>
         </p:nvSpPr>
         <p:spPr>
           <a:xfrm>
-            <a:off x="25755156" y="12696063"/>
+            <a:off x="25755156" y="11900535"/>
             <a:ext cx="7873344" cy="0"/>
+          </a:xfrm>
+          <a:prstGeom prst="line">
+            <a:avLst/>
+          </a:prstGeom>
+          <a:noFill/>
+          <a:ln w="12700">
+            <a:solidFill>
+              <a:srgbClr val="12202E"/>
+            </a:solidFill>
+            <a:prstDash val="solid"/>
+          </a:ln>
+        </p:spPr>
+      </p:sp>
+      <p:sp>
+        <p:nvSpPr>
+          <p:cNvPr id="156" name="Text 151"/>
+          <p:cNvSpPr txBox="1"/>
+          <p:nvPr/>
+        </p:nvSpPr>
+        <p:spPr>
+          <a:xfrm>
+            <a:off x="25755156" y="11900535"/>
+            <a:ext cx="1325880" cy="288036"/>
+          </a:xfrm>
+          <a:prstGeom prst="rect">
+            <a:avLst/>
+          </a:prstGeom>
+          <a:noFill/>
+          <a:ln/>
+        </p:spPr>
+        <p:txBody>
+          <a:bodyPr wrap="square" lIns="0" tIns="0" rIns="0" bIns="0" rtlCol="0" anchor="ctr"/>
+          <a:lstStyle/>
+          <a:p>
+            <a:pPr indent="0" marL="0">
+              <a:buNone/>
+            </a:pPr>
+            <a:r>
+              <a:rPr lang="en-US" sz="1150" b="1" dirty="0">
+                <a:solidFill>
+                  <a:srgbClr val="3F4B57"/>
+                </a:solidFill>
+                <a:latin typeface="Calibri" pitchFamily="34" charset="0"/>
+                <a:ea typeface="Calibri" pitchFamily="34" charset="-122"/>
+                <a:cs typeface="Calibri" pitchFamily="34" charset="-120"/>
+              </a:rPr>
+              <a:t>Additional</a:t>
+            </a:r>
+            <a:endParaRPr lang="en-US" sz="1150" dirty="0"/>
+          </a:p>
+        </p:txBody>
+      </p:sp>
+      <p:sp>
+        <p:nvSpPr>
+          <p:cNvPr id="157" name="Text 152"/>
+          <p:cNvSpPr txBox="1"/>
+          <p:nvPr/>
+        </p:nvSpPr>
+        <p:spPr>
+          <a:xfrm>
+            <a:off x="27081036" y="11900535"/>
+            <a:ext cx="1691640" cy="288036"/>
+          </a:xfrm>
+          <a:prstGeom prst="rect">
+            <a:avLst/>
+          </a:prstGeom>
+          <a:noFill/>
+          <a:ln/>
+        </p:spPr>
+        <p:txBody>
+          <a:bodyPr wrap="square" lIns="0" tIns="0" rIns="0" bIns="0" rtlCol="0" anchor="ctr"/>
+          <a:lstStyle/>
+          <a:p>
+            <a:pPr indent="0" marL="0">
+              <a:buNone/>
+            </a:pPr>
+            <a:r>
+              <a:rPr lang="en-US" sz="1200" b="1" dirty="0">
+                <a:solidFill>
+                  <a:srgbClr val="12202E"/>
+                </a:solidFill>
+                <a:latin typeface="Calibri" pitchFamily="34" charset="0"/>
+                <a:ea typeface="Calibri" pitchFamily="34" charset="-122"/>
+                <a:cs typeface="Calibri" pitchFamily="34" charset="-120"/>
+              </a:rPr>
+              <a:t>Cost</a:t>
+            </a:r>
+            <a:endParaRPr lang="en-US" sz="1200" dirty="0"/>
+          </a:p>
+        </p:txBody>
+      </p:sp>
+      <p:sp>
+        <p:nvSpPr>
+          <p:cNvPr id="158" name="Shape 153"/>
+          <p:cNvSpPr/>
+          <p:nvPr/>
+        </p:nvSpPr>
+        <p:spPr>
+          <a:xfrm>
+            <a:off x="28772676" y="11941683"/>
+            <a:ext cx="822960" cy="205740"/>
+          </a:xfrm>
+          <a:prstGeom prst="roundRect">
+            <a:avLst>
+              <a:gd name="adj" fmla="val 17778"/>
+            </a:avLst>
+          </a:prstGeom>
+          <a:solidFill>
+            <a:srgbClr val="FBE3D5"/>
+          </a:solidFill>
+          <a:ln w="12700">
+            <a:solidFill>
+              <a:srgbClr val="C4501B"/>
+            </a:solidFill>
+            <a:prstDash val="solid"/>
+          </a:ln>
+        </p:spPr>
+      </p:sp>
+      <p:sp>
+        <p:nvSpPr>
+          <p:cNvPr id="159" name="Text 154"/>
+          <p:cNvSpPr txBox="1"/>
+          <p:nvPr/>
+        </p:nvSpPr>
+        <p:spPr>
+          <a:xfrm>
+            <a:off x="28772676" y="11941683"/>
+            <a:ext cx="822960" cy="205740"/>
+          </a:xfrm>
+          <a:prstGeom prst="rect">
+            <a:avLst/>
+          </a:prstGeom>
+          <a:noFill/>
+          <a:ln/>
+        </p:spPr>
+        <p:txBody>
+          <a:bodyPr wrap="square" lIns="0" tIns="0" rIns="0" bIns="0" rtlCol="0" anchor="ctr"/>
+          <a:lstStyle/>
+          <a:p>
+            <a:pPr algn="ctr" indent="0" marL="0">
+              <a:buNone/>
+            </a:pPr>
+            <a:r>
+              <a:rPr lang="en-US" sz="1050" b="1" dirty="0">
+                <a:solidFill>
+                  <a:srgbClr val="7A2E0B"/>
+                </a:solidFill>
+                <a:latin typeface="Calibri" pitchFamily="34" charset="0"/>
+                <a:ea typeface="Calibri" pitchFamily="34" charset="-122"/>
+                <a:cs typeface="Calibri" pitchFamily="34" charset="-120"/>
+              </a:rPr>
+              <a:t>Partial</a:t>
+            </a:r>
+            <a:endParaRPr lang="en-US" sz="1050" dirty="0"/>
+          </a:p>
+        </p:txBody>
+      </p:sp>
+      <p:sp>
+        <p:nvSpPr>
+          <p:cNvPr id="160" name="Text 155"/>
+          <p:cNvSpPr txBox="1"/>
+          <p:nvPr/>
+        </p:nvSpPr>
+        <p:spPr>
+          <a:xfrm>
+            <a:off x="29687076" y="11900535"/>
+            <a:ext cx="3941424" cy="288036"/>
+          </a:xfrm>
+          <a:prstGeom prst="rect">
+            <a:avLst/>
+          </a:prstGeom>
+          <a:noFill/>
+          <a:ln/>
+        </p:spPr>
+        <p:txBody>
+          <a:bodyPr wrap="square" lIns="0" tIns="0" rIns="0" bIns="0" rtlCol="0" anchor="ctr"/>
+          <a:lstStyle/>
+          <a:p>
+            <a:pPr indent="0" marL="0">
+              <a:buNone/>
+            </a:pPr>
+            <a:r>
+              <a:rPr lang="en-US" sz="1200" dirty="0">
+                <a:solidFill>
+                  <a:srgbClr val="12202E"/>
+                </a:solidFill>
+                <a:latin typeface="Calibri" pitchFamily="34" charset="0"/>
+                <a:ea typeface="Calibri" pitchFamily="34" charset="-122"/>
+                <a:cs typeface="Calibri" pitchFamily="34" charset="-120"/>
+              </a:rPr>
+              <a:t>Reuses routine panel data; cost analysis </a:t>
+            </a:r>
+            <a:pPr indent="0" marL="0">
+              <a:buNone/>
+            </a:pPr>
+            <a:r>
+              <a:rPr lang="en-US" sz="1200" dirty="0">
+                <a:solidFill>
+                  <a:srgbClr val="A3410F"/>
+                </a:solidFill>
+                <a:latin typeface="Calibri" pitchFamily="34" charset="0"/>
+                <a:ea typeface="Calibri" pitchFamily="34" charset="-122"/>
+                <a:cs typeface="Calibri" pitchFamily="34" charset="-120"/>
+              </a:rPr>
+              <a:t>[ ]</a:t>
+            </a:r>
+            <a:endParaRPr lang="en-US" sz="1200" dirty="0"/>
+          </a:p>
+        </p:txBody>
+      </p:sp>
+      <p:sp>
+        <p:nvSpPr>
+          <p:cNvPr id="161" name="Shape 156"/>
+          <p:cNvSpPr/>
+          <p:nvPr/>
+        </p:nvSpPr>
+        <p:spPr>
+          <a:xfrm>
+            <a:off x="27081036" y="12188571"/>
+            <a:ext cx="6547464" cy="0"/>
+          </a:xfrm>
+          <a:prstGeom prst="line">
+            <a:avLst/>
+          </a:prstGeom>
+          <a:noFill/>
+          <a:ln w="9525">
+            <a:solidFill>
+              <a:srgbClr val="E0E4E8"/>
+            </a:solidFill>
+            <a:prstDash val="solid"/>
+          </a:ln>
+        </p:spPr>
+      </p:sp>
+      <p:sp>
+        <p:nvSpPr>
+          <p:cNvPr id="162" name="Text 157"/>
+          <p:cNvSpPr txBox="1"/>
+          <p:nvPr/>
+        </p:nvSpPr>
+        <p:spPr>
+          <a:xfrm>
+            <a:off x="27081036" y="12188571"/>
+            <a:ext cx="1691640" cy="288036"/>
+          </a:xfrm>
+          <a:prstGeom prst="rect">
+            <a:avLst/>
+          </a:prstGeom>
+          <a:noFill/>
+          <a:ln/>
+        </p:spPr>
+        <p:txBody>
+          <a:bodyPr wrap="square" lIns="0" tIns="0" rIns="0" bIns="0" rtlCol="0" anchor="ctr"/>
+          <a:lstStyle/>
+          <a:p>
+            <a:pPr indent="0" marL="0">
+              <a:buNone/>
+            </a:pPr>
+            <a:r>
+              <a:rPr lang="en-US" sz="1200" b="1" dirty="0">
+                <a:solidFill>
+                  <a:srgbClr val="12202E"/>
+                </a:solidFill>
+                <a:latin typeface="Calibri" pitchFamily="34" charset="0"/>
+                <a:ea typeface="Calibri" pitchFamily="34" charset="-122"/>
+                <a:cs typeface="Calibri" pitchFamily="34" charset="-120"/>
+              </a:rPr>
+              <a:t>Turnaround</a:t>
+            </a:r>
+            <a:endParaRPr lang="en-US" sz="1200" dirty="0"/>
+          </a:p>
+        </p:txBody>
+      </p:sp>
+      <p:sp>
+        <p:nvSpPr>
+          <p:cNvPr id="163" name="Shape 158"/>
+          <p:cNvSpPr/>
+          <p:nvPr/>
+        </p:nvSpPr>
+        <p:spPr>
+          <a:xfrm>
+            <a:off x="28772676" y="12229719"/>
+            <a:ext cx="822960" cy="205740"/>
+          </a:xfrm>
+          <a:prstGeom prst="roundRect">
+            <a:avLst>
+              <a:gd name="adj" fmla="val 17778"/>
+            </a:avLst>
+          </a:prstGeom>
+          <a:solidFill>
+            <a:srgbClr val="FBE3D5"/>
+          </a:solidFill>
+          <a:ln w="12700">
+            <a:solidFill>
+              <a:srgbClr val="C4501B"/>
+            </a:solidFill>
+            <a:prstDash val="solid"/>
+          </a:ln>
+        </p:spPr>
+      </p:sp>
+      <p:sp>
+        <p:nvSpPr>
+          <p:cNvPr id="164" name="Text 159"/>
+          <p:cNvSpPr txBox="1"/>
+          <p:nvPr/>
+        </p:nvSpPr>
+        <p:spPr>
+          <a:xfrm>
+            <a:off x="28772676" y="12229719"/>
+            <a:ext cx="822960" cy="205740"/>
+          </a:xfrm>
+          <a:prstGeom prst="rect">
+            <a:avLst/>
+          </a:prstGeom>
+          <a:noFill/>
+          <a:ln/>
+        </p:spPr>
+        <p:txBody>
+          <a:bodyPr wrap="square" lIns="0" tIns="0" rIns="0" bIns="0" rtlCol="0" anchor="ctr"/>
+          <a:lstStyle/>
+          <a:p>
+            <a:pPr algn="ctr" indent="0" marL="0">
+              <a:buNone/>
+            </a:pPr>
+            <a:r>
+              <a:rPr lang="en-US" sz="1050" b="1" dirty="0">
+                <a:solidFill>
+                  <a:srgbClr val="7A2E0B"/>
+                </a:solidFill>
+                <a:latin typeface="Calibri" pitchFamily="34" charset="0"/>
+                <a:ea typeface="Calibri" pitchFamily="34" charset="-122"/>
+                <a:cs typeface="Calibri" pitchFamily="34" charset="-120"/>
+              </a:rPr>
+              <a:t>Partial</a:t>
+            </a:r>
+            <a:endParaRPr lang="en-US" sz="1050" dirty="0"/>
+          </a:p>
+        </p:txBody>
+      </p:sp>
+      <p:sp>
+        <p:nvSpPr>
+          <p:cNvPr id="165" name="Text 160"/>
+          <p:cNvSpPr txBox="1"/>
+          <p:nvPr/>
+        </p:nvSpPr>
+        <p:spPr>
+          <a:xfrm>
+            <a:off x="29687076" y="12188571"/>
+            <a:ext cx="3941424" cy="288036"/>
+          </a:xfrm>
+          <a:prstGeom prst="rect">
+            <a:avLst/>
+          </a:prstGeom>
+          <a:noFill/>
+          <a:ln/>
+        </p:spPr>
+        <p:txBody>
+          <a:bodyPr wrap="square" lIns="0" tIns="0" rIns="0" bIns="0" rtlCol="0" anchor="ctr"/>
+          <a:lstStyle/>
+          <a:p>
+            <a:pPr indent="0" marL="0">
+              <a:buNone/>
+            </a:pPr>
+            <a:r>
+              <a:rPr lang="en-US" sz="1200" dirty="0">
+                <a:solidFill>
+                  <a:srgbClr val="12202E"/>
+                </a:solidFill>
+                <a:latin typeface="Calibri" pitchFamily="34" charset="0"/>
+                <a:ea typeface="Calibri" pitchFamily="34" charset="-122"/>
+                <a:cs typeface="Calibri" pitchFamily="34" charset="-120"/>
+              </a:rPr>
+              <a:t>Inference in seconds; end-to-end time </a:t>
+            </a:r>
+            <a:pPr indent="0" marL="0">
+              <a:buNone/>
+            </a:pPr>
+            <a:r>
+              <a:rPr lang="en-US" sz="1200" dirty="0">
+                <a:solidFill>
+                  <a:srgbClr val="A3410F"/>
+                </a:solidFill>
+                <a:latin typeface="Calibri" pitchFamily="34" charset="0"/>
+                <a:ea typeface="Calibri" pitchFamily="34" charset="-122"/>
+                <a:cs typeface="Calibri" pitchFamily="34" charset="-120"/>
+              </a:rPr>
+              <a:t>[ ]</a:t>
+            </a:r>
+            <a:endParaRPr lang="en-US" sz="1200" dirty="0"/>
+          </a:p>
+        </p:txBody>
+      </p:sp>
+      <p:sp>
+        <p:nvSpPr>
+          <p:cNvPr id="166" name="Shape 161"/>
+          <p:cNvSpPr/>
+          <p:nvPr/>
+        </p:nvSpPr>
+        <p:spPr>
+          <a:xfrm>
+            <a:off x="27081036" y="12476607"/>
+            <a:ext cx="6547464" cy="0"/>
+          </a:xfrm>
+          <a:prstGeom prst="line">
+            <a:avLst/>
+          </a:prstGeom>
+          <a:noFill/>
+          <a:ln w="9525">
+            <a:solidFill>
+              <a:srgbClr val="E0E4E8"/>
+            </a:solidFill>
+            <a:prstDash val="solid"/>
+          </a:ln>
+        </p:spPr>
+      </p:sp>
+      <p:sp>
+        <p:nvSpPr>
+          <p:cNvPr id="167" name="Shape 162"/>
+          <p:cNvSpPr/>
+          <p:nvPr/>
+        </p:nvSpPr>
+        <p:spPr>
+          <a:xfrm>
+            <a:off x="25755156" y="12476607"/>
+            <a:ext cx="7873344" cy="0"/>
+          </a:xfrm>
+          <a:prstGeom prst="line">
+            <a:avLst/>
+          </a:prstGeom>
+          <a:noFill/>
+          <a:ln w="12700">
+            <a:solidFill>
+              <a:srgbClr val="12202E"/>
+            </a:solidFill>
+            <a:prstDash val="solid"/>
+          </a:ln>
+        </p:spPr>
+      </p:sp>
+      <p:sp>
+        <p:nvSpPr>
+          <p:cNvPr id="168" name="Text 163"/>
+          <p:cNvSpPr txBox="1"/>
+          <p:nvPr/>
+        </p:nvSpPr>
+        <p:spPr>
+          <a:xfrm>
+            <a:off x="25755156" y="12476607"/>
+            <a:ext cx="1325880" cy="288036"/>
+          </a:xfrm>
+          <a:prstGeom prst="rect">
+            <a:avLst/>
+          </a:prstGeom>
+          <a:noFill/>
+          <a:ln/>
+        </p:spPr>
+        <p:txBody>
+          <a:bodyPr wrap="square" lIns="0" tIns="0" rIns="0" bIns="0" rtlCol="0" anchor="ctr"/>
+          <a:lstStyle/>
+          <a:p>
+            <a:pPr indent="0" marL="0">
+              <a:buNone/>
+            </a:pPr>
+            <a:r>
+              <a:rPr lang="en-US" sz="1150" b="1" dirty="0">
+                <a:solidFill>
+                  <a:srgbClr val="3F4B57"/>
+                </a:solidFill>
+                <a:latin typeface="Calibri" pitchFamily="34" charset="0"/>
+                <a:ea typeface="Calibri" pitchFamily="34" charset="-122"/>
+                <a:cs typeface="Calibri" pitchFamily="34" charset="-120"/>
+              </a:rPr>
+              <a:t>Validation</a:t>
+            </a:r>
+            <a:endParaRPr lang="en-US" sz="1150" dirty="0"/>
+          </a:p>
+        </p:txBody>
+      </p:sp>
+      <p:sp>
+        <p:nvSpPr>
+          <p:cNvPr id="169" name="Text 164"/>
+          <p:cNvSpPr txBox="1"/>
+          <p:nvPr/>
+        </p:nvSpPr>
+        <p:spPr>
+          <a:xfrm>
+            <a:off x="27081036" y="12476607"/>
+            <a:ext cx="1691640" cy="288036"/>
+          </a:xfrm>
+          <a:prstGeom prst="rect">
+            <a:avLst/>
+          </a:prstGeom>
+          <a:noFill/>
+          <a:ln/>
+        </p:spPr>
+        <p:txBody>
+          <a:bodyPr wrap="square" lIns="0" tIns="0" rIns="0" bIns="0" rtlCol="0" anchor="ctr"/>
+          <a:lstStyle/>
+          <a:p>
+            <a:pPr indent="0" marL="0">
+              <a:buNone/>
+            </a:pPr>
+            <a:r>
+              <a:rPr lang="en-US" sz="1200" b="1" dirty="0">
+                <a:solidFill>
+                  <a:srgbClr val="12202E"/>
+                </a:solidFill>
+                <a:latin typeface="Calibri" pitchFamily="34" charset="0"/>
+                <a:ea typeface="Calibri" pitchFamily="34" charset="-122"/>
+                <a:cs typeface="Calibri" pitchFamily="34" charset="-120"/>
+              </a:rPr>
+              <a:t>Sample size</a:t>
+            </a:r>
+            <a:endParaRPr lang="en-US" sz="1200" dirty="0"/>
+          </a:p>
+        </p:txBody>
+      </p:sp>
+      <p:sp>
+        <p:nvSpPr>
+          <p:cNvPr id="170" name="Shape 165"/>
+          <p:cNvSpPr/>
+          <p:nvPr/>
+        </p:nvSpPr>
+        <p:spPr>
+          <a:xfrm>
+            <a:off x="28772676" y="12517755"/>
+            <a:ext cx="822960" cy="205740"/>
+          </a:xfrm>
+          <a:prstGeom prst="roundRect">
+            <a:avLst>
+              <a:gd name="adj" fmla="val 17778"/>
+            </a:avLst>
+          </a:prstGeom>
+          <a:solidFill>
+            <a:srgbClr val="FBE3D5"/>
+          </a:solidFill>
+          <a:ln w="12700">
+            <a:solidFill>
+              <a:srgbClr val="C4501B"/>
+            </a:solidFill>
+            <a:prstDash val="solid"/>
+          </a:ln>
+        </p:spPr>
+      </p:sp>
+      <p:sp>
+        <p:nvSpPr>
+          <p:cNvPr id="171" name="Text 166"/>
+          <p:cNvSpPr txBox="1"/>
+          <p:nvPr/>
+        </p:nvSpPr>
+        <p:spPr>
+          <a:xfrm>
+            <a:off x="28772676" y="12517755"/>
+            <a:ext cx="822960" cy="205740"/>
+          </a:xfrm>
+          <a:prstGeom prst="rect">
+            <a:avLst/>
+          </a:prstGeom>
+          <a:noFill/>
+          <a:ln/>
+        </p:spPr>
+        <p:txBody>
+          <a:bodyPr wrap="square" lIns="0" tIns="0" rIns="0" bIns="0" rtlCol="0" anchor="ctr"/>
+          <a:lstStyle/>
+          <a:p>
+            <a:pPr algn="ctr" indent="0" marL="0">
+              <a:buNone/>
+            </a:pPr>
+            <a:r>
+              <a:rPr lang="en-US" sz="1050" b="1" dirty="0">
+                <a:solidFill>
+                  <a:srgbClr val="7A2E0B"/>
+                </a:solidFill>
+                <a:latin typeface="Calibri" pitchFamily="34" charset="0"/>
+                <a:ea typeface="Calibri" pitchFamily="34" charset="-122"/>
+                <a:cs typeface="Calibri" pitchFamily="34" charset="-120"/>
+              </a:rPr>
+              <a:t>Partial</a:t>
+            </a:r>
+            <a:endParaRPr lang="en-US" sz="1050" dirty="0"/>
+          </a:p>
+        </p:txBody>
+      </p:sp>
+      <p:sp>
+        <p:nvSpPr>
+          <p:cNvPr id="172" name="Text 167"/>
+          <p:cNvSpPr txBox="1"/>
+          <p:nvPr/>
+        </p:nvSpPr>
+        <p:spPr>
+          <a:xfrm>
+            <a:off x="29687076" y="12476607"/>
+            <a:ext cx="3941424" cy="288036"/>
+          </a:xfrm>
+          <a:prstGeom prst="rect">
+            <a:avLst/>
+          </a:prstGeom>
+          <a:noFill/>
+          <a:ln/>
+        </p:spPr>
+        <p:txBody>
+          <a:bodyPr wrap="square" lIns="0" tIns="0" rIns="0" bIns="0" rtlCol="0" anchor="ctr"/>
+          <a:lstStyle/>
+          <a:p>
+            <a:pPr indent="0" marL="0">
+              <a:buNone/>
+            </a:pPr>
+            <a:r>
+              <a:rPr lang="en-US" sz="1200" dirty="0">
+                <a:solidFill>
+                  <a:srgbClr val="12202E"/>
+                </a:solidFill>
+                <a:latin typeface="Calibri" pitchFamily="34" charset="0"/>
+                <a:ea typeface="Calibri" pitchFamily="34" charset="-122"/>
+                <a:cs typeface="Calibri" pitchFamily="34" charset="-120"/>
+              </a:rPr>
+              <a:t>Post hoc: ≈ ±0.05 AUROC with 334 test patients</a:t>
+            </a:r>
+            <a:endParaRPr lang="en-US" sz="1200" dirty="0"/>
+          </a:p>
+        </p:txBody>
+      </p:sp>
+      <p:sp>
+        <p:nvSpPr>
+          <p:cNvPr id="173" name="Shape 168"/>
+          <p:cNvSpPr/>
+          <p:nvPr/>
+        </p:nvSpPr>
+        <p:spPr>
+          <a:xfrm>
+            <a:off x="27081036" y="12764643"/>
+            <a:ext cx="6547464" cy="0"/>
+          </a:xfrm>
+          <a:prstGeom prst="line">
+            <a:avLst/>
+          </a:prstGeom>
+          <a:noFill/>
+          <a:ln w="9525">
+            <a:solidFill>
+              <a:srgbClr val="E0E4E8"/>
+            </a:solidFill>
+            <a:prstDash val="solid"/>
+          </a:ln>
+        </p:spPr>
+      </p:sp>
+      <p:sp>
+        <p:nvSpPr>
+          <p:cNvPr id="174" name="Text 169"/>
+          <p:cNvSpPr txBox="1"/>
+          <p:nvPr/>
+        </p:nvSpPr>
+        <p:spPr>
+          <a:xfrm>
+            <a:off x="27081036" y="12764643"/>
+            <a:ext cx="1691640" cy="288036"/>
+          </a:xfrm>
+          <a:prstGeom prst="rect">
+            <a:avLst/>
+          </a:prstGeom>
+          <a:noFill/>
+          <a:ln/>
+        </p:spPr>
+        <p:txBody>
+          <a:bodyPr wrap="square" lIns="0" tIns="0" rIns="0" bIns="0" rtlCol="0" anchor="ctr"/>
+          <a:lstStyle/>
+          <a:p>
+            <a:pPr indent="0" marL="0">
+              <a:buNone/>
+            </a:pPr>
+            <a:r>
+              <a:rPr lang="en-US" sz="1200" b="1" dirty="0">
+                <a:solidFill>
+                  <a:srgbClr val="12202E"/>
+                </a:solidFill>
+                <a:latin typeface="Calibri" pitchFamily="34" charset="0"/>
+                <a:ea typeface="Calibri" pitchFamily="34" charset="-122"/>
+                <a:cs typeface="Calibri" pitchFamily="34" charset="-120"/>
+              </a:rPr>
+              <a:t>NRI / DCA</a:t>
+            </a:r>
+            <a:endParaRPr lang="en-US" sz="1200" dirty="0"/>
+          </a:p>
+        </p:txBody>
+      </p:sp>
+      <p:sp>
+        <p:nvSpPr>
+          <p:cNvPr id="175" name="Shape 170"/>
+          <p:cNvSpPr/>
+          <p:nvPr/>
+        </p:nvSpPr>
+        <p:spPr>
+          <a:xfrm>
+            <a:off x="28772676" y="12805791"/>
+            <a:ext cx="822960" cy="205740"/>
+          </a:xfrm>
+          <a:prstGeom prst="roundRect">
+            <a:avLst>
+              <a:gd name="adj" fmla="val 17778"/>
+            </a:avLst>
+          </a:prstGeom>
+          <a:solidFill>
+            <a:srgbClr val="FFFFFF"/>
+          </a:solidFill>
+          <a:ln w="12700">
+            <a:solidFill>
+              <a:srgbClr val="6B7682"/>
+            </a:solidFill>
+            <a:prstDash val="solid"/>
+          </a:ln>
+        </p:spPr>
+      </p:sp>
+      <p:sp>
+        <p:nvSpPr>
+          <p:cNvPr id="176" name="Text 171"/>
+          <p:cNvSpPr txBox="1"/>
+          <p:nvPr/>
+        </p:nvSpPr>
+        <p:spPr>
+          <a:xfrm>
+            <a:off x="28772676" y="12805791"/>
+            <a:ext cx="822960" cy="205740"/>
+          </a:xfrm>
+          <a:prstGeom prst="rect">
+            <a:avLst/>
+          </a:prstGeom>
+          <a:noFill/>
+          <a:ln/>
+        </p:spPr>
+        <p:txBody>
+          <a:bodyPr wrap="square" lIns="0" tIns="0" rIns="0" bIns="0" rtlCol="0" anchor="ctr"/>
+          <a:lstStyle/>
+          <a:p>
+            <a:pPr algn="ctr" indent="0" marL="0">
+              <a:buNone/>
+            </a:pPr>
+            <a:r>
+              <a:rPr lang="en-US" sz="1050" b="1" dirty="0">
+                <a:solidFill>
+                  <a:srgbClr val="3F4B57"/>
+                </a:solidFill>
+                <a:latin typeface="Calibri" pitchFamily="34" charset="0"/>
+                <a:ea typeface="Calibri" pitchFamily="34" charset="-122"/>
+                <a:cs typeface="Calibri" pitchFamily="34" charset="-120"/>
+              </a:rPr>
+              <a:t>Not yet</a:t>
+            </a:r>
+            <a:endParaRPr lang="en-US" sz="1050" dirty="0"/>
+          </a:p>
+        </p:txBody>
+      </p:sp>
+      <p:sp>
+        <p:nvSpPr>
+          <p:cNvPr id="177" name="Text 172"/>
+          <p:cNvSpPr txBox="1"/>
+          <p:nvPr/>
+        </p:nvSpPr>
+        <p:spPr>
+          <a:xfrm>
+            <a:off x="29687076" y="12764643"/>
+            <a:ext cx="3941424" cy="288036"/>
+          </a:xfrm>
+          <a:prstGeom prst="rect">
+            <a:avLst/>
+          </a:prstGeom>
+          <a:noFill/>
+          <a:ln/>
+        </p:spPr>
+        <p:txBody>
+          <a:bodyPr wrap="square" lIns="0" tIns="0" rIns="0" bIns="0" rtlCol="0" anchor="ctr"/>
+          <a:lstStyle/>
+          <a:p>
+            <a:pPr indent="0" marL="0">
+              <a:buNone/>
+            </a:pPr>
+            <a:r>
+              <a:rPr lang="en-US" sz="1200" dirty="0">
+                <a:solidFill>
+                  <a:srgbClr val="12202E"/>
+                </a:solidFill>
+                <a:latin typeface="Calibri" pitchFamily="34" charset="0"/>
+                <a:ea typeface="Calibri" pitchFamily="34" charset="-122"/>
+                <a:cs typeface="Calibri" pitchFamily="34" charset="-120"/>
+              </a:rPr>
+              <a:t>Versus burden + locus model; triage threshold</a:t>
+            </a:r>
+            <a:endParaRPr lang="en-US" sz="1200" dirty="0"/>
+          </a:p>
+        </p:txBody>
+      </p:sp>
+      <p:sp>
+        <p:nvSpPr>
+          <p:cNvPr id="178" name="Shape 173"/>
+          <p:cNvSpPr/>
+          <p:nvPr/>
+        </p:nvSpPr>
+        <p:spPr>
+          <a:xfrm>
+            <a:off x="27081036" y="13052679"/>
+            <a:ext cx="6547464" cy="0"/>
+          </a:xfrm>
+          <a:prstGeom prst="line">
+            <a:avLst/>
+          </a:prstGeom>
+          <a:noFill/>
+          <a:ln w="9525">
+            <a:solidFill>
+              <a:srgbClr val="E0E4E8"/>
+            </a:solidFill>
+            <a:prstDash val="solid"/>
+          </a:ln>
+        </p:spPr>
+      </p:sp>
+      <p:sp>
+        <p:nvSpPr>
+          <p:cNvPr id="179" name="Shape 174"/>
+          <p:cNvSpPr/>
+          <p:nvPr/>
+        </p:nvSpPr>
+        <p:spPr>
+          <a:xfrm>
+            <a:off x="25755156" y="13052679"/>
+            <a:ext cx="7873344" cy="0"/>
+          </a:xfrm>
+          <a:prstGeom prst="line">
+            <a:avLst/>
+          </a:prstGeom>
+          <a:noFill/>
+          <a:ln w="12700">
+            <a:solidFill>
+              <a:srgbClr val="12202E"/>
+            </a:solidFill>
+            <a:prstDash val="solid"/>
+          </a:ln>
+        </p:spPr>
+      </p:sp>
+      <p:sp>
+        <p:nvSpPr>
+          <p:cNvPr id="180" name="Text 175"/>
+          <p:cNvSpPr txBox="1"/>
+          <p:nvPr/>
+        </p:nvSpPr>
+        <p:spPr>
+          <a:xfrm>
+            <a:off x="25755156" y="13052679"/>
+            <a:ext cx="1325880" cy="288036"/>
+          </a:xfrm>
+          <a:prstGeom prst="rect">
+            <a:avLst/>
+          </a:prstGeom>
+          <a:noFill/>
+          <a:ln/>
+        </p:spPr>
+        <p:txBody>
+          <a:bodyPr wrap="square" lIns="0" tIns="0" rIns="0" bIns="0" rtlCol="0" anchor="ctr"/>
+          <a:lstStyle/>
+          <a:p>
+            <a:pPr indent="0" marL="0">
+              <a:buNone/>
+            </a:pPr>
+            <a:r>
+              <a:rPr lang="en-US" sz="1150" b="1" dirty="0">
+                <a:solidFill>
+                  <a:srgbClr val="3F4B57"/>
+                </a:solidFill>
+                <a:latin typeface="Calibri" pitchFamily="34" charset="0"/>
+                <a:ea typeface="Calibri" pitchFamily="34" charset="-122"/>
+                <a:cs typeface="Calibri" pitchFamily="34" charset="-120"/>
+              </a:rPr>
+              <a:t>Post-adoption</a:t>
+            </a:r>
+            <a:endParaRPr lang="en-US" sz="1150" dirty="0"/>
+          </a:p>
+        </p:txBody>
+      </p:sp>
+      <p:sp>
+        <p:nvSpPr>
+          <p:cNvPr id="181" name="Text 176"/>
+          <p:cNvSpPr txBox="1"/>
+          <p:nvPr/>
+        </p:nvSpPr>
+        <p:spPr>
+          <a:xfrm>
+            <a:off x="27081036" y="13052679"/>
+            <a:ext cx="1691640" cy="288036"/>
+          </a:xfrm>
+          <a:prstGeom prst="rect">
+            <a:avLst/>
+          </a:prstGeom>
+          <a:noFill/>
+          <a:ln/>
+        </p:spPr>
+        <p:txBody>
+          <a:bodyPr wrap="square" lIns="0" tIns="0" rIns="0" bIns="0" rtlCol="0" anchor="ctr"/>
+          <a:lstStyle/>
+          <a:p>
+            <a:pPr indent="0" marL="0">
+              <a:buNone/>
+            </a:pPr>
+            <a:r>
+              <a:rPr lang="en-US" sz="1200" b="1" dirty="0">
+                <a:solidFill>
+                  <a:srgbClr val="12202E"/>
+                </a:solidFill>
+                <a:latin typeface="Calibri" pitchFamily="34" charset="0"/>
+                <a:ea typeface="Calibri" pitchFamily="34" charset="-122"/>
+                <a:cs typeface="Calibri" pitchFamily="34" charset="-120"/>
+              </a:rPr>
+              <a:t>Monitoring</a:t>
+            </a:r>
+            <a:endParaRPr lang="en-US" sz="1200" dirty="0"/>
+          </a:p>
+        </p:txBody>
+      </p:sp>
+      <p:sp>
+        <p:nvSpPr>
+          <p:cNvPr id="182" name="Shape 177"/>
+          <p:cNvSpPr/>
+          <p:nvPr/>
+        </p:nvSpPr>
+        <p:spPr>
+          <a:xfrm>
+            <a:off x="28772676" y="13093827"/>
+            <a:ext cx="822960" cy="205740"/>
+          </a:xfrm>
+          <a:prstGeom prst="roundRect">
+            <a:avLst>
+              <a:gd name="adj" fmla="val 17778"/>
+            </a:avLst>
+          </a:prstGeom>
+          <a:solidFill>
+            <a:srgbClr val="FFFFFF"/>
+          </a:solidFill>
+          <a:ln w="12700">
+            <a:solidFill>
+              <a:srgbClr val="6B7682"/>
+            </a:solidFill>
+            <a:prstDash val="solid"/>
+          </a:ln>
+        </p:spPr>
+      </p:sp>
+      <p:sp>
+        <p:nvSpPr>
+          <p:cNvPr id="183" name="Text 178"/>
+          <p:cNvSpPr txBox="1"/>
+          <p:nvPr/>
+        </p:nvSpPr>
+        <p:spPr>
+          <a:xfrm>
+            <a:off x="28772676" y="13093827"/>
+            <a:ext cx="822960" cy="205740"/>
+          </a:xfrm>
+          <a:prstGeom prst="rect">
+            <a:avLst/>
+          </a:prstGeom>
+          <a:noFill/>
+          <a:ln/>
+        </p:spPr>
+        <p:txBody>
+          <a:bodyPr wrap="square" lIns="0" tIns="0" rIns="0" bIns="0" rtlCol="0" anchor="ctr"/>
+          <a:lstStyle/>
+          <a:p>
+            <a:pPr algn="ctr" indent="0" marL="0">
+              <a:buNone/>
+            </a:pPr>
+            <a:r>
+              <a:rPr lang="en-US" sz="1050" b="1" dirty="0">
+                <a:solidFill>
+                  <a:srgbClr val="3F4B57"/>
+                </a:solidFill>
+                <a:latin typeface="Calibri" pitchFamily="34" charset="0"/>
+                <a:ea typeface="Calibri" pitchFamily="34" charset="-122"/>
+                <a:cs typeface="Calibri" pitchFamily="34" charset="-120"/>
+              </a:rPr>
+              <a:t>Not yet</a:t>
+            </a:r>
+            <a:endParaRPr lang="en-US" sz="1050" dirty="0"/>
+          </a:p>
+        </p:txBody>
+      </p:sp>
+      <p:sp>
+        <p:nvSpPr>
+          <p:cNvPr id="184" name="Text 179"/>
+          <p:cNvSpPr txBox="1"/>
+          <p:nvPr/>
+        </p:nvSpPr>
+        <p:spPr>
+          <a:xfrm>
+            <a:off x="29687076" y="13052679"/>
+            <a:ext cx="3941424" cy="288036"/>
+          </a:xfrm>
+          <a:prstGeom prst="rect">
+            <a:avLst/>
+          </a:prstGeom>
+          <a:noFill/>
+          <a:ln/>
+        </p:spPr>
+        <p:txBody>
+          <a:bodyPr wrap="square" lIns="0" tIns="0" rIns="0" bIns="0" rtlCol="0" anchor="ctr"/>
+          <a:lstStyle/>
+          <a:p>
+            <a:pPr indent="0" marL="0">
+              <a:buNone/>
+            </a:pPr>
+            <a:r>
+              <a:rPr lang="en-US" sz="1200" dirty="0">
+                <a:solidFill>
+                  <a:srgbClr val="12202E"/>
+                </a:solidFill>
+                <a:latin typeface="Calibri" pitchFamily="34" charset="0"/>
+                <a:ea typeface="Calibri" pitchFamily="34" charset="-122"/>
+                <a:cs typeface="Calibri" pitchFamily="34" charset="-120"/>
+              </a:rPr>
+              <a:t>Drift with panel versions and populations</a:t>
+            </a:r>
+            <a:endParaRPr lang="en-US" sz="1200" dirty="0"/>
+          </a:p>
+        </p:txBody>
+      </p:sp>
+      <p:sp>
+        <p:nvSpPr>
+          <p:cNvPr id="185" name="Shape 180"/>
+          <p:cNvSpPr/>
+          <p:nvPr/>
+        </p:nvSpPr>
+        <p:spPr>
+          <a:xfrm>
+            <a:off x="27081036" y="13340715"/>
+            <a:ext cx="6547464" cy="0"/>
+          </a:xfrm>
+          <a:prstGeom prst="line">
+            <a:avLst/>
+          </a:prstGeom>
+          <a:noFill/>
+          <a:ln w="9525">
+            <a:solidFill>
+              <a:srgbClr val="E0E4E8"/>
+            </a:solidFill>
+            <a:prstDash val="solid"/>
+          </a:ln>
+        </p:spPr>
+      </p:sp>
+      <p:sp>
+        <p:nvSpPr>
+          <p:cNvPr id="186" name="Shape 181"/>
+          <p:cNvSpPr/>
+          <p:nvPr/>
+        </p:nvSpPr>
+        <p:spPr>
+          <a:xfrm>
+            <a:off x="25755156" y="13340715"/>
+            <a:ext cx="7873344" cy="0"/>
+          </a:xfrm>
+          <a:prstGeom prst="line">
+            <a:avLst/>
+          </a:prstGeom>
+          <a:noFill/>
+          <a:ln w="12700">
+            <a:solidFill>
+              <a:srgbClr val="12202E"/>
+            </a:solidFill>
+            <a:prstDash val="solid"/>
+          </a:ln>
+        </p:spPr>
+      </p:sp>
+      <p:sp>
+        <p:nvSpPr>
+          <p:cNvPr id="187" name="Text 182"/>
+          <p:cNvSpPr txBox="1"/>
+          <p:nvPr/>
+        </p:nvSpPr>
+        <p:spPr>
+          <a:xfrm>
+            <a:off x="25755156" y="13432155"/>
+            <a:ext cx="7873344" cy="679514"/>
+          </a:xfrm>
+          <a:prstGeom prst="rect">
+            <a:avLst/>
+          </a:prstGeom>
+          <a:noFill/>
+          <a:ln/>
+        </p:spPr>
+        <p:txBody>
+          <a:bodyPr wrap="square" lIns="0" tIns="0" rIns="0" bIns="0" rtlCol="0" anchor="t"/>
+          <a:lstStyle/>
+          <a:p>
+            <a:pPr indent="0" marL="0">
+              <a:buNone/>
+            </a:pPr>
+            <a:r>
+              <a:rPr lang="en-US" sz="1350" b="1" dirty="0">
+                <a:solidFill>
+                  <a:srgbClr val="3F4B57"/>
+                </a:solidFill>
+                <a:latin typeface="Calibri" pitchFamily="34" charset="0"/>
+                <a:ea typeface="Calibri" pitchFamily="34" charset="-122"/>
+                <a:cs typeface="Calibri" pitchFamily="34" charset="-120"/>
+              </a:rPr>
+              <a:t>Figure 5. </a:t>
+            </a:r>
+            <a:pPr indent="0" marL="0">
+              <a:buNone/>
+            </a:pPr>
+            <a:r>
+              <a:rPr lang="en-US" sz="1350" dirty="0">
+                <a:solidFill>
+                  <a:srgbClr val="3F4B57"/>
+                </a:solidFill>
+                <a:latin typeface="Calibri" pitchFamily="34" charset="0"/>
+                <a:ea typeface="Calibri" pitchFamily="34" charset="-122"/>
+                <a:cs typeface="Calibri" pitchFamily="34" charset="-120"/>
+              </a:rPr>
+              <a:t>Assessment along the seven EBAI dimensions and validation requirements for class B. Replicate values from MSK-IMPACT 2017; [ ] to compute on MSK-CHORD. CN, copy number; DCA, decision-curve analysis; NRI, net reclassification improvement.</a:t>
+            </a:r>
+            <a:endParaRPr lang="en-US" sz="1350" dirty="0"/>
+          </a:p>
+        </p:txBody>
+      </p:sp>
+      <p:sp>
+        <p:nvSpPr>
+          <p:cNvPr id="188" name="Shape 183"/>
+          <p:cNvSpPr/>
+          <p:nvPr/>
+        </p:nvSpPr>
+        <p:spPr>
+          <a:xfrm>
+            <a:off x="25755156" y="14385988"/>
+            <a:ext cx="7873344" cy="0"/>
+          </a:xfrm>
+          <a:prstGeom prst="line">
+            <a:avLst/>
+          </a:prstGeom>
+          <a:noFill/>
+          <a:ln w="28575">
+            <a:solidFill>
+              <a:srgbClr val="12202E"/>
+            </a:solidFill>
+            <a:prstDash val="solid"/>
+          </a:ln>
+        </p:spPr>
+      </p:sp>
+      <p:sp>
+        <p:nvSpPr>
+          <p:cNvPr id="189" name="Text 184"/>
+          <p:cNvSpPr txBox="1"/>
+          <p:nvPr/>
+        </p:nvSpPr>
+        <p:spPr>
+          <a:xfrm>
+            <a:off x="25755156" y="14477428"/>
+            <a:ext cx="7873344" cy="566928"/>
+          </a:xfrm>
+          <a:prstGeom prst="rect">
+            <a:avLst/>
+          </a:prstGeom>
+          <a:noFill/>
+          <a:ln/>
+        </p:spPr>
+        <p:txBody>
+          <a:bodyPr wrap="square" lIns="0" tIns="0" rIns="0" bIns="0" rtlCol="0" anchor="t"/>
+          <a:lstStyle/>
+          <a:p>
+            <a:pPr indent="0" marL="0">
+              <a:buNone/>
+            </a:pPr>
+            <a:r>
+              <a:rPr lang="en-US" sz="3200" b="1" dirty="0">
+                <a:solidFill>
+                  <a:srgbClr val="12202E"/>
+                </a:solidFill>
+                <a:latin typeface="Cambria" pitchFamily="34" charset="0"/>
+                <a:ea typeface="Cambria" pitchFamily="34" charset="-122"/>
+                <a:cs typeface="Cambria" pitchFamily="34" charset="-120"/>
+              </a:rPr>
+              <a:t>6  Discussion</a:t>
+            </a:r>
+            <a:endParaRPr lang="en-US" sz="3200" dirty="0"/>
+          </a:p>
+        </p:txBody>
+      </p:sp>
+      <p:sp>
+        <p:nvSpPr>
+          <p:cNvPr id="190" name="Text 185"/>
+          <p:cNvSpPr txBox="1"/>
+          <p:nvPr/>
+        </p:nvSpPr>
+        <p:spPr>
+          <a:xfrm>
+            <a:off x="25755156" y="15254668"/>
+            <a:ext cx="7873344" cy="2516124"/>
+          </a:xfrm>
+          <a:prstGeom prst="rect">
+            <a:avLst/>
+          </a:prstGeom>
+          <a:noFill/>
+          <a:ln/>
+        </p:spPr>
+        <p:txBody>
+          <a:bodyPr wrap="square" lIns="0" tIns="0" rIns="0" bIns="0" rtlCol="0" anchor="t"/>
+          <a:lstStyle/>
+          <a:p>
+            <a:pPr marL="342900" indent="-342900">
+              <a:spcAft>
+                <a:spcPts val="600"/>
+              </a:spcAft>
+              <a:buSzPct val="100000"/>
+              <a:buChar char="•"/>
+            </a:pPr>
+            <a:r>
+              <a:rPr lang="en-US" sz="1650" dirty="0">
+                <a:solidFill>
+                  <a:srgbClr val="12202E"/>
+                </a:solidFill>
+                <a:latin typeface="Calibri" pitchFamily="34" charset="0"/>
+                <a:ea typeface="Calibri" pitchFamily="34" charset="-122"/>
+                <a:cs typeface="Calibri" pitchFamily="34" charset="-120"/>
+              </a:rPr>
+              <a:t>A targeted panel predicts part of the unassayed genome; per-gene AUROC and simple baselines, not pooled AUROC alone, show how much.</a:t>
+            </a:r>
+            <a:endParaRPr lang="en-US" sz="1650" dirty="0"/>
+          </a:p>
+          <a:p>
+            <a:pPr marL="342900" indent="-342900">
+              <a:spcAft>
+                <a:spcPts val="600"/>
+              </a:spcAft>
+              <a:buSzPct val="100000"/>
+              <a:buChar char="•"/>
+            </a:pPr>
+            <a:r>
+              <a:rPr lang="en-US" sz="1650" dirty="0">
+                <a:solidFill>
+                  <a:srgbClr val="12202E"/>
+                </a:solidFill>
+                <a:latin typeface="Calibri" pitchFamily="34" charset="0"/>
+                <a:ea typeface="Calibri" pitchFamily="34" charset="-122"/>
+                <a:cs typeface="Calibri" pitchFamily="34" charset="-120"/>
+              </a:rPr>
+              <a:t>The signal is copy-number co-location and mutational burden; a generative model must add joint fidelity to justify its complexity.</a:t>
+            </a:r>
+            <a:endParaRPr lang="en-US" sz="1650" dirty="0"/>
+          </a:p>
+          <a:p>
+            <a:pPr marL="342900" indent="-342900">
+              <a:spcAft>
+                <a:spcPts val="600"/>
+              </a:spcAft>
+              <a:buSzPct val="100000"/>
+              <a:buChar char="•"/>
+            </a:pPr>
+            <a:r>
+              <a:rPr lang="en-US" sz="1650" dirty="0">
+                <a:solidFill>
+                  <a:srgbClr val="12202E"/>
+                </a:solidFill>
+                <a:latin typeface="Calibri" pitchFamily="34" charset="0"/>
+                <a:ea typeface="Calibri" pitchFamily="34" charset="-122"/>
+                <a:cs typeface="Calibri" pitchFamily="34" charset="-120"/>
+              </a:rPr>
+              <a:t>EBAI class B: NPV 0.86 at 90% sensitivity does not support rule-out; use is enrichment, with confirmatory CGP.</a:t>
+            </a:r>
+            <a:endParaRPr lang="en-US" sz="1650" dirty="0"/>
+          </a:p>
+          <a:p>
+            <a:pPr marL="342900" indent="-342900">
+              <a:spcAft>
+                <a:spcPts val="600"/>
+              </a:spcAft>
+              <a:buSzPct val="100000"/>
+              <a:buChar char="•"/>
+            </a:pPr>
+            <a:r>
+              <a:rPr lang="en-US" sz="1650" dirty="0">
+                <a:solidFill>
+                  <a:srgbClr val="12202E"/>
+                </a:solidFill>
+                <a:latin typeface="Calibri" pitchFamily="34" charset="0"/>
+                <a:ea typeface="Calibri" pitchFamily="34" charset="-122"/>
+                <a:cs typeface="Calibri" pitchFamily="34" charset="-120"/>
+              </a:rPr>
+              <a:t>Next: independent multi-centre validation, fairness audit, DCA and post-deployment drift monitoring.</a:t>
+            </a:r>
+            <a:endParaRPr lang="en-US" sz="1650" dirty="0"/>
+          </a:p>
+        </p:txBody>
+      </p:sp>
+      <p:sp>
+        <p:nvSpPr>
+          <p:cNvPr id="191" name="Shape 186"/>
+          <p:cNvSpPr/>
+          <p:nvPr/>
+        </p:nvSpPr>
+        <p:spPr>
+          <a:xfrm>
+            <a:off x="571500" y="18336960"/>
+            <a:ext cx="33057000" cy="0"/>
           </a:xfrm>
           <a:prstGeom prst="line">
             <a:avLst/>
@@ -9016,251 +10533,7 @@
       </p:sp>
       <p:sp>
         <p:nvSpPr>
-          <p:cNvPr id="152" name="Text 147"/>
-          <p:cNvSpPr txBox="1"/>
-          <p:nvPr/>
-        </p:nvSpPr>
-        <p:spPr>
-          <a:xfrm>
-            <a:off x="25755156" y="12787503"/>
-            <a:ext cx="7873344" cy="679514"/>
-          </a:xfrm>
-          <a:prstGeom prst="rect">
-            <a:avLst/>
-          </a:prstGeom>
-          <a:noFill/>
-          <a:ln/>
-        </p:spPr>
-        <p:txBody>
-          <a:bodyPr wrap="square" lIns="0" tIns="0" rIns="0" bIns="0" rtlCol="0" anchor="t"/>
-          <a:lstStyle/>
-          <a:p>
-            <a:pPr indent="0" marL="0">
-              <a:buNone/>
-            </a:pPr>
-            <a:r>
-              <a:rPr lang="en-US" sz="1350" b="1" dirty="0">
-                <a:solidFill>
-                  <a:srgbClr val="3F4B57"/>
-                </a:solidFill>
-                <a:latin typeface="Calibri" pitchFamily="34" charset="0"/>
-                <a:ea typeface="Calibri" pitchFamily="34" charset="-122"/>
-                <a:cs typeface="Calibri" pitchFamily="34" charset="-120"/>
-              </a:rPr>
-              <a:t>Figure 5. </a:t>
-            </a:r>
-            <a:pPr indent="0" marL="0">
-              <a:buNone/>
-            </a:pPr>
-            <a:r>
-              <a:rPr lang="en-US" sz="1350" dirty="0">
-                <a:solidFill>
-                  <a:srgbClr val="3F4B57"/>
-                </a:solidFill>
-                <a:latin typeface="Calibri" pitchFamily="34" charset="0"/>
-                <a:ea typeface="Calibri" pitchFamily="34" charset="-122"/>
-                <a:cs typeface="Calibri" pitchFamily="34" charset="-120"/>
-              </a:rPr>
-              <a:t>Assessment against the ESMO EBAI class B requirements. Replicate values from MSK-IMPACT 2017; [ ] to be computed on MSK-CHORD. Se, sensitivity for ≥1 altered target gene.</a:t>
-            </a:r>
-            <a:endParaRPr lang="en-US" sz="1350" dirty="0"/>
-          </a:p>
-        </p:txBody>
-      </p:sp>
-      <p:sp>
-        <p:nvSpPr>
-          <p:cNvPr id="153" name="Shape 148"/>
-          <p:cNvSpPr/>
-          <p:nvPr/>
-        </p:nvSpPr>
-        <p:spPr>
-          <a:xfrm>
-            <a:off x="25755156" y="13741336"/>
-            <a:ext cx="7873344" cy="0"/>
-          </a:xfrm>
-          <a:prstGeom prst="line">
-            <a:avLst/>
-          </a:prstGeom>
-          <a:noFill/>
-          <a:ln w="28575">
-            <a:solidFill>
-              <a:srgbClr val="12202E"/>
-            </a:solidFill>
-            <a:prstDash val="solid"/>
-          </a:ln>
-        </p:spPr>
-      </p:sp>
-      <p:sp>
-        <p:nvSpPr>
-          <p:cNvPr id="154" name="Text 149"/>
-          <p:cNvSpPr txBox="1"/>
-          <p:nvPr/>
-        </p:nvSpPr>
-        <p:spPr>
-          <a:xfrm>
-            <a:off x="25755156" y="13832776"/>
-            <a:ext cx="7873344" cy="566928"/>
-          </a:xfrm>
-          <a:prstGeom prst="rect">
-            <a:avLst/>
-          </a:prstGeom>
-          <a:noFill/>
-          <a:ln/>
-        </p:spPr>
-        <p:txBody>
-          <a:bodyPr wrap="square" lIns="0" tIns="0" rIns="0" bIns="0" rtlCol="0" anchor="t"/>
-          <a:lstStyle/>
-          <a:p>
-            <a:pPr indent="0" marL="0">
-              <a:buNone/>
-            </a:pPr>
-            <a:r>
-              <a:rPr lang="en-US" sz="3200" b="1" dirty="0">
-                <a:solidFill>
-                  <a:srgbClr val="12202E"/>
-                </a:solidFill>
-                <a:latin typeface="Cambria" pitchFamily="34" charset="0"/>
-                <a:ea typeface="Cambria" pitchFamily="34" charset="-122"/>
-                <a:cs typeface="Cambria" pitchFamily="34" charset="-120"/>
-              </a:rPr>
-              <a:t>6  Discussion</a:t>
-            </a:r>
-            <a:endParaRPr lang="en-US" sz="3200" dirty="0"/>
-          </a:p>
-        </p:txBody>
-      </p:sp>
-      <p:sp>
-        <p:nvSpPr>
-          <p:cNvPr id="155" name="Text 150"/>
-          <p:cNvSpPr txBox="1"/>
-          <p:nvPr/>
-        </p:nvSpPr>
-        <p:spPr>
-          <a:xfrm>
-            <a:off x="25755156" y="14610016"/>
-            <a:ext cx="7873344" cy="3039999"/>
-          </a:xfrm>
-          <a:prstGeom prst="rect">
-            <a:avLst/>
-          </a:prstGeom>
-          <a:noFill/>
-          <a:ln/>
-        </p:spPr>
-        <p:txBody>
-          <a:bodyPr wrap="square" lIns="0" tIns="0" rIns="0" bIns="0" rtlCol="0" anchor="t"/>
-          <a:lstStyle/>
-          <a:p>
-            <a:pPr marL="342900" indent="-342900">
-              <a:spcAft>
-                <a:spcPts val="600"/>
-              </a:spcAft>
-              <a:buSzPct val="100000"/>
-              <a:buChar char="•"/>
-            </a:pPr>
-            <a:r>
-              <a:rPr lang="en-US" sz="1650" dirty="0">
-                <a:solidFill>
-                  <a:srgbClr val="12202E"/>
-                </a:solidFill>
-                <a:latin typeface="Calibri" pitchFamily="34" charset="0"/>
-                <a:ea typeface="Calibri" pitchFamily="34" charset="-122"/>
-                <a:cs typeface="Calibri" pitchFamily="34" charset="-120"/>
-              </a:rPr>
-              <a:t>A targeted panel carries predictive information on unassayed genes; per-gene AUROC and simple baselines, not pooled AUROC alone, measure how much.</a:t>
-            </a:r>
-            <a:endParaRPr lang="en-US" sz="1650" dirty="0"/>
-          </a:p>
-          <a:p>
-            <a:pPr marL="342900" indent="-342900">
-              <a:spcAft>
-                <a:spcPts val="600"/>
-              </a:spcAft>
-              <a:buSzPct val="100000"/>
-              <a:buChar char="•"/>
-            </a:pPr>
-            <a:r>
-              <a:rPr lang="en-US" sz="1650" dirty="0">
-                <a:solidFill>
-                  <a:srgbClr val="12202E"/>
-                </a:solidFill>
-                <a:latin typeface="Calibri" pitchFamily="34" charset="0"/>
-                <a:ea typeface="Calibri" pitchFamily="34" charset="-122"/>
-                <a:cs typeface="Calibri" pitchFamily="34" charset="-120"/>
-              </a:rPr>
-              <a:t>The signal is mainly copy-number co-location and mutational burden; a generative model must add joint fidelity to justify its complexity.</a:t>
-            </a:r>
-            <a:endParaRPr lang="en-US" sz="1650" dirty="0"/>
-          </a:p>
-          <a:p>
-            <a:pPr marL="342900" indent="-342900">
-              <a:spcAft>
-                <a:spcPts val="600"/>
-              </a:spcAft>
-              <a:buSzPct val="100000"/>
-              <a:buChar char="•"/>
-            </a:pPr>
-            <a:r>
-              <a:rPr lang="en-US" sz="1650" dirty="0">
-                <a:solidFill>
-                  <a:srgbClr val="12202E"/>
-                </a:solidFill>
-                <a:latin typeface="Calibri" pitchFamily="34" charset="0"/>
-                <a:ea typeface="Calibri" pitchFamily="34" charset="-122"/>
-                <a:cs typeface="Calibri" pitchFamily="34" charset="-120"/>
-              </a:rPr>
-              <a:t>Limitations: masked-panel evaluation is an upper bound; single institution and split; fairness and actionable genes not yet evaluated.</a:t>
-            </a:r>
-            <a:endParaRPr lang="en-US" sz="1650" dirty="0"/>
-          </a:p>
-          <a:p>
-            <a:pPr marL="342900" indent="-342900">
-              <a:spcAft>
-                <a:spcPts val="600"/>
-              </a:spcAft>
-              <a:buSzPct val="100000"/>
-              <a:buChar char="•"/>
-            </a:pPr>
-            <a:r>
-              <a:rPr lang="en-US" sz="1650" dirty="0">
-                <a:solidFill>
-                  <a:srgbClr val="12202E"/>
-                </a:solidFill>
-                <a:latin typeface="Calibri" pitchFamily="34" charset="0"/>
-                <a:ea typeface="Calibri" pitchFamily="34" charset="-122"/>
-                <a:cs typeface="Calibri" pitchFamily="34" charset="-120"/>
-              </a:rPr>
-              <a:t>As an EBAI class B pre-screening tool, negatives still require confirmatory CGP (NPV 0.86 at 90% sensitivity).</a:t>
-            </a:r>
-            <a:endParaRPr lang="en-US" sz="1650" dirty="0"/>
-          </a:p>
-        </p:txBody>
-      </p:sp>
-      <p:sp>
-        <p:nvSpPr>
-          <p:cNvPr id="156" name="Shape 151"/>
-          <p:cNvSpPr/>
-          <p:nvPr/>
-        </p:nvSpPr>
-        <p:spPr>
-          <a:xfrm>
-            <a:off x="571500" y="18336960"/>
-            <a:ext cx="33057000" cy="0"/>
-          </a:xfrm>
-          <a:prstGeom prst="line">
-            <a:avLst/>
-          </a:prstGeom>
-          <a:noFill/>
-          <a:ln w="19050">
-            <a:solidFill>
-              <a:srgbClr val="12202E"/>
-            </a:solidFill>
-            <a:prstDash val="solid"/>
-          </a:ln>
-        </p:spPr>
-      </p:sp>
-      <p:sp>
-        <p:nvSpPr>
-          <p:cNvPr id="157" name="Text 152"/>
+          <p:cNvPr id="192" name="Text 187"/>
           <p:cNvSpPr txBox="1"/>
           <p:nvPr/>
         </p:nvSpPr>
@@ -9367,7 +10640,7 @@
       </p:sp>
       <p:sp>
         <p:nvSpPr>
-          <p:cNvPr id="158" name="Text 153"/>
+          <p:cNvPr id="193" name="Text 188"/>
           <p:cNvSpPr txBox="1"/>
           <p:nvPr/>
         </p:nvSpPr>
@@ -9437,7 +10710,7 @@
       </p:sp>
       <p:sp>
         <p:nvSpPr>
-          <p:cNvPr id="159" name="Text 154"/>
+          <p:cNvPr id="194" name="Text 189"/>
           <p:cNvSpPr txBox="1"/>
           <p:nvPr/>
         </p:nvSpPr>
@@ -9510,7 +10783,7 @@
       </p:sp>
       <p:sp>
         <p:nvSpPr>
-          <p:cNvPr id="160" name="Shape 155"/>
+          <p:cNvPr id="195" name="Shape 190"/>
           <p:cNvSpPr/>
           <p:nvPr/>
         </p:nvSpPr>
@@ -9535,7 +10808,7 @@
       </p:sp>
       <p:sp>
         <p:nvSpPr>
-          <p:cNvPr id="161" name="Text 156"/>
+          <p:cNvPr id="196" name="Text 191"/>
           <p:cNvSpPr txBox="1"/>
           <p:nvPr/>
         </p:nvSpPr>

</xml_diff>

<commit_message>
Justify the 70/15/15 patient-level split on the P305 poster
Co-Authored-By: Claude Opus 5.5 <noreply@anthropic.com>
Claude-Session: https://claude.ai/code/session_01XfxNdpDPmWZQpH5ScSMkJ1
</commit_message>
<xml_diff>
--- a/docs/poster/ESMO_P305_poster.pptx
+++ b/docs/poster/ESMO_P305_poster.pptx
@@ -1761,7 +1761,7 @@
         </p:nvSpPr>
         <p:spPr>
           <a:xfrm>
-            <a:off x="571500" y="10407206"/>
+            <a:off x="571500" y="10343198"/>
             <a:ext cx="7873344" cy="0"/>
           </a:xfrm>
           <a:prstGeom prst="line">
@@ -1784,7 +1784,7 @@
         </p:nvSpPr>
         <p:spPr>
           <a:xfrm>
-            <a:off x="571500" y="10498646"/>
+            <a:off x="571500" y="10434638"/>
             <a:ext cx="7873344" cy="566928"/>
           </a:xfrm>
           <a:prstGeom prst="rect">
@@ -1823,7 +1823,7 @@
         </p:nvSpPr>
         <p:spPr>
           <a:xfrm>
-            <a:off x="571500" y="11275886"/>
+            <a:off x="571500" y="11211878"/>
             <a:ext cx="5314507" cy="566928"/>
           </a:xfrm>
           <a:prstGeom prst="rect">
@@ -1843,7 +1843,7 @@
         </p:nvSpPr>
         <p:spPr>
           <a:xfrm>
-            <a:off x="571500" y="11275886"/>
+            <a:off x="571500" y="11211878"/>
             <a:ext cx="5314507" cy="566928"/>
           </a:xfrm>
           <a:prstGeom prst="rect">
@@ -1882,7 +1882,7 @@
         </p:nvSpPr>
         <p:spPr>
           <a:xfrm>
-            <a:off x="5886007" y="11275886"/>
+            <a:off x="5886007" y="11211878"/>
             <a:ext cx="2558837" cy="566928"/>
           </a:xfrm>
           <a:prstGeom prst="rect">
@@ -1907,7 +1907,7 @@
         </p:nvSpPr>
         <p:spPr>
           <a:xfrm>
-            <a:off x="5886007" y="11275886"/>
+            <a:off x="5886007" y="11211878"/>
             <a:ext cx="2558837" cy="566928"/>
           </a:xfrm>
           <a:prstGeom prst="rect">
@@ -1946,7 +1946,7 @@
         </p:nvSpPr>
         <p:spPr>
           <a:xfrm>
-            <a:off x="571500" y="11952542"/>
+            <a:off x="571500" y="11888534"/>
             <a:ext cx="7873344" cy="442722"/>
           </a:xfrm>
           <a:prstGeom prst="rect">
@@ -1999,7 +1999,7 @@
         </p:nvSpPr>
         <p:spPr>
           <a:xfrm>
-            <a:off x="571500" y="12861608"/>
+            <a:off x="571500" y="12733592"/>
             <a:ext cx="7873344" cy="239649"/>
           </a:xfrm>
           <a:prstGeom prst="rect">
@@ -2059,7 +2059,7 @@
           </p:nvPr>
         </p:nvGraphicFramePr>
         <p:xfrm>
-          <a:off x="571500" y="13210985"/>
+          <a:off x="571500" y="13082969"/>
           <a:ext cx="7873344" cy="914400"/>
         </p:xfrm>
         <a:graphic>
@@ -2748,7 +2748,7 @@
                           <a:ea typeface="Calibri" pitchFamily="34" charset="-122"/>
                           <a:cs typeface="Calibri" pitchFamily="34" charset="-120"/>
                         </a:rPr>
-                        <a:t>Split (patient level): train / val / test</a:t>
+                        <a:t>Patient-level split: train / validation / test</a:t>
                       </a:r>
                       <a:endParaRPr lang="en-US" sz="1600" dirty="0">
                         <a:latin typeface="Calibri" charset="0"/>
@@ -2874,7 +2874,7 @@
         </p:nvSpPr>
         <p:spPr>
           <a:xfrm>
-            <a:off x="571500" y="13210985"/>
+            <a:off x="571500" y="13082969"/>
             <a:ext cx="7873344" cy="0"/>
           </a:xfrm>
           <a:prstGeom prst="line">
@@ -2897,7 +2897,7 @@
         </p:nvSpPr>
         <p:spPr>
           <a:xfrm>
-            <a:off x="571500" y="15515273"/>
+            <a:off x="571500" y="15387257"/>
             <a:ext cx="7873344" cy="0"/>
           </a:xfrm>
           <a:prstGeom prst="line">
@@ -2920,8 +2920,8 @@
         </p:nvSpPr>
         <p:spPr>
           <a:xfrm>
-            <a:off x="571500" y="15981617"/>
-            <a:ext cx="7873344" cy="239649"/>
+            <a:off x="571500" y="15789593"/>
+            <a:ext cx="7873344" cy="442722"/>
           </a:xfrm>
           <a:prstGeom prst="rect">
             <a:avLst/>
@@ -2959,7 +2959,7 @@
                 <a:ea typeface="Calibri" pitchFamily="34" charset="-122"/>
                 <a:cs typeface="Calibri" pitchFamily="34" charset="-120"/>
               </a:rPr>
-              <a:t>The abstract reports 75 / 15 / 15%, which sums to 105%; 70 / 15 / 15% is assumed here.</a:t>
+              <a:t>Test (15%, ≈334 patients) and validation (15%) as in the abstract; the remaining 70% trains the model. The abstract’s “75%” for training would sum to 105%.</a:t>
             </a:r>
             <a:endParaRPr lang="en-US" sz="1300" dirty="0"/>
           </a:p>
@@ -2973,7 +2973,7 @@
         </p:nvSpPr>
         <p:spPr>
           <a:xfrm>
-            <a:off x="571500" y="16495586"/>
+            <a:off x="571500" y="16506635"/>
             <a:ext cx="7873344" cy="1489329"/>
           </a:xfrm>
           <a:prstGeom prst="rect">

</xml_diff>

<commit_message>
Remove QR code from P305 poster footer
Co-Authored-By: Claude Opus 5.5 <noreply@anthropic.com>
Claude-Session: https://claude.ai/code/session_01XfxNdpDPmWZQpH5ScSMkJ1
</commit_message>
<xml_diff>
--- a/docs/poster/ESMO_P305_poster.pptx
+++ b/docs/poster/ESMO_P305_poster.pptx
@@ -11119,7 +11119,7 @@
         <p:spPr>
           <a:xfrm>
             <a:off x="571500" y="18474120"/>
-            <a:ext cx="15380928" cy="1188720"/>
+            <a:ext cx="16144452" cy="1188720"/>
           </a:xfrm>
           <a:prstGeom prst="rect">
             <a:avLst/>
@@ -11225,8 +11225,8 @@
         </p:nvSpPr>
         <p:spPr>
           <a:xfrm>
-            <a:off x="16336476" y="18474120"/>
-            <a:ext cx="7690464" cy="1188720"/>
+            <a:off x="17100000" y="18474120"/>
+            <a:ext cx="8072226" cy="1188720"/>
           </a:xfrm>
           <a:prstGeom prst="rect">
             <a:avLst/>
@@ -11267,7 +11267,7 @@
                 <a:ea typeface="Calibri" pitchFamily="34" charset="-122"/>
                 <a:cs typeface="Calibri" pitchFamily="34" charset="-120"/>
               </a:rPr>
-              <a:t>MSK-CHORD and msk_impact_2017 via cBioPortal. Code: github.com/chiaralouisa/brainmets-POP (QR)</a:t>
+              <a:t>MSK-CHORD and msk_impact_2017 via cBioPortal. Code and split IDs: github.com/chiaralouisa/brainmets-POP, available on request.</a:t>
             </a:r>
             <a:endParaRPr lang="en-US" sz="1250" dirty="0"/>
           </a:p>
@@ -11281,8 +11281,8 @@
         </p:nvSpPr>
         <p:spPr>
           <a:xfrm>
-            <a:off x="24410988" y="18474120"/>
-            <a:ext cx="7690464" cy="1188720"/>
+            <a:off x="25556274" y="18474120"/>
+            <a:ext cx="8072226" cy="1188720"/>
           </a:xfrm>
           <a:prstGeom prst="rect">
             <a:avLst/>
@@ -11346,30 +11346,6 @@
           </a:p>
         </p:txBody>
       </p:sp>
-      <p:pic>
-        <p:nvPicPr>
-          <p:cNvPr id="202" name="Image 0" descr="QR code: github.com/chiaralouisa/brainmets-POP">    </p:cNvPr>
-          <p:cNvPicPr>
-            <a:picLocks noChangeAspect="1"/>
-          </p:cNvPicPr>
-          <p:nvPr/>
-        </p:nvPicPr>
-        <p:blipFill>
-          <a:blip r:embed="rId2"/>
-          <a:stretch>
-            <a:fillRect/>
-          </a:stretch>
-        </p:blipFill>
-        <p:spPr>
-          <a:xfrm>
-            <a:off x="32485500" y="18474120"/>
-            <a:ext cx="1143000" cy="1143000"/>
-          </a:xfrm>
-          <a:prstGeom prst="rect">
-            <a:avLst/>
-          </a:prstGeom>
-        </p:spPr>
-      </p:pic>
     </p:spTree>
   </p:cSld>
   <p:clrMapOvr>

</xml_diff>